<commit_message>
Clarify app flow and production models
</commit_message>
<xml_diff>
--- a/docs/AVIC-Portfolio-Intelligence-Brief.pptx
+++ b/docs/AVIC-Portfolio-Intelligence-Brief.pptx
@@ -2,24 +2,24 @@
 <file path=ppt/presentation.xml><?xml version="1.0" encoding="utf-8"?>
 <p:presentation xmlns:p="http://schemas.openxmlformats.org/presentationml/2006/main">
   <p:sldMasterIdLst>
-    <p:sldMasterId xmlns:r="http://schemas.openxmlformats.org/officeDocument/2006/relationships" id="2147483648" r:id="Ra77d0e8be4b3455e"/>
+    <p:sldMasterId xmlns:r="http://schemas.openxmlformats.org/officeDocument/2006/relationships" id="2147483648" r:id="R63960dcaa187434c"/>
   </p:sldMasterIdLst>
   <p:notesMasterIdLst>
-    <p:notesMasterId xmlns:r="http://schemas.openxmlformats.org/officeDocument/2006/relationships" r:id="R28aa200bd4154883"/>
+    <p:notesMasterId xmlns:r="http://schemas.openxmlformats.org/officeDocument/2006/relationships" r:id="Rced797c5856141c3"/>
   </p:notesMasterIdLst>
   <p:sldIdLst>
-    <p:sldId xmlns:r="http://schemas.openxmlformats.org/officeDocument/2006/relationships" id="256" r:id="R3f33761b4403475f"/>
-    <p:sldId xmlns:r="http://schemas.openxmlformats.org/officeDocument/2006/relationships" id="257" r:id="R778035856a374fc5"/>
-    <p:sldId xmlns:r="http://schemas.openxmlformats.org/officeDocument/2006/relationships" id="258" r:id="Rf654728e28da4e52"/>
-    <p:sldId xmlns:r="http://schemas.openxmlformats.org/officeDocument/2006/relationships" id="259" r:id="R9d1a6c586785497b"/>
-    <p:sldId xmlns:r="http://schemas.openxmlformats.org/officeDocument/2006/relationships" id="260" r:id="Rc95b1a8c03374898"/>
-    <p:sldId xmlns:r="http://schemas.openxmlformats.org/officeDocument/2006/relationships" id="261" r:id="R1ad9330891d149ed"/>
-    <p:sldId xmlns:r="http://schemas.openxmlformats.org/officeDocument/2006/relationships" id="262" r:id="Re9e9ccf1c63f42e0"/>
-    <p:sldId xmlns:r="http://schemas.openxmlformats.org/officeDocument/2006/relationships" id="263" r:id="R506a4b733fea4efa"/>
-    <p:sldId xmlns:r="http://schemas.openxmlformats.org/officeDocument/2006/relationships" id="264" r:id="R1f5ede5f6ad44826"/>
-    <p:sldId xmlns:r="http://schemas.openxmlformats.org/officeDocument/2006/relationships" id="265" r:id="R70bd9aee6bd048ae"/>
-    <p:sldId xmlns:r="http://schemas.openxmlformats.org/officeDocument/2006/relationships" id="266" r:id="R2ac825dae39b471c"/>
-    <p:sldId xmlns:r="http://schemas.openxmlformats.org/officeDocument/2006/relationships" id="267" r:id="R245794c459b644b2"/>
+    <p:sldId xmlns:r="http://schemas.openxmlformats.org/officeDocument/2006/relationships" id="256" r:id="R906b2c5764a5491b"/>
+    <p:sldId xmlns:r="http://schemas.openxmlformats.org/officeDocument/2006/relationships" id="257" r:id="R6a7998e8820d4f9a"/>
+    <p:sldId xmlns:r="http://schemas.openxmlformats.org/officeDocument/2006/relationships" id="258" r:id="R815210af8e0946c5"/>
+    <p:sldId xmlns:r="http://schemas.openxmlformats.org/officeDocument/2006/relationships" id="259" r:id="R186e00f308f04148"/>
+    <p:sldId xmlns:r="http://schemas.openxmlformats.org/officeDocument/2006/relationships" id="260" r:id="R1d6e00d4b5f44a64"/>
+    <p:sldId xmlns:r="http://schemas.openxmlformats.org/officeDocument/2006/relationships" id="261" r:id="R4d53b327790342ca"/>
+    <p:sldId xmlns:r="http://schemas.openxmlformats.org/officeDocument/2006/relationships" id="262" r:id="Rb1058d5465ce4cbe"/>
+    <p:sldId xmlns:r="http://schemas.openxmlformats.org/officeDocument/2006/relationships" id="263" r:id="R25105acb0d5b463c"/>
+    <p:sldId xmlns:r="http://schemas.openxmlformats.org/officeDocument/2006/relationships" id="264" r:id="R70932fa76f2e45d9"/>
+    <p:sldId xmlns:r="http://schemas.openxmlformats.org/officeDocument/2006/relationships" id="265" r:id="Rd9cccab51b5a40b8"/>
+    <p:sldId xmlns:r="http://schemas.openxmlformats.org/officeDocument/2006/relationships" id="266" r:id="Rf86d0d9f5e9a4ec8"/>
+    <p:sldId xmlns:r="http://schemas.openxmlformats.org/officeDocument/2006/relationships" id="267" r:id="R9064c475adcb484c"/>
   </p:sldIdLst>
   <p:sldSz cx="12192000" cy="6858000"/>
   <p:notesSz cx="6858000" cy="9144000"/>
@@ -553,7 +553,7 @@
           <a:lstStyle xmlns:a="http://schemas.openxmlformats.org/drawingml/2006/main"/>
           <a:p xmlns:a="http://schemas.openxmlformats.org/drawingml/2006/main">
             <a:r>
-              <a:t>This slide defines the demo boundary. The interface, database, file import, retrieval, source drill-down, saved evidence, and feedback capture are implemented. Live connectors, public filings, identity, source access enforcement, schedules, webhooks, and the reviewer interface are absent.</a:t>
+              <a:t>This slide defines the boundary. The current app implements the interface, API routes, file import, PostgreSQL storage, local retrieval, fixed brief generation, source drill-down, saved brief runs, and feedback capture. The demo uses 10 fictional companies, static source files, a local database, word-hash vectors, and a fixed reference date. Live connectors, public filings, sign-in, source access enforcement, schedules, webhooks, reviewer tools, text-embedding-3-large, gpt-5.6-sol, and the Responses API are not active.</a:t>
             </a:r>
           </a:p>
           <a:p xmlns:a="http://schemas.openxmlformats.org/drawingml/2006/main">
@@ -568,17 +568,37 @@
           </a:p>
           <a:p xmlns:a="http://schemas.openxmlformats.org/drawingml/2006/main">
             <a:r>
-              <a:t>- /Users/alexthorpe/Documents/GitHub/AVIC/README.md</a:t>
-            </a:r>
-          </a:p>
-          <a:p xmlns:a="http://schemas.openxmlformats.org/drawingml/2006/main">
-            <a:r>
-              <a:t>- /Users/alexthorpe/Documents/GitHub/AVIC/app</a:t>
-            </a:r>
-          </a:p>
-          <a:p xmlns:a="http://schemas.openxmlformats.org/drawingml/2006/main">
-            <a:r>
-              <a:t>- /Users/alexthorpe/Documents/GitHub/AVIC/lib</a:t>
+              <a:t>- /Users/alexthorpe/Documents/GitHub/AVIC/app/page.tsx</a:t>
+            </a:r>
+          </a:p>
+          <a:p xmlns:a="http://schemas.openxmlformats.org/drawingml/2006/main">
+            <a:r>
+              <a:t>- /Users/alexthorpe/Documents/GitHub/AVIC/app/api/briefs/route.ts</a:t>
+            </a:r>
+          </a:p>
+          <a:p xmlns:a="http://schemas.openxmlformats.org/drawingml/2006/main">
+            <a:r>
+              <a:t>- /Users/alexthorpe/Documents/GitHub/AVIC/app/api/sources/[id]/route.ts</a:t>
+            </a:r>
+          </a:p>
+          <a:p xmlns:a="http://schemas.openxmlformats.org/drawingml/2006/main">
+            <a:r>
+              <a:t>- /Users/alexthorpe/Documents/GitHub/AVIC/app/api/feedback/route.ts</a:t>
+            </a:r>
+          </a:p>
+          <a:p xmlns:a="http://schemas.openxmlformats.org/drawingml/2006/main">
+            <a:r>
+              <a:t>- /Users/alexthorpe/Documents/GitHub/AVIC/lib/ingestion.ts</a:t>
+            </a:r>
+          </a:p>
+          <a:p xmlns:a="http://schemas.openxmlformats.org/drawingml/2006/main">
+            <a:r>
+              <a:t>- /Users/alexthorpe/Documents/GitHub/AVIC/lib/retrieval.ts</a:t>
+            </a:r>
+          </a:p>
+          <a:p xmlns:a="http://schemas.openxmlformats.org/drawingml/2006/main">
+            <a:r>
+              <a:t>- /Users/alexthorpe/Documents/GitHub/AVIC/lib/brief.ts</a:t>
             </a:r>
           </a:p>
           <a:p xmlns:a="http://schemas.openxmlformats.org/drawingml/2006/main">
@@ -588,7 +608,12 @@
           </a:p>
           <a:p xmlns:a="http://schemas.openxmlformats.org/drawingml/2006/main">
             <a:r>
-              <a:t>- /Users/alexthorpe/Documents/GitHub/AVIC/demo_data/manifest.json</a:t>
+              <a:t>- https://developers.openai.com/api/docs/models/text-embedding-3-large</a:t>
+            </a:r>
+          </a:p>
+          <a:p xmlns:a="http://schemas.openxmlformats.org/drawingml/2006/main">
+            <a:r>
+              <a:t>- https://developers.openai.com/api/docs/models/gpt-5.6-sol</a:t>
             </a:r>
           </a:p>
           <a:p xmlns:a="http://schemas.openxmlformats.org/drawingml/2006/main">
@@ -1173,7 +1198,7 @@
           <a:lstStyle xmlns:a="http://schemas.openxmlformats.org/drawingml/2006/main"/>
           <a:p xmlns:a="http://schemas.openxmlformats.org/drawingml/2006/main">
             <a:r>
-              <a:t>Read the diagram from left to right. Import finishes before a request. The request reads the local evidence store and never waits for a source system. Solid nodes are in the prototype. The dashed callout lists production additions.</a:t>
+              <a:t>Current flow: file import validates each supplied company ID, keeps the source record, calculates a checksum, creates chunks and local word-hash vectors, and writes the data to PostgreSQL. A brief request uses a fixed query. SQL filters by company before it ranks up to 30 source records. Five companies use tailored templates. The other companies use one generic rule. The service checks source IDs and company isolation, saves the brief and ranked source records, and returns the result to the interface. The request path calls no source system and no external model. The production target uses text-embedding-3-large for retrieval vectors and gpt-5.6-sol through the Responses API for brief generation.</a:t>
             </a:r>
           </a:p>
           <a:p xmlns:a="http://schemas.openxmlformats.org/drawingml/2006/main">
@@ -1188,16 +1213,6 @@
           </a:p>
           <a:p xmlns:a="http://schemas.openxmlformats.org/drawingml/2006/main">
             <a:r>
-              <a:t>- /Users/alexthorpe/Documents/GitHub/AVIC/docs/AIVC_Technical_Challenge_Task_4.2.pdf</a:t>
-            </a:r>
-          </a:p>
-          <a:p xmlns:a="http://schemas.openxmlformats.org/drawingml/2006/main">
-            <a:r>
-              <a:t>- /Users/alexthorpe/Documents/GitHub/AVIC/docs/architecture.md</a:t>
-            </a:r>
-          </a:p>
-          <a:p xmlns:a="http://schemas.openxmlformats.org/drawingml/2006/main">
-            <a:r>
               <a:t>- /Users/alexthorpe/Documents/GitHub/AVIC/lib/ingestion.ts</a:t>
             </a:r>
           </a:p>
@@ -1213,7 +1228,32 @@
           </a:p>
           <a:p xmlns:a="http://schemas.openxmlformats.org/drawingml/2006/main">
             <a:r>
+              <a:t>- /Users/alexthorpe/Documents/GitHub/AVIC/app/api/briefs/route.ts</a:t>
+            </a:r>
+          </a:p>
+          <a:p xmlns:a="http://schemas.openxmlformats.org/drawingml/2006/main">
+            <a:r>
+              <a:t>- /Users/alexthorpe/Documents/GitHub/AVIC/app/page.tsx</a:t>
+            </a:r>
+          </a:p>
+          <a:p xmlns:a="http://schemas.openxmlformats.org/drawingml/2006/main">
+            <a:r>
               <a:t>- /Users/alexthorpe/Documents/GitHub/AVIC/db/schema.sql</a:t>
+            </a:r>
+          </a:p>
+          <a:p xmlns:a="http://schemas.openxmlformats.org/drawingml/2006/main">
+            <a:r>
+              <a:t>- https://developers.openai.com/api/docs/models/text-embedding-3-large</a:t>
+            </a:r>
+          </a:p>
+          <a:p xmlns:a="http://schemas.openxmlformats.org/drawingml/2006/main">
+            <a:r>
+              <a:t>- https://developers.openai.com/api/docs/models/gpt-5.6-sol</a:t>
+            </a:r>
+          </a:p>
+          <a:p xmlns:a="http://schemas.openxmlformats.org/drawingml/2006/main">
+            <a:r>
+              <a:t>- https://developers.openai.com/api/docs/guides/latest-model</a:t>
             </a:r>
           </a:p>
           <a:p xmlns:a="http://schemas.openxmlformats.org/drawingml/2006/main">
@@ -1393,7 +1433,7 @@
           <a:lstStyle xmlns:a="http://schemas.openxmlformats.org/drawingml/2006/main"/>
           <a:p xmlns:a="http://schemas.openxmlformats.org/drawingml/2006/main">
             <a:r>
-              <a:t>The hard company filter runs before ranking. The 38/32/20/10 weights are initial hand-set heuristics and are not calibrated. Source checks confirm valid IDs and company isolation. They do not prove that every statement is semantically entailed by its source.</a:t>
+              <a:t>The request contains only a company ID. The server uses one fixed retrieval query. SQL filters source records and chunks by that company ID before scoring. The score is 38 percent full-text rank, 32 percent local word-hash vector similarity, 20 percent source quality, and 10 percent recency against a fixed date. The query returns up to 30 source records. Fixed templates or one generic rule write the brief. No external model runs. The production target keeps the hard company filter and source IDs. It replaces the local word-hash vectors with text-embedding-3-large and uses gpt-5.6-sol through the Responses API for structured brief generation.</a:t>
             </a:r>
           </a:p>
           <a:p xmlns:a="http://schemas.openxmlformats.org/drawingml/2006/main">
@@ -1418,7 +1458,22 @@
           </a:p>
           <a:p xmlns:a="http://schemas.openxmlformats.org/drawingml/2006/main">
             <a:r>
-              <a:t>- /Users/alexthorpe/Documents/GitHub/AVIC/scripts/verify-v1.ts</a:t>
+              <a:t>- /Users/alexthorpe/Documents/GitHub/AVIC/app/api/briefs/route.ts</a:t>
+            </a:r>
+          </a:p>
+          <a:p xmlns:a="http://schemas.openxmlformats.org/drawingml/2006/main">
+            <a:r>
+              <a:t>- https://developers.openai.com/api/docs/models/text-embedding-3-large</a:t>
+            </a:r>
+          </a:p>
+          <a:p xmlns:a="http://schemas.openxmlformats.org/drawingml/2006/main">
+            <a:r>
+              <a:t>- https://developers.openai.com/api/docs/models/gpt-5.6-sol</a:t>
+            </a:r>
+          </a:p>
+          <a:p xmlns:a="http://schemas.openxmlformats.org/drawingml/2006/main">
+            <a:r>
+              <a:t>- https://developers.openai.com/api/docs/guides/latest-model</a:t>
             </a:r>
           </a:p>
           <a:p xmlns:a="http://schemas.openxmlformats.org/drawingml/2006/main">
@@ -1493,7 +1548,7 @@
           <a:lstStyle xmlns:a="http://schemas.openxmlformats.org/drawingml/2006/main"/>
           <a:p xmlns:a="http://schemas.openxmlformats.org/drawingml/2006/main">
             <a:r>
-              <a:t>The V1 stack favors one codebase, one evidence store, and repeatable local behavior. The main trade-offs are no live freshness, no access enforcement, and limited semantic quality.</a:t>
+              <a:t>The local prototype uses no external model. For production, choose text-embedding-3-large because OpenAI identifies it as the most capable embedding model. Choose gpt-5.6-sol because OpenAI identifies it as the flagship model for complex professional work. Use the Responses API and a structured output schema. Start with medium reasoning effort. Increase the effort only when the evaluation set shows a useful quality gain and the request stays within the response-time target.</a:t>
             </a:r>
           </a:p>
           <a:p xmlns:a="http://schemas.openxmlformats.org/drawingml/2006/main">
@@ -1508,22 +1563,42 @@
           </a:p>
           <a:p xmlns:a="http://schemas.openxmlformats.org/drawingml/2006/main">
             <a:r>
-              <a:t>- /Users/alexthorpe/Documents/GitHub/AVIC/README.md</a:t>
-            </a:r>
-          </a:p>
-          <a:p xmlns:a="http://schemas.openxmlformats.org/drawingml/2006/main">
-            <a:r>
               <a:t>- /Users/alexthorpe/Documents/GitHub/AVIC/package.json</a:t>
             </a:r>
           </a:p>
           <a:p xmlns:a="http://schemas.openxmlformats.org/drawingml/2006/main">
             <a:r>
-              <a:t>- /Users/alexthorpe/Documents/GitHub/AVIC/docker-compose.yml</a:t>
-            </a:r>
-          </a:p>
-          <a:p xmlns:a="http://schemas.openxmlformats.org/drawingml/2006/main">
-            <a:r>
               <a:t>- /Users/alexthorpe/Documents/GitHub/AVIC/db/schema.sql</a:t>
+            </a:r>
+          </a:p>
+          <a:p xmlns:a="http://schemas.openxmlformats.org/drawingml/2006/main">
+            <a:r>
+              <a:t>- /Users/alexthorpe/Documents/GitHub/AVIC/lib/ingestion.ts</a:t>
+            </a:r>
+          </a:p>
+          <a:p xmlns:a="http://schemas.openxmlformats.org/drawingml/2006/main">
+            <a:r>
+              <a:t>- /Users/alexthorpe/Documents/GitHub/AVIC/lib/retrieval.ts</a:t>
+            </a:r>
+          </a:p>
+          <a:p xmlns:a="http://schemas.openxmlformats.org/drawingml/2006/main">
+            <a:r>
+              <a:t>- /Users/alexthorpe/Documents/GitHub/AVIC/lib/brief.ts</a:t>
+            </a:r>
+          </a:p>
+          <a:p xmlns:a="http://schemas.openxmlformats.org/drawingml/2006/main">
+            <a:r>
+              <a:t>- https://developers.openai.com/api/docs/models/text-embedding-3-large</a:t>
+            </a:r>
+          </a:p>
+          <a:p xmlns:a="http://schemas.openxmlformats.org/drawingml/2006/main">
+            <a:r>
+              <a:t>- https://developers.openai.com/api/docs/models/gpt-5.6-sol</a:t>
+            </a:r>
+          </a:p>
+          <a:p xmlns:a="http://schemas.openxmlformats.org/drawingml/2006/main">
+            <a:r>
+              <a:t>- https://developers.openai.com/api/docs/guides/latest-model</a:t>
             </a:r>
           </a:p>
           <a:p xmlns:a="http://schemas.openxmlformats.org/drawingml/2006/main">
@@ -1696,7 +1771,7 @@
   </p:cSld>
   <p:clrMap bg1="lt1" tx1="dk1" bg2="lt2" tx2="dk2" accent1="accent1" accent2="accent2" accent3="accent3" accent4="accent4" accent5="accent5" accent6="accent6" hlink="hlink" folHlink="folHlink"/>
   <p:sldLayoutIdLst>
-    <p:sldLayoutId xmlns:r="http://schemas.openxmlformats.org/officeDocument/2006/relationships" id="2147483649" r:id="R8ab26cdb8c8643a5"/>
+    <p:sldLayoutId xmlns:r="http://schemas.openxmlformats.org/officeDocument/2006/relationships" id="2147483649" r:id="Rbdd50923d7ec4471"/>
   </p:sldLayoutIdLst>
   <p:txStyles>
     <p:titleStyle>
@@ -2767,7 +2842,7 @@
                 <a:ea typeface="Helvetica Neue"/>
                 <a:cs typeface="Helvetica Neue"/>
               </a:rPr>
-              <a:t>What is real, and what is simulated?</a:t>
+              <a:t>What runs today, and what is planned?</a:t>
             </a:r>
           </a:p>
         </p:txBody>
@@ -2984,7 +3059,7 @@
                 <a:ea typeface="Helvetica Neue"/>
                 <a:cs typeface="Helvetica Neue"/>
               </a:rPr>
-              <a:t>REAL TODAY</a:t>
+              <a:t>RUNS TODAY</a:t>
             </a:r>
           </a:p>
         </p:txBody>
@@ -3702,7 +3777,7 @@
                 <a:ea typeface="Helvetica Neue"/>
                 <a:cs typeface="Helvetica Neue"/>
               </a:rPr>
-              <a:t>Company-scoped retrieval</a:t>
+              <a:t>Company-scoped top-30 retrieval</a:t>
             </a:r>
           </a:p>
         </p:txBody>
@@ -3891,7 +3966,7 @@
                 <a:ea typeface="Helvetica Neue"/>
                 <a:cs typeface="Helvetica Neue"/>
               </a:rPr>
-              <a:t>Evidence and original-source drill-down</a:t>
+              <a:t>Evidence and full source record drill-down</a:t>
             </a:r>
           </a:p>
         </p:txBody>
@@ -4080,7 +4155,7 @@
                 <a:ea typeface="Helvetica Neue"/>
                 <a:cs typeface="Helvetica Neue"/>
               </a:rPr>
-              <a:t>Saved brief runs and evidence sets</a:t>
+              <a:t>Saved brief runs and ranked source records</a:t>
             </a:r>
           </a:p>
         </p:txBody>
@@ -4436,7 +4511,7 @@
                 <a:ea typeface="Helvetica Neue"/>
                 <a:cs typeface="Helvetica Neue"/>
               </a:rPr>
-              <a:t>SIMULATED OR ABSENT</a:t>
+              <a:t>DEMO OR NOT BUILT</a:t>
             </a:r>
           </a:p>
         </p:txBody>
@@ -4624,7 +4699,7 @@
                 <a:ea typeface="Helvetica Neue"/>
                 <a:cs typeface="Helvetica Neue"/>
               </a:rPr>
-              <a:t>5 tailored brief templates and 5 generic briefs</a:t>
+              <a:t>5 tailored templates and 5 briefs from one generic rule</a:t>
             </a:r>
           </a:p>
         </p:txBody>
@@ -4812,7 +4887,7 @@
                 <a:ea typeface="Helvetica Neue"/>
                 <a:cs typeface="Helvetica Neue"/>
               </a:rPr>
-              <a:t>Word-hash vectors, not model embeddings</a:t>
+              <a:t>text-embedding-3-large is not active</a:t>
             </a:r>
           </a:p>
         </p:txBody>
@@ -4906,7 +4981,7 @@
                 <a:ea typeface="Helvetica Neue"/>
                 <a:cs typeface="Helvetica Neue"/>
               </a:rPr>
-              <a:t>Rule-based brief text; no external model</a:t>
+              <a:t>gpt-5.6-sol and Responses API are not active</a:t>
             </a:r>
           </a:p>
         </p:txBody>
@@ -5153,7 +5228,7 @@
                 <a:ea typeface="Helvetica Neue"/>
                 <a:cs typeface="Helvetica Neue"/>
               </a:rPr>
-              <a:t>The local OpenAI API key is not used.</a:t>
+              <a:t>The current app sends no OpenAI API request.</a:t>
             </a:r>
           </a:p>
         </p:txBody>
@@ -10215,7 +10290,7 @@
           <p:nvPr/>
         </p:nvPicPr>
         <p:blipFill>
-          <a:blip xmlns:r="http://schemas.openxmlformats.org/officeDocument/2006/relationships" xmlns:a="http://schemas.openxmlformats.org/drawingml/2006/main" r:embed="R82aac3e88b4640c6"/>
+          <a:blip xmlns:r="http://schemas.openxmlformats.org/officeDocument/2006/relationships" xmlns:a="http://schemas.openxmlformats.org/drawingml/2006/main" r:embed="R5c6e5bd4ac444ba7"/>
           <a:stretch xmlns:a="http://schemas.openxmlformats.org/drawingml/2006/main"/>
         </p:blipFill>
         <p:spPr>
@@ -12033,7 +12108,7 @@
         </p:spPr>
         <p:txBody>
           <a:bodyPr xmlns:a="http://schemas.openxmlformats.org/drawingml/2006/main" anchor="t">
-            <a:normAutofit fontScale="94444"/>
+            <a:normAutofit fontScale="100000"/>
           </a:bodyPr>
           <a:lstStyle xmlns:a="http://schemas.openxmlformats.org/drawingml/2006/main"/>
           <a:p xmlns:a="http://schemas.openxmlformats.org/drawingml/2006/main">
@@ -12049,7 +12124,7 @@
               </a:defRPr>
             </a:pPr>
             <a:r>
-              <a:rPr sz="1350" b="0">
+              <a:rPr sz="1275" b="0">
                 <a:solidFill>
                   <a:srgbClr val="667085"/>
                 </a:solidFill>
@@ -12057,7 +12132,7 @@
                 <a:ea typeface="Helvetica Neue"/>
                 <a:cs typeface="Helvetica Neue"/>
               </a:rPr>
-              <a:t>Evidence is prepared before the request. The request path never calls a source system.</a:t>
+              <a:t>The app imports files before a request. A brief reads local PostgreSQL. It calls no source system or external model.</a:t>
             </a:r>
           </a:p>
         </p:txBody>
@@ -12212,7 +12287,7 @@
                 <a:ea typeface="Helvetica Neue"/>
                 <a:cs typeface="Helvetica Neue"/>
               </a:rPr>
-              <a:t>CRM</a:t>
+              <a:t>Static CRM</a:t>
             </a:r>
           </a:p>
           <a:p xmlns:a="http://schemas.openxmlformats.org/drawingml/2006/main">
@@ -12236,7 +12311,7 @@
                 <a:ea typeface="Helvetica Neue"/>
                 <a:cs typeface="Helvetica Neue"/>
               </a:rPr>
-              <a:t>Meetings</a:t>
+              <a:t>Meeting notes</a:t>
             </a:r>
           </a:p>
           <a:p xmlns:a="http://schemas.openxmlformats.org/drawingml/2006/main">
@@ -12284,7 +12359,7 @@
                 <a:ea typeface="Helvetica Neue"/>
                 <a:cs typeface="Helvetica Neue"/>
               </a:rPr>
-              <a:t>News</a:t>
+              <a:t>News records</a:t>
             </a:r>
           </a:p>
           <a:p xmlns:a="http://schemas.openxmlformats.org/drawingml/2006/main">
@@ -12308,7 +12383,7 @@
                 <a:ea typeface="Helvetica Neue"/>
                 <a:cs typeface="Helvetica Neue"/>
               </a:rPr>
-              <a:t>Company filings: future</a:t>
+              <a:t>No filings adapter</a:t>
             </a:r>
           </a:p>
         </p:txBody>
@@ -12463,7 +12538,7 @@
                 <a:ea typeface="Helvetica Neue"/>
                 <a:cs typeface="Helvetica Neue"/>
               </a:rPr>
-              <a:t>File readers in V1</a:t>
+              <a:t>Read each file</a:t>
             </a:r>
           </a:p>
           <a:p xmlns:a="http://schemas.openxmlformats.org/drawingml/2006/main">
@@ -12487,7 +12562,7 @@
                 <a:ea typeface="Helvetica Neue"/>
                 <a:cs typeface="Helvetica Neue"/>
               </a:rPr>
-              <a:t>Validate</a:t>
+              <a:t>Validate record</a:t>
             </a:r>
           </a:p>
           <a:p xmlns:a="http://schemas.openxmlformats.org/drawingml/2006/main">
@@ -12511,7 +12586,7 @@
                 <a:ea typeface="Helvetica Neue"/>
                 <a:cs typeface="Helvetica Neue"/>
               </a:rPr>
-              <a:t>Map company</a:t>
+              <a:t>Check company ID</a:t>
             </a:r>
           </a:p>
           <a:p xmlns:a="http://schemas.openxmlformats.org/drawingml/2006/main">
@@ -12535,7 +12610,7 @@
                 <a:ea typeface="Helvetica Neue"/>
                 <a:cs typeface="Helvetica Neue"/>
               </a:rPr>
-              <a:t>Keep original</a:t>
+              <a:t>Keep source record</a:t>
             </a:r>
           </a:p>
           <a:p xmlns:a="http://schemas.openxmlformats.org/drawingml/2006/main">
@@ -12559,7 +12634,7 @@
                 <a:ea typeface="Helvetica Neue"/>
                 <a:cs typeface="Helvetica Neue"/>
               </a:rPr>
-              <a:t>Checksum + chunk</a:t>
+              <a:t>Checksum and chunk</a:t>
             </a:r>
           </a:p>
         </p:txBody>
@@ -12690,7 +12765,7 @@
         </p:spPr>
         <p:txBody>
           <a:bodyPr xmlns:a="http://schemas.openxmlformats.org/drawingml/2006/main" anchor="t">
-            <a:normAutofit fontScale="100000"/>
+            <a:normAutofit fontScale="94180"/>
           </a:bodyPr>
           <a:lstStyle xmlns:a="http://schemas.openxmlformats.org/drawingml/2006/main"/>
           <a:p xmlns:a="http://schemas.openxmlformats.org/drawingml/2006/main">
@@ -12738,7 +12813,7 @@
                 <a:ea typeface="Helvetica Neue"/>
                 <a:cs typeface="Helvetica Neue"/>
               </a:rPr>
-              <a:t>Companies, facts, dates</a:t>
+              <a:t>Companies and source records</a:t>
             </a:r>
           </a:p>
           <a:p xmlns:a="http://schemas.openxmlformats.org/drawingml/2006/main">
@@ -12762,7 +12837,7 @@
                 <a:ea typeface="Helvetica Neue"/>
                 <a:cs typeface="Helvetica Neue"/>
               </a:rPr>
-              <a:t>Originals, chunks, vectors</a:t>
+              <a:t>Facts and dates</a:t>
             </a:r>
           </a:p>
           <a:p xmlns:a="http://schemas.openxmlformats.org/drawingml/2006/main">
@@ -12786,7 +12861,31 @@
                 <a:ea typeface="Helvetica Neue"/>
                 <a:cs typeface="Helvetica Neue"/>
               </a:rPr>
-              <a:t>Saved runs and evidence</a:t>
+              <a:t>Chunks and word-hash vectors</a:t>
+            </a:r>
+          </a:p>
+          <a:p xmlns:a="http://schemas.openxmlformats.org/drawingml/2006/main">
+            <a:pPr algn="l">
+              <a:buNone/>
+              <a:defRPr sz="1125" b="0">
+                <a:solidFill>
+                  <a:srgbClr val="667085"/>
+                </a:solidFill>
+                <a:latin typeface="Helvetica Neue"/>
+                <a:ea typeface="Helvetica Neue"/>
+                <a:cs typeface="Helvetica Neue"/>
+              </a:defRPr>
+            </a:pPr>
+            <a:r>
+              <a:rPr sz="1050" b="0">
+                <a:solidFill>
+                  <a:srgbClr val="344054"/>
+                </a:solidFill>
+                <a:latin typeface="Helvetica Neue"/>
+                <a:ea typeface="Helvetica Neue"/>
+                <a:cs typeface="Helvetica Neue"/>
+              </a:rPr>
+              <a:t>Brief runs and evidence</a:t>
             </a:r>
           </a:p>
         </p:txBody>
@@ -12941,7 +13040,7 @@
                 <a:ea typeface="Helvetica Neue"/>
                 <a:cs typeface="Helvetica Neue"/>
               </a:rPr>
-              <a:t>Hard company filter</a:t>
+              <a:t>Company ID filter in SQL</a:t>
             </a:r>
           </a:p>
           <a:p xmlns:a="http://schemas.openxmlformats.org/drawingml/2006/main">
@@ -12965,7 +13064,7 @@
                 <a:ea typeface="Helvetica Neue"/>
                 <a:cs typeface="Helvetica Neue"/>
               </a:rPr>
-              <a:t>Full-text and word-hash search</a:t>
+              <a:t>Full-text and local vector search</a:t>
             </a:r>
           </a:p>
           <a:p xmlns:a="http://schemas.openxmlformats.org/drawingml/2006/main">
@@ -12989,7 +13088,31 @@
                 <a:ea typeface="Helvetica Neue"/>
                 <a:cs typeface="Helvetica Neue"/>
               </a:rPr>
-              <a:t>Initial rank by match, quality, and recency</a:t>
+              <a:t>Rank up to 30 source records</a:t>
+            </a:r>
+          </a:p>
+          <a:p xmlns:a="http://schemas.openxmlformats.org/drawingml/2006/main">
+            <a:pPr algn="l">
+              <a:buNone/>
+              <a:defRPr sz="1125" b="0">
+                <a:solidFill>
+                  <a:srgbClr val="667085"/>
+                </a:solidFill>
+                <a:latin typeface="Helvetica Neue"/>
+                <a:ea typeface="Helvetica Neue"/>
+                <a:cs typeface="Helvetica Neue"/>
+              </a:defRPr>
+            </a:pPr>
+            <a:r>
+              <a:rPr sz="1050" b="0">
+                <a:solidFill>
+                  <a:srgbClr val="344054"/>
+                </a:solidFill>
+                <a:latin typeface="Helvetica Neue"/>
+                <a:ea typeface="Helvetica Neue"/>
+                <a:cs typeface="Helvetica Neue"/>
+              </a:rPr>
+              <a:t>Use quality and recency</a:t>
             </a:r>
           </a:p>
         </p:txBody>
@@ -13144,7 +13267,7 @@
                 <a:ea typeface="Helvetica Neue"/>
                 <a:cs typeface="Helvetica Neue"/>
               </a:rPr>
-              <a:t>Portfolio and pipeline</a:t>
+              <a:t>Portfolio or pipeline</a:t>
             </a:r>
           </a:p>
           <a:p xmlns:a="http://schemas.openxmlformats.org/drawingml/2006/main">
@@ -13192,7 +13315,7 @@
                 <a:ea typeface="Helvetica Neue"/>
                 <a:cs typeface="Helvetica Neue"/>
               </a:rPr>
-              <a:t>Open evidence and source</a:t>
+              <a:t>Open evidence and full source</a:t>
             </a:r>
           </a:p>
           <a:p xmlns:a="http://schemas.openxmlformats.org/drawingml/2006/main">
@@ -13216,14 +13339,14 @@
                 <a:ea typeface="Helvetica Neue"/>
                 <a:cs typeface="Helvetica Neue"/>
               </a:rPr>
-              <a:t>Feedback</a:t>
+              <a:t>Send feedback</a:t>
             </a:r>
           </a:p>
         </p:txBody>
       </p:sp>
       <p:cxnSp>
         <p:nvCxnSpPr>
-          <p:cNvPr id="103" name=""/>
+          <p:cNvPr id="175" name=""/>
           <p:cNvCxnSpPr>
             <a:stCxn xmlns:a="http://schemas.openxmlformats.org/drawingml/2006/main" id="5" idx="3"/>
             <a:endCxn xmlns:a="http://schemas.openxmlformats.org/drawingml/2006/main" id="8" idx="1"/>
@@ -13249,7 +13372,7 @@
       </p:cxnSp>
       <p:cxnSp>
         <p:nvCxnSpPr>
-          <p:cNvPr id="104" name=""/>
+          <p:cNvPr id="176" name=""/>
           <p:cNvCxnSpPr>
             <a:stCxn xmlns:a="http://schemas.openxmlformats.org/drawingml/2006/main" id="8" idx="3"/>
             <a:endCxn xmlns:a="http://schemas.openxmlformats.org/drawingml/2006/main" id="11" idx="1"/>
@@ -13275,7 +13398,7 @@
       </p:cxnSp>
       <p:cxnSp>
         <p:nvCxnSpPr>
-          <p:cNvPr id="105" name=""/>
+          <p:cNvPr id="177" name=""/>
           <p:cNvCxnSpPr>
             <a:stCxn xmlns:a="http://schemas.openxmlformats.org/drawingml/2006/main" id="11" idx="3"/>
             <a:endCxn xmlns:a="http://schemas.openxmlformats.org/drawingml/2006/main" id="14" idx="1"/>
@@ -13301,7 +13424,7 @@
       </p:cxnSp>
       <p:cxnSp>
         <p:nvCxnSpPr>
-          <p:cNvPr id="106" name=""/>
+          <p:cNvPr id="178" name=""/>
           <p:cNvCxnSpPr>
             <a:stCxn xmlns:a="http://schemas.openxmlformats.org/drawingml/2006/main" id="14" idx="3"/>
             <a:endCxn xmlns:a="http://schemas.openxmlformats.org/drawingml/2006/main" id="17" idx="1"/>
@@ -13475,7 +13598,7 @@
                 <a:ea typeface="Helvetica Neue"/>
                 <a:cs typeface="Helvetica Neue"/>
               </a:rPr>
-              <a:t>Source integrity · company filter before rank · source references · saved evidence · feedback</a:t>
+              <a:t>Checksums · company filter before rank · source IDs · saved source ranks · feedback</a:t>
             </a:r>
           </a:p>
         </p:txBody>
@@ -13526,7 +13649,7 @@
               </a:defRPr>
             </a:pPr>
             <a:r>
-              <a:rPr sz="1050" b="1">
+              <a:rPr sz="975" b="1">
                 <a:solidFill>
                   <a:srgbClr val="315F9F"/>
                 </a:solidFill>
@@ -13534,7 +13657,7 @@
                 <a:ea typeface="Helvetica Neue"/>
                 <a:cs typeface="Helvetica Neue"/>
               </a:rPr>
-              <a:t>PRODUCTION ADDS    Authenticated connectors · source access rules · schedules · reconciliation · approved embeddings and model service</a:t>
+              <a:t>PRODUCTION TARGET    Connectors · access rules · schedules · reconciliation · text-embedding-3-large · gpt-5.6-sol through Responses API</a:t>
             </a:r>
           </a:p>
         </p:txBody>
@@ -13569,6 +13692,7 @@
           <a:lstStyle xmlns:a="http://schemas.openxmlformats.org/drawingml/2006/main"/>
           <a:p xmlns:a="http://schemas.openxmlformats.org/drawingml/2006/main">
             <a:pPr algn="l">
+              <a:buNone/>
               <a:defRPr sz="1050" b="1">
                 <a:solidFill>
                   <a:srgbClr val="315F9F"/>
@@ -13587,7 +13711,7 @@
                 <a:ea typeface="Helvetica Neue"/>
                 <a:cs typeface="Helvetica Neue"/>
               </a:rPr>
-              <a:t>1  PREPARE EVIDENCE · BEFORE REQUEST</a:t>
+              <a:t>1  CURRENT IMPORT · BEFORE REQUEST</a:t>
             </a:r>
           </a:p>
         </p:txBody>
@@ -13622,6 +13746,7 @@
           <a:lstStyle xmlns:a="http://schemas.openxmlformats.org/drawingml/2006/main"/>
           <a:p xmlns:a="http://schemas.openxmlformats.org/drawingml/2006/main">
             <a:pPr algn="l">
+              <a:buNone/>
               <a:defRPr sz="1050" b="1">
                 <a:solidFill>
                   <a:srgbClr val="315F9F"/>
@@ -13640,7 +13765,7 @@
                 <a:ea typeface="Helvetica Neue"/>
                 <a:cs typeface="Helvetica Neue"/>
               </a:rPr>
-              <a:t>2  BUILD COMPANY BRIEF · ON REQUEST</a:t>
+              <a:t>2  CURRENT BRIEF · ON REQUEST</a:t>
             </a:r>
           </a:p>
         </p:txBody>
@@ -13772,6 +13897,7 @@
           <a:lstStyle xmlns:a="http://schemas.openxmlformats.org/drawingml/2006/main"/>
           <a:p xmlns:a="http://schemas.openxmlformats.org/drawingml/2006/main">
             <a:pPr algn="l">
+              <a:buNone/>
               <a:defRPr sz="1350" b="1">
                 <a:solidFill>
                   <a:srgbClr val="344054"/>
@@ -13825,6 +13951,7 @@
           <a:lstStyle xmlns:a="http://schemas.openxmlformats.org/drawingml/2006/main"/>
           <a:p xmlns:a="http://schemas.openxmlformats.org/drawingml/2006/main">
             <a:pPr algn="l">
+              <a:buNone/>
               <a:defRPr sz="1050" b="0">
                 <a:solidFill>
                   <a:srgbClr val="344054"/>
@@ -13843,11 +13970,12 @@
                 <a:ea typeface="Helvetica Neue"/>
                 <a:cs typeface="Helvetica Neue"/>
               </a:rPr>
-              <a:t>Key facts</a:t>
-            </a:r>
-          </a:p>
-          <a:p xmlns:a="http://schemas.openxmlformats.org/drawingml/2006/main">
-            <a:pPr algn="l">
+              <a:t>Fixed brief rules</a:t>
+            </a:r>
+          </a:p>
+          <a:p xmlns:a="http://schemas.openxmlformats.org/drawingml/2006/main">
+            <a:pPr algn="l">
+              <a:buNone/>
               <a:defRPr sz="1050" b="0">
                 <a:solidFill>
                   <a:srgbClr val="344054"/>
@@ -13866,11 +13994,12 @@
                 <a:ea typeface="Helvetica Neue"/>
                 <a:cs typeface="Helvetica Neue"/>
               </a:rPr>
-              <a:t>Risks</a:t>
-            </a:r>
-          </a:p>
-          <a:p xmlns:a="http://schemas.openxmlformats.org/drawingml/2006/main">
-            <a:pPr algn="l">
+              <a:t>No model call</a:t>
+            </a:r>
+          </a:p>
+          <a:p xmlns:a="http://schemas.openxmlformats.org/drawingml/2006/main">
+            <a:pPr algn="l">
+              <a:buNone/>
               <a:defRPr sz="1050" b="0">
                 <a:solidFill>
                   <a:srgbClr val="344054"/>
@@ -13889,11 +14018,12 @@
                 <a:ea typeface="Helvetica Neue"/>
                 <a:cs typeface="Helvetica Neue"/>
               </a:rPr>
-              <a:t>Questions</a:t>
-            </a:r>
-          </a:p>
-          <a:p xmlns:a="http://schemas.openxmlformats.org/drawingml/2006/main">
-            <a:pPr algn="l">
+              <a:t/>
+            </a:r>
+          </a:p>
+          <a:p xmlns:a="http://schemas.openxmlformats.org/drawingml/2006/main">
+            <a:pPr algn="l">
+              <a:buNone/>
               <a:defRPr sz="1050" b="0">
                 <a:solidFill>
                   <a:srgbClr val="344054"/>
@@ -13912,11 +14042,12 @@
                 <a:ea typeface="Helvetica Neue"/>
                 <a:cs typeface="Helvetica Neue"/>
               </a:rPr>
-              <a:t>Check source IDs</a:t>
-            </a:r>
-          </a:p>
-          <a:p xmlns:a="http://schemas.openxmlformats.org/drawingml/2006/main">
-            <a:pPr algn="l">
+              <a:t>Check source IDs and company</a:t>
+            </a:r>
+          </a:p>
+          <a:p xmlns:a="http://schemas.openxmlformats.org/drawingml/2006/main">
+            <a:pPr algn="l">
+              <a:buNone/>
               <a:defRPr sz="1050" b="0">
                 <a:solidFill>
                   <a:srgbClr val="344054"/>
@@ -13935,37 +14066,14 @@
                 <a:ea typeface="Helvetica Neue"/>
                 <a:cs typeface="Helvetica Neue"/>
               </a:rPr>
-              <a:t>Check company isolation</a:t>
-            </a:r>
-          </a:p>
-          <a:p xmlns:a="http://schemas.openxmlformats.org/drawingml/2006/main">
-            <a:pPr algn="l">
-              <a:defRPr sz="1050" b="0">
-                <a:solidFill>
-                  <a:srgbClr val="344054"/>
-                </a:solidFill>
-                <a:latin typeface="Helvetica Neue"/>
-                <a:ea typeface="Helvetica Neue"/>
-                <a:cs typeface="Helvetica Neue"/>
-              </a:defRPr>
-            </a:pPr>
-            <a:r>
-              <a:rPr sz="1050" b="0">
-                <a:solidFill>
-                  <a:srgbClr val="344054"/>
-                </a:solidFill>
-                <a:latin typeface="Helvetica Neue"/>
-                <a:ea typeface="Helvetica Neue"/>
-                <a:cs typeface="Helvetica Neue"/>
-              </a:rPr>
-              <a:t>Save evidence set</a:t>
+              <a:t>Save brief and source ranks</a:t>
             </a:r>
           </a:p>
         </p:txBody>
       </p:sp>
       <p:cxnSp>
         <p:nvCxnSpPr>
-          <p:cNvPr id="118" name=""/>
+          <p:cNvPr id="190" name=""/>
           <p:cNvCxnSpPr>
             <a:stCxn xmlns:a="http://schemas.openxmlformats.org/drawingml/2006/main" id="14" idx="3"/>
             <a:endCxn xmlns:a="http://schemas.openxmlformats.org/drawingml/2006/main" id="78" idx="1"/>
@@ -13991,7 +14099,7 @@
       </p:cxnSp>
       <p:cxnSp>
         <p:nvCxnSpPr>
-          <p:cNvPr id="119" name=""/>
+          <p:cNvPr id="191" name=""/>
           <p:cNvCxnSpPr>
             <a:stCxn xmlns:a="http://schemas.openxmlformats.org/drawingml/2006/main" id="78" idx="3"/>
             <a:endCxn xmlns:a="http://schemas.openxmlformats.org/drawingml/2006/main" id="17" idx="1"/>
@@ -16306,7 +16414,7 @@
               </a:defRPr>
             </a:pPr>
             <a:r>
-              <a:rPr sz="3000" b="1">
+              <a:rPr sz="2700" b="1">
                 <a:solidFill>
                   <a:srgbClr val="101828"/>
                 </a:solidFill>
@@ -16314,7 +16422,7 @@
                 <a:ea typeface="Helvetica Neue"/>
                 <a:cs typeface="Helvetica Neue"/>
               </a:rPr>
-              <a:t>How does retrieval become a brief?</a:t>
+              <a:t>How does the current app retrieve and write the brief?</a:t>
             </a:r>
           </a:p>
         </p:txBody>
@@ -17139,7 +17247,7 @@
                 <a:ea typeface="Helvetica Neue"/>
                 <a:cs typeface="Helvetica Neue"/>
               </a:rPr>
-              <a:t>Full-text search and word-hash similarity</a:t>
+              <a:t>PostgreSQL full-text and word-hash similarity</a:t>
             </a:r>
           </a:p>
         </p:txBody>
@@ -17292,7 +17400,7 @@
                 <a:ea typeface="Helvetica Neue"/>
                 <a:cs typeface="Helvetica Neue"/>
               </a:rPr>
-              <a:t>Rule-based Key facts, Risks, and Questions</a:t>
+              <a:t>Five tailored templates or one generic rule. No model call.</a:t>
             </a:r>
           </a:p>
         </p:txBody>
@@ -17445,7 +17553,7 @@
                 <a:ea typeface="Helvetica Neue"/>
                 <a:cs typeface="Helvetica Neue"/>
               </a:rPr>
-              <a:t>Valid source IDs</a:t>
+              <a:t>Check source IDs</a:t>
             </a:r>
           </a:p>
           <a:p xmlns:a="http://schemas.openxmlformats.org/drawingml/2006/main">
@@ -17469,7 +17577,7 @@
                 <a:ea typeface="Helvetica Neue"/>
                 <a:cs typeface="Helvetica Neue"/>
               </a:rPr>
-              <a:t>Company isolation</a:t>
+              <a:t>Check company isolation</a:t>
             </a:r>
           </a:p>
           <a:p xmlns:a="http://schemas.openxmlformats.org/drawingml/2006/main">
@@ -17493,14 +17601,14 @@
                 <a:ea typeface="Helvetica Neue"/>
                 <a:cs typeface="Helvetica Neue"/>
               </a:rPr>
-              <a:t>Saved evidence set</a:t>
+              <a:t>Save brief and source ranks</a:t>
             </a:r>
           </a:p>
         </p:txBody>
       </p:sp>
       <p:cxnSp>
         <p:nvCxnSpPr>
-          <p:cNvPr id="105" name=""/>
+          <p:cNvPr id="157" name=""/>
           <p:cNvCxnSpPr>
             <a:stCxn xmlns:a="http://schemas.openxmlformats.org/drawingml/2006/main" id="16" idx="3"/>
             <a:endCxn xmlns:a="http://schemas.openxmlformats.org/drawingml/2006/main" id="19" idx="1"/>
@@ -17526,7 +17634,7 @@
       </p:cxnSp>
       <p:cxnSp>
         <p:nvCxnSpPr>
-          <p:cNvPr id="106" name=""/>
+          <p:cNvPr id="158" name=""/>
           <p:cNvCxnSpPr>
             <a:stCxn xmlns:a="http://schemas.openxmlformats.org/drawingml/2006/main" id="19" idx="3"/>
             <a:endCxn xmlns:a="http://schemas.openxmlformats.org/drawingml/2006/main" id="22" idx="1"/>
@@ -17604,7 +17712,7 @@
                 <a:ea typeface="Helvetica Neue"/>
                 <a:cs typeface="Helvetica Neue"/>
               </a:rPr>
-              <a:t>The brief can show: Confirmed · Values differ · Not confirmed · Update needed</a:t>
+              <a:t>CURRENT V1: fixed query, initial weights, fixed date, and no external model.</a:t>
             </a:r>
           </a:p>
         </p:txBody>
@@ -17663,7 +17771,7 @@
                 <a:ea typeface="Helvetica Neue"/>
                 <a:cs typeface="Helvetica Neue"/>
               </a:rPr>
-              <a:t>The current path uses initial weights and rule-based text. It does not use an external model.</a:t>
+              <a:t>PRODUCTION TARGET: text-embedding-3-large retrieval; gpt-5.6-sol brief through Responses API.</a:t>
             </a:r>
           </a:p>
         </p:txBody>
@@ -17743,7 +17851,7 @@
               </a:defRPr>
             </a:pPr>
             <a:r>
-              <a:rPr sz="3000" b="1">
+              <a:rPr sz="2550" b="1">
                 <a:solidFill>
                   <a:srgbClr val="101828"/>
                 </a:solidFill>
@@ -17751,7 +17859,7 @@
                 <a:ea typeface="Helvetica Neue"/>
                 <a:cs typeface="Helvetica Neue"/>
               </a:rPr>
-              <a:t>Why did I choose this stack?</a:t>
+              <a:t>Which stack runs now, and which model is the quality-first target?</a:t>
             </a:r>
           </a:p>
         </p:txBody>
@@ -17873,63 +17981,6 @@
           </a:ln>
         </p:spPr>
         <p:txBody>
-          <a:bodyPr xmlns:a="http://schemas.openxmlformats.org/drawingml/2006/main" anchor="t"/>
-          <a:lstStyle xmlns:a="http://schemas.openxmlformats.org/drawingml/2006/main"/>
-          <a:p xmlns:a="http://schemas.openxmlformats.org/drawingml/2006/main">
-            <a:pPr algn="l">
-              <a:buNone/>
-              <a:defRPr sz="1050" b="1">
-                <a:solidFill>
-                  <a:srgbClr val="315F9F"/>
-                </a:solidFill>
-                <a:latin typeface="Helvetica Neue"/>
-                <a:ea typeface="Helvetica Neue"/>
-                <a:cs typeface="Helvetica Neue"/>
-              </a:defRPr>
-            </a:pPr>
-            <a:r>
-              <a:rPr sz="1050" b="1">
-                <a:solidFill>
-                  <a:srgbClr val="315F9F"/>
-                </a:solidFill>
-                <a:latin typeface="Helvetica Neue"/>
-                <a:ea typeface="Helvetica Neue"/>
-                <a:cs typeface="Helvetica Neue"/>
-              </a:rPr>
-              <a:t>CHOICE</a:t>
-            </a:r>
-          </a:p>
-        </p:txBody>
-      </p:sp>
-      <p:sp>
-        <p:nvSpPr>
-          <p:cNvPr id="5" name="">
-            <a:extLst xmlns:a="http://schemas.openxmlformats.org/drawingml/2006/main">
-              <a:ext uri="{FF2B5EF4-FFF2-40B4-BE49-F238E27FC236}">
-                <a16:creationId xmlns:a16="http://schemas.microsoft.com/office/drawing/2014/main" id="{7F4CD62E-8C04-4F26-9606-CF238E6B5EFC}"/>
-              </a:ext>
-            </a:extLst>
-          </p:cNvPr>
-          <p:cNvSpPr>
-            <a:spLocks xmlns:a="http://schemas.openxmlformats.org/drawingml/2006/main" noGrp="1"/>
-          </p:cNvSpPr>
-          <p:nvPr/>
-        </p:nvSpPr>
-        <p:spPr>
-          <a:xfrm xmlns:a="http://schemas.openxmlformats.org/drawingml/2006/main">
-            <a:off x="3333750" y="1466850"/>
-            <a:ext cx="3238500" cy="209550"/>
-          </a:xfrm>
-          <a:prstGeom xmlns:a="http://schemas.openxmlformats.org/drawingml/2006/main" prst="rect">
-            <a:avLst/>
-          </a:prstGeom>
-          <a:noFill xmlns:a="http://schemas.openxmlformats.org/drawingml/2006/main"/>
-          <a:ln xmlns:a="http://schemas.openxmlformats.org/drawingml/2006/main" w="0">
-            <a:noFill/>
-            <a:prstDash val="solid"/>
-          </a:ln>
-        </p:spPr>
-        <p:txBody>
           <a:bodyPr xmlns:a="http://schemas.openxmlformats.org/drawingml/2006/main" anchor="t">
             <a:normAutofit fontScale="73809"/>
           </a:bodyPr>
@@ -17955,29 +18006,29 @@
                 <a:ea typeface="Helvetica Neue"/>
                 <a:cs typeface="Helvetica Neue"/>
               </a:rPr>
-              <a:t>REASON</a:t>
-            </a:r>
-          </a:p>
-        </p:txBody>
-      </p:sp>
-      <p:sp>
-        <p:nvSpPr>
-          <p:cNvPr id="6" name="">
-            <a:extLst xmlns:a="http://schemas.openxmlformats.org/drawingml/2006/main">
-              <a:ext uri="{FF2B5EF4-FFF2-40B4-BE49-F238E27FC236}">
-                <a16:creationId xmlns:a16="http://schemas.microsoft.com/office/drawing/2014/main" id="{B98364E2-4CA2-464C-B7ED-DF6E422AB2EF}"/>
-              </a:ext>
-            </a:extLst>
-          </p:cNvPr>
-          <p:cNvSpPr>
-            <a:spLocks xmlns:a="http://schemas.openxmlformats.org/drawingml/2006/main" noGrp="1"/>
-          </p:cNvSpPr>
-          <p:nvPr/>
-        </p:nvSpPr>
-        <p:spPr>
-          <a:xfrm xmlns:a="http://schemas.openxmlformats.org/drawingml/2006/main">
-            <a:off x="7067550" y="1466850"/>
-            <a:ext cx="4248150" cy="209550"/>
+              <a:t>CURRENT CHOICE</a:t>
+            </a:r>
+          </a:p>
+        </p:txBody>
+      </p:sp>
+      <p:sp>
+        <p:nvSpPr>
+          <p:cNvPr id="5" name="">
+            <a:extLst xmlns:a="http://schemas.openxmlformats.org/drawingml/2006/main">
+              <a:ext uri="{FF2B5EF4-FFF2-40B4-BE49-F238E27FC236}">
+                <a16:creationId xmlns:a16="http://schemas.microsoft.com/office/drawing/2014/main" id="{7F4CD62E-8C04-4F26-9606-CF238E6B5EFC}"/>
+              </a:ext>
+            </a:extLst>
+          </p:cNvPr>
+          <p:cNvSpPr>
+            <a:spLocks xmlns:a="http://schemas.openxmlformats.org/drawingml/2006/main" noGrp="1"/>
+          </p:cNvSpPr>
+          <p:nvPr/>
+        </p:nvSpPr>
+        <p:spPr>
+          <a:xfrm xmlns:a="http://schemas.openxmlformats.org/drawingml/2006/main">
+            <a:off x="3333750" y="1466850"/>
+            <a:ext cx="3238500" cy="209550"/>
           </a:xfrm>
           <a:prstGeom xmlns:a="http://schemas.openxmlformats.org/drawingml/2006/main" prst="rect">
             <a:avLst/>
@@ -18014,7 +18065,66 @@
                 <a:ea typeface="Helvetica Neue"/>
                 <a:cs typeface="Helvetica Neue"/>
               </a:rPr>
-              <a:t>TRADE-OFF</a:t>
+              <a:t>WHY IT FITS V1</a:t>
+            </a:r>
+          </a:p>
+        </p:txBody>
+      </p:sp>
+      <p:sp>
+        <p:nvSpPr>
+          <p:cNvPr id="6" name="">
+            <a:extLst xmlns:a="http://schemas.openxmlformats.org/drawingml/2006/main">
+              <a:ext uri="{FF2B5EF4-FFF2-40B4-BE49-F238E27FC236}">
+                <a16:creationId xmlns:a16="http://schemas.microsoft.com/office/drawing/2014/main" id="{B98364E2-4CA2-464C-B7ED-DF6E422AB2EF}"/>
+              </a:ext>
+            </a:extLst>
+          </p:cNvPr>
+          <p:cNvSpPr>
+            <a:spLocks xmlns:a="http://schemas.openxmlformats.org/drawingml/2006/main" noGrp="1"/>
+          </p:cNvSpPr>
+          <p:nvPr/>
+        </p:nvSpPr>
+        <p:spPr>
+          <a:xfrm xmlns:a="http://schemas.openxmlformats.org/drawingml/2006/main">
+            <a:off x="7067550" y="1466850"/>
+            <a:ext cx="4248150" cy="209550"/>
+          </a:xfrm>
+          <a:prstGeom xmlns:a="http://schemas.openxmlformats.org/drawingml/2006/main" prst="rect">
+            <a:avLst/>
+          </a:prstGeom>
+          <a:noFill xmlns:a="http://schemas.openxmlformats.org/drawingml/2006/main"/>
+          <a:ln xmlns:a="http://schemas.openxmlformats.org/drawingml/2006/main" w="0">
+            <a:noFill/>
+            <a:prstDash val="solid"/>
+          </a:ln>
+        </p:spPr>
+        <p:txBody>
+          <a:bodyPr xmlns:a="http://schemas.openxmlformats.org/drawingml/2006/main" anchor="t">
+            <a:normAutofit fontScale="73809"/>
+          </a:bodyPr>
+          <a:lstStyle xmlns:a="http://schemas.openxmlformats.org/drawingml/2006/main"/>
+          <a:p xmlns:a="http://schemas.openxmlformats.org/drawingml/2006/main">
+            <a:pPr algn="l">
+              <a:buNone/>
+              <a:defRPr sz="1050" b="1">
+                <a:solidFill>
+                  <a:srgbClr val="315F9F"/>
+                </a:solidFill>
+                <a:latin typeface="Helvetica Neue"/>
+                <a:ea typeface="Helvetica Neue"/>
+                <a:cs typeface="Helvetica Neue"/>
+              </a:defRPr>
+            </a:pPr>
+            <a:r>
+              <a:rPr sz="1050" b="1">
+                <a:solidFill>
+                  <a:srgbClr val="315F9F"/>
+                </a:solidFill>
+                <a:latin typeface="Helvetica Neue"/>
+                <a:ea typeface="Helvetica Neue"/>
+                <a:cs typeface="Helvetica Neue"/>
+              </a:rPr>
+              <a:t>PRODUCTION TARGET</a:t>
             </a:r>
           </a:p>
         </p:txBody>
@@ -18226,7 +18336,7 @@
                 <a:ea typeface="Helvetica Neue"/>
                 <a:cs typeface="Helvetica Neue"/>
               </a:rPr>
-              <a:t>Service separation is limited until scale or ownership requires it.</a:t>
+              <a:t>Keep one service until scale or ownership requires a split.</a:t>
             </a:r>
           </a:p>
         </p:txBody>
@@ -18438,7 +18548,7 @@
                 <a:ea typeface="Helvetica Neue"/>
                 <a:cs typeface="Helvetica Neue"/>
               </a:rPr>
-              <a:t>Exact search has not been tested on the full 250-company scope.</a:t>
+              <a:t>Test retrieval and response time on the 250-company scope.</a:t>
             </a:r>
           </a:p>
         </p:txBody>
@@ -18650,7 +18760,7 @@
                 <a:ea typeface="Helvetica Neue"/>
                 <a:cs typeface="Helvetica Neue"/>
               </a:rPr>
-              <a:t>There is no live freshness, access enforcement, or managed operation.</a:t>
+              <a:t>Add managed connectors, access rules, schedules, and reconciliation.</a:t>
             </a:r>
           </a:p>
         </p:txBody>
@@ -18744,7 +18854,7 @@
                 <a:ea typeface="Helvetica Neue"/>
                 <a:cs typeface="Helvetica Neue"/>
               </a:rPr>
-              <a:t>Word-hash vectors and rule-based briefs</a:t>
+              <a:t>Word-hash vectors and fixed brief rules</a:t>
             </a:r>
           </a:p>
         </p:txBody>
@@ -18803,7 +18913,7 @@
                 <a:ea typeface="Helvetica Neue"/>
                 <a:cs typeface="Helvetica Neue"/>
               </a:rPr>
-              <a:t>The result is repeatable and easy to inspect and test.</a:t>
+              <a:t>The app calls no external model. Results are repeatable and easy to test.</a:t>
             </a:r>
           </a:p>
         </p:txBody>
@@ -18862,7 +18972,7 @@
                 <a:ea typeface="Helvetica Neue"/>
                 <a:cs typeface="Helvetica Neue"/>
               </a:rPr>
-              <a:t>Language and semantic quality are limited. No source data goes to an external model.</a:t>
+              <a:t>Quality-first target: text-embedding-3-large and gpt-5.6-sol through Responses API.</a:t>
             </a:r>
           </a:p>
         </p:txBody>

</xml_diff>

<commit_message>
Use OpenAI embeddings for retrieval
</commit_message>
<xml_diff>
--- a/docs/AVIC-Portfolio-Intelligence-Brief.pptx
+++ b/docs/AVIC-Portfolio-Intelligence-Brief.pptx
@@ -2,25 +2,25 @@
 <file path=ppt/presentation.xml><?xml version="1.0" encoding="utf-8"?>
 <p:presentation xmlns:p="http://schemas.openxmlformats.org/presentationml/2006/main">
   <p:sldMasterIdLst>
-    <p:sldMasterId xmlns:r="http://schemas.openxmlformats.org/officeDocument/2006/relationships" id="2147483648" r:id="R64585f2ff5cf4f87"/>
+    <p:sldMasterId xmlns:r="http://schemas.openxmlformats.org/officeDocument/2006/relationships" id="2147483648" r:id="Rd02e71a8567d4297"/>
   </p:sldMasterIdLst>
   <p:notesMasterIdLst>
-    <p:notesMasterId xmlns:r="http://schemas.openxmlformats.org/officeDocument/2006/relationships" r:id="R6fa6ff1ebcc8479b"/>
+    <p:notesMasterId xmlns:r="http://schemas.openxmlformats.org/officeDocument/2006/relationships" r:id="R3d3a98c7d5a44b21"/>
   </p:notesMasterIdLst>
   <p:sldIdLst>
-    <p:sldId xmlns:r="http://schemas.openxmlformats.org/officeDocument/2006/relationships" id="256" r:id="R9caf27d6e933410a"/>
-    <p:sldId xmlns:r="http://schemas.openxmlformats.org/officeDocument/2006/relationships" id="257" r:id="Rb526ee678f874284"/>
-    <p:sldId xmlns:r="http://schemas.openxmlformats.org/officeDocument/2006/relationships" id="258" r:id="R0893ad1fc4de42bd"/>
-    <p:sldId xmlns:r="http://schemas.openxmlformats.org/officeDocument/2006/relationships" id="259" r:id="R8832c422342948d5"/>
-    <p:sldId xmlns:r="http://schemas.openxmlformats.org/officeDocument/2006/relationships" id="260" r:id="Rfc7c33ba8cf14241"/>
-    <p:sldId xmlns:r="http://schemas.openxmlformats.org/officeDocument/2006/relationships" id="261" r:id="R97ffcdd3528749f6"/>
-    <p:sldId xmlns:r="http://schemas.openxmlformats.org/officeDocument/2006/relationships" id="262" r:id="R92ede51ca20a4b85"/>
-    <p:sldId xmlns:r="http://schemas.openxmlformats.org/officeDocument/2006/relationships" id="263" r:id="Rc5fee69536464d43"/>
-    <p:sldId xmlns:r="http://schemas.openxmlformats.org/officeDocument/2006/relationships" id="264" r:id="R724800fe55594ed6"/>
-    <p:sldId xmlns:r="http://schemas.openxmlformats.org/officeDocument/2006/relationships" id="265" r:id="R30d104b9e8224fc7"/>
-    <p:sldId xmlns:r="http://schemas.openxmlformats.org/officeDocument/2006/relationships" id="266" r:id="R81da1baac9ef4b05"/>
-    <p:sldId xmlns:r="http://schemas.openxmlformats.org/officeDocument/2006/relationships" id="267" r:id="R007c9af60f3d4bbf"/>
-    <p:sldId xmlns:r="http://schemas.openxmlformats.org/officeDocument/2006/relationships" id="268" r:id="R82a2f23a29dc449a"/>
+    <p:sldId xmlns:r="http://schemas.openxmlformats.org/officeDocument/2006/relationships" id="256" r:id="R04a49e85fbbc43c5"/>
+    <p:sldId xmlns:r="http://schemas.openxmlformats.org/officeDocument/2006/relationships" id="257" r:id="R2ead53493d8d4331"/>
+    <p:sldId xmlns:r="http://schemas.openxmlformats.org/officeDocument/2006/relationships" id="258" r:id="R326f5a2c063849f7"/>
+    <p:sldId xmlns:r="http://schemas.openxmlformats.org/officeDocument/2006/relationships" id="259" r:id="R013bb9e948344376"/>
+    <p:sldId xmlns:r="http://schemas.openxmlformats.org/officeDocument/2006/relationships" id="260" r:id="R032ef100e65940c5"/>
+    <p:sldId xmlns:r="http://schemas.openxmlformats.org/officeDocument/2006/relationships" id="261" r:id="R85cd60057b58447e"/>
+    <p:sldId xmlns:r="http://schemas.openxmlformats.org/officeDocument/2006/relationships" id="262" r:id="R0562e76f4d6243a3"/>
+    <p:sldId xmlns:r="http://schemas.openxmlformats.org/officeDocument/2006/relationships" id="263" r:id="Rae81ef0d84cd437c"/>
+    <p:sldId xmlns:r="http://schemas.openxmlformats.org/officeDocument/2006/relationships" id="264" r:id="R81cdd1edc90048ee"/>
+    <p:sldId xmlns:r="http://schemas.openxmlformats.org/officeDocument/2006/relationships" id="265" r:id="R5421a2dadcf64aff"/>
+    <p:sldId xmlns:r="http://schemas.openxmlformats.org/officeDocument/2006/relationships" id="266" r:id="Rc555590593e34167"/>
+    <p:sldId xmlns:r="http://schemas.openxmlformats.org/officeDocument/2006/relationships" id="267" r:id="Rdd64a1de86e3458c"/>
+    <p:sldId xmlns:r="http://schemas.openxmlformats.org/officeDocument/2006/relationships" id="268" r:id="R8e5f72e408b34f1d"/>
   </p:sldIdLst>
   <p:sldSz cx="12192000" cy="6858000"/>
   <p:notesSz cx="6858000" cy="9144000"/>
@@ -654,7 +654,7 @@
           <a:lstStyle xmlns:a="http://schemas.openxmlformats.org/drawingml/2006/main"/>
           <a:p xmlns:a="http://schemas.openxmlformats.org/drawingml/2006/main">
             <a:r>
-              <a:t>This slide defines the boundary. The current app implements the interface, API routes, file import, PostgreSQL storage, local retrieval, fixed brief generation, source drill-down, saved brief runs, and feedback capture. The demo uses 10 fictional companies, static source files, a local database, word-hash vectors, and a fixed reference date. Live connectors, public filings, sign-in, source access enforcement, schedules, webhooks, reviewer tools, text-embedding-3-large, gpt-5.6-sol, and the Responses API are not active.</a:t>
+              <a:t>This slide defines the current boundary. The app implements the interface, API routes, file import, PostgreSQL storage, OpenAI embeddings, company-scoped retrieval, fixed brief generation, source drill-down, saved brief runs, and feedback capture. It uses 10 fictional companies, static source files, a local database, and a fixed reference date. It sends fictional chunk and query text to the OpenAI Embeddings API. Live connectors, public filings, sign-in, source access enforcement, schedules, webhooks, reviewer tools, gpt-5.6-sol, and the Responses API are not active.</a:t>
             </a:r>
           </a:p>
           <a:p xmlns:a="http://schemas.openxmlformats.org/drawingml/2006/main">
@@ -674,17 +674,7 @@
           </a:p>
           <a:p xmlns:a="http://schemas.openxmlformats.org/drawingml/2006/main">
             <a:r>
-              <a:t>- /Users/alexthorpe/Documents/GitHub/AVIC/app/api/briefs/route.ts</a:t>
-            </a:r>
-          </a:p>
-          <a:p xmlns:a="http://schemas.openxmlformats.org/drawingml/2006/main">
-            <a:r>
-              <a:t>- /Users/alexthorpe/Documents/GitHub/AVIC/app/api/sources/[id]/route.ts</a:t>
-            </a:r>
-          </a:p>
-          <a:p xmlns:a="http://schemas.openxmlformats.org/drawingml/2006/main">
-            <a:r>
-              <a:t>- /Users/alexthorpe/Documents/GitHub/AVIC/app/api/feedback/route.ts</a:t>
+              <a:t>- /Users/alexthorpe/Documents/GitHub/AVIC/lib/embeddings.ts</a:t>
             </a:r>
           </a:p>
           <a:p xmlns:a="http://schemas.openxmlformats.org/drawingml/2006/main">
@@ -710,11 +700,6 @@
           <a:p xmlns:a="http://schemas.openxmlformats.org/drawingml/2006/main">
             <a:r>
               <a:t>- https://developers.openai.com/api/docs/models/text-embedding-3-large</a:t>
-            </a:r>
-          </a:p>
-          <a:p xmlns:a="http://schemas.openxmlformats.org/drawingml/2006/main">
-            <a:r>
-              <a:t>- https://developers.openai.com/api/docs/models/gpt-5.6-sol</a:t>
             </a:r>
           </a:p>
           <a:p xmlns:a="http://schemas.openxmlformats.org/drawingml/2006/main">
@@ -1194,7 +1179,7 @@
           <a:lstStyle xmlns:a="http://schemas.openxmlformats.org/drawingml/2006/main"/>
           <a:p xmlns:a="http://schemas.openxmlformats.org/drawingml/2006/main">
             <a:r>
-              <a:t>The current checkout has 10 curated companies, 59 source records, 59 local vectors, 32 application tests, and 17 database checks. The source-reference checks validate IDs and company scope. They do not prove semantic entailment.</a:t>
+              <a:t>The current checkout has 10 curated companies, 59 source records, and 59 current OpenAI embeddings. It has 46 passing automated tests. The live checks include one embedding smoke check and 19 V1 checks. The source checks validate IDs and company scope. They do not prove semantic support.</a:t>
             </a:r>
           </a:p>
           <a:p xmlns:a="http://schemas.openxmlformats.org/drawingml/2006/main">
@@ -1209,12 +1194,12 @@
           </a:p>
           <a:p xmlns:a="http://schemas.openxmlformats.org/drawingml/2006/main">
             <a:r>
+              <a:t>- /Users/alexthorpe/Documents/GitHub/AVIC/scripts/verify-embeddings.ts</a:t>
+            </a:r>
+          </a:p>
+          <a:p xmlns:a="http://schemas.openxmlformats.org/drawingml/2006/main">
+            <a:r>
               <a:t>- /Users/alexthorpe/Documents/GitHub/AVIC/scripts/verify-v1.ts</a:t>
-            </a:r>
-          </a:p>
-          <a:p xmlns:a="http://schemas.openxmlformats.org/drawingml/2006/main">
-            <a:r>
-              <a:t>- /Users/alexthorpe/Documents/GitHub/AVIC/demo_data/manifest.json</a:t>
             </a:r>
           </a:p>
           <a:p xmlns:a="http://schemas.openxmlformats.org/drawingml/2006/main">
@@ -1299,7 +1284,7 @@
           <a:lstStyle xmlns:a="http://schemas.openxmlformats.org/drawingml/2006/main"/>
           <a:p xmlns:a="http://schemas.openxmlformats.org/drawingml/2006/main">
             <a:r>
-              <a:t>Current flow: file import validates each supplied company ID, keeps the source record, calculates a checksum, creates chunks and local word-hash vectors, and writes the data to PostgreSQL. A brief request uses a fixed query. SQL filters by company before it ranks up to 30 source records. Five companies use tailored templates. The other companies use one generic rule. The service checks source IDs and company isolation, saves the brief and ranked source records, and returns the result to the interface. The request path calls no source system and no external model. The production target uses text-embedding-3-large for retrieval vectors and gpt-5.6-sol through the Responses API for brief generation.</a:t>
+              <a:t>The file import validates each company ID and keeps the source record. It calculates checksums, creates chunks, and sends fictional chunk text to the OpenAI Embeddings API. PostgreSQL stores the returned embeddings. A brief request sends one fixed query to the same API. SQL then filters by company and ranks up to 30 source records. Fixed local rules create the brief. The service checks citations and company isolation. It saves the brief and ranked source records. It does not call a source system or a generation model during the request.</a:t>
             </a:r>
           </a:p>
           <a:p xmlns:a="http://schemas.openxmlformats.org/drawingml/2006/main">
@@ -1314,6 +1299,11 @@
           </a:p>
           <a:p xmlns:a="http://schemas.openxmlformats.org/drawingml/2006/main">
             <a:r>
+              <a:t>- /Users/alexthorpe/Documents/GitHub/AVIC/lib/embeddings.ts</a:t>
+            </a:r>
+          </a:p>
+          <a:p xmlns:a="http://schemas.openxmlformats.org/drawingml/2006/main">
+            <a:r>
               <a:t>- /Users/alexthorpe/Documents/GitHub/AVIC/lib/ingestion.ts</a:t>
             </a:r>
           </a:p>
@@ -1334,11 +1324,6 @@
           </a:p>
           <a:p xmlns:a="http://schemas.openxmlformats.org/drawingml/2006/main">
             <a:r>
-              <a:t>- /Users/alexthorpe/Documents/GitHub/AVIC/app/page.tsx</a:t>
-            </a:r>
-          </a:p>
-          <a:p xmlns:a="http://schemas.openxmlformats.org/drawingml/2006/main">
-            <a:r>
               <a:t>- /Users/alexthorpe/Documents/GitHub/AVIC/db/schema.sql</a:t>
             </a:r>
           </a:p>
@@ -1349,12 +1334,7 @@
           </a:p>
           <a:p xmlns:a="http://schemas.openxmlformats.org/drawingml/2006/main">
             <a:r>
-              <a:t>- https://developers.openai.com/api/docs/models/gpt-5.6-sol</a:t>
-            </a:r>
-          </a:p>
-          <a:p xmlns:a="http://schemas.openxmlformats.org/drawingml/2006/main">
-            <a:r>
-              <a:t>- https://developers.openai.com/api/docs/guides/latest-model</a:t>
+              <a:t>- https://developers.openai.com/api/reference/ruby/resources/embeddings/methods/create</a:t>
             </a:r>
           </a:p>
           <a:p xmlns:a="http://schemas.openxmlformats.org/drawingml/2006/main">
@@ -1429,7 +1409,7 @@
           <a:lstStyle xmlns:a="http://schemas.openxmlformats.org/drawingml/2006/main"/>
           <a:p xmlns:a="http://schemas.openxmlformats.org/drawingml/2006/main">
             <a:r>
-              <a:t>The importer maps every record to a known company, keeps the original content, calculates a checksum, and creates structured facts plus search chunks. PostgreSQL keeps both structured and unstructured evidence. Public filings are a planned source only.</a:t>
+              <a:t>The importer maps every record to one known company. It keeps the original content and calculates a checksum. It creates structured facts and search chunks. It sends only fictional normalized chunk text to the OpenAI Embeddings API. It stores the model, dimension, input checksum, and creation time with each embedding. A repeat import does not request an embedding when this fingerprint is current. Public filings are a planned source only.</a:t>
             </a:r>
           </a:p>
           <a:p xmlns:a="http://schemas.openxmlformats.org/drawingml/2006/main">
@@ -1444,7 +1424,7 @@
           </a:p>
           <a:p xmlns:a="http://schemas.openxmlformats.org/drawingml/2006/main">
             <a:r>
-              <a:t>- /Users/alexthorpe/Documents/GitHub/AVIC/docs/AIVC_Technical_Challenge_Task_4.2.pdf</a:t>
+              <a:t>- /Users/alexthorpe/Documents/GitHub/AVIC/lib/embeddings.ts</a:t>
             </a:r>
           </a:p>
           <a:p xmlns:a="http://schemas.openxmlformats.org/drawingml/2006/main">
@@ -1534,7 +1514,7 @@
           <a:lstStyle xmlns:a="http://schemas.openxmlformats.org/drawingml/2006/main"/>
           <a:p xmlns:a="http://schemas.openxmlformats.org/drawingml/2006/main">
             <a:r>
-              <a:t>The request contains only a company ID. The server uses one fixed retrieval query. SQL filters source records and chunks by that company ID before scoring. The score is 38 percent full-text rank, 32 percent local word-hash vector similarity, 20 percent source quality, and 10 percent recency against a fixed date. The query returns up to 30 source records. Fixed templates or one generic rule write the brief. No external model runs. The production target keeps the hard company filter and source IDs. It replaces the local word-hash vectors with text-embedding-3-large and uses gpt-5.6-sol through the Responses API for structured brief generation.</a:t>
+              <a:t>The request contains only a company ID. The server uses one fixed retrieval query. OpenAI creates the query embedding. SQL filters source records and chunks by the selected company before scoring. The score is 38 percent full-text rank, 32 percent embedding similarity, 20 percent source quality, and 10 percent recency. The query returns up to 30 source records. Fixed templates or one generic rule write the brief. No generation model runs.</a:t>
             </a:r>
           </a:p>
           <a:p xmlns:a="http://schemas.openxmlformats.org/drawingml/2006/main">
@@ -1549,6 +1529,11 @@
           </a:p>
           <a:p xmlns:a="http://schemas.openxmlformats.org/drawingml/2006/main">
             <a:r>
+              <a:t>- /Users/alexthorpe/Documents/GitHub/AVIC/lib/embeddings.ts</a:t>
+            </a:r>
+          </a:p>
+          <a:p xmlns:a="http://schemas.openxmlformats.org/drawingml/2006/main">
+            <a:r>
               <a:t>- /Users/alexthorpe/Documents/GitHub/AVIC/lib/retrieval.ts</a:t>
             </a:r>
           </a:p>
@@ -1565,16 +1550,6 @@
           <a:p xmlns:a="http://schemas.openxmlformats.org/drawingml/2006/main">
             <a:r>
               <a:t>- https://developers.openai.com/api/docs/models/text-embedding-3-large</a:t>
-            </a:r>
-          </a:p>
-          <a:p xmlns:a="http://schemas.openxmlformats.org/drawingml/2006/main">
-            <a:r>
-              <a:t>- https://developers.openai.com/api/docs/models/gpt-5.6-sol</a:t>
-            </a:r>
-          </a:p>
-          <a:p xmlns:a="http://schemas.openxmlformats.org/drawingml/2006/main">
-            <a:r>
-              <a:t>- https://developers.openai.com/api/docs/guides/latest-model</a:t>
             </a:r>
           </a:p>
           <a:p xmlns:a="http://schemas.openxmlformats.org/drawingml/2006/main">
@@ -1649,7 +1624,7 @@
           <a:lstStyle xmlns:a="http://schemas.openxmlformats.org/drawingml/2006/main"/>
           <a:p xmlns:a="http://schemas.openxmlformats.org/drawingml/2006/main">
             <a:r>
-              <a:t>The local prototype uses no external model. For production, choose text-embedding-3-large because OpenAI identifies it as the most capable embedding model. Choose gpt-5.6-sol because OpenAI identifies it as the flagship model for complex professional work. Use the Responses API and a structured output schema. Start with medium reasoning effort. Increase the effort only when the evaluation set shows a useful quality gain and the request stays within the response-time target.</a:t>
+              <a:t>The active retrieval model is text-embedding-3-large with 1,536 dimensions. OpenAI identifies it as its most capable embedding model. The brief engine uses fixed local rules and does not use a generation model. A later evaluated version can use gpt-5.6-sol through the Responses API for grounded generation.</a:t>
             </a:r>
           </a:p>
           <a:p xmlns:a="http://schemas.openxmlformats.org/drawingml/2006/main">
@@ -1669,21 +1644,16 @@
           </a:p>
           <a:p xmlns:a="http://schemas.openxmlformats.org/drawingml/2006/main">
             <a:r>
+              <a:t>- /Users/alexthorpe/Documents/GitHub/AVIC/lib/embeddings.ts</a:t>
+            </a:r>
+          </a:p>
+          <a:p xmlns:a="http://schemas.openxmlformats.org/drawingml/2006/main">
+            <a:r>
               <a:t>- /Users/alexthorpe/Documents/GitHub/AVIC/db/schema.sql</a:t>
             </a:r>
           </a:p>
           <a:p xmlns:a="http://schemas.openxmlformats.org/drawingml/2006/main">
             <a:r>
-              <a:t>- /Users/alexthorpe/Documents/GitHub/AVIC/lib/ingestion.ts</a:t>
-            </a:r>
-          </a:p>
-          <a:p xmlns:a="http://schemas.openxmlformats.org/drawingml/2006/main">
-            <a:r>
-              <a:t>- /Users/alexthorpe/Documents/GitHub/AVIC/lib/retrieval.ts</a:t>
-            </a:r>
-          </a:p>
-          <a:p xmlns:a="http://schemas.openxmlformats.org/drawingml/2006/main">
-            <a:r>
               <a:t>- /Users/alexthorpe/Documents/GitHub/AVIC/lib/brief.ts</a:t>
             </a:r>
           </a:p>
@@ -1695,11 +1665,6 @@
           <a:p xmlns:a="http://schemas.openxmlformats.org/drawingml/2006/main">
             <a:r>
               <a:t>- https://developers.openai.com/api/docs/models/gpt-5.6-sol</a:t>
-            </a:r>
-          </a:p>
-          <a:p xmlns:a="http://schemas.openxmlformats.org/drawingml/2006/main">
-            <a:r>
-              <a:t>- https://developers.openai.com/api/docs/guides/latest-model</a:t>
             </a:r>
           </a:p>
           <a:p xmlns:a="http://schemas.openxmlformats.org/drawingml/2006/main">
@@ -1774,7 +1739,7 @@
           <a:lstStyle xmlns:a="http://schemas.openxmlformats.org/drawingml/2006/main"/>
           <a:p xmlns:a="http://schemas.openxmlformats.org/drawingml/2006/main">
             <a:r>
-              <a:t>These checks are proposed acceptance targets. Retrieval uses code checks for must-find evidence in the first 30 results and zero records from another company. Grounding uses a source-ID check and a reviewer check that the source supports the factual claim. Product evaluation measures response time and RC usefulness. Operations evaluation tests repeat import and source-change behavior. Run the same set after each small change. Use the set to compare gpt-5.6-sol at medium and high reasoning effort. Keep the lower effort when both settings pass.</a:t>
+              <a:t>These checks are proposed acceptance targets. Retrieval uses code checks for must-find evidence in the first 30 results and zero records from another company. Grounding uses a source-ID check and a reviewer check. Product evaluation measures response time and RC usefulness. Operations evaluation tests repeat import and source-change behavior. Run the same set after each retrieval rule, embedding model, generation rule, or source rule change.</a:t>
             </a:r>
           </a:p>
           <a:p xmlns:a="http://schemas.openxmlformats.org/drawingml/2006/main">
@@ -1810,21 +1775,6 @@
           <a:p xmlns:a="http://schemas.openxmlformats.org/drawingml/2006/main">
             <a:r>
               <a:t>- /Users/alexthorpe/Documents/GitHub/AVIC/scripts/verify-v1.ts</a:t>
-            </a:r>
-          </a:p>
-          <a:p xmlns:a="http://schemas.openxmlformats.org/drawingml/2006/main">
-            <a:r>
-              <a:t>- https://developers.openai.com/api/reference/java/resources/evals/methods/create</a:t>
-            </a:r>
-          </a:p>
-          <a:p xmlns:a="http://schemas.openxmlformats.org/drawingml/2006/main">
-            <a:r>
-              <a:t>- https://developers.openai.com/api/reference/resources/graders</a:t>
-            </a:r>
-          </a:p>
-          <a:p xmlns:a="http://schemas.openxmlformats.org/drawingml/2006/main">
-            <a:r>
-              <a:t>- https://developers.openai.com/api/docs/guides/latest-model</a:t>
             </a:r>
           </a:p>
           <a:p xmlns:a="http://schemas.openxmlformats.org/drawingml/2006/main">
@@ -1897,7 +1847,7 @@
   </p:cSld>
   <p:clrMap bg1="lt1" tx1="dk1" bg2="lt2" tx2="dk2" accent1="accent1" accent2="accent2" accent3="accent3" accent4="accent4" accent5="accent5" accent6="accent6" hlink="hlink" folHlink="folHlink"/>
   <p:sldLayoutIdLst>
-    <p:sldLayoutId xmlns:r="http://schemas.openxmlformats.org/officeDocument/2006/relationships" id="2147483649" r:id="Rfea9ec3f2f9f434e"/>
+    <p:sldLayoutId xmlns:r="http://schemas.openxmlformats.org/officeDocument/2006/relationships" id="2147483649" r:id="R49905dda250b4e24"/>
   </p:sldLayoutIdLst>
   <p:txStyles>
     <p:titleStyle>
@@ -5009,7 +4959,7 @@
                 <a:ea typeface="Helvetica Neue"/>
                 <a:cs typeface="Helvetica Neue"/>
               </a:rPr>
-              <a:t>Checksum-based record updates</a:t>
+              <a:t>OpenAI embeddings and repeat-import control</a:t>
             </a:r>
           </a:p>
         </p:txBody>
@@ -6308,7 +6258,7 @@
                 <a:ea typeface="Helvetica Neue"/>
                 <a:cs typeface="Helvetica Neue"/>
               </a:rPr>
-              <a:t>text-embedding-3-large is not active</a:t>
+              <a:t>OpenAI embeddings use fictional demo text</a:t>
             </a:r>
           </a:p>
         </p:txBody>
@@ -6649,7 +6599,7 @@
                 <a:ea typeface="Helvetica Neue"/>
                 <a:cs typeface="Helvetica Neue"/>
               </a:rPr>
-              <a:t>The current app sends no OpenAI API request.</a:t>
+              <a:t>The app sends fictional chunk and query text only to the OpenAI Embeddings API.</a:t>
             </a:r>
           </a:p>
         </p:txBody>
@@ -9371,7 +9321,7 @@
                 <a:ea typeface="Helvetica Neue"/>
                 <a:cs typeface="Helvetica Neue"/>
               </a:rPr>
-              <a:t>Evaluated embeddings and grounded generation</a:t>
+              <a:t>Embedding evaluation and grounded generation</a:t>
             </a:r>
           </a:p>
           <a:p xmlns:a="http://schemas.openxmlformats.org/drawingml/2006/main">
@@ -11711,7 +11661,7 @@
           <p:nvPr/>
         </p:nvPicPr>
         <p:blipFill>
-          <a:blip xmlns:r="http://schemas.openxmlformats.org/officeDocument/2006/relationships" xmlns:a="http://schemas.openxmlformats.org/drawingml/2006/main" r:embed="R74609029c3734c30"/>
+          <a:blip xmlns:r="http://schemas.openxmlformats.org/officeDocument/2006/relationships" xmlns:a="http://schemas.openxmlformats.org/drawingml/2006/main" r:embed="Rb2c1f4bc312244ea"/>
           <a:stretch xmlns:a="http://schemas.openxmlformats.org/drawingml/2006/main"/>
         </p:blipFill>
         <p:spPr>
@@ -12450,7 +12400,7 @@
         </p:spPr>
         <p:txBody>
           <a:bodyPr xmlns:a="http://schemas.openxmlformats.org/drawingml/2006/main" anchor="t">
-            <a:normAutofit fontScale="84776"/>
+            <a:normAutofit fontScale="67871"/>
           </a:bodyPr>
           <a:lstStyle xmlns:a="http://schemas.openxmlformats.org/drawingml/2006/main"/>
           <a:p xmlns:a="http://schemas.openxmlformats.org/drawingml/2006/main">
@@ -12474,7 +12424,7 @@
                 <a:ea typeface="Helvetica Neue"/>
                 <a:cs typeface="Helvetica Neue"/>
               </a:rPr>
-              <a:t>chunks with demo vectors</a:t>
+              <a:t>chunks with OpenAI embeddings</a:t>
             </a:r>
           </a:p>
         </p:txBody>
@@ -12509,7 +12459,7 @@
         </p:spPr>
         <p:txBody>
           <a:bodyPr xmlns:a="http://schemas.openxmlformats.org/drawingml/2006/main" anchor="t">
-            <a:normAutofit fontScale="77497"/>
+            <a:normAutofit fontScale="87983"/>
           </a:bodyPr>
           <a:lstStyle xmlns:a="http://schemas.openxmlformats.org/drawingml/2006/main"/>
           <a:p xmlns:a="http://schemas.openxmlformats.org/drawingml/2006/main">
@@ -12533,7 +12483,7 @@
                 <a:ea typeface="Helvetica Neue"/>
                 <a:cs typeface="Helvetica Neue"/>
               </a:rPr>
-              <a:t>One repeatable demo vector per chunk</a:t>
+              <a:t>One current embedding per chunk</a:t>
             </a:r>
           </a:p>
         </p:txBody>
@@ -12627,7 +12577,7 @@
                 <a:ea typeface="Helvetica Neue"/>
                 <a:cs typeface="Helvetica Neue"/>
               </a:rPr>
-              <a:t>49</a:t>
+              <a:t>66</a:t>
             </a:r>
           </a:p>
         </p:txBody>
@@ -12721,7 +12671,7 @@
         </p:spPr>
         <p:txBody>
           <a:bodyPr xmlns:a="http://schemas.openxmlformats.org/drawingml/2006/main" anchor="t">
-            <a:normAutofit fontScale="80843"/>
+            <a:normAutofit fontScale="96117"/>
           </a:bodyPr>
           <a:lstStyle xmlns:a="http://schemas.openxmlformats.org/drawingml/2006/main"/>
           <a:p xmlns:a="http://schemas.openxmlformats.org/drawingml/2006/main">
@@ -12745,7 +12695,7 @@
                 <a:ea typeface="Helvetica Neue"/>
                 <a:cs typeface="Helvetica Neue"/>
               </a:rPr>
-              <a:t>32 app tests and 17 database checks</a:t>
+              <a:t>46 app tests and 20 live checks</a:t>
             </a:r>
           </a:p>
         </p:txBody>
@@ -12839,7 +12789,7 @@
                 <a:ea typeface="Helvetica Neue"/>
                 <a:cs typeface="Helvetica Neue"/>
               </a:rPr>
-              <a:t>What the current local checks confirm</a:t>
+              <a:t>What the current checks confirm</a:t>
             </a:r>
           </a:p>
         </p:txBody>
@@ -12990,7 +12940,7 @@
                 <a:ea typeface="Helvetica Neue"/>
                 <a:cs typeface="Helvetica Neue"/>
               </a:rPr>
-              <a:t>All 10 companies return a local brief</a:t>
+              <a:t>All 10 companies return a source-supported brief</a:t>
             </a:r>
           </a:p>
         </p:txBody>
@@ -13049,7 +12999,7 @@
                 <a:ea typeface="Helvetica Neue"/>
                 <a:cs typeface="Helvetica Neue"/>
               </a:rPr>
-              <a:t>Each result is under 30 seconds in the current check.</a:t>
+              <a:t>All 10 briefs are under 1 second in the current live check.</a:t>
             </a:r>
           </a:p>
         </p:txBody>
@@ -13318,7 +13268,7 @@
                 <a:ea typeface="Helvetica Neue"/>
                 <a:cs typeface="Helvetica Neue"/>
               </a:rPr>
-              <a:t>Current local results on the curated dataset. They are not production benchmarks.</a:t>
+              <a:t>Current results on the curated dataset. They are not production benchmarks.</a:t>
             </a:r>
           </a:p>
         </p:txBody>
@@ -13553,7 +13503,7 @@
                 <a:ea typeface="Helvetica Neue"/>
                 <a:cs typeface="Helvetica Neue"/>
               </a:rPr>
-              <a:t>The app imports files before a request. A brief reads local PostgreSQL. It calls no source system or external model.</a:t>
+              <a:t>OpenAI creates embeddings at import and request time. The brief reads PostgreSQL. It does not call a source system.</a:t>
             </a:r>
           </a:p>
         </p:txBody>
@@ -14058,6 +14008,30 @@
               <a:t>Checksum and chunk</a:t>
             </a:r>
           </a:p>
+          <a:p xmlns:a="http://schemas.openxmlformats.org/drawingml/2006/main">
+            <a:pPr algn="l">
+              <a:buNone/>
+              <a:defRPr sz="1125" b="0">
+                <a:solidFill>
+                  <a:srgbClr val="667085"/>
+                </a:solidFill>
+                <a:latin typeface="Helvetica Neue"/>
+                <a:ea typeface="Helvetica Neue"/>
+                <a:cs typeface="Helvetica Neue"/>
+              </a:defRPr>
+            </a:pPr>
+            <a:r>
+              <a:rPr sz="1050" b="0">
+                <a:solidFill>
+                  <a:srgbClr val="344054"/>
+                </a:solidFill>
+                <a:latin typeface="Helvetica Neue"/>
+                <a:ea typeface="Helvetica Neue"/>
+                <a:cs typeface="Helvetica Neue"/>
+              </a:rPr>
+              <a:t>Request embeddings</a:t>
+            </a:r>
+          </a:p>
         </p:txBody>
       </p:sp>
       <p:sp>
@@ -14282,7 +14256,7 @@
                 <a:ea typeface="Helvetica Neue"/>
                 <a:cs typeface="Helvetica Neue"/>
               </a:rPr>
-              <a:t>Chunks and demo vectors</a:t>
+              <a:t>Chunks and embeddings</a:t>
             </a:r>
           </a:p>
           <a:p xmlns:a="http://schemas.openxmlformats.org/drawingml/2006/main">
@@ -14437,7 +14411,7 @@
         </p:spPr>
         <p:txBody>
           <a:bodyPr xmlns:a="http://schemas.openxmlformats.org/drawingml/2006/main" anchor="t">
-            <a:normAutofit fontScale="100000"/>
+            <a:normAutofit fontScale="88868"/>
           </a:bodyPr>
           <a:lstStyle xmlns:a="http://schemas.openxmlformats.org/drawingml/2006/main"/>
           <a:p xmlns:a="http://schemas.openxmlformats.org/drawingml/2006/main">
@@ -14461,6 +14435,30 @@
                 <a:ea typeface="Helvetica Neue"/>
                 <a:cs typeface="Helvetica Neue"/>
               </a:rPr>
+              <a:t>Create query embedding</a:t>
+            </a:r>
+          </a:p>
+          <a:p xmlns:a="http://schemas.openxmlformats.org/drawingml/2006/main">
+            <a:pPr algn="l">
+              <a:buNone/>
+              <a:defRPr sz="1125" b="0">
+                <a:solidFill>
+                  <a:srgbClr val="667085"/>
+                </a:solidFill>
+                <a:latin typeface="Helvetica Neue"/>
+                <a:ea typeface="Helvetica Neue"/>
+                <a:cs typeface="Helvetica Neue"/>
+              </a:defRPr>
+            </a:pPr>
+            <a:r>
+              <a:rPr sz="1050" b="0">
+                <a:solidFill>
+                  <a:srgbClr val="344054"/>
+                </a:solidFill>
+                <a:latin typeface="Helvetica Neue"/>
+                <a:ea typeface="Helvetica Neue"/>
+                <a:cs typeface="Helvetica Neue"/>
+              </a:rPr>
               <a:t>Company ID filter in SQL</a:t>
             </a:r>
           </a:p>
@@ -14485,7 +14483,7 @@
                 <a:ea typeface="Helvetica Neue"/>
                 <a:cs typeface="Helvetica Neue"/>
               </a:rPr>
-              <a:t>Full-text and local vector search</a:t>
+              <a:t>Full-text and embedding search</a:t>
             </a:r>
           </a:p>
           <a:p xmlns:a="http://schemas.openxmlformats.org/drawingml/2006/main">
@@ -14509,7 +14507,7 @@
                 <a:ea typeface="Helvetica Neue"/>
                 <a:cs typeface="Helvetica Neue"/>
               </a:rPr>
-              <a:t>Rank up to 30 source records</a:t>
+              <a:t>Rank up to 30 records</a:t>
             </a:r>
           </a:p>
           <a:p xmlns:a="http://schemas.openxmlformats.org/drawingml/2006/main">
@@ -14767,7 +14765,7 @@
       </p:sp>
       <p:cxnSp>
         <p:nvCxnSpPr>
-          <p:cNvPr id="247" name=""/>
+          <p:cNvPr id="319" name=""/>
           <p:cNvCxnSpPr>
             <a:stCxn xmlns:a="http://schemas.openxmlformats.org/drawingml/2006/main" id="5" idx="3"/>
             <a:endCxn xmlns:a="http://schemas.openxmlformats.org/drawingml/2006/main" id="8" idx="1"/>
@@ -14793,7 +14791,7 @@
       </p:cxnSp>
       <p:cxnSp>
         <p:nvCxnSpPr>
-          <p:cNvPr id="248" name=""/>
+          <p:cNvPr id="320" name=""/>
           <p:cNvCxnSpPr>
             <a:stCxn xmlns:a="http://schemas.openxmlformats.org/drawingml/2006/main" id="8" idx="3"/>
             <a:endCxn xmlns:a="http://schemas.openxmlformats.org/drawingml/2006/main" id="11" idx="1"/>
@@ -14819,7 +14817,7 @@
       </p:cxnSp>
       <p:cxnSp>
         <p:nvCxnSpPr>
-          <p:cNvPr id="249" name=""/>
+          <p:cNvPr id="321" name=""/>
           <p:cNvCxnSpPr>
             <a:stCxn xmlns:a="http://schemas.openxmlformats.org/drawingml/2006/main" id="11" idx="3"/>
             <a:endCxn xmlns:a="http://schemas.openxmlformats.org/drawingml/2006/main" id="14" idx="1"/>
@@ -14845,7 +14843,7 @@
       </p:cxnSp>
       <p:cxnSp>
         <p:nvCxnSpPr>
-          <p:cNvPr id="250" name=""/>
+          <p:cNvPr id="322" name=""/>
           <p:cNvCxnSpPr>
             <a:stCxn xmlns:a="http://schemas.openxmlformats.org/drawingml/2006/main" id="14" idx="3"/>
             <a:endCxn xmlns:a="http://schemas.openxmlformats.org/drawingml/2006/main" id="17" idx="1"/>
@@ -15019,7 +15017,7 @@
                 <a:ea typeface="Helvetica Neue"/>
                 <a:cs typeface="Helvetica Neue"/>
               </a:rPr>
-              <a:t>Checksums · company filter before rank · source IDs · saved source ranks · feedback</a:t>
+              <a:t>Checksums · embedding fingerprints · company filter before rank · source IDs · saved source ranks · feedback</a:t>
             </a:r>
           </a:p>
         </p:txBody>
@@ -15078,7 +15076,7 @@
                 <a:ea typeface="Helvetica Neue"/>
                 <a:cs typeface="Helvetica Neue"/>
               </a:rPr>
-              <a:t>PRODUCTION TARGET    Connectors · access rules · schedules · reconciliation · text-embedding-3-large (Embeddings API) · gpt-5.6-sol (Responses API)</a:t>
+              <a:t>PRODUCTION TARGET    Managed connectors · access rules · schedules · reconciliation · optional grounded generation with gpt-5.6-sol</a:t>
             </a:r>
           </a:p>
         </p:txBody>
@@ -15415,7 +15413,7 @@
                 <a:ea typeface="Helvetica Neue"/>
                 <a:cs typeface="Helvetica Neue"/>
               </a:rPr>
-              <a:t>No model call</a:t>
+              <a:t>No generation model</a:t>
             </a:r>
           </a:p>
           <a:p xmlns:a="http://schemas.openxmlformats.org/drawingml/2006/main">
@@ -15494,7 +15492,7 @@
       </p:sp>
       <p:cxnSp>
         <p:nvCxnSpPr>
-          <p:cNvPr id="262" name=""/>
+          <p:cNvPr id="334" name=""/>
           <p:cNvCxnSpPr>
             <a:stCxn xmlns:a="http://schemas.openxmlformats.org/drawingml/2006/main" id="14" idx="3"/>
             <a:endCxn xmlns:a="http://schemas.openxmlformats.org/drawingml/2006/main" id="78" idx="1"/>
@@ -15520,7 +15518,7 @@
       </p:cxnSp>
       <p:cxnSp>
         <p:nvCxnSpPr>
-          <p:cNvPr id="263" name=""/>
+          <p:cNvPr id="335" name=""/>
           <p:cNvCxnSpPr>
             <a:stCxn xmlns:a="http://schemas.openxmlformats.org/drawingml/2006/main" id="78" idx="3"/>
             <a:endCxn xmlns:a="http://schemas.openxmlformats.org/drawingml/2006/main" id="17" idx="1"/>
@@ -16666,7 +16664,7 @@
         </p:spPr>
         <p:txBody>
           <a:bodyPr xmlns:a="http://schemas.openxmlformats.org/drawingml/2006/main" anchor="t">
-            <a:normAutofit fontScale="94444"/>
+            <a:normAutofit fontScale="92403"/>
           </a:bodyPr>
           <a:lstStyle xmlns:a="http://schemas.openxmlformats.org/drawingml/2006/main"/>
           <a:p xmlns:a="http://schemas.openxmlformats.org/drawingml/2006/main">
@@ -16690,7 +16688,7 @@
                 <a:ea typeface="Helvetica Neue"/>
                 <a:cs typeface="Helvetica Neue"/>
               </a:rPr>
-              <a:t>Create facts, chunks, search text, and local vectors</a:t>
+              <a:t>Create facts, chunks, search text, and OpenAI embeddings</a:t>
             </a:r>
           </a:p>
         </p:txBody>
@@ -17672,7 +17670,7 @@
         </p:spPr>
         <p:txBody>
           <a:bodyPr xmlns:a="http://schemas.openxmlformats.org/drawingml/2006/main" anchor="t">
-            <a:normAutofit fontScale="96585"/>
+            <a:normAutofit fontScale="100000"/>
           </a:bodyPr>
           <a:lstStyle xmlns:a="http://schemas.openxmlformats.org/drawingml/2006/main"/>
           <a:p xmlns:a="http://schemas.openxmlformats.org/drawingml/2006/main">
@@ -17696,7 +17694,7 @@
                 <a:ea typeface="Helvetica Neue"/>
                 <a:cs typeface="Helvetica Neue"/>
               </a:rPr>
-              <a:t>Repeatable demo vectors</a:t>
+              <a:t>OpenAI embeddings</a:t>
             </a:r>
           </a:p>
         </p:txBody>
@@ -17731,7 +17729,7 @@
         </p:spPr>
         <p:txBody>
           <a:bodyPr xmlns:a="http://schemas.openxmlformats.org/drawingml/2006/main" anchor="t">
-            <a:normAutofit fontScale="88132"/>
+            <a:normAutofit fontScale="81975"/>
           </a:bodyPr>
           <a:lstStyle xmlns:a="http://schemas.openxmlformats.org/drawingml/2006/main"/>
           <a:p xmlns:a="http://schemas.openxmlformats.org/drawingml/2006/main">
@@ -17755,7 +17753,7 @@
                 <a:ea typeface="Helvetica Neue"/>
                 <a:cs typeface="Helvetica Neue"/>
               </a:rPr>
-              <a:t>Checksums update changed records and avoid duplicates. Production also needs authenticated connectors, incremental import, deletion handling, schedules, and access rules.</a:t>
+              <a:t>Checksums and embedding fingerprints avoid duplicates and repeat API calls. Production also needs authenticated connectors, incremental import, deletion handling, schedules, and access rules.</a:t>
             </a:r>
           </a:p>
         </p:txBody>
@@ -18329,7 +18327,7 @@
                 <a:ea typeface="Helvetica Neue"/>
                 <a:cs typeface="Helvetica Neue"/>
               </a:rPr>
-              <a:t>32% demo vector</a:t>
+              <a:t>32% embedding</a:t>
             </a:r>
           </a:p>
         </p:txBody>
@@ -18668,7 +18666,7 @@
                 <a:ea typeface="Helvetica Neue"/>
                 <a:cs typeface="Helvetica Neue"/>
               </a:rPr>
-              <a:t>PostgreSQL full-text and demo-vector similarity</a:t>
+              <a:t>PostgreSQL full-text and embedding similarity</a:t>
             </a:r>
           </a:p>
         </p:txBody>
@@ -18821,7 +18819,7 @@
                 <a:ea typeface="Helvetica Neue"/>
                 <a:cs typeface="Helvetica Neue"/>
               </a:rPr>
-              <a:t>Five tailored templates or one generic rule. No model call.</a:t>
+              <a:t>Five tailored templates or one generic rule. No generation model.</a:t>
             </a:r>
           </a:p>
         </p:txBody>
@@ -19029,7 +19027,7 @@
       </p:sp>
       <p:cxnSp>
         <p:nvCxnSpPr>
-          <p:cNvPr id="209" name=""/>
+          <p:cNvPr id="261" name=""/>
           <p:cNvCxnSpPr>
             <a:stCxn xmlns:a="http://schemas.openxmlformats.org/drawingml/2006/main" id="16" idx="3"/>
             <a:endCxn xmlns:a="http://schemas.openxmlformats.org/drawingml/2006/main" id="19" idx="1"/>
@@ -19055,7 +19053,7 @@
       </p:cxnSp>
       <p:cxnSp>
         <p:nvCxnSpPr>
-          <p:cNvPr id="210" name=""/>
+          <p:cNvPr id="262" name=""/>
           <p:cNvCxnSpPr>
             <a:stCxn xmlns:a="http://schemas.openxmlformats.org/drawingml/2006/main" id="19" idx="3"/>
             <a:endCxn xmlns:a="http://schemas.openxmlformats.org/drawingml/2006/main" id="22" idx="1"/>
@@ -19133,7 +19131,7 @@
                 <a:ea typeface="Helvetica Neue"/>
                 <a:cs typeface="Helvetica Neue"/>
               </a:rPr>
-              <a:t>CURRENT V1: fixed query, initial weights, fixed date, and no external model.</a:t>
+              <a:t>CURRENT V1: OpenAI query embedding, fixed query, initial weights, and a fixed date.</a:t>
             </a:r>
           </a:p>
         </p:txBody>
@@ -19192,7 +19190,7 @@
                 <a:ea typeface="Helvetica Neue"/>
                 <a:cs typeface="Helvetica Neue"/>
               </a:rPr>
-              <a:t>TARGET: text-embedding-3-large via Embeddings API; gpt-5.6-sol via Responses API.</a:t>
+              <a:t>TARGET: tune retrieval with reviewed questions; add gpt-5.6-sol only for grounded generation.</a:t>
             </a:r>
           </a:p>
         </p:txBody>
@@ -19910,7 +19908,7 @@
                 <a:ea typeface="Helvetica Neue"/>
                 <a:cs typeface="Helvetica Neue"/>
               </a:rPr>
-              <a:t>One store holds facts, evidence text, vectors, audit data, and feedback.</a:t>
+              <a:t>One store holds facts, evidence text, embeddings, audit data, and feedback.</a:t>
             </a:r>
           </a:p>
         </p:txBody>
@@ -20275,7 +20273,7 @@
                 <a:ea typeface="Helvetica Neue"/>
                 <a:cs typeface="Helvetica Neue"/>
               </a:rPr>
-              <a:t>Demo vectors and fixed brief rules</a:t>
+              <a:t>text-embedding-3-large and fixed brief rules</a:t>
             </a:r>
           </a:p>
         </p:txBody>
@@ -20334,7 +20332,7 @@
                 <a:ea typeface="Helvetica Neue"/>
                 <a:cs typeface="Helvetica Neue"/>
               </a:rPr>
-              <a:t>The app calls no external model. Results are repeatable and easy to test.</a:t>
+              <a:t>OpenAI creates semantic embeddings. Fixed rules keep brief output repeatable.</a:t>
             </a:r>
           </a:p>
         </p:txBody>
@@ -20393,7 +20391,7 @@
                 <a:ea typeface="Helvetica Neue"/>
                 <a:cs typeface="Helvetica Neue"/>
               </a:rPr>
-              <a:t>Target: text-embedding-3-large via Embeddings API; gpt-5.6-sol via Responses API.</a:t>
+              <a:t>Evaluate retrieval. Add gpt-5.6-sol only for grounded generation.</a:t>
             </a:r>
           </a:p>
         </p:txBody>
@@ -21784,7 +21782,7 @@
                 <a:ea typeface="Helvetica Neue"/>
                 <a:cs typeface="Helvetica Neue"/>
               </a:rPr>
-              <a:t>Run the same set after a retrieval, prompt, model, or source-rule change.</a:t>
+              <a:t>Run the same set after a retrieval, embedding model, generation rule, or source-rule change.</a:t>
             </a:r>
           </a:p>
         </p:txBody>

</xml_diff>

<commit_message>
Add source-supported brief generation
</commit_message>
<xml_diff>
--- a/docs/AVIC-Portfolio-Intelligence-Brief.pptx
+++ b/docs/AVIC-Portfolio-Intelligence-Brief.pptx
@@ -2,25 +2,25 @@
 <file path=ppt/presentation.xml><?xml version="1.0" encoding="utf-8"?>
 <p:presentation xmlns:p="http://schemas.openxmlformats.org/presentationml/2006/main">
   <p:sldMasterIdLst>
-    <p:sldMasterId xmlns:r="http://schemas.openxmlformats.org/officeDocument/2006/relationships" id="2147483648" r:id="Rd02e71a8567d4297"/>
+    <p:sldMasterId xmlns:r="http://schemas.openxmlformats.org/officeDocument/2006/relationships" id="2147483648" r:id="R28e7d875e78a450e"/>
   </p:sldMasterIdLst>
   <p:notesMasterIdLst>
-    <p:notesMasterId xmlns:r="http://schemas.openxmlformats.org/officeDocument/2006/relationships" r:id="R3d3a98c7d5a44b21"/>
+    <p:notesMasterId xmlns:r="http://schemas.openxmlformats.org/officeDocument/2006/relationships" r:id="Rc51ddf0d83754fd7"/>
   </p:notesMasterIdLst>
   <p:sldIdLst>
-    <p:sldId xmlns:r="http://schemas.openxmlformats.org/officeDocument/2006/relationships" id="256" r:id="R04a49e85fbbc43c5"/>
-    <p:sldId xmlns:r="http://schemas.openxmlformats.org/officeDocument/2006/relationships" id="257" r:id="R2ead53493d8d4331"/>
-    <p:sldId xmlns:r="http://schemas.openxmlformats.org/officeDocument/2006/relationships" id="258" r:id="R326f5a2c063849f7"/>
-    <p:sldId xmlns:r="http://schemas.openxmlformats.org/officeDocument/2006/relationships" id="259" r:id="R013bb9e948344376"/>
-    <p:sldId xmlns:r="http://schemas.openxmlformats.org/officeDocument/2006/relationships" id="260" r:id="R032ef100e65940c5"/>
-    <p:sldId xmlns:r="http://schemas.openxmlformats.org/officeDocument/2006/relationships" id="261" r:id="R85cd60057b58447e"/>
-    <p:sldId xmlns:r="http://schemas.openxmlformats.org/officeDocument/2006/relationships" id="262" r:id="R0562e76f4d6243a3"/>
-    <p:sldId xmlns:r="http://schemas.openxmlformats.org/officeDocument/2006/relationships" id="263" r:id="Rae81ef0d84cd437c"/>
-    <p:sldId xmlns:r="http://schemas.openxmlformats.org/officeDocument/2006/relationships" id="264" r:id="R81cdd1edc90048ee"/>
-    <p:sldId xmlns:r="http://schemas.openxmlformats.org/officeDocument/2006/relationships" id="265" r:id="R5421a2dadcf64aff"/>
-    <p:sldId xmlns:r="http://schemas.openxmlformats.org/officeDocument/2006/relationships" id="266" r:id="Rc555590593e34167"/>
-    <p:sldId xmlns:r="http://schemas.openxmlformats.org/officeDocument/2006/relationships" id="267" r:id="Rdd64a1de86e3458c"/>
-    <p:sldId xmlns:r="http://schemas.openxmlformats.org/officeDocument/2006/relationships" id="268" r:id="R8e5f72e408b34f1d"/>
+    <p:sldId xmlns:r="http://schemas.openxmlformats.org/officeDocument/2006/relationships" id="256" r:id="R80df3a4af3804efe"/>
+    <p:sldId xmlns:r="http://schemas.openxmlformats.org/officeDocument/2006/relationships" id="257" r:id="Rc085733bffde4451"/>
+    <p:sldId xmlns:r="http://schemas.openxmlformats.org/officeDocument/2006/relationships" id="258" r:id="R0e4dc282173b4bca"/>
+    <p:sldId xmlns:r="http://schemas.openxmlformats.org/officeDocument/2006/relationships" id="259" r:id="Rfebbaed3e18649f6"/>
+    <p:sldId xmlns:r="http://schemas.openxmlformats.org/officeDocument/2006/relationships" id="260" r:id="R5aaaf61f02414940"/>
+    <p:sldId xmlns:r="http://schemas.openxmlformats.org/officeDocument/2006/relationships" id="261" r:id="Rd8f4bbc746ad40c0"/>
+    <p:sldId xmlns:r="http://schemas.openxmlformats.org/officeDocument/2006/relationships" id="262" r:id="R07d035118cae4aa9"/>
+    <p:sldId xmlns:r="http://schemas.openxmlformats.org/officeDocument/2006/relationships" id="263" r:id="Rb0fd2217f5b944b1"/>
+    <p:sldId xmlns:r="http://schemas.openxmlformats.org/officeDocument/2006/relationships" id="264" r:id="R90dcd2d281cf4823"/>
+    <p:sldId xmlns:r="http://schemas.openxmlformats.org/officeDocument/2006/relationships" id="265" r:id="Rb3997c55670741d6"/>
+    <p:sldId xmlns:r="http://schemas.openxmlformats.org/officeDocument/2006/relationships" id="266" r:id="R0a06857624b34db2"/>
+    <p:sldId xmlns:r="http://schemas.openxmlformats.org/officeDocument/2006/relationships" id="267" r:id="R2d5aa8a29f8b4d52"/>
+    <p:sldId xmlns:r="http://schemas.openxmlformats.org/officeDocument/2006/relationships" id="268" r:id="Rc05ab1eed37c4a5d"/>
   </p:sldIdLst>
   <p:sldSz cx="12192000" cy="6858000"/>
   <p:notesSz cx="6858000" cy="9144000"/>
@@ -654,7 +654,7 @@
           <a:lstStyle xmlns:a="http://schemas.openxmlformats.org/drawingml/2006/main"/>
           <a:p xmlns:a="http://schemas.openxmlformats.org/drawingml/2006/main">
             <a:r>
-              <a:t>This slide defines the current boundary. The app implements the interface, API routes, file import, PostgreSQL storage, OpenAI embeddings, company-scoped retrieval, fixed brief generation, source drill-down, saved brief runs, and feedback capture. It uses 10 fictional companies, static source files, a local database, and a fixed reference date. It sends fictional chunk and query text to the OpenAI Embeddings API. Live connectors, public filings, sign-in, source access enforcement, schedules, webhooks, reviewer tools, gpt-5.6-sol, and the Responses API are not active.</a:t>
+              <a:t>This slide defines the current boundary. The app implements the interface, API routes, file import, PostgreSQL storage, OpenAI embeddings, company-scoped retrieval, source-supported generation with gpt-5.6-sol, strict checks, source drill-down, local fallback, saved generation audit data, and feedback capture. It uses 10 fictional companies, static source files, a local database, and a fixed reference date. The OpenAI request contains selected fictional text only. It excludes raw JSON, source locators, access metadata, and records for unrelated companies. Live connectors, public filings, sign-in, source access enforcement, schedules, webhooks, and a reviewer screen are not active.</a:t>
             </a:r>
           </a:p>
           <a:p xmlns:a="http://schemas.openxmlformats.org/drawingml/2006/main">
@@ -689,6 +689,11 @@
           </a:p>
           <a:p xmlns:a="http://schemas.openxmlformats.org/drawingml/2006/main">
             <a:r>
+              <a:t>- /Users/alexthorpe/Documents/GitHub/AVIC/lib/brief-generation.ts</a:t>
+            </a:r>
+          </a:p>
+          <a:p xmlns:a="http://schemas.openxmlformats.org/drawingml/2006/main">
+            <a:r>
               <a:t>- /Users/alexthorpe/Documents/GitHub/AVIC/lib/brief.ts</a:t>
             </a:r>
           </a:p>
@@ -700,6 +705,16 @@
           <a:p xmlns:a="http://schemas.openxmlformats.org/drawingml/2006/main">
             <a:r>
               <a:t>- https://developers.openai.com/api/docs/models/text-embedding-3-large</a:t>
+            </a:r>
+          </a:p>
+          <a:p xmlns:a="http://schemas.openxmlformats.org/drawingml/2006/main">
+            <a:r>
+              <a:t>- https://developers.openai.com/api/docs/models/gpt-5.6-sol</a:t>
+            </a:r>
+          </a:p>
+          <a:p xmlns:a="http://schemas.openxmlformats.org/drawingml/2006/main">
+            <a:r>
+              <a:t>- https://developers.openai.com/api/reference/cli/resources/responses/methods/create</a:t>
             </a:r>
           </a:p>
           <a:p xmlns:a="http://schemas.openxmlformats.org/drawingml/2006/main">
@@ -774,7 +789,7 @@
           <a:lstStyle xmlns:a="http://schemas.openxmlformats.org/drawingml/2006/main"/>
           <a:p xmlns:a="http://schemas.openxmlformats.org/drawingml/2006/main">
             <a:r>
-              <a:t>This is a proposed plan for two people. The 250-company test appears in weeks 7 and 8 because it has not been run. The plan depends on source access, company IDs, access rules, and RC review time.</a:t>
+              <a:t>This is a proposed plan for two people. The 250-company test appears in weeks 7 and 8 because it has not been run. Weeks 5 and 6 include retrieval evaluation and generation-and-fallback evaluation. The plan depends on source access, company IDs, access rules, and review time from the AIVC principal.</a:t>
             </a:r>
           </a:p>
           <a:p xmlns:a="http://schemas.openxmlformats.org/drawingml/2006/main">
@@ -784,6 +799,11 @@
           </a:p>
           <a:p xmlns:a="http://schemas.openxmlformats.org/drawingml/2006/main">
             <a:r>
+              <a:t/>
+            </a:r>
+          </a:p>
+          <a:p xmlns:a="http://schemas.openxmlformats.org/drawingml/2006/main">
+            <a:r>
               <a:t>[Sources]</a:t>
             </a:r>
           </a:p>
@@ -800,6 +820,11 @@
           <a:p xmlns:a="http://schemas.openxmlformats.org/drawingml/2006/main">
             <a:r>
               <a:t>- /Users/alexthorpe/Documents/GitHub/AVIC/docs/architecture.md</a:t>
+            </a:r>
+          </a:p>
+          <a:p xmlns:a="http://schemas.openxmlformats.org/drawingml/2006/main">
+            <a:r>
+              <a:t>- /Users/alexthorpe/Documents/GitHub/AVIC/scripts/verify-generation.ts</a:t>
             </a:r>
           </a:p>
           <a:p xmlns:a="http://schemas.openxmlformats.org/drawingml/2006/main">
@@ -874,7 +899,7 @@
           <a:lstStyle xmlns:a="http://schemas.openxmlformats.org/drawingml/2006/main"/>
           <a:p xmlns:a="http://schemas.openxmlformats.org/drawingml/2006/main">
             <a:r>
-              <a:t>The first risk is evidence retrieval, not model choice. The next slice should use one approved source and a small reference answer set. The decision is whether to approve that source-to-brief pilot after the named owners confirm access and evaluation conditions.</a:t>
+              <a:t>The first risk is evidence retrieval, not model choice. The next slice should use one approved source and a small reference answer set. With more time, evaluate both retrieval and source-supported generation, then add the reviewer workflow and monitoring. The decision is whether to approve that source-to-brief pilot after the named owners confirm access and evaluation conditions.</a:t>
             </a:r>
           </a:p>
           <a:p xmlns:a="http://schemas.openxmlformats.org/drawingml/2006/main">
@@ -909,7 +934,17 @@
           </a:p>
           <a:p xmlns:a="http://schemas.openxmlformats.org/drawingml/2006/main">
             <a:r>
+              <a:t>- /Users/alexthorpe/Documents/GitHub/AVIC/lib/brief-generation.ts</a:t>
+            </a:r>
+          </a:p>
+          <a:p xmlns:a="http://schemas.openxmlformats.org/drawingml/2006/main">
+            <a:r>
               <a:t>- /Users/alexthorpe/Documents/GitHub/AVIC/scripts/verify-v1.ts</a:t>
+            </a:r>
+          </a:p>
+          <a:p xmlns:a="http://schemas.openxmlformats.org/drawingml/2006/main">
+            <a:r>
+              <a:t>- /Users/alexthorpe/Documents/GitHub/AVIC/scripts/verify-generation.ts</a:t>
             </a:r>
           </a:p>
           <a:p xmlns:a="http://schemas.openxmlformats.org/drawingml/2006/main">
@@ -1079,7 +1114,7 @@
           <a:lstStyle xmlns:a="http://schemas.openxmlformats.org/drawingml/2006/main"/>
           <a:p xmlns:a="http://schemas.openxmlformats.org/drawingml/2006/main">
             <a:r>
-              <a:t>Show the desktop flow. RC selects a company, scans the brief, opens the evidence and original source, and sends feedback without changing context.</a:t>
+              <a:t>Show the desktop flow. The AIVC principal selects a company, scans the brief, opens the evidence and original source, and sends feedback without changing context.</a:t>
             </a:r>
           </a:p>
           <a:p xmlns:a="http://schemas.openxmlformats.org/drawingml/2006/main">
@@ -1179,7 +1214,7 @@
           <a:lstStyle xmlns:a="http://schemas.openxmlformats.org/drawingml/2006/main"/>
           <a:p xmlns:a="http://schemas.openxmlformats.org/drawingml/2006/main">
             <a:r>
-              <a:t>The current checkout has 10 curated companies, 59 source records, and 59 current OpenAI embeddings. It has 46 passing automated tests. The live checks include one embedding smoke check and 19 V1 checks. The source checks validate IDs and company scope. They do not prove semantic support.</a:t>
+              <a:t>The working prototype is an internal company-intelligence interface. It uses 10 fictional companies and 59 fictional source records. Two companies represent the portfolio. Eight companies represent the pipeline. The app imports static CRM, meeting, Slack, and news files. It creates OpenAI embeddings, stores evidence in PostgreSQL, retrieves evidence for one company, and uses gpt-5.6-sol to create a source-supported brief. The principal can open the evidence and original record for each statement and can send feedback. The prototype has no live connectors and gives no investment recommendation.</a:t>
             </a:r>
           </a:p>
           <a:p xmlns:a="http://schemas.openxmlformats.org/drawingml/2006/main">
@@ -1200,6 +1235,11 @@
           <a:p xmlns:a="http://schemas.openxmlformats.org/drawingml/2006/main">
             <a:r>
               <a:t>- /Users/alexthorpe/Documents/GitHub/AVIC/scripts/verify-v1.ts</a:t>
+            </a:r>
+          </a:p>
+          <a:p xmlns:a="http://schemas.openxmlformats.org/drawingml/2006/main">
+            <a:r>
+              <a:t>- /Users/alexthorpe/Documents/GitHub/AVIC/scripts/verify-generation.ts</a:t>
             </a:r>
           </a:p>
           <a:p xmlns:a="http://schemas.openxmlformats.org/drawingml/2006/main">
@@ -1284,7 +1324,7 @@
           <a:lstStyle xmlns:a="http://schemas.openxmlformats.org/drawingml/2006/main"/>
           <a:p xmlns:a="http://schemas.openxmlformats.org/drawingml/2006/main">
             <a:r>
-              <a:t>The file import validates each company ID and keeps the source record. It calculates checksums, creates chunks, and sends fictional chunk text to the OpenAI Embeddings API. PostgreSQL stores the returned embeddings. A brief request sends one fixed query to the same API. SQL then filters by company and ranks up to 30 source records. Fixed local rules create the brief. The service checks citations and company isolation. It saves the brief and ranked source records. It does not call a source system or a generation model during the request.</a:t>
+              <a:t>The file import validates each company ID, keeps the source record, calculates checksums, creates chunks, and sends fictional normalized chunk text to the OpenAI Embeddings API. PostgreSQL stores the returned embeddings. A brief request creates one query embedding. SQL filters by company and ranks up to 30 source records. The server sends only the selected company metadata and retrieved evidence to gpt-5.6-sol through the Responses API. It requests a strict schema with low reasoning effort, no tools, and no response storage. A 27-second model timeout and a 29-second request budget have no automatic retry. The server checks source IDs, company isolation, exact source quotes, typed values, qualitative support, source status, and investment safety. It saves the brief, generation mode, model data, and source ranks. If generation fails a check or exceeds the budget, local rules create a source-supported fallback. The app does not call a source system during a brief request.</a:t>
             </a:r>
           </a:p>
           <a:p xmlns:a="http://schemas.openxmlformats.org/drawingml/2006/main">
@@ -1314,6 +1354,11 @@
           </a:p>
           <a:p xmlns:a="http://schemas.openxmlformats.org/drawingml/2006/main">
             <a:r>
+              <a:t>- /Users/alexthorpe/Documents/GitHub/AVIC/lib/brief-generation.ts</a:t>
+            </a:r>
+          </a:p>
+          <a:p xmlns:a="http://schemas.openxmlformats.org/drawingml/2006/main">
+            <a:r>
               <a:t>- /Users/alexthorpe/Documents/GitHub/AVIC/lib/brief.ts</a:t>
             </a:r>
           </a:p>
@@ -1329,12 +1374,12 @@
           </a:p>
           <a:p xmlns:a="http://schemas.openxmlformats.org/drawingml/2006/main">
             <a:r>
-              <a:t>- https://developers.openai.com/api/docs/models/text-embedding-3-large</a:t>
-            </a:r>
-          </a:p>
-          <a:p xmlns:a="http://schemas.openxmlformats.org/drawingml/2006/main">
-            <a:r>
-              <a:t>- https://developers.openai.com/api/reference/ruby/resources/embeddings/methods/create</a:t>
+              <a:t>- https://developers.openai.com/api/docs/models/gpt-5.6-sol</a:t>
+            </a:r>
+          </a:p>
+          <a:p xmlns:a="http://schemas.openxmlformats.org/drawingml/2006/main">
+            <a:r>
+              <a:t>- https://developers.openai.com/api/reference/cli/resources/responses/methods/create</a:t>
             </a:r>
           </a:p>
           <a:p xmlns:a="http://schemas.openxmlformats.org/drawingml/2006/main">
@@ -1514,7 +1559,7 @@
           <a:lstStyle xmlns:a="http://schemas.openxmlformats.org/drawingml/2006/main"/>
           <a:p xmlns:a="http://schemas.openxmlformats.org/drawingml/2006/main">
             <a:r>
-              <a:t>The request contains only a company ID. The server uses one fixed retrieval query. OpenAI creates the query embedding. SQL filters source records and chunks by the selected company before scoring. The score is 38 percent full-text rank, 32 percent embedding similarity, 20 percent source quality, and 10 percent recency. The query returns up to 30 source records. Fixed templates or one generic rule write the brief. No generation model runs.</a:t>
+              <a:t>The request contains only a company ID. The server uses one fixed retrieval query. OpenAI creates the query embedding. SQL filters records and chunks by the selected company before scoring. The score is 38 percent full-text rank, 32 percent embedding similarity, 20 percent source quality, and 10 percent recency. The query returns up to 30 source records. The server sends selected evidence to gpt-5.6-sol through the Responses API. It checks the strict result before it saves the brief. Local rules create the fallback only when the generated result is late, invalid, or unavailable.</a:t>
             </a:r>
           </a:p>
           <a:p xmlns:a="http://schemas.openxmlformats.org/drawingml/2006/main">
@@ -1539,6 +1584,11 @@
           </a:p>
           <a:p xmlns:a="http://schemas.openxmlformats.org/drawingml/2006/main">
             <a:r>
+              <a:t>- /Users/alexthorpe/Documents/GitHub/AVIC/lib/brief-generation.ts</a:t>
+            </a:r>
+          </a:p>
+          <a:p xmlns:a="http://schemas.openxmlformats.org/drawingml/2006/main">
+            <a:r>
               <a:t>- /Users/alexthorpe/Documents/GitHub/AVIC/lib/brief.ts</a:t>
             </a:r>
           </a:p>
@@ -1549,7 +1599,12 @@
           </a:p>
           <a:p xmlns:a="http://schemas.openxmlformats.org/drawingml/2006/main">
             <a:r>
-              <a:t>- https://developers.openai.com/api/docs/models/text-embedding-3-large</a:t>
+              <a:t>- https://developers.openai.com/api/docs/models/gpt-5.6-sol</a:t>
+            </a:r>
+          </a:p>
+          <a:p xmlns:a="http://schemas.openxmlformats.org/drawingml/2006/main">
+            <a:r>
+              <a:t>- https://developers.openai.com/api/reference/cli/resources/responses/methods/create</a:t>
             </a:r>
           </a:p>
           <a:p xmlns:a="http://schemas.openxmlformats.org/drawingml/2006/main">
@@ -1624,7 +1679,7 @@
           <a:lstStyle xmlns:a="http://schemas.openxmlformats.org/drawingml/2006/main"/>
           <a:p xmlns:a="http://schemas.openxmlformats.org/drawingml/2006/main">
             <a:r>
-              <a:t>The active retrieval model is text-embedding-3-large with 1,536 dimensions. OpenAI identifies it as its most capable embedding model. The brief engine uses fixed local rules and does not use a generation model. A later evaluated version can use gpt-5.6-sol through the Responses API for grounded generation.</a:t>
+              <a:t>The active retrieval model is text-embedding-3-large with 1,536 dimensions. The active brief model is gpt-5.6-sol through the Responses API. The app uses low reasoning effort. In the measured demo checks, low effort produced two valid briefs in 15.4 and 20.9 seconds. Medium effort was slower and sometimes exceeded the test timeout. Keep low effort until a reviewed evaluation shows a useful quality gain.</a:t>
             </a:r>
           </a:p>
           <a:p xmlns:a="http://schemas.openxmlformats.org/drawingml/2006/main">
@@ -1649,22 +1704,32 @@
           </a:p>
           <a:p xmlns:a="http://schemas.openxmlformats.org/drawingml/2006/main">
             <a:r>
+              <a:t>- /Users/alexthorpe/Documents/GitHub/AVIC/lib/brief-generation.ts</a:t>
+            </a:r>
+          </a:p>
+          <a:p xmlns:a="http://schemas.openxmlformats.org/drawingml/2006/main">
+            <a:r>
+              <a:t>- /Users/alexthorpe/Documents/GitHub/AVIC/scripts/verify-generation.ts</a:t>
+            </a:r>
+          </a:p>
+          <a:p xmlns:a="http://schemas.openxmlformats.org/drawingml/2006/main">
+            <a:r>
               <a:t>- /Users/alexthorpe/Documents/GitHub/AVIC/db/schema.sql</a:t>
             </a:r>
           </a:p>
           <a:p xmlns:a="http://schemas.openxmlformats.org/drawingml/2006/main">
             <a:r>
-              <a:t>- /Users/alexthorpe/Documents/GitHub/AVIC/lib/brief.ts</a:t>
-            </a:r>
-          </a:p>
-          <a:p xmlns:a="http://schemas.openxmlformats.org/drawingml/2006/main">
-            <a:r>
               <a:t>- https://developers.openai.com/api/docs/models/text-embedding-3-large</a:t>
             </a:r>
           </a:p>
           <a:p xmlns:a="http://schemas.openxmlformats.org/drawingml/2006/main">
             <a:r>
               <a:t>- https://developers.openai.com/api/docs/models/gpt-5.6-sol</a:t>
+            </a:r>
+          </a:p>
+          <a:p xmlns:a="http://schemas.openxmlformats.org/drawingml/2006/main">
+            <a:r>
+              <a:t>- https://developers.openai.com/api/docs/guides/latest-model</a:t>
             </a:r>
           </a:p>
           <a:p xmlns:a="http://schemas.openxmlformats.org/drawingml/2006/main">
@@ -1739,7 +1804,7 @@
           <a:lstStyle xmlns:a="http://schemas.openxmlformats.org/drawingml/2006/main"/>
           <a:p xmlns:a="http://schemas.openxmlformats.org/drawingml/2006/main">
             <a:r>
-              <a:t>These checks are proposed acceptance targets. Retrieval uses code checks for must-find evidence in the first 30 results and zero records from another company. Grounding uses a source-ID check and a reviewer check. Product evaluation measures response time and RC usefulness. Operations evaluation tests repeat import and source-change behavior. Run the same set after each retrieval rule, embedding model, generation rule, or source rule change.</a:t>
+              <a:t>The current checkout has 69 passing app tests. The 22 live checks include 19 V1 database checks, one embedding check, and two source-supported generation checks. VectorForge took 15.4 seconds. Kestrel Health took 20.9 seconds. Both generated briefs kept citations and the required conflict or unverified state. The local check covers all 10 fictional companies. It does not use the generation model. Use two checks for each evaluation type. Retrieval checks that a must-find source is in the first 30 results and that no result belongs to another company. Grounding checks that each claim cites retrieved evidence and that each numeric value appears in a cited source. Product evaluation measures response time and usefulness for the AIVC principal. Operations evaluation checks that invalid generated output uses the fallback and that a changed source changes the next brief. Run the same set after each retrieval, prompt, model, schema, or source-rule change.</a:t>
             </a:r>
           </a:p>
           <a:p xmlns:a="http://schemas.openxmlformats.org/drawingml/2006/main">
@@ -1749,6 +1814,11 @@
           </a:p>
           <a:p xmlns:a="http://schemas.openxmlformats.org/drawingml/2006/main">
             <a:r>
+              <a:t/>
+            </a:r>
+          </a:p>
+          <a:p xmlns:a="http://schemas.openxmlformats.org/drawingml/2006/main">
+            <a:r>
               <a:t>[Sources]</a:t>
             </a:r>
           </a:p>
@@ -1764,6 +1834,11 @@
           </a:p>
           <a:p xmlns:a="http://schemas.openxmlformats.org/drawingml/2006/main">
             <a:r>
+              <a:t>- /Users/alexthorpe/Documents/GitHub/AVIC/lib/brief-generation.ts</a:t>
+            </a:r>
+          </a:p>
+          <a:p xmlns:a="http://schemas.openxmlformats.org/drawingml/2006/main">
+            <a:r>
               <a:t>- /Users/alexthorpe/Documents/GitHub/AVIC/lib/brief.ts</a:t>
             </a:r>
           </a:p>
@@ -1775,6 +1850,16 @@
           <a:p xmlns:a="http://schemas.openxmlformats.org/drawingml/2006/main">
             <a:r>
               <a:t>- /Users/alexthorpe/Documents/GitHub/AVIC/scripts/verify-v1.ts</a:t>
+            </a:r>
+          </a:p>
+          <a:p xmlns:a="http://schemas.openxmlformats.org/drawingml/2006/main">
+            <a:r>
+              <a:t>- /Users/alexthorpe/Documents/GitHub/AVIC/scripts/verify-generation.ts</a:t>
+            </a:r>
+          </a:p>
+          <a:p xmlns:a="http://schemas.openxmlformats.org/drawingml/2006/main">
+            <a:r>
+              <a:t>- /Users/alexthorpe/Documents/GitHub/AVIC/tests</a:t>
             </a:r>
           </a:p>
           <a:p xmlns:a="http://schemas.openxmlformats.org/drawingml/2006/main">
@@ -1847,7 +1932,7 @@
   </p:cSld>
   <p:clrMap bg1="lt1" tx1="dk1" bg2="lt2" tx2="dk2" accent1="accent1" accent2="accent2" accent3="accent3" accent4="accent4" accent5="accent5" accent6="accent6" hlink="hlink" folHlink="folHlink"/>
   <p:sldLayoutIdLst>
-    <p:sldLayoutId xmlns:r="http://schemas.openxmlformats.org/officeDocument/2006/relationships" id="2147483649" r:id="R49905dda250b4e24"/>
+    <p:sldLayoutId xmlns:r="http://schemas.openxmlformats.org/officeDocument/2006/relationships" id="2147483649" r:id="R694b0c3947ac4262"/>
   </p:sldLayoutIdLst>
   <p:txStyles>
     <p:titleStyle>
@@ -2600,7 +2685,7 @@
         </p:spPr>
         <p:txBody>
           <a:bodyPr xmlns:a="http://schemas.openxmlformats.org/drawingml/2006/main" anchor="t">
-            <a:normAutofit fontScale="92998"/>
+            <a:normAutofit fontScale="94483"/>
           </a:bodyPr>
           <a:lstStyle xmlns:a="http://schemas.openxmlformats.org/drawingml/2006/main"/>
           <a:p xmlns:a="http://schemas.openxmlformats.org/drawingml/2006/main">
@@ -2624,7 +2709,7 @@
                 <a:ea typeface="Helvetica Neue"/>
                 <a:cs typeface="Helvetica Neue"/>
               </a:rPr>
-              <a:t>Company briefs from imported evidence in 30 seconds or less</a:t>
+              <a:t>Company briefs from fictional evidence in 30 seconds or less</a:t>
             </a:r>
           </a:p>
         </p:txBody>
@@ -3100,7 +3185,7 @@
                 <a:ea typeface="Helvetica Neue"/>
                 <a:cs typeface="Helvetica Neue"/>
               </a:rPr>
-              <a:t>RC is preparing for a company discussion</a:t>
+              <a:t>An AIVC principal prepares for a company discussion</a:t>
             </a:r>
           </a:p>
         </p:txBody>
@@ -5148,7 +5233,7 @@
                 <a:ea typeface="Helvetica Neue"/>
                 <a:cs typeface="Helvetica Neue"/>
               </a:rPr>
-              <a:t>Company-scoped top-30 retrieval</a:t>
+              <a:t>Company-scoped retrieval and gpt-5.6-sol</a:t>
             </a:r>
           </a:p>
         </p:txBody>
@@ -5337,7 +5422,7 @@
                 <a:ea typeface="Helvetica Neue"/>
                 <a:cs typeface="Helvetica Neue"/>
               </a:rPr>
-              <a:t>Evidence and full source record drill-down</a:t>
+              <a:t>Strict schema, citations, and source drill-down</a:t>
             </a:r>
           </a:p>
         </p:txBody>
@@ -5526,7 +5611,7 @@
                 <a:ea typeface="Helvetica Neue"/>
                 <a:cs typeface="Helvetica Neue"/>
               </a:rPr>
-              <a:t>Saved brief runs and ranked source records</a:t>
+              <a:t>Local fallback and saved brief audit</a:t>
             </a:r>
           </a:p>
         </p:txBody>
@@ -5882,7 +5967,7 @@
                 <a:ea typeface="Helvetica Neue"/>
                 <a:cs typeface="Helvetica Neue"/>
               </a:rPr>
-              <a:t>DEMO OR NOT BUILT</a:t>
+              <a:t>DEMO BOUNDARY</a:t>
             </a:r>
           </a:p>
         </p:txBody>
@@ -6070,7 +6155,7 @@
                 <a:ea typeface="Helvetica Neue"/>
                 <a:cs typeface="Helvetica Neue"/>
               </a:rPr>
-              <a:t>5 tailored templates and 5 briefs from one generic rule</a:t>
+              <a:t>Deterministic templates remain as the failure fallback</a:t>
             </a:r>
           </a:p>
         </p:txBody>
@@ -6352,7 +6437,7 @@
                 <a:ea typeface="Helvetica Neue"/>
                 <a:cs typeface="Helvetica Neue"/>
               </a:rPr>
-              <a:t>gpt-5.6-sol and Responses API are not active</a:t>
+              <a:t>gpt-5.6-sol and Responses API are active for briefs</a:t>
             </a:r>
           </a:p>
         </p:txBody>
@@ -6561,8 +6646,8 @@
         </p:nvSpPr>
         <p:spPr>
           <a:xfrm xmlns:a="http://schemas.openxmlformats.org/drawingml/2006/main">
-            <a:off x="6134100" y="5514975"/>
-            <a:ext cx="4762500" cy="228600"/>
+            <a:off x="6134100" y="5410200"/>
+            <a:ext cx="4762500" cy="400050"/>
           </a:xfrm>
           <a:prstGeom xmlns:a="http://schemas.openxmlformats.org/drawingml/2006/main" prst="rect">
             <a:avLst/>
@@ -6575,7 +6660,7 @@
         </p:spPr>
         <p:txBody>
           <a:bodyPr xmlns:a="http://schemas.openxmlformats.org/drawingml/2006/main" anchor="t">
-            <a:normAutofit fontScale="75000"/>
+            <a:normAutofit fontScale="84375"/>
           </a:bodyPr>
           <a:lstStyle xmlns:a="http://schemas.openxmlformats.org/drawingml/2006/main"/>
           <a:p xmlns:a="http://schemas.openxmlformats.org/drawingml/2006/main">
@@ -6599,7 +6684,7 @@
                 <a:ea typeface="Helvetica Neue"/>
                 <a:cs typeface="Helvetica Neue"/>
               </a:rPr>
-              <a:t>The app sends fictional chunk and query text only to the OpenAI Embeddings API.</a:t>
+              <a:t>OpenAI receives fictional text only. It receives no raw JSON or unrelated company records.</a:t>
             </a:r>
           </a:p>
         </p:txBody>
@@ -7687,7 +7772,7 @@
                 <a:ea typeface="Helvetica Neue"/>
                 <a:cs typeface="Helvetica Neue"/>
               </a:rPr>
-              <a:t>Grounded generation</a:t>
+              <a:t>Generation and fallback evaluation</a:t>
             </a:r>
           </a:p>
         </p:txBody>
@@ -7980,7 +8065,7 @@
                 <a:ea typeface="Helvetica Neue"/>
                 <a:cs typeface="Helvetica Neue"/>
               </a:rPr>
-              <a:t>250-company test and RC pilot</a:t>
+              <a:t>250-company test and principal pilot</a:t>
             </a:r>
           </a:p>
         </p:txBody>
@@ -9063,7 +9148,7 @@
                 <a:ea typeface="Helvetica Neue"/>
                 <a:cs typeface="Helvetica Neue"/>
               </a:rPr>
-              <a:t>RC review</a:t>
+              <a:t>Principal review</a:t>
             </a:r>
           </a:p>
         </p:txBody>
@@ -9321,7 +9406,7 @@
                 <a:ea typeface="Helvetica Neue"/>
                 <a:cs typeface="Helvetica Neue"/>
               </a:rPr>
-              <a:t>Embedding evaluation and grounded generation</a:t>
+              <a:t>Retrieval and generation evaluation</a:t>
             </a:r>
           </a:p>
           <a:p xmlns:a="http://schemas.openxmlformats.org/drawingml/2006/main">
@@ -9498,7 +9583,7 @@
                 <a:ea typeface="Helvetica Neue"/>
                 <a:cs typeface="Helvetica Neue"/>
               </a:rPr>
-              <a:t>Approve one source-to-brief pilot after source owners, access owners, and RC confirm the test set.</a:t>
+              <a:t>Approve one source-to-brief pilot after source owners, access owners, and the AIVC principal confirm the test set.</a:t>
             </a:r>
           </a:p>
         </p:txBody>
@@ -9709,7 +9794,7 @@
         </p:spPr>
         <p:txBody>
           <a:bodyPr xmlns:a="http://schemas.openxmlformats.org/drawingml/2006/main" anchor="t">
-            <a:normAutofit fontScale="100000"/>
+            <a:normAutofit fontScale="88933"/>
           </a:bodyPr>
           <a:lstStyle xmlns:a="http://schemas.openxmlformats.org/drawingml/2006/main"/>
           <a:p xmlns:a="http://schemas.openxmlformats.org/drawingml/2006/main">
@@ -9733,7 +9818,7 @@
                 <a:ea typeface="Helvetica Neue"/>
                 <a:cs typeface="Helvetica Neue"/>
               </a:rPr>
-              <a:t>RC prepares for discussions across about 50 portfolio companies and 200 pipeline companies.</a:t>
+              <a:t>An AIVC principal prepares for discussions across about 50 portfolio companies and 200 pipeline companies.</a:t>
             </a:r>
           </a:p>
         </p:txBody>
@@ -9792,7 +9877,7 @@
                 <a:ea typeface="Helvetica Neue"/>
                 <a:cs typeface="Helvetica Neue"/>
               </a:rPr>
-              <a:t>The facts are spread across CRM records, meeting notes, Slack, filings, and news. RC must find the latest value, check the source, and see what is missing.</a:t>
+              <a:t>The facts are spread across CRM records, meeting notes, Slack, filings, and news. The AIVC principal must find the latest value, check the source, and see what is missing.</a:t>
             </a:r>
           </a:p>
         </p:txBody>
@@ -10527,7 +10612,7 @@
                 <a:ea typeface="Helvetica Neue"/>
                 <a:cs typeface="Helvetica Neue"/>
               </a:rPr>
-              <a:t>AVIC organizes evidence. RC keeps the investment judgment.</a:t>
+              <a:t>AVIC organizes evidence. The AIVC principal keeps the investment judgment.</a:t>
             </a:r>
           </a:p>
         </p:txBody>
@@ -10615,7 +10700,7 @@
                 <a:ea typeface="Helvetica Neue"/>
                 <a:cs typeface="Helvetica Neue"/>
               </a:rPr>
-              <a:t>What does the working prototype let RC do?</a:t>
+              <a:t>What does the working prototype let an AIVC principal do?</a:t>
             </a:r>
           </a:p>
         </p:txBody>
@@ -11661,7 +11746,7 @@
           <p:nvPr/>
         </p:nvPicPr>
         <p:blipFill>
-          <a:blip xmlns:r="http://schemas.openxmlformats.org/officeDocument/2006/relationships" xmlns:a="http://schemas.openxmlformats.org/drawingml/2006/main" r:embed="Rb2c1f4bc312244ea"/>
+          <a:blip xmlns:r="http://schemas.openxmlformats.org/officeDocument/2006/relationships" xmlns:a="http://schemas.openxmlformats.org/drawingml/2006/main" r:embed="R2ebf4d9526ec427f"/>
           <a:stretch xmlns:a="http://schemas.openxmlformats.org/drawingml/2006/main"/>
         </p:blipFill>
         <p:spPr>
@@ -11759,7 +11844,7 @@
                 <a:ea typeface="Helvetica Neue"/>
                 <a:cs typeface="Helvetica Neue"/>
               </a:rPr>
-              <a:t>What works today, and how did I test it?</a:t>
+              <a:t>What is the working prototype?</a:t>
             </a:r>
           </a:p>
         </p:txBody>
@@ -12000,7 +12085,7 @@
                 <a:ea typeface="Helvetica Neue"/>
                 <a:cs typeface="Helvetica Neue"/>
               </a:rPr>
-              <a:t>curated companies</a:t>
+              <a:t>fictional companies</a:t>
             </a:r>
           </a:p>
         </p:txBody>
@@ -12577,7 +12662,7 @@
                 <a:ea typeface="Helvetica Neue"/>
                 <a:cs typeface="Helvetica Neue"/>
               </a:rPr>
-              <a:t>66</a:t>
+              <a:t>V1</a:t>
             </a:r>
           </a:p>
         </p:txBody>
@@ -12636,7 +12721,7 @@
                 <a:ea typeface="Helvetica Neue"/>
                 <a:cs typeface="Helvetica Neue"/>
               </a:rPr>
-              <a:t>passing checks</a:t>
+              <a:t>working prototype</a:t>
             </a:r>
           </a:p>
         </p:txBody>
@@ -12671,7 +12756,7 @@
         </p:spPr>
         <p:txBody>
           <a:bodyPr xmlns:a="http://schemas.openxmlformats.org/drawingml/2006/main" anchor="t">
-            <a:normAutofit fontScale="96117"/>
+            <a:normAutofit fontScale="100000"/>
           </a:bodyPr>
           <a:lstStyle xmlns:a="http://schemas.openxmlformats.org/drawingml/2006/main"/>
           <a:p xmlns:a="http://schemas.openxmlformats.org/drawingml/2006/main">
@@ -12695,7 +12780,7 @@
                 <a:ea typeface="Helvetica Neue"/>
                 <a:cs typeface="Helvetica Neue"/>
               </a:rPr>
-              <a:t>46 app tests and 20 live checks</a:t>
+              <a:t>Source-supported briefs</a:t>
             </a:r>
           </a:p>
         </p:txBody>
@@ -12789,7 +12874,7 @@
                 <a:ea typeface="Helvetica Neue"/>
                 <a:cs typeface="Helvetica Neue"/>
               </a:rPr>
-              <a:t>What the current checks confirm</a:t>
+              <a:t>What the prototype does</a:t>
             </a:r>
           </a:p>
         </p:txBody>
@@ -12940,7 +13025,7 @@
                 <a:ea typeface="Helvetica Neue"/>
                 <a:cs typeface="Helvetica Neue"/>
               </a:rPr>
-              <a:t>All 10 companies return a source-supported brief</a:t>
+              <a:t>Builds one current brief from selected evidence</a:t>
             </a:r>
           </a:p>
         </p:txBody>
@@ -12975,7 +13060,7 @@
         </p:spPr>
         <p:txBody>
           <a:bodyPr xmlns:a="http://schemas.openxmlformats.org/drawingml/2006/main" anchor="t">
-            <a:normAutofit fontScale="100000"/>
+            <a:normAutofit fontScale="80597"/>
           </a:bodyPr>
           <a:lstStyle xmlns:a="http://schemas.openxmlformats.org/drawingml/2006/main"/>
           <a:p xmlns:a="http://schemas.openxmlformats.org/drawingml/2006/main">
@@ -12999,7 +13084,7 @@
                 <a:ea typeface="Helvetica Neue"/>
                 <a:cs typeface="Helvetica Neue"/>
               </a:rPr>
-              <a:t>All 10 briefs are under 1 second in the current live check.</a:t>
+              <a:t>The principal can open each statement, source excerpt, and original record.</a:t>
             </a:r>
           </a:p>
         </p:txBody>
@@ -13150,7 +13235,7 @@
                 <a:ea typeface="Helvetica Neue"/>
                 <a:cs typeface="Helvetica Neue"/>
               </a:rPr>
-              <a:t>Source IDs are valid and company-scoped</a:t>
+              <a:t>Keeps judgment with the AIVC principal</a:t>
             </a:r>
           </a:p>
         </p:txBody>
@@ -13185,7 +13270,7 @@
         </p:spPr>
         <p:txBody>
           <a:bodyPr xmlns:a="http://schemas.openxmlformats.org/drawingml/2006/main" anchor="t">
-            <a:normAutofit fontScale="91943"/>
+            <a:normAutofit fontScale="87203"/>
           </a:bodyPr>
           <a:lstStyle xmlns:a="http://schemas.openxmlformats.org/drawingml/2006/main"/>
           <a:p xmlns:a="http://schemas.openxmlformats.org/drawingml/2006/main">
@@ -13209,7 +13294,7 @@
                 <a:ea typeface="Helvetica Neue"/>
                 <a:cs typeface="Helvetica Neue"/>
               </a:rPr>
-              <a:t>The demo covers conflict, earlier value, unverified claim, and missing data.</a:t>
+              <a:t>The app shows conflicts and missing data. It does not give investment advice.</a:t>
             </a:r>
           </a:p>
         </p:txBody>
@@ -13268,7 +13353,7 @@
                 <a:ea typeface="Helvetica Neue"/>
                 <a:cs typeface="Helvetica Neue"/>
               </a:rPr>
-              <a:t>Current results on the curated dataset. They are not production benchmarks.</a:t>
+              <a:t>FICTIONAL DEMO DATA ONLY · NO LIVE CONNECTORS · NO INVESTMENT RECOMMENDATIONS</a:t>
             </a:r>
           </a:p>
         </p:txBody>
@@ -13503,7 +13588,7 @@
                 <a:ea typeface="Helvetica Neue"/>
                 <a:cs typeface="Helvetica Neue"/>
               </a:rPr>
-              <a:t>OpenAI creates embeddings at import and request time. The brief reads PostgreSQL. It does not call a source system.</a:t>
+              <a:t>OpenAI creates embeddings and source-supported briefs. The app does not call a source system at request time.</a:t>
             </a:r>
           </a:p>
         </p:txBody>
@@ -14765,7 +14850,7 @@
       </p:sp>
       <p:cxnSp>
         <p:nvCxnSpPr>
-          <p:cNvPr id="319" name=""/>
+          <p:cNvPr id="392" name=""/>
           <p:cNvCxnSpPr>
             <a:stCxn xmlns:a="http://schemas.openxmlformats.org/drawingml/2006/main" id="5" idx="3"/>
             <a:endCxn xmlns:a="http://schemas.openxmlformats.org/drawingml/2006/main" id="8" idx="1"/>
@@ -14791,7 +14876,7 @@
       </p:cxnSp>
       <p:cxnSp>
         <p:nvCxnSpPr>
-          <p:cNvPr id="320" name=""/>
+          <p:cNvPr id="393" name=""/>
           <p:cNvCxnSpPr>
             <a:stCxn xmlns:a="http://schemas.openxmlformats.org/drawingml/2006/main" id="8" idx="3"/>
             <a:endCxn xmlns:a="http://schemas.openxmlformats.org/drawingml/2006/main" id="11" idx="1"/>
@@ -14817,7 +14902,7 @@
       </p:cxnSp>
       <p:cxnSp>
         <p:nvCxnSpPr>
-          <p:cNvPr id="321" name=""/>
+          <p:cNvPr id="394" name=""/>
           <p:cNvCxnSpPr>
             <a:stCxn xmlns:a="http://schemas.openxmlformats.org/drawingml/2006/main" id="11" idx="3"/>
             <a:endCxn xmlns:a="http://schemas.openxmlformats.org/drawingml/2006/main" id="14" idx="1"/>
@@ -14843,7 +14928,7 @@
       </p:cxnSp>
       <p:cxnSp>
         <p:nvCxnSpPr>
-          <p:cNvPr id="322" name=""/>
+          <p:cNvPr id="395" name=""/>
           <p:cNvCxnSpPr>
             <a:stCxn xmlns:a="http://schemas.openxmlformats.org/drawingml/2006/main" id="14" idx="3"/>
             <a:endCxn xmlns:a="http://schemas.openxmlformats.org/drawingml/2006/main" id="17" idx="1"/>
@@ -15017,7 +15102,7 @@
                 <a:ea typeface="Helvetica Neue"/>
                 <a:cs typeface="Helvetica Neue"/>
               </a:rPr>
-              <a:t>Checksums · embedding fingerprints · company filter before rank · source IDs · saved source ranks · feedback</a:t>
+              <a:t>Checksums · company filter · selected source IDs · value support · source-status guard · timeout · fallback · feedback</a:t>
             </a:r>
           </a:p>
         </p:txBody>
@@ -15076,7 +15161,7 @@
                 <a:ea typeface="Helvetica Neue"/>
                 <a:cs typeface="Helvetica Neue"/>
               </a:rPr>
-              <a:t>PRODUCTION TARGET    Managed connectors · access rules · schedules · reconciliation · optional grounded generation with gpt-5.6-sol</a:t>
+              <a:t>PRODUCTION HARDENING    Managed connectors · access rules · reviewed prompts · model policy · monitoring</a:t>
             </a:r>
           </a:p>
         </p:txBody>
@@ -15389,7 +15474,7 @@
                 <a:ea typeface="Helvetica Neue"/>
                 <a:cs typeface="Helvetica Neue"/>
               </a:rPr>
-              <a:t>Fixed brief rules</a:t>
+              <a:t>gpt-5.6-sol</a:t>
             </a:r>
           </a:p>
           <a:p xmlns:a="http://schemas.openxmlformats.org/drawingml/2006/main">
@@ -15413,7 +15498,7 @@
                 <a:ea typeface="Helvetica Neue"/>
                 <a:cs typeface="Helvetica Neue"/>
               </a:rPr>
-              <a:t>No generation model</a:t>
+              <a:t>Responses API</a:t>
             </a:r>
           </a:p>
           <a:p xmlns:a="http://schemas.openxmlformats.org/drawingml/2006/main">
@@ -15437,7 +15522,7 @@
                 <a:ea typeface="Helvetica Neue"/>
                 <a:cs typeface="Helvetica Neue"/>
               </a:rPr>
-              <a:t/>
+              <a:t>Selected sources</a:t>
             </a:r>
           </a:p>
           <a:p xmlns:a="http://schemas.openxmlformats.org/drawingml/2006/main">
@@ -15461,7 +15546,7 @@
                 <a:ea typeface="Helvetica Neue"/>
                 <a:cs typeface="Helvetica Neue"/>
               </a:rPr>
-              <a:t>Check source IDs and company</a:t>
+              <a:t>Strict checks</a:t>
             </a:r>
           </a:p>
           <a:p xmlns:a="http://schemas.openxmlformats.org/drawingml/2006/main">
@@ -15485,14 +15570,14 @@
                 <a:ea typeface="Helvetica Neue"/>
                 <a:cs typeface="Helvetica Neue"/>
               </a:rPr>
-              <a:t>Save brief and source ranks</a:t>
+              <a:t>Save or fallback</a:t>
             </a:r>
           </a:p>
         </p:txBody>
       </p:sp>
       <p:cxnSp>
         <p:nvCxnSpPr>
-          <p:cNvPr id="334" name=""/>
+          <p:cNvPr id="407" name=""/>
           <p:cNvCxnSpPr>
             <a:stCxn xmlns:a="http://schemas.openxmlformats.org/drawingml/2006/main" id="14" idx="3"/>
             <a:endCxn xmlns:a="http://schemas.openxmlformats.org/drawingml/2006/main" id="78" idx="1"/>
@@ -15518,7 +15603,7 @@
       </p:cxnSp>
       <p:cxnSp>
         <p:nvCxnSpPr>
-          <p:cNvPr id="335" name=""/>
+          <p:cNvPr id="408" name=""/>
           <p:cNvCxnSpPr>
             <a:stCxn xmlns:a="http://schemas.openxmlformats.org/drawingml/2006/main" id="78" idx="3"/>
             <a:endCxn xmlns:a="http://schemas.openxmlformats.org/drawingml/2006/main" id="17" idx="1"/>
@@ -15579,6 +15664,28 @@
           </a:ln>
         </p:spPr>
       </p:sp>
+      <p:pic>
+        <p:nvPicPr>
+          <p:cNvPr id="410" name=""/>
+          <p:cNvPicPr>
+            <a:picLocks xmlns:a="http://schemas.openxmlformats.org/drawingml/2006/main" noChangeAspect="1"/>
+          </p:cNvPicPr>
+          <p:nvPr/>
+        </p:nvPicPr>
+        <p:blipFill>
+          <a:blip xmlns:r="http://schemas.openxmlformats.org/officeDocument/2006/relationships" xmlns:a="http://schemas.openxmlformats.org/drawingml/2006/main" r:embed="R2daf070dfb6046b3"/>
+          <a:stretch xmlns:a="http://schemas.openxmlformats.org/drawingml/2006/main"/>
+        </p:blipFill>
+        <p:spPr>
+          <a:xfrm xmlns:a="http://schemas.openxmlformats.org/drawingml/2006/main">
+            <a:off x="439341" y="1476375"/>
+            <a:ext cx="11084719" cy="4667250"/>
+          </a:xfrm>
+          <a:prstGeom xmlns:a="http://schemas.openxmlformats.org/drawingml/2006/main" prst="rect">
+            <a:avLst/>
+          </a:prstGeom>
+        </p:spPr>
+      </p:pic>
     </p:spTree>
     <p:extLst>
       <p:ext uri="{BB962C8B-B14F-4D97-AF65-F5344CB8AC3E}">
@@ -18819,7 +18926,9 @@
                 <a:ea typeface="Helvetica Neue"/>
                 <a:cs typeface="Helvetica Neue"/>
               </a:rPr>
-              <a:t>Five tailored templates or one generic rule. No generation model.</a:t>
+              <a:t>gpt-5.6-sol uses retrieved evidence.
+Strict schema.
+Local fallback.</a:t>
             </a:r>
           </a:p>
         </p:txBody>
@@ -18948,7 +19057,7 @@
         </p:spPr>
         <p:txBody>
           <a:bodyPr xmlns:a="http://schemas.openxmlformats.org/drawingml/2006/main" anchor="t">
-            <a:normAutofit fontScale="100000"/>
+            <a:normAutofit fontScale="97778"/>
           </a:bodyPr>
           <a:lstStyle xmlns:a="http://schemas.openxmlformats.org/drawingml/2006/main"/>
           <a:p xmlns:a="http://schemas.openxmlformats.org/drawingml/2006/main">
@@ -18996,6 +19105,30 @@
                 <a:ea typeface="Helvetica Neue"/>
                 <a:cs typeface="Helvetica Neue"/>
               </a:rPr>
+              <a:t>Check values</a:t>
+            </a:r>
+          </a:p>
+          <a:p xmlns:a="http://schemas.openxmlformats.org/drawingml/2006/main">
+            <a:pPr algn="l">
+              <a:buNone/>
+              <a:defRPr sz="1125" b="0">
+                <a:solidFill>
+                  <a:srgbClr val="667085"/>
+                </a:solidFill>
+                <a:latin typeface="Helvetica Neue"/>
+                <a:ea typeface="Helvetica Neue"/>
+                <a:cs typeface="Helvetica Neue"/>
+              </a:defRPr>
+            </a:pPr>
+            <a:r>
+              <a:rPr sz="1125" b="0">
+                <a:solidFill>
+                  <a:srgbClr val="667085"/>
+                </a:solidFill>
+                <a:latin typeface="Helvetica Neue"/>
+                <a:ea typeface="Helvetica Neue"/>
+                <a:cs typeface="Helvetica Neue"/>
+              </a:rPr>
               <a:t>Check company isolation</a:t>
             </a:r>
           </a:p>
@@ -19020,14 +19153,14 @@
                 <a:ea typeface="Helvetica Neue"/>
                 <a:cs typeface="Helvetica Neue"/>
               </a:rPr>
-              <a:t>Save brief and source ranks</a:t>
+              <a:t>Save mode and source ranks</a:t>
             </a:r>
           </a:p>
         </p:txBody>
       </p:sp>
       <p:cxnSp>
         <p:nvCxnSpPr>
-          <p:cNvPr id="261" name=""/>
+          <p:cNvPr id="313" name=""/>
           <p:cNvCxnSpPr>
             <a:stCxn xmlns:a="http://schemas.openxmlformats.org/drawingml/2006/main" id="16" idx="3"/>
             <a:endCxn xmlns:a="http://schemas.openxmlformats.org/drawingml/2006/main" id="19" idx="1"/>
@@ -19053,7 +19186,7 @@
       </p:cxnSp>
       <p:cxnSp>
         <p:nvCxnSpPr>
-          <p:cNvPr id="262" name=""/>
+          <p:cNvPr id="314" name=""/>
           <p:cNvCxnSpPr>
             <a:stCxn xmlns:a="http://schemas.openxmlformats.org/drawingml/2006/main" id="19" idx="3"/>
             <a:endCxn xmlns:a="http://schemas.openxmlformats.org/drawingml/2006/main" id="22" idx="1"/>
@@ -19107,7 +19240,7 @@
         </p:spPr>
         <p:txBody>
           <a:bodyPr xmlns:a="http://schemas.openxmlformats.org/drawingml/2006/main" anchor="t">
-            <a:normAutofit fontScale="90196"/>
+            <a:normAutofit fontScale="86738"/>
           </a:bodyPr>
           <a:lstStyle xmlns:a="http://schemas.openxmlformats.org/drawingml/2006/main"/>
           <a:p xmlns:a="http://schemas.openxmlformats.org/drawingml/2006/main">
@@ -19131,7 +19264,7 @@
                 <a:ea typeface="Helvetica Neue"/>
                 <a:cs typeface="Helvetica Neue"/>
               </a:rPr>
-              <a:t>CURRENT V1: OpenAI query embedding, fixed query, initial weights, and a fixed date.</a:t>
+              <a:t>CURRENT V1: OpenAI embeddings, source-supported Responses generation, a fixed query, and initial weights.</a:t>
             </a:r>
           </a:p>
         </p:txBody>
@@ -19190,7 +19323,7 @@
                 <a:ea typeface="Helvetica Neue"/>
                 <a:cs typeface="Helvetica Neue"/>
               </a:rPr>
-              <a:t>TARGET: tune retrieval with reviewed questions; add gpt-5.6-sol only for grounded generation.</a:t>
+              <a:t>TARGET: tune retrieval, the prompt, and reasoning effort with reviewed questions.</a:t>
             </a:r>
           </a:p>
         </p:txBody>
@@ -19278,7 +19411,7 @@
                 <a:ea typeface="Helvetica Neue"/>
                 <a:cs typeface="Helvetica Neue"/>
               </a:rPr>
-              <a:t>Which stack runs now, and which model is the quality-first target?</a:t>
+              <a:t>Which stack generates the briefs now?</a:t>
             </a:r>
           </a:p>
         </p:txBody>
@@ -19425,7 +19558,7 @@
                 <a:ea typeface="Helvetica Neue"/>
                 <a:cs typeface="Helvetica Neue"/>
               </a:rPr>
-              <a:t>CURRENT CHOICE</a:t>
+              <a:t>RUNS NOW</a:t>
             </a:r>
           </a:p>
         </p:txBody>
@@ -19484,7 +19617,7 @@
                 <a:ea typeface="Helvetica Neue"/>
                 <a:cs typeface="Helvetica Neue"/>
               </a:rPr>
-              <a:t>WHY IT FITS V1</a:t>
+              <a:t>ROLE IN THE BRIEF</a:t>
             </a:r>
           </a:p>
         </p:txBody>
@@ -19543,7 +19676,7 @@
                 <a:ea typeface="Helvetica Neue"/>
                 <a:cs typeface="Helvetica Neue"/>
               </a:rPr>
-              <a:t>PRODUCTION TARGET</a:t>
+              <a:t>PRODUCTION HARDENING</a:t>
             </a:r>
           </a:p>
         </p:txBody>
@@ -19696,7 +19829,7 @@
                 <a:ea typeface="Helvetica Neue"/>
                 <a:cs typeface="Helvetica Neue"/>
               </a:rPr>
-              <a:t>One codebase supports the interface and server routes.</a:t>
+              <a:t>The app serves the interface, brief routes, evidence, and feedback.</a:t>
             </a:r>
           </a:p>
         </p:txBody>
@@ -19908,7 +20041,7 @@
                 <a:ea typeface="Helvetica Neue"/>
                 <a:cs typeface="Helvetica Neue"/>
               </a:rPr>
-              <a:t>One store holds facts, evidence text, embeddings, audit data, and feedback.</a:t>
+              <a:t>The store holds evidence, embeddings, brief audit data, and feedback.</a:t>
             </a:r>
           </a:p>
         </p:txBody>
@@ -20120,7 +20253,7 @@
                 <a:ea typeface="Helvetica Neue"/>
                 <a:cs typeface="Helvetica Neue"/>
               </a:rPr>
-              <a:t>The demo is repeatable and does not need source credentials.</a:t>
+              <a:t>Static fictional files make the demo repeatable without source credentials.</a:t>
             </a:r>
           </a:p>
         </p:txBody>
@@ -20273,7 +20406,7 @@
                 <a:ea typeface="Helvetica Neue"/>
                 <a:cs typeface="Helvetica Neue"/>
               </a:rPr>
-              <a:t>text-embedding-3-large and fixed brief rules</a:t>
+              <a:t>text-embedding-3-large and gpt-5.6-sol</a:t>
             </a:r>
           </a:p>
         </p:txBody>
@@ -20332,7 +20465,7 @@
                 <a:ea typeface="Helvetica Neue"/>
                 <a:cs typeface="Helvetica Neue"/>
               </a:rPr>
-              <a:t>OpenAI creates semantic embeddings. Fixed rules keep brief output repeatable.</a:t>
+              <a:t>Embeddings retrieve evidence. GPT-5.6 Sol writes the source-supported brief now.</a:t>
             </a:r>
           </a:p>
         </p:txBody>
@@ -20391,7 +20524,7 @@
                 <a:ea typeface="Helvetica Neue"/>
                 <a:cs typeface="Helvetica Neue"/>
               </a:rPr>
-              <a:t>Evaluate retrieval. Add gpt-5.6-sol only for grounded generation.</a:t>
+              <a:t>Evaluate retrieval, prompts, and model settings. Keep low effort unless a test shows a quality gain.</a:t>
             </a:r>
           </a:p>
         </p:txBody>
@@ -20479,7 +20612,7 @@
                 <a:ea typeface="Helvetica Neue"/>
                 <a:cs typeface="Helvetica Neue"/>
               </a:rPr>
-              <a:t>V1 evaluation uses eight acceptance checks</a:t>
+              <a:t>How did I test the working prototype?</a:t>
             </a:r>
           </a:p>
         </p:txBody>
@@ -20661,7 +20794,7 @@
                 <a:ea typeface="Helvetica Neue"/>
                 <a:cs typeface="Helvetica Neue"/>
               </a:rPr>
-              <a:t>PROPOSED EVALUATION SET</a:t>
+              <a:t>CURRENT RESULT</a:t>
             </a:r>
           </a:p>
         </p:txBody>
@@ -20720,7 +20853,7 @@
                 <a:ea typeface="Helvetica Neue"/>
                 <a:cs typeface="Helvetica Neue"/>
               </a:rPr>
-              <a:t>Use reviewed company questions that include confirmed facts, true conflicts, missing facts, and changed records.</a:t>
+              <a:t>91 checks pass: 69 app tests and 22 live checks. Two live GPT briefs finish in 30 seconds or less.</a:t>
             </a:r>
           </a:p>
         </p:txBody>
@@ -21144,7 +21277,7 @@
         </p:spPr>
         <p:txBody>
           <a:bodyPr xmlns:a="http://schemas.openxmlformats.org/drawingml/2006/main" anchor="t">
-            <a:normAutofit fontScale="100000"/>
+            <a:normAutofit fontScale="90128"/>
           </a:bodyPr>
           <a:lstStyle xmlns:a="http://schemas.openxmlformats.org/drawingml/2006/main"/>
           <a:p xmlns:a="http://schemas.openxmlformats.org/drawingml/2006/main">
@@ -21168,7 +21301,7 @@
                 <a:ea typeface="Helvetica Neue"/>
                 <a:cs typeface="Helvetica Neue"/>
               </a:rPr>
-              <a:t>Each claim has a source</a:t>
+              <a:t>Claim cites retrieved evidence</a:t>
             </a:r>
           </a:p>
           <a:p xmlns:a="http://schemas.openxmlformats.org/drawingml/2006/main">
@@ -21192,7 +21325,7 @@
                 <a:ea typeface="Helvetica Neue"/>
                 <a:cs typeface="Helvetica Neue"/>
               </a:rPr>
-              <a:t>Reviewer confirms support</a:t>
+              <a:t>Number matches a cited source</a:t>
             </a:r>
           </a:p>
         </p:txBody>
@@ -21380,7 +21513,7 @@
         </p:spPr>
         <p:txBody>
           <a:bodyPr xmlns:a="http://schemas.openxmlformats.org/drawingml/2006/main" anchor="t">
-            <a:normAutofit fontScale="100000"/>
+            <a:normAutofit fontScale="90884"/>
           </a:bodyPr>
           <a:lstStyle xmlns:a="http://schemas.openxmlformats.org/drawingml/2006/main"/>
           <a:p xmlns:a="http://schemas.openxmlformats.org/drawingml/2006/main">
@@ -21428,7 +21561,7 @@
                 <a:ea typeface="Helvetica Neue"/>
                 <a:cs typeface="Helvetica Neue"/>
               </a:rPr>
-              <a:t>RC score is 4 of 5 or more</a:t>
+              <a:t>Principal score is 4 of 5 or more</a:t>
             </a:r>
           </a:p>
         </p:txBody>
@@ -21616,7 +21749,7 @@
         </p:spPr>
         <p:txBody>
           <a:bodyPr xmlns:a="http://schemas.openxmlformats.org/drawingml/2006/main" anchor="t">
-            <a:normAutofit fontScale="88278"/>
+            <a:normAutofit fontScale="80597"/>
           </a:bodyPr>
           <a:lstStyle xmlns:a="http://schemas.openxmlformats.org/drawingml/2006/main"/>
           <a:p xmlns:a="http://schemas.openxmlformats.org/drawingml/2006/main">
@@ -21640,7 +21773,7 @@
                 <a:ea typeface="Helvetica Neue"/>
                 <a:cs typeface="Helvetica Neue"/>
               </a:rPr>
-              <a:t>No duplicate on repeat import</a:t>
+              <a:t>Invalid output uses fallback</a:t>
             </a:r>
           </a:p>
           <a:p xmlns:a="http://schemas.openxmlformats.org/drawingml/2006/main">
@@ -21664,7 +21797,7 @@
                 <a:ea typeface="Helvetica Neue"/>
                 <a:cs typeface="Helvetica Neue"/>
               </a:rPr>
-              <a:t>Next brief uses changed content</a:t>
+              <a:t>Changed source changes next brief</a:t>
             </a:r>
           </a:p>
         </p:txBody>
@@ -21723,7 +21856,7 @@
                 <a:ea typeface="Helvetica Neue"/>
                 <a:cs typeface="Helvetica Neue"/>
               </a:rPr>
-              <a:t>Code checks: Retrieval and Operations · Reviewer checks: Grounding and Product</a:t>
+              <a:t>Code checks: Retrieval, Grounding, and Operations · Reviewer checks: Product</a:t>
             </a:r>
           </a:p>
         </p:txBody>
@@ -21782,7 +21915,7 @@
                 <a:ea typeface="Helvetica Neue"/>
                 <a:cs typeface="Helvetica Neue"/>
               </a:rPr>
-              <a:t>Run the same set after a retrieval, embedding model, generation rule, or source-rule change.</a:t>
+              <a:t>Run the same set after a retrieval, prompt, model, schema, or source-rule change.</a:t>
             </a:r>
           </a:p>
         </p:txBody>

</xml_diff>

<commit_message>
Name the product Lens in the deck
</commit_message>
<xml_diff>
--- a/docs/AVIC-Portfolio-Intelligence-Brief.pptx
+++ b/docs/AVIC-Portfolio-Intelligence-Brief.pptx
@@ -2,25 +2,25 @@
 <file path=ppt/presentation.xml><?xml version="1.0" encoding="utf-8"?>
 <p:presentation xmlns:p="http://schemas.openxmlformats.org/presentationml/2006/main">
   <p:sldMasterIdLst>
-    <p:sldMasterId xmlns:r="http://schemas.openxmlformats.org/officeDocument/2006/relationships" id="2147483648" r:id="R28e7d875e78a450e"/>
+    <p:sldMasterId xmlns:r="http://schemas.openxmlformats.org/officeDocument/2006/relationships" id="2147483648" r:id="R88a50a33176e4852"/>
   </p:sldMasterIdLst>
   <p:notesMasterIdLst>
-    <p:notesMasterId xmlns:r="http://schemas.openxmlformats.org/officeDocument/2006/relationships" r:id="Rc51ddf0d83754fd7"/>
+    <p:notesMasterId xmlns:r="http://schemas.openxmlformats.org/officeDocument/2006/relationships" r:id="Rb58efab9cff4472b"/>
   </p:notesMasterIdLst>
   <p:sldIdLst>
-    <p:sldId xmlns:r="http://schemas.openxmlformats.org/officeDocument/2006/relationships" id="256" r:id="R80df3a4af3804efe"/>
-    <p:sldId xmlns:r="http://schemas.openxmlformats.org/officeDocument/2006/relationships" id="257" r:id="Rc085733bffde4451"/>
-    <p:sldId xmlns:r="http://schemas.openxmlformats.org/officeDocument/2006/relationships" id="258" r:id="R0e4dc282173b4bca"/>
-    <p:sldId xmlns:r="http://schemas.openxmlformats.org/officeDocument/2006/relationships" id="259" r:id="Rfebbaed3e18649f6"/>
-    <p:sldId xmlns:r="http://schemas.openxmlformats.org/officeDocument/2006/relationships" id="260" r:id="R5aaaf61f02414940"/>
-    <p:sldId xmlns:r="http://schemas.openxmlformats.org/officeDocument/2006/relationships" id="261" r:id="Rd8f4bbc746ad40c0"/>
-    <p:sldId xmlns:r="http://schemas.openxmlformats.org/officeDocument/2006/relationships" id="262" r:id="R07d035118cae4aa9"/>
-    <p:sldId xmlns:r="http://schemas.openxmlformats.org/officeDocument/2006/relationships" id="263" r:id="Rb0fd2217f5b944b1"/>
-    <p:sldId xmlns:r="http://schemas.openxmlformats.org/officeDocument/2006/relationships" id="264" r:id="R90dcd2d281cf4823"/>
-    <p:sldId xmlns:r="http://schemas.openxmlformats.org/officeDocument/2006/relationships" id="265" r:id="Rb3997c55670741d6"/>
-    <p:sldId xmlns:r="http://schemas.openxmlformats.org/officeDocument/2006/relationships" id="266" r:id="R0a06857624b34db2"/>
-    <p:sldId xmlns:r="http://schemas.openxmlformats.org/officeDocument/2006/relationships" id="267" r:id="R2d5aa8a29f8b4d52"/>
-    <p:sldId xmlns:r="http://schemas.openxmlformats.org/officeDocument/2006/relationships" id="268" r:id="Rc05ab1eed37c4a5d"/>
+    <p:sldId xmlns:r="http://schemas.openxmlformats.org/officeDocument/2006/relationships" id="256" r:id="R1372511d332c48e4"/>
+    <p:sldId xmlns:r="http://schemas.openxmlformats.org/officeDocument/2006/relationships" id="257" r:id="Ra864fdb52707442b"/>
+    <p:sldId xmlns:r="http://schemas.openxmlformats.org/officeDocument/2006/relationships" id="258" r:id="Rcec8a628e68f44bc"/>
+    <p:sldId xmlns:r="http://schemas.openxmlformats.org/officeDocument/2006/relationships" id="259" r:id="R3559208efc5d4203"/>
+    <p:sldId xmlns:r="http://schemas.openxmlformats.org/officeDocument/2006/relationships" id="260" r:id="Re4f7be25bdf74e92"/>
+    <p:sldId xmlns:r="http://schemas.openxmlformats.org/officeDocument/2006/relationships" id="261" r:id="Rf8bfd2e02f104e5f"/>
+    <p:sldId xmlns:r="http://schemas.openxmlformats.org/officeDocument/2006/relationships" id="262" r:id="R71a33f3fb7df49ee"/>
+    <p:sldId xmlns:r="http://schemas.openxmlformats.org/officeDocument/2006/relationships" id="263" r:id="Rfef7b1c65c3f432e"/>
+    <p:sldId xmlns:r="http://schemas.openxmlformats.org/officeDocument/2006/relationships" id="264" r:id="R003a7ea81aca4c72"/>
+    <p:sldId xmlns:r="http://schemas.openxmlformats.org/officeDocument/2006/relationships" id="265" r:id="R2ab191b14c3c41f7"/>
+    <p:sldId xmlns:r="http://schemas.openxmlformats.org/officeDocument/2006/relationships" id="266" r:id="R8bbf83dfbc1945a4"/>
+    <p:sldId xmlns:r="http://schemas.openxmlformats.org/officeDocument/2006/relationships" id="267" r:id="Rc9de37b2fbf246a4"/>
+    <p:sldId xmlns:r="http://schemas.openxmlformats.org/officeDocument/2006/relationships" id="268" r:id="Rb898ac1c3337492a"/>
   </p:sldIdLst>
   <p:sldSz cx="12192000" cy="6858000"/>
   <p:notesSz cx="6858000" cy="9144000"/>
@@ -454,7 +454,7 @@
           <a:lstStyle xmlns:a="http://schemas.openxmlformats.org/drawingml/2006/main"/>
           <a:p xmlns:a="http://schemas.openxmlformats.org/drawingml/2006/main">
             <a:r>
-              <a:t>Open with the answer: AVIC is a working local prototype that builds a company brief from imported evidence. Production freshness and access control are not part of this build.</a:t>
+              <a:t>Open with the answer: Lens is a working local prototype that builds a company brief from imported evidence. Production freshness and access control are not part of this build.</a:t>
             </a:r>
           </a:p>
           <a:p xmlns:a="http://schemas.openxmlformats.org/drawingml/2006/main">
@@ -654,7 +654,7 @@
           <a:lstStyle xmlns:a="http://schemas.openxmlformats.org/drawingml/2006/main"/>
           <a:p xmlns:a="http://schemas.openxmlformats.org/drawingml/2006/main">
             <a:r>
-              <a:t>This slide defines the current boundary. The app implements the interface, API routes, file import, PostgreSQL storage, OpenAI embeddings, company-scoped retrieval, source-supported generation with gpt-5.6-sol, strict checks, source drill-down, local fallback, saved generation audit data, and feedback capture. It uses 10 fictional companies, static source files, a local database, and a fixed reference date. The OpenAI request contains selected fictional text only. It excludes raw JSON, source locators, access metadata, and records for unrelated companies. Live connectors, public filings, sign-in, source access enforcement, schedules, webhooks, and a reviewer screen are not active.</a:t>
+              <a:t>This slide defines the current Lens boundary. The app implements the interface, API routes, file import, PostgreSQL storage, OpenAI embeddings, company-scoped retrieval, source-supported generation with gpt-5.6-sol, strict checks, source drill-down, local fallback, saved generation audit data, and feedback capture. It uses 10 fictional companies, static source files, a local database, and a fixed reference date. The OpenAI request contains selected fictional text only. It excludes raw JSON, source locators, access metadata, and records for unrelated companies. Live connectors, public filings, sign-in, source access enforcement, schedules, webhooks, and a reviewer screen are not active.</a:t>
             </a:r>
           </a:p>
           <a:p xmlns:a="http://schemas.openxmlformats.org/drawingml/2006/main">
@@ -1214,7 +1214,7 @@
           <a:lstStyle xmlns:a="http://schemas.openxmlformats.org/drawingml/2006/main"/>
           <a:p xmlns:a="http://schemas.openxmlformats.org/drawingml/2006/main">
             <a:r>
-              <a:t>The working prototype is an internal company-intelligence interface. It uses 10 fictional companies and 59 fictional source records. Two companies represent the portfolio. Eight companies represent the pipeline. The app imports static CRM, meeting, Slack, and news files. It creates OpenAI embeddings, stores evidence in PostgreSQL, retrieves evidence for one company, and uses gpt-5.6-sol to create a source-supported brief. The principal can open the evidence and original record for each statement and can send feedback. The prototype has no live connectors and gives no investment recommendation.</a:t>
+              <a:t>Lens is an internal company-intelligence interface. It uses 10 fictional companies and 59 fictional source records. Two companies represent the portfolio. Eight companies represent the pipeline. The app imports static CRM, meeting, Slack, and news files. It creates OpenAI embeddings, stores evidence in PostgreSQL, retrieves evidence for one company, and uses gpt-5.6-sol to create a source-supported brief. The principal can open the evidence and original record for each statement and can send feedback. The prototype has no live connectors and gives no investment recommendation.</a:t>
             </a:r>
           </a:p>
           <a:p xmlns:a="http://schemas.openxmlformats.org/drawingml/2006/main">
@@ -1324,7 +1324,7 @@
           <a:lstStyle xmlns:a="http://schemas.openxmlformats.org/drawingml/2006/main"/>
           <a:p xmlns:a="http://schemas.openxmlformats.org/drawingml/2006/main">
             <a:r>
-              <a:t>The file import validates each company ID, keeps the source record, calculates checksums, creates chunks, and sends fictional normalized chunk text to the OpenAI Embeddings API. PostgreSQL stores the returned embeddings. A brief request creates one query embedding. SQL filters by company and ranks up to 30 source records. The server sends only the selected company metadata and retrieved evidence to gpt-5.6-sol through the Responses API. It requests a strict schema with low reasoning effort, no tools, and no response storage. A 27-second model timeout and a 29-second request budget have no automatic retry. The server checks source IDs, company isolation, exact source quotes, typed values, qualitative support, source status, and investment safety. It saves the brief, generation mode, model data, and source ranks. If generation fails a check or exceeds the budget, local rules create a source-supported fallback. The app does not call a source system during a brief request.</a:t>
+              <a:t>The file import validates each company ID, keeps the source record, calculates checksums, creates chunks, and sends fictional normalized chunk text to the OpenAI Embeddings API. PostgreSQL stores the returned embeddings. A brief request creates one query embedding. SQL filters by company and ranks up to 30 source records. The server sends only the selected company metadata and retrieved evidence to gpt-5.6-sol through the Responses API. It requests a strict schema with low reasoning effort, no tools, and no response storage. A 27-second model timeout and a 29-second request budget have no automatic retry. The server checks source IDs, company isolation, exact source quotes, typed values, qualitative support, source status, and investment safety. It saves the brief, generation mode, model data, and source ranks. If generation fails a check or exceeds the budget, local rules create a source-supported fallback. The app does not call a source system during a brief request. V1 does not watch a folder or Slack. To add a demo record, add it in a supported format, run the import route or the data import command, and select Refresh Brief. The importer reuses unchanged embeddings and embeds only new or changed chunks. A Slack thread must be added to the Slack JSON file with a known company ID.</a:t>
             </a:r>
           </a:p>
           <a:p xmlns:a="http://schemas.openxmlformats.org/drawingml/2006/main">
@@ -1932,7 +1932,7 @@
   </p:cSld>
   <p:clrMap bg1="lt1" tx1="dk1" bg2="lt2" tx2="dk2" accent1="accent1" accent2="accent2" accent3="accent3" accent4="accent4" accent5="accent5" accent6="accent6" hlink="hlink" folHlink="folHlink"/>
   <p:sldLayoutIdLst>
-    <p:sldLayoutId xmlns:r="http://schemas.openxmlformats.org/officeDocument/2006/relationships" id="2147483649" r:id="R694b0c3947ac4262"/>
+    <p:sldLayoutId xmlns:r="http://schemas.openxmlformats.org/officeDocument/2006/relationships" id="2147483649" r:id="R4749e594489245b8"/>
   </p:sldLayoutIdLst>
   <p:txStyles>
     <p:titleStyle>
@@ -2626,7 +2626,7 @@
                 <a:ea typeface="Helvetica Neue"/>
                 <a:cs typeface="Helvetica Neue"/>
               </a:rPr>
-              <a:t>AVIC</a:t>
+              <a:t>Lens</a:t>
             </a:r>
           </a:p>
           <a:p xmlns:a="http://schemas.openxmlformats.org/drawingml/2006/main">
@@ -2650,7 +2650,7 @@
                 <a:ea typeface="Helvetica Neue"/>
                 <a:cs typeface="Helvetica Neue"/>
               </a:rPr>
-              <a:t>Portfolio intelligence for AIVC</a:t>
+              <a:t>Company intelligence for AIVC</a:t>
             </a:r>
           </a:p>
         </p:txBody>
@@ -2915,7 +2915,7 @@
                 <a:ea typeface="Helvetica Neue"/>
                 <a:cs typeface="Helvetica Neue"/>
               </a:rPr>
-              <a:t>AVIC</a:t>
+              <a:t>Lens</a:t>
             </a:r>
           </a:p>
         </p:txBody>
@@ -4298,7 +4298,7 @@
                 <a:ea typeface="Helvetica Neue"/>
                 <a:cs typeface="Helvetica Neue"/>
               </a:rPr>
-              <a:t>What runs today, and what is planned?</a:t>
+              <a:t>What runs in Lens today, and what is planned?</a:t>
             </a:r>
           </a:p>
         </p:txBody>
@@ -4855,7 +4855,7 @@
                 <a:ea typeface="Helvetica Neue"/>
                 <a:cs typeface="Helvetica Neue"/>
               </a:rPr>
-              <a:t>PostgreSQL schema and file import</a:t>
+              <a:t>PostgreSQL schema and manual file import</a:t>
             </a:r>
           </a:p>
         </p:txBody>
@@ -6155,7 +6155,7 @@
                 <a:ea typeface="Helvetica Neue"/>
                 <a:cs typeface="Helvetica Neue"/>
               </a:rPr>
-              <a:t>Deterministic templates remain as the failure fallback</a:t>
+              <a:t>Source-supported local rules remain as the failure fallback</a:t>
             </a:r>
           </a:p>
         </p:txBody>
@@ -6507,7 +6507,7 @@
         </p:spPr>
         <p:txBody>
           <a:bodyPr xmlns:a="http://schemas.openxmlformats.org/drawingml/2006/main" anchor="t">
-            <a:normAutofit fontScale="100000"/>
+            <a:normAutofit fontScale="97015"/>
           </a:bodyPr>
           <a:lstStyle xmlns:a="http://schemas.openxmlformats.org/drawingml/2006/main"/>
           <a:p xmlns:a="http://schemas.openxmlformats.org/drawingml/2006/main">
@@ -6531,7 +6531,7 @@
                 <a:ea typeface="Helvetica Neue"/>
                 <a:cs typeface="Helvetica Neue"/>
               </a:rPr>
-              <a:t>No live connectors or public-filings adapter</a:t>
+              <a:t>No automatic source watcher, live connectors, or filings adapter</a:t>
             </a:r>
           </a:p>
         </p:txBody>
@@ -9671,7 +9671,7 @@
                 <a:ea typeface="Helvetica Neue"/>
                 <a:cs typeface="Helvetica Neue"/>
               </a:rPr>
-              <a:t>What job is AVIC replacing?</a:t>
+              <a:t>What job does Lens replace?</a:t>
             </a:r>
           </a:p>
         </p:txBody>
@@ -10612,7 +10612,7 @@
                 <a:ea typeface="Helvetica Neue"/>
                 <a:cs typeface="Helvetica Neue"/>
               </a:rPr>
-              <a:t>AVIC organizes evidence. The AIVC principal keeps the investment judgment.</a:t>
+              <a:t>Lens organizes evidence. The AIVC principal keeps the investment judgment.</a:t>
             </a:r>
           </a:p>
         </p:txBody>
@@ -10700,7 +10700,7 @@
                 <a:ea typeface="Helvetica Neue"/>
                 <a:cs typeface="Helvetica Neue"/>
               </a:rPr>
-              <a:t>What does the working prototype let an AIVC principal do?</a:t>
+              <a:t>What does Lens let an AIVC principal do?</a:t>
             </a:r>
           </a:p>
         </p:txBody>
@@ -11746,7 +11746,7 @@
           <p:nvPr/>
         </p:nvPicPr>
         <p:blipFill>
-          <a:blip xmlns:r="http://schemas.openxmlformats.org/officeDocument/2006/relationships" xmlns:a="http://schemas.openxmlformats.org/drawingml/2006/main" r:embed="R2ebf4d9526ec427f"/>
+          <a:blip xmlns:r="http://schemas.openxmlformats.org/officeDocument/2006/relationships" xmlns:a="http://schemas.openxmlformats.org/drawingml/2006/main" r:embed="Rb94da86ce9544af9"/>
           <a:stretch xmlns:a="http://schemas.openxmlformats.org/drawingml/2006/main"/>
         </p:blipFill>
         <p:spPr>
@@ -11844,7 +11844,7 @@
                 <a:ea typeface="Helvetica Neue"/>
                 <a:cs typeface="Helvetica Neue"/>
               </a:rPr>
-              <a:t>What is the working prototype?</a:t>
+              <a:t>What is Lens?</a:t>
             </a:r>
           </a:p>
         </p:txBody>
@@ -13441,7 +13441,7 @@
                 <a:ea typeface="Helvetica Neue"/>
                 <a:cs typeface="Helvetica Neue"/>
               </a:rPr>
-              <a:t>How does the system work end to end?</a:t>
+              <a:t>How does Lens work end to end?</a:t>
             </a:r>
           </a:p>
         </p:txBody>
@@ -13588,7 +13588,7 @@
                 <a:ea typeface="Helvetica Neue"/>
                 <a:cs typeface="Helvetica Neue"/>
               </a:rPr>
-              <a:t>OpenAI creates embeddings and source-supported briefs. The app does not call a source system at request time.</a:t>
+              <a:t>Import reads new or changed demo records. Refresh Brief retrieves them and writes a new brief. There is no live source watcher.</a:t>
             </a:r>
           </a:p>
         </p:txBody>
@@ -14850,7 +14850,7 @@
       </p:sp>
       <p:cxnSp>
         <p:nvCxnSpPr>
-          <p:cNvPr id="392" name=""/>
+          <p:cNvPr id="429" name=""/>
           <p:cNvCxnSpPr>
             <a:stCxn xmlns:a="http://schemas.openxmlformats.org/drawingml/2006/main" id="5" idx="3"/>
             <a:endCxn xmlns:a="http://schemas.openxmlformats.org/drawingml/2006/main" id="8" idx="1"/>
@@ -14876,7 +14876,7 @@
       </p:cxnSp>
       <p:cxnSp>
         <p:nvCxnSpPr>
-          <p:cNvPr id="393" name=""/>
+          <p:cNvPr id="430" name=""/>
           <p:cNvCxnSpPr>
             <a:stCxn xmlns:a="http://schemas.openxmlformats.org/drawingml/2006/main" id="8" idx="3"/>
             <a:endCxn xmlns:a="http://schemas.openxmlformats.org/drawingml/2006/main" id="11" idx="1"/>
@@ -14902,7 +14902,7 @@
       </p:cxnSp>
       <p:cxnSp>
         <p:nvCxnSpPr>
-          <p:cNvPr id="394" name=""/>
+          <p:cNvPr id="431" name=""/>
           <p:cNvCxnSpPr>
             <a:stCxn xmlns:a="http://schemas.openxmlformats.org/drawingml/2006/main" id="11" idx="3"/>
             <a:endCxn xmlns:a="http://schemas.openxmlformats.org/drawingml/2006/main" id="14" idx="1"/>
@@ -14928,7 +14928,7 @@
       </p:cxnSp>
       <p:cxnSp>
         <p:nvCxnSpPr>
-          <p:cNvPr id="395" name=""/>
+          <p:cNvPr id="432" name=""/>
           <p:cNvCxnSpPr>
             <a:stCxn xmlns:a="http://schemas.openxmlformats.org/drawingml/2006/main" id="14" idx="3"/>
             <a:endCxn xmlns:a="http://schemas.openxmlformats.org/drawingml/2006/main" id="17" idx="1"/>
@@ -15577,7 +15577,7 @@
       </p:sp>
       <p:cxnSp>
         <p:nvCxnSpPr>
-          <p:cNvPr id="407" name=""/>
+          <p:cNvPr id="444" name=""/>
           <p:cNvCxnSpPr>
             <a:stCxn xmlns:a="http://schemas.openxmlformats.org/drawingml/2006/main" id="14" idx="3"/>
             <a:endCxn xmlns:a="http://schemas.openxmlformats.org/drawingml/2006/main" id="78" idx="1"/>
@@ -15603,7 +15603,7 @@
       </p:cxnSp>
       <p:cxnSp>
         <p:nvCxnSpPr>
-          <p:cNvPr id="408" name=""/>
+          <p:cNvPr id="445" name=""/>
           <p:cNvCxnSpPr>
             <a:stCxn xmlns:a="http://schemas.openxmlformats.org/drawingml/2006/main" id="78" idx="3"/>
             <a:endCxn xmlns:a="http://schemas.openxmlformats.org/drawingml/2006/main" id="17" idx="1"/>
@@ -15666,14 +15666,14 @@
       </p:sp>
       <p:pic>
         <p:nvPicPr>
-          <p:cNvPr id="410" name=""/>
+          <p:cNvPr id="447" name=""/>
           <p:cNvPicPr>
             <a:picLocks xmlns:a="http://schemas.openxmlformats.org/drawingml/2006/main" noChangeAspect="1"/>
           </p:cNvPicPr>
           <p:nvPr/>
         </p:nvPicPr>
         <p:blipFill>
-          <a:blip xmlns:r="http://schemas.openxmlformats.org/officeDocument/2006/relationships" xmlns:a="http://schemas.openxmlformats.org/drawingml/2006/main" r:embed="R2daf070dfb6046b3"/>
+          <a:blip xmlns:r="http://schemas.openxmlformats.org/officeDocument/2006/relationships" xmlns:a="http://schemas.openxmlformats.org/drawingml/2006/main" r:embed="Ra80e808e43054a71"/>
           <a:stretch xmlns:a="http://schemas.openxmlformats.org/drawingml/2006/main"/>
         </p:blipFill>
         <p:spPr>
@@ -17948,7 +17948,7 @@
                 <a:ea typeface="Helvetica Neue"/>
                 <a:cs typeface="Helvetica Neue"/>
               </a:rPr>
-              <a:t>How does the current app retrieve and write the brief?</a:t>
+              <a:t>How does Lens retrieve and write the brief?</a:t>
             </a:r>
           </a:p>
         </p:txBody>
@@ -19160,7 +19160,7 @@
       </p:sp>
       <p:cxnSp>
         <p:nvCxnSpPr>
-          <p:cNvPr id="313" name=""/>
+          <p:cNvPr id="339" name=""/>
           <p:cNvCxnSpPr>
             <a:stCxn xmlns:a="http://schemas.openxmlformats.org/drawingml/2006/main" id="16" idx="3"/>
             <a:endCxn xmlns:a="http://schemas.openxmlformats.org/drawingml/2006/main" id="19" idx="1"/>
@@ -19186,7 +19186,7 @@
       </p:cxnSp>
       <p:cxnSp>
         <p:nvCxnSpPr>
-          <p:cNvPr id="314" name=""/>
+          <p:cNvPr id="340" name=""/>
           <p:cNvCxnSpPr>
             <a:stCxn xmlns:a="http://schemas.openxmlformats.org/drawingml/2006/main" id="19" idx="3"/>
             <a:endCxn xmlns:a="http://schemas.openxmlformats.org/drawingml/2006/main" id="22" idx="1"/>
@@ -19240,7 +19240,7 @@
         </p:spPr>
         <p:txBody>
           <a:bodyPr xmlns:a="http://schemas.openxmlformats.org/drawingml/2006/main" anchor="t">
-            <a:normAutofit fontScale="86738"/>
+            <a:normAutofit fontScale="90196"/>
           </a:bodyPr>
           <a:lstStyle xmlns:a="http://schemas.openxmlformats.org/drawingml/2006/main"/>
           <a:p xmlns:a="http://schemas.openxmlformats.org/drawingml/2006/main">
@@ -19264,7 +19264,7 @@
                 <a:ea typeface="Helvetica Neue"/>
                 <a:cs typeface="Helvetica Neue"/>
               </a:rPr>
-              <a:t>CURRENT V1: OpenAI embeddings, source-supported Responses generation, a fixed query, and initial weights.</a:t>
+              <a:t>LENS V1: OpenAI embeddings, source-supported Responses generation, a fixed query, and initial weights.</a:t>
             </a:r>
           </a:p>
         </p:txBody>
@@ -19411,7 +19411,7 @@
                 <a:ea typeface="Helvetica Neue"/>
                 <a:cs typeface="Helvetica Neue"/>
               </a:rPr>
-              <a:t>Which stack generates the briefs now?</a:t>
+              <a:t>Which stack runs Lens today?</a:t>
             </a:r>
           </a:p>
         </p:txBody>
@@ -20612,7 +20612,7 @@
                 <a:ea typeface="Helvetica Neue"/>
                 <a:cs typeface="Helvetica Neue"/>
               </a:rPr>
-              <a:t>How did I test the working prototype?</a:t>
+              <a:t>How did I test Lens?</a:t>
             </a:r>
           </a:p>
         </p:txBody>

</xml_diff>

<commit_message>
Focus the stack slide on the current system
</commit_message>
<xml_diff>
--- a/docs/AVIC-Portfolio-Intelligence-Brief.pptx
+++ b/docs/AVIC-Portfolio-Intelligence-Brief.pptx
@@ -2,23 +2,23 @@
 <file path=ppt/presentation.xml><?xml version="1.0" encoding="utf-8"?>
 <p:presentation xmlns:p="http://schemas.openxmlformats.org/presentationml/2006/main">
   <p:sldMasterIdLst>
-    <p:sldMasterId xmlns:r="http://schemas.openxmlformats.org/officeDocument/2006/relationships" id="2147483648" r:id="Re0868600ead34373"/>
+    <p:sldMasterId xmlns:r="http://schemas.openxmlformats.org/officeDocument/2006/relationships" id="2147483648" r:id="R6397e53850d24f14"/>
   </p:sldMasterIdLst>
   <p:notesMasterIdLst>
-    <p:notesMasterId xmlns:r="http://schemas.openxmlformats.org/officeDocument/2006/relationships" r:id="R576d7dc289104efb"/>
+    <p:notesMasterId xmlns:r="http://schemas.openxmlformats.org/officeDocument/2006/relationships" r:id="R0fba8331acd3456e"/>
   </p:notesMasterIdLst>
   <p:sldIdLst>
-    <p:sldId xmlns:r="http://schemas.openxmlformats.org/officeDocument/2006/relationships" id="256" r:id="R872a6917c71b41fa"/>
-    <p:sldId xmlns:r="http://schemas.openxmlformats.org/officeDocument/2006/relationships" id="257" r:id="R881c4d487f934cb7"/>
-    <p:sldId xmlns:r="http://schemas.openxmlformats.org/officeDocument/2006/relationships" id="258" r:id="R3c5041ed86df4415"/>
-    <p:sldId xmlns:r="http://schemas.openxmlformats.org/officeDocument/2006/relationships" id="259" r:id="Rc4657ce04d094a3c"/>
-    <p:sldId xmlns:r="http://schemas.openxmlformats.org/officeDocument/2006/relationships" id="260" r:id="Ra62dddc77eb94664"/>
-    <p:sldId xmlns:r="http://schemas.openxmlformats.org/officeDocument/2006/relationships" id="261" r:id="R8275c9b4934a4cd3"/>
-    <p:sldId xmlns:r="http://schemas.openxmlformats.org/officeDocument/2006/relationships" id="262" r:id="R718b4475a91247bd"/>
-    <p:sldId xmlns:r="http://schemas.openxmlformats.org/officeDocument/2006/relationships" id="263" r:id="R0f31c833c054498f"/>
-    <p:sldId xmlns:r="http://schemas.openxmlformats.org/officeDocument/2006/relationships" id="264" r:id="Rb4943ef13f1f4096"/>
-    <p:sldId xmlns:r="http://schemas.openxmlformats.org/officeDocument/2006/relationships" id="265" r:id="R8be9617bb7b342c9"/>
-    <p:sldId xmlns:r="http://schemas.openxmlformats.org/officeDocument/2006/relationships" id="266" r:id="R1fd0dd78788d4d44"/>
+    <p:sldId xmlns:r="http://schemas.openxmlformats.org/officeDocument/2006/relationships" id="256" r:id="R8f6d8264f5454b44"/>
+    <p:sldId xmlns:r="http://schemas.openxmlformats.org/officeDocument/2006/relationships" id="257" r:id="Rc1fe31f04f954d2a"/>
+    <p:sldId xmlns:r="http://schemas.openxmlformats.org/officeDocument/2006/relationships" id="258" r:id="Rda442934642e4598"/>
+    <p:sldId xmlns:r="http://schemas.openxmlformats.org/officeDocument/2006/relationships" id="259" r:id="Rd9a6adf44306461b"/>
+    <p:sldId xmlns:r="http://schemas.openxmlformats.org/officeDocument/2006/relationships" id="260" r:id="R8710ee47edd248ab"/>
+    <p:sldId xmlns:r="http://schemas.openxmlformats.org/officeDocument/2006/relationships" id="261" r:id="R614aabe5e8d442d9"/>
+    <p:sldId xmlns:r="http://schemas.openxmlformats.org/officeDocument/2006/relationships" id="262" r:id="Rb11f5a3e61fc4ff6"/>
+    <p:sldId xmlns:r="http://schemas.openxmlformats.org/officeDocument/2006/relationships" id="263" r:id="R1d34bfaafb4e4066"/>
+    <p:sldId xmlns:r="http://schemas.openxmlformats.org/officeDocument/2006/relationships" id="264" r:id="R5b8ddfc1dfd54fcd"/>
+    <p:sldId xmlns:r="http://schemas.openxmlformats.org/officeDocument/2006/relationships" id="265" r:id="Rd565366f6d3c4927"/>
+    <p:sldId xmlns:r="http://schemas.openxmlformats.org/officeDocument/2006/relationships" id="266" r:id="R78a920d42fee4373"/>
   </p:sldIdLst>
   <p:sldSz cx="12192000" cy="6858000"/>
   <p:notesSz cx="6858000" cy="9144000"/>
@@ -1715,7 +1715,7 @@
   </p:cSld>
   <p:clrMap bg1="lt1" tx1="dk1" bg2="lt2" tx2="dk2" accent1="accent1" accent2="accent2" accent3="accent3" accent4="accent4" accent5="accent5" accent6="accent6" hlink="hlink" folHlink="folHlink"/>
   <p:sldLayoutIdLst>
-    <p:sldLayoutId xmlns:r="http://schemas.openxmlformats.org/officeDocument/2006/relationships" id="2147483649" r:id="Rc1d236053e1a4f85"/>
+    <p:sldLayoutId xmlns:r="http://schemas.openxmlformats.org/officeDocument/2006/relationships" id="2147483649" r:id="Rab9c785ff53b48de"/>
   </p:sldLayoutIdLst>
   <p:txStyles>
     <p:titleStyle>
@@ -7760,7 +7760,7 @@
           <p:nvPr/>
         </p:nvPicPr>
         <p:blipFill>
-          <a:blip xmlns:r="http://schemas.openxmlformats.org/officeDocument/2006/relationships" xmlns:a="http://schemas.openxmlformats.org/drawingml/2006/main" r:embed="Ra57d55140a23493d"/>
+          <a:blip xmlns:r="http://schemas.openxmlformats.org/officeDocument/2006/relationships" xmlns:a="http://schemas.openxmlformats.org/drawingml/2006/main" r:embed="R2cff69eb9a9d4181"/>
           <a:stretch xmlns:a="http://schemas.openxmlformats.org/drawingml/2006/main"/>
         </p:blipFill>
         <p:spPr>
@@ -9267,7 +9267,7 @@
       </p:sp>
       <p:cxnSp>
         <p:nvCxnSpPr>
-          <p:cNvPr id="577" name=""/>
+          <p:cNvPr id="651" name=""/>
           <p:cNvCxnSpPr>
             <a:stCxn xmlns:a="http://schemas.openxmlformats.org/drawingml/2006/main" id="5" idx="3"/>
             <a:endCxn xmlns:a="http://schemas.openxmlformats.org/drawingml/2006/main" id="8" idx="1"/>
@@ -9293,7 +9293,7 @@
       </p:cxnSp>
       <p:cxnSp>
         <p:nvCxnSpPr>
-          <p:cNvPr id="578" name=""/>
+          <p:cNvPr id="652" name=""/>
           <p:cNvCxnSpPr>
             <a:stCxn xmlns:a="http://schemas.openxmlformats.org/drawingml/2006/main" id="8" idx="3"/>
             <a:endCxn xmlns:a="http://schemas.openxmlformats.org/drawingml/2006/main" id="11" idx="1"/>
@@ -9319,7 +9319,7 @@
       </p:cxnSp>
       <p:cxnSp>
         <p:nvCxnSpPr>
-          <p:cNvPr id="579" name=""/>
+          <p:cNvPr id="653" name=""/>
           <p:cNvCxnSpPr>
             <a:stCxn xmlns:a="http://schemas.openxmlformats.org/drawingml/2006/main" id="11" idx="3"/>
             <a:endCxn xmlns:a="http://schemas.openxmlformats.org/drawingml/2006/main" id="14" idx="1"/>
@@ -9345,7 +9345,7 @@
       </p:cxnSp>
       <p:cxnSp>
         <p:nvCxnSpPr>
-          <p:cNvPr id="580" name=""/>
+          <p:cNvPr id="654" name=""/>
           <p:cNvCxnSpPr>
             <a:stCxn xmlns:a="http://schemas.openxmlformats.org/drawingml/2006/main" id="14" idx="3"/>
             <a:endCxn xmlns:a="http://schemas.openxmlformats.org/drawingml/2006/main" id="17" idx="1"/>
@@ -9994,7 +9994,7 @@
       </p:sp>
       <p:cxnSp>
         <p:nvCxnSpPr>
-          <p:cNvPr id="592" name=""/>
+          <p:cNvPr id="666" name=""/>
           <p:cNvCxnSpPr>
             <a:stCxn xmlns:a="http://schemas.openxmlformats.org/drawingml/2006/main" id="14" idx="3"/>
             <a:endCxn xmlns:a="http://schemas.openxmlformats.org/drawingml/2006/main" id="78" idx="1"/>
@@ -10020,7 +10020,7 @@
       </p:cxnSp>
       <p:cxnSp>
         <p:nvCxnSpPr>
-          <p:cNvPr id="593" name=""/>
+          <p:cNvPr id="667" name=""/>
           <p:cNvCxnSpPr>
             <a:stCxn xmlns:a="http://schemas.openxmlformats.org/drawingml/2006/main" id="78" idx="3"/>
             <a:endCxn xmlns:a="http://schemas.openxmlformats.org/drawingml/2006/main" id="17" idx="1"/>
@@ -10083,14 +10083,14 @@
       </p:sp>
       <p:pic>
         <p:nvPicPr>
-          <p:cNvPr id="595" name=""/>
+          <p:cNvPr id="669" name=""/>
           <p:cNvPicPr>
             <a:picLocks xmlns:a="http://schemas.openxmlformats.org/drawingml/2006/main" noChangeAspect="1"/>
           </p:cNvPicPr>
           <p:nvPr/>
         </p:nvPicPr>
         <p:blipFill>
-          <a:blip xmlns:r="http://schemas.openxmlformats.org/officeDocument/2006/relationships" xmlns:a="http://schemas.openxmlformats.org/drawingml/2006/main" r:embed="Rc9fefb31f0a64bae"/>
+          <a:blip xmlns:r="http://schemas.openxmlformats.org/officeDocument/2006/relationships" xmlns:a="http://schemas.openxmlformats.org/drawingml/2006/main" r:embed="Rbb742f6ece3b412e"/>
           <a:stretch xmlns:a="http://schemas.openxmlformats.org/drawingml/2006/main"/>
         </p:blipFill>
         <p:spPr>
@@ -11372,7 +11372,7 @@
       </p:sp>
       <p:cxnSp>
         <p:nvCxnSpPr>
-          <p:cNvPr id="443" name=""/>
+          <p:cNvPr id="495" name=""/>
           <p:cNvCxnSpPr>
             <a:stCxn xmlns:a="http://schemas.openxmlformats.org/drawingml/2006/main" id="16" idx="3"/>
             <a:endCxn xmlns:a="http://schemas.openxmlformats.org/drawingml/2006/main" id="19" idx="1"/>
@@ -11398,7 +11398,7 @@
       </p:cxnSp>
       <p:cxnSp>
         <p:nvCxnSpPr>
-          <p:cNvPr id="444" name=""/>
+          <p:cNvPr id="496" name=""/>
           <p:cNvCxnSpPr>
             <a:stCxn xmlns:a="http://schemas.openxmlformats.org/drawingml/2006/main" id="19" idx="3"/>
             <a:endCxn xmlns:a="http://schemas.openxmlformats.org/drawingml/2006/main" id="22" idx="1"/>
@@ -11770,7 +11770,7 @@
                 <a:ea typeface="Helvetica Neue"/>
                 <a:cs typeface="Helvetica Neue"/>
               </a:rPr>
-              <a:t>RUNS NOW</a:t>
+              <a:t>TECHNOLOGY</a:t>
             </a:r>
           </a:p>
         </p:txBody>
@@ -11792,7 +11792,7 @@
         <p:spPr>
           <a:xfrm xmlns:a="http://schemas.openxmlformats.org/drawingml/2006/main">
             <a:off x="3333750" y="1466850"/>
-            <a:ext cx="3238500" cy="209550"/>
+            <a:ext cx="7981950" cy="209550"/>
           </a:xfrm>
           <a:prstGeom xmlns:a="http://schemas.openxmlformats.org/drawingml/2006/main" prst="rect">
             <a:avLst/>
@@ -11829,66 +11829,7 @@
                 <a:ea typeface="Helvetica Neue"/>
                 <a:cs typeface="Helvetica Neue"/>
               </a:rPr>
-              <a:t>ROLE IN THE BRIEF</a:t>
-            </a:r>
-          </a:p>
-        </p:txBody>
-      </p:sp>
-      <p:sp>
-        <p:nvSpPr>
-          <p:cNvPr id="6" name="">
-            <a:extLst xmlns:a="http://schemas.openxmlformats.org/drawingml/2006/main">
-              <a:ext uri="{FF2B5EF4-FFF2-40B4-BE49-F238E27FC236}">
-                <a16:creationId xmlns:a16="http://schemas.microsoft.com/office/drawing/2014/main" id="{B98364E2-4CA2-464C-B7ED-DF6E422AB2EF}"/>
-              </a:ext>
-            </a:extLst>
-          </p:cNvPr>
-          <p:cNvSpPr>
-            <a:spLocks xmlns:a="http://schemas.openxmlformats.org/drawingml/2006/main" noGrp="1"/>
-          </p:cNvSpPr>
-          <p:nvPr/>
-        </p:nvSpPr>
-        <p:spPr>
-          <a:xfrm xmlns:a="http://schemas.openxmlformats.org/drawingml/2006/main">
-            <a:off x="7067550" y="1466850"/>
-            <a:ext cx="4248150" cy="209550"/>
-          </a:xfrm>
-          <a:prstGeom xmlns:a="http://schemas.openxmlformats.org/drawingml/2006/main" prst="rect">
-            <a:avLst/>
-          </a:prstGeom>
-          <a:noFill xmlns:a="http://schemas.openxmlformats.org/drawingml/2006/main"/>
-          <a:ln xmlns:a="http://schemas.openxmlformats.org/drawingml/2006/main" w="0">
-            <a:noFill/>
-            <a:prstDash val="solid"/>
-          </a:ln>
-        </p:spPr>
-        <p:txBody>
-          <a:bodyPr xmlns:a="http://schemas.openxmlformats.org/drawingml/2006/main" anchor="t">
-            <a:normAutofit fontScale="73809"/>
-          </a:bodyPr>
-          <a:lstStyle xmlns:a="http://schemas.openxmlformats.org/drawingml/2006/main"/>
-          <a:p xmlns:a="http://schemas.openxmlformats.org/drawingml/2006/main">
-            <a:pPr algn="l">
-              <a:buNone/>
-              <a:defRPr sz="1050" b="1">
-                <a:solidFill>
-                  <a:srgbClr val="315F9F"/>
-                </a:solidFill>
-                <a:latin typeface="Helvetica Neue"/>
-                <a:ea typeface="Helvetica Neue"/>
-                <a:cs typeface="Helvetica Neue"/>
-              </a:defRPr>
-            </a:pPr>
-            <a:r>
-              <a:rPr sz="1050" b="1">
-                <a:solidFill>
-                  <a:srgbClr val="315F9F"/>
-                </a:solidFill>
-                <a:latin typeface="Helvetica Neue"/>
-                <a:ea typeface="Helvetica Neue"/>
-                <a:cs typeface="Helvetica Neue"/>
-              </a:rPr>
-              <a:t>PRODUCTION HARDENING</a:t>
+              <a:t>ROLE IN LENS</a:t>
             </a:r>
           </a:p>
         </p:txBody>
@@ -12004,7 +11945,7 @@
         <p:spPr>
           <a:xfrm xmlns:a="http://schemas.openxmlformats.org/drawingml/2006/main">
             <a:off x="3333750" y="1971675"/>
-            <a:ext cx="3333750" cy="571500"/>
+            <a:ext cx="7734300" cy="571500"/>
           </a:xfrm>
           <a:prstGeom xmlns:a="http://schemas.openxmlformats.org/drawingml/2006/main" prst="rect">
             <a:avLst/>
@@ -12041,66 +11982,7 @@
                 <a:ea typeface="Helvetica Neue"/>
                 <a:cs typeface="Helvetica Neue"/>
               </a:rPr>
-              <a:t>The app serves the interface, brief routes, evidence, and feedback.</a:t>
-            </a:r>
-          </a:p>
-        </p:txBody>
-      </p:sp>
-      <p:sp>
-        <p:nvSpPr>
-          <p:cNvPr id="10" name="">
-            <a:extLst xmlns:a="http://schemas.openxmlformats.org/drawingml/2006/main">
-              <a:ext uri="{FF2B5EF4-FFF2-40B4-BE49-F238E27FC236}">
-                <a16:creationId xmlns:a16="http://schemas.microsoft.com/office/drawing/2014/main" id="{A6F435AE-0B0F-4977-9819-786E47BD64E5}"/>
-              </a:ext>
-            </a:extLst>
-          </p:cNvPr>
-          <p:cNvSpPr>
-            <a:spLocks xmlns:a="http://schemas.openxmlformats.org/drawingml/2006/main" noGrp="1"/>
-          </p:cNvSpPr>
-          <p:nvPr/>
-        </p:nvSpPr>
-        <p:spPr>
-          <a:xfrm xmlns:a="http://schemas.openxmlformats.org/drawingml/2006/main">
-            <a:off x="7067550" y="1971675"/>
-            <a:ext cx="4000500" cy="571500"/>
-          </a:xfrm>
-          <a:prstGeom xmlns:a="http://schemas.openxmlformats.org/drawingml/2006/main" prst="rect">
-            <a:avLst/>
-          </a:prstGeom>
-          <a:noFill xmlns:a="http://schemas.openxmlformats.org/drawingml/2006/main"/>
-          <a:ln xmlns:a="http://schemas.openxmlformats.org/drawingml/2006/main" w="0">
-            <a:noFill/>
-            <a:prstDash val="solid"/>
-          </a:ln>
-        </p:spPr>
-        <p:txBody>
-          <a:bodyPr xmlns:a="http://schemas.openxmlformats.org/drawingml/2006/main" anchor="t">
-            <a:normAutofit fontScale="100000"/>
-          </a:bodyPr>
-          <a:lstStyle xmlns:a="http://schemas.openxmlformats.org/drawingml/2006/main"/>
-          <a:p xmlns:a="http://schemas.openxmlformats.org/drawingml/2006/main">
-            <a:pPr algn="l">
-              <a:buNone/>
-              <a:defRPr sz="1275" b="0">
-                <a:solidFill>
-                  <a:srgbClr val="344054"/>
-                </a:solidFill>
-                <a:latin typeface="Helvetica Neue"/>
-                <a:ea typeface="Helvetica Neue"/>
-                <a:cs typeface="Helvetica Neue"/>
-              </a:defRPr>
-            </a:pPr>
-            <a:r>
-              <a:rPr sz="1275" b="0">
-                <a:solidFill>
-                  <a:srgbClr val="344054"/>
-                </a:solidFill>
-                <a:latin typeface="Helvetica Neue"/>
-                <a:ea typeface="Helvetica Neue"/>
-                <a:cs typeface="Helvetica Neue"/>
-              </a:rPr>
-              <a:t>Keep one service until scale or ownership requires a split.</a:t>
+              <a:t>Serves the interface, API routes, evidence views, and feedback.</a:t>
             </a:r>
           </a:p>
         </p:txBody>
@@ -12216,7 +12098,7 @@
         <p:spPr>
           <a:xfrm xmlns:a="http://schemas.openxmlformats.org/drawingml/2006/main">
             <a:off x="3333750" y="3000375"/>
-            <a:ext cx="3333750" cy="571500"/>
+            <a:ext cx="7734300" cy="571500"/>
           </a:xfrm>
           <a:prstGeom xmlns:a="http://schemas.openxmlformats.org/drawingml/2006/main" prst="rect">
             <a:avLst/>
@@ -12253,66 +12135,7 @@
                 <a:ea typeface="Helvetica Neue"/>
                 <a:cs typeface="Helvetica Neue"/>
               </a:rPr>
-              <a:t>The store holds evidence, embeddings, brief audit data, and feedback.</a:t>
-            </a:r>
-          </a:p>
-        </p:txBody>
-      </p:sp>
-      <p:sp>
-        <p:nvSpPr>
-          <p:cNvPr id="14" name="">
-            <a:extLst xmlns:a="http://schemas.openxmlformats.org/drawingml/2006/main">
-              <a:ext uri="{FF2B5EF4-FFF2-40B4-BE49-F238E27FC236}">
-                <a16:creationId xmlns:a16="http://schemas.microsoft.com/office/drawing/2014/main" id="{7AF879C1-6960-4435-8103-05F80DC16085}"/>
-              </a:ext>
-            </a:extLst>
-          </p:cNvPr>
-          <p:cNvSpPr>
-            <a:spLocks xmlns:a="http://schemas.openxmlformats.org/drawingml/2006/main" noGrp="1"/>
-          </p:cNvSpPr>
-          <p:nvPr/>
-        </p:nvSpPr>
-        <p:spPr>
-          <a:xfrm xmlns:a="http://schemas.openxmlformats.org/drawingml/2006/main">
-            <a:off x="7067550" y="3000375"/>
-            <a:ext cx="4000500" cy="571500"/>
-          </a:xfrm>
-          <a:prstGeom xmlns:a="http://schemas.openxmlformats.org/drawingml/2006/main" prst="rect">
-            <a:avLst/>
-          </a:prstGeom>
-          <a:noFill xmlns:a="http://schemas.openxmlformats.org/drawingml/2006/main"/>
-          <a:ln xmlns:a="http://schemas.openxmlformats.org/drawingml/2006/main" w="0">
-            <a:noFill/>
-            <a:prstDash val="solid"/>
-          </a:ln>
-        </p:spPr>
-        <p:txBody>
-          <a:bodyPr xmlns:a="http://schemas.openxmlformats.org/drawingml/2006/main" anchor="t">
-            <a:normAutofit fontScale="100000"/>
-          </a:bodyPr>
-          <a:lstStyle xmlns:a="http://schemas.openxmlformats.org/drawingml/2006/main"/>
-          <a:p xmlns:a="http://schemas.openxmlformats.org/drawingml/2006/main">
-            <a:pPr algn="l">
-              <a:buNone/>
-              <a:defRPr sz="1275" b="0">
-                <a:solidFill>
-                  <a:srgbClr val="344054"/>
-                </a:solidFill>
-                <a:latin typeface="Helvetica Neue"/>
-                <a:ea typeface="Helvetica Neue"/>
-                <a:cs typeface="Helvetica Neue"/>
-              </a:defRPr>
-            </a:pPr>
-            <a:r>
-              <a:rPr sz="1275" b="0">
-                <a:solidFill>
-                  <a:srgbClr val="344054"/>
-                </a:solidFill>
-                <a:latin typeface="Helvetica Neue"/>
-                <a:ea typeface="Helvetica Neue"/>
-                <a:cs typeface="Helvetica Neue"/>
-              </a:rPr>
-              <a:t>Test retrieval and response time on the 250-company scope.</a:t>
+              <a:t>Stores evidence, embeddings, brief audit data, and feedback.</a:t>
             </a:r>
           </a:p>
         </p:txBody>
@@ -12428,7 +12251,7 @@
         <p:spPr>
           <a:xfrm xmlns:a="http://schemas.openxmlformats.org/drawingml/2006/main">
             <a:off x="3333750" y="4029075"/>
-            <a:ext cx="3333750" cy="571500"/>
+            <a:ext cx="7734300" cy="571500"/>
           </a:xfrm>
           <a:prstGeom xmlns:a="http://schemas.openxmlformats.org/drawingml/2006/main" prst="rect">
             <a:avLst/>
@@ -12465,66 +12288,7 @@
                 <a:ea typeface="Helvetica Neue"/>
                 <a:cs typeface="Helvetica Neue"/>
               </a:rPr>
-              <a:t>Static fictional files make the demo repeatable without source credentials.</a:t>
-            </a:r>
-          </a:p>
-        </p:txBody>
-      </p:sp>
-      <p:sp>
-        <p:nvSpPr>
-          <p:cNvPr id="18" name="">
-            <a:extLst xmlns:a="http://schemas.openxmlformats.org/drawingml/2006/main">
-              <a:ext uri="{FF2B5EF4-FFF2-40B4-BE49-F238E27FC236}">
-                <a16:creationId xmlns:a16="http://schemas.microsoft.com/office/drawing/2014/main" id="{053B12CA-0085-4447-849D-DEE811EB562C}"/>
-              </a:ext>
-            </a:extLst>
-          </p:cNvPr>
-          <p:cNvSpPr>
-            <a:spLocks xmlns:a="http://schemas.openxmlformats.org/drawingml/2006/main" noGrp="1"/>
-          </p:cNvSpPr>
-          <p:nvPr/>
-        </p:nvSpPr>
-        <p:spPr>
-          <a:xfrm xmlns:a="http://schemas.openxmlformats.org/drawingml/2006/main">
-            <a:off x="7067550" y="4029075"/>
-            <a:ext cx="4000500" cy="571500"/>
-          </a:xfrm>
-          <a:prstGeom xmlns:a="http://schemas.openxmlformats.org/drawingml/2006/main" prst="rect">
-            <a:avLst/>
-          </a:prstGeom>
-          <a:noFill xmlns:a="http://schemas.openxmlformats.org/drawingml/2006/main"/>
-          <a:ln xmlns:a="http://schemas.openxmlformats.org/drawingml/2006/main" w="0">
-            <a:noFill/>
-            <a:prstDash val="solid"/>
-          </a:ln>
-        </p:spPr>
-        <p:txBody>
-          <a:bodyPr xmlns:a="http://schemas.openxmlformats.org/drawingml/2006/main" anchor="t">
-            <a:normAutofit fontScale="100000"/>
-          </a:bodyPr>
-          <a:lstStyle xmlns:a="http://schemas.openxmlformats.org/drawingml/2006/main"/>
-          <a:p xmlns:a="http://schemas.openxmlformats.org/drawingml/2006/main">
-            <a:pPr algn="l">
-              <a:buNone/>
-              <a:defRPr sz="1275" b="0">
-                <a:solidFill>
-                  <a:srgbClr val="344054"/>
-                </a:solidFill>
-                <a:latin typeface="Helvetica Neue"/>
-                <a:ea typeface="Helvetica Neue"/>
-                <a:cs typeface="Helvetica Neue"/>
-              </a:defRPr>
-            </a:pPr>
-            <a:r>
-              <a:rPr sz="1275" b="0">
-                <a:solidFill>
-                  <a:srgbClr val="344054"/>
-                </a:solidFill>
-                <a:latin typeface="Helvetica Neue"/>
-                <a:ea typeface="Helvetica Neue"/>
-                <a:cs typeface="Helvetica Neue"/>
-              </a:rPr>
-              <a:t>Add managed connectors, access rules, schedules, and reconciliation.</a:t>
+              <a:t>Imports the fictional source files and runs the local database.</a:t>
             </a:r>
           </a:p>
         </p:txBody>
@@ -12640,7 +12404,7 @@
         <p:spPr>
           <a:xfrm xmlns:a="http://schemas.openxmlformats.org/drawingml/2006/main">
             <a:off x="3333750" y="5057775"/>
-            <a:ext cx="3333750" cy="571500"/>
+            <a:ext cx="7734300" cy="571500"/>
           </a:xfrm>
           <a:prstGeom xmlns:a="http://schemas.openxmlformats.org/drawingml/2006/main" prst="rect">
             <a:avLst/>
@@ -12677,66 +12441,7 @@
                 <a:ea typeface="Helvetica Neue"/>
                 <a:cs typeface="Helvetica Neue"/>
               </a:rPr>
-              <a:t>Embeddings retrieve evidence. GPT-5.6 Sol writes the source-supported brief now.</a:t>
-            </a:r>
-          </a:p>
-        </p:txBody>
-      </p:sp>
-      <p:sp>
-        <p:nvSpPr>
-          <p:cNvPr id="22" name="">
-            <a:extLst xmlns:a="http://schemas.openxmlformats.org/drawingml/2006/main">
-              <a:ext uri="{FF2B5EF4-FFF2-40B4-BE49-F238E27FC236}">
-                <a16:creationId xmlns:a16="http://schemas.microsoft.com/office/drawing/2014/main" id="{612DA721-F40D-4B55-AC96-2E48A46CC6D5}"/>
-              </a:ext>
-            </a:extLst>
-          </p:cNvPr>
-          <p:cNvSpPr>
-            <a:spLocks xmlns:a="http://schemas.openxmlformats.org/drawingml/2006/main" noGrp="1"/>
-          </p:cNvSpPr>
-          <p:nvPr/>
-        </p:nvSpPr>
-        <p:spPr>
-          <a:xfrm xmlns:a="http://schemas.openxmlformats.org/drawingml/2006/main">
-            <a:off x="7067550" y="5057775"/>
-            <a:ext cx="4000500" cy="571500"/>
-          </a:xfrm>
-          <a:prstGeom xmlns:a="http://schemas.openxmlformats.org/drawingml/2006/main" prst="rect">
-            <a:avLst/>
-          </a:prstGeom>
-          <a:noFill xmlns:a="http://schemas.openxmlformats.org/drawingml/2006/main"/>
-          <a:ln xmlns:a="http://schemas.openxmlformats.org/drawingml/2006/main" w="0">
-            <a:noFill/>
-            <a:prstDash val="solid"/>
-          </a:ln>
-        </p:spPr>
-        <p:txBody>
-          <a:bodyPr xmlns:a="http://schemas.openxmlformats.org/drawingml/2006/main" anchor="t">
-            <a:normAutofit fontScale="100000"/>
-          </a:bodyPr>
-          <a:lstStyle xmlns:a="http://schemas.openxmlformats.org/drawingml/2006/main"/>
-          <a:p xmlns:a="http://schemas.openxmlformats.org/drawingml/2006/main">
-            <a:pPr algn="l">
-              <a:buNone/>
-              <a:defRPr sz="1275" b="0">
-                <a:solidFill>
-                  <a:srgbClr val="344054"/>
-                </a:solidFill>
-                <a:latin typeface="Helvetica Neue"/>
-                <a:ea typeface="Helvetica Neue"/>
-                <a:cs typeface="Helvetica Neue"/>
-              </a:defRPr>
-            </a:pPr>
-            <a:r>
-              <a:rPr sz="1275" b="0">
-                <a:solidFill>
-                  <a:srgbClr val="344054"/>
-                </a:solidFill>
-                <a:latin typeface="Helvetica Neue"/>
-                <a:ea typeface="Helvetica Neue"/>
-                <a:cs typeface="Helvetica Neue"/>
-              </a:rPr>
-              <a:t>Evaluate retrieval, prompts, and model settings. Keep low effort unless a test shows a quality gain.</a:t>
+              <a:t>Finds related evidence and writes the source-supported brief.</a:t>
             </a:r>
           </a:p>
         </p:txBody>

</xml_diff>

<commit_message>
Name OpenAI in the foundation layer
</commit_message>
<xml_diff>
--- a/docs/AVIC-Portfolio-Intelligence-Brief.pptx
+++ b/docs/AVIC-Portfolio-Intelligence-Brief.pptx
@@ -2,23 +2,23 @@
 <file path=ppt/presentation.xml><?xml version="1.0" encoding="utf-8"?>
 <p:presentation xmlns:p="http://schemas.openxmlformats.org/presentationml/2006/main">
   <p:sldMasterIdLst>
-    <p:sldMasterId xmlns:r="http://schemas.openxmlformats.org/officeDocument/2006/relationships" id="2147483648" r:id="R6397e53850d24f14"/>
+    <p:sldMasterId xmlns:r="http://schemas.openxmlformats.org/officeDocument/2006/relationships" id="2147483648" r:id="R3b7b45de51ce4e48"/>
   </p:sldMasterIdLst>
   <p:notesMasterIdLst>
-    <p:notesMasterId xmlns:r="http://schemas.openxmlformats.org/officeDocument/2006/relationships" r:id="R0fba8331acd3456e"/>
+    <p:notesMasterId xmlns:r="http://schemas.openxmlformats.org/officeDocument/2006/relationships" r:id="R40a0c24913a64f67"/>
   </p:notesMasterIdLst>
   <p:sldIdLst>
-    <p:sldId xmlns:r="http://schemas.openxmlformats.org/officeDocument/2006/relationships" id="256" r:id="R8f6d8264f5454b44"/>
-    <p:sldId xmlns:r="http://schemas.openxmlformats.org/officeDocument/2006/relationships" id="257" r:id="Rc1fe31f04f954d2a"/>
-    <p:sldId xmlns:r="http://schemas.openxmlformats.org/officeDocument/2006/relationships" id="258" r:id="Rda442934642e4598"/>
-    <p:sldId xmlns:r="http://schemas.openxmlformats.org/officeDocument/2006/relationships" id="259" r:id="Rd9a6adf44306461b"/>
-    <p:sldId xmlns:r="http://schemas.openxmlformats.org/officeDocument/2006/relationships" id="260" r:id="R8710ee47edd248ab"/>
-    <p:sldId xmlns:r="http://schemas.openxmlformats.org/officeDocument/2006/relationships" id="261" r:id="R614aabe5e8d442d9"/>
-    <p:sldId xmlns:r="http://schemas.openxmlformats.org/officeDocument/2006/relationships" id="262" r:id="Rb11f5a3e61fc4ff6"/>
-    <p:sldId xmlns:r="http://schemas.openxmlformats.org/officeDocument/2006/relationships" id="263" r:id="R1d34bfaafb4e4066"/>
-    <p:sldId xmlns:r="http://schemas.openxmlformats.org/officeDocument/2006/relationships" id="264" r:id="R5b8ddfc1dfd54fcd"/>
-    <p:sldId xmlns:r="http://schemas.openxmlformats.org/officeDocument/2006/relationships" id="265" r:id="Rd565366f6d3c4927"/>
-    <p:sldId xmlns:r="http://schemas.openxmlformats.org/officeDocument/2006/relationships" id="266" r:id="R78a920d42fee4373"/>
+    <p:sldId xmlns:r="http://schemas.openxmlformats.org/officeDocument/2006/relationships" id="256" r:id="Rfc70a94677694fac"/>
+    <p:sldId xmlns:r="http://schemas.openxmlformats.org/officeDocument/2006/relationships" id="257" r:id="Rea395bdfaf90483a"/>
+    <p:sldId xmlns:r="http://schemas.openxmlformats.org/officeDocument/2006/relationships" id="258" r:id="Rb649c47639d44ae0"/>
+    <p:sldId xmlns:r="http://schemas.openxmlformats.org/officeDocument/2006/relationships" id="259" r:id="Rb5d7813082044946"/>
+    <p:sldId xmlns:r="http://schemas.openxmlformats.org/officeDocument/2006/relationships" id="260" r:id="Raf5c0346304f4848"/>
+    <p:sldId xmlns:r="http://schemas.openxmlformats.org/officeDocument/2006/relationships" id="261" r:id="Rc0d6e800fd6a4c52"/>
+    <p:sldId xmlns:r="http://schemas.openxmlformats.org/officeDocument/2006/relationships" id="262" r:id="Ra1faa956b9604cdd"/>
+    <p:sldId xmlns:r="http://schemas.openxmlformats.org/officeDocument/2006/relationships" id="263" r:id="Rc13cac6a1cf942e8"/>
+    <p:sldId xmlns:r="http://schemas.openxmlformats.org/officeDocument/2006/relationships" id="264" r:id="Rfa0d2ff427504e5d"/>
+    <p:sldId xmlns:r="http://schemas.openxmlformats.org/officeDocument/2006/relationships" id="265" r:id="R45da4b2750df4a6e"/>
+    <p:sldId xmlns:r="http://schemas.openxmlformats.org/officeDocument/2006/relationships" id="266" r:id="Rcddbb35e049543c2"/>
   </p:sldIdLst>
   <p:sldSz cx="12192000" cy="6858000"/>
   <p:notesSz cx="6858000" cy="9144000"/>
@@ -1715,7 +1715,7 @@
   </p:cSld>
   <p:clrMap bg1="lt1" tx1="dk1" bg2="lt2" tx2="dk2" accent1="accent1" accent2="accent2" accent3="accent3" accent4="accent4" accent5="accent5" accent6="accent6" hlink="hlink" folHlink="folHlink"/>
   <p:sldLayoutIdLst>
-    <p:sldLayoutId xmlns:r="http://schemas.openxmlformats.org/officeDocument/2006/relationships" id="2147483649" r:id="Rab9c785ff53b48de"/>
+    <p:sldLayoutId xmlns:r="http://schemas.openxmlformats.org/officeDocument/2006/relationships" id="2147483649" r:id="Rc0a580d107784eee"/>
   </p:sldLayoutIdLst>
   <p:txStyles>
     <p:titleStyle>
@@ -7760,7 +7760,7 @@
           <p:nvPr/>
         </p:nvPicPr>
         <p:blipFill>
-          <a:blip xmlns:r="http://schemas.openxmlformats.org/officeDocument/2006/relationships" xmlns:a="http://schemas.openxmlformats.org/drawingml/2006/main" r:embed="R2cff69eb9a9d4181"/>
+          <a:blip xmlns:r="http://schemas.openxmlformats.org/officeDocument/2006/relationships" xmlns:a="http://schemas.openxmlformats.org/drawingml/2006/main" r:embed="Rc7f01ea0a4f24da3"/>
           <a:stretch xmlns:a="http://schemas.openxmlformats.org/drawingml/2006/main"/>
         </p:blipFill>
         <p:spPr>
@@ -9267,7 +9267,7 @@
       </p:sp>
       <p:cxnSp>
         <p:nvCxnSpPr>
-          <p:cNvPr id="651" name=""/>
+          <p:cNvPr id="725" name=""/>
           <p:cNvCxnSpPr>
             <a:stCxn xmlns:a="http://schemas.openxmlformats.org/drawingml/2006/main" id="5" idx="3"/>
             <a:endCxn xmlns:a="http://schemas.openxmlformats.org/drawingml/2006/main" id="8" idx="1"/>
@@ -9293,7 +9293,7 @@
       </p:cxnSp>
       <p:cxnSp>
         <p:nvCxnSpPr>
-          <p:cNvPr id="652" name=""/>
+          <p:cNvPr id="726" name=""/>
           <p:cNvCxnSpPr>
             <a:stCxn xmlns:a="http://schemas.openxmlformats.org/drawingml/2006/main" id="8" idx="3"/>
             <a:endCxn xmlns:a="http://schemas.openxmlformats.org/drawingml/2006/main" id="11" idx="1"/>
@@ -9319,7 +9319,7 @@
       </p:cxnSp>
       <p:cxnSp>
         <p:nvCxnSpPr>
-          <p:cNvPr id="653" name=""/>
+          <p:cNvPr id="727" name=""/>
           <p:cNvCxnSpPr>
             <a:stCxn xmlns:a="http://schemas.openxmlformats.org/drawingml/2006/main" id="11" idx="3"/>
             <a:endCxn xmlns:a="http://schemas.openxmlformats.org/drawingml/2006/main" id="14" idx="1"/>
@@ -9345,7 +9345,7 @@
       </p:cxnSp>
       <p:cxnSp>
         <p:nvCxnSpPr>
-          <p:cNvPr id="654" name=""/>
+          <p:cNvPr id="728" name=""/>
           <p:cNvCxnSpPr>
             <a:stCxn xmlns:a="http://schemas.openxmlformats.org/drawingml/2006/main" id="14" idx="3"/>
             <a:endCxn xmlns:a="http://schemas.openxmlformats.org/drawingml/2006/main" id="17" idx="1"/>
@@ -9994,7 +9994,7 @@
       </p:sp>
       <p:cxnSp>
         <p:nvCxnSpPr>
-          <p:cNvPr id="666" name=""/>
+          <p:cNvPr id="740" name=""/>
           <p:cNvCxnSpPr>
             <a:stCxn xmlns:a="http://schemas.openxmlformats.org/drawingml/2006/main" id="14" idx="3"/>
             <a:endCxn xmlns:a="http://schemas.openxmlformats.org/drawingml/2006/main" id="78" idx="1"/>
@@ -10020,7 +10020,7 @@
       </p:cxnSp>
       <p:cxnSp>
         <p:nvCxnSpPr>
-          <p:cNvPr id="667" name=""/>
+          <p:cNvPr id="741" name=""/>
           <p:cNvCxnSpPr>
             <a:stCxn xmlns:a="http://schemas.openxmlformats.org/drawingml/2006/main" id="78" idx="3"/>
             <a:endCxn xmlns:a="http://schemas.openxmlformats.org/drawingml/2006/main" id="17" idx="1"/>
@@ -10083,14 +10083,14 @@
       </p:sp>
       <p:pic>
         <p:nvPicPr>
-          <p:cNvPr id="669" name=""/>
+          <p:cNvPr id="743" name=""/>
           <p:cNvPicPr>
             <a:picLocks xmlns:a="http://schemas.openxmlformats.org/drawingml/2006/main" noChangeAspect="1"/>
           </p:cNvPicPr>
           <p:nvPr/>
         </p:nvPicPr>
         <p:blipFill>
-          <a:blip xmlns:r="http://schemas.openxmlformats.org/officeDocument/2006/relationships" xmlns:a="http://schemas.openxmlformats.org/drawingml/2006/main" r:embed="Rbb742f6ece3b412e"/>
+          <a:blip xmlns:r="http://schemas.openxmlformats.org/officeDocument/2006/relationships" xmlns:a="http://schemas.openxmlformats.org/drawingml/2006/main" r:embed="R33d1060601e44edc"/>
           <a:stretch xmlns:a="http://schemas.openxmlformats.org/drawingml/2006/main"/>
         </p:blipFill>
         <p:spPr>
@@ -11372,7 +11372,7 @@
       </p:sp>
       <p:cxnSp>
         <p:nvCxnSpPr>
-          <p:cNvPr id="495" name=""/>
+          <p:cNvPr id="547" name=""/>
           <p:cNvCxnSpPr>
             <a:stCxn xmlns:a="http://schemas.openxmlformats.org/drawingml/2006/main" id="16" idx="3"/>
             <a:endCxn xmlns:a="http://schemas.openxmlformats.org/drawingml/2006/main" id="19" idx="1"/>
@@ -11398,7 +11398,7 @@
       </p:cxnSp>
       <p:cxnSp>
         <p:nvCxnSpPr>
-          <p:cNvPr id="496" name=""/>
+          <p:cNvPr id="548" name=""/>
           <p:cNvCxnSpPr>
             <a:stCxn xmlns:a="http://schemas.openxmlformats.org/drawingml/2006/main" id="19" idx="3"/>
             <a:endCxn xmlns:a="http://schemas.openxmlformats.org/drawingml/2006/main" id="22" idx="1"/>
@@ -12382,7 +12382,7 @@
                 <a:ea typeface="Helvetica Neue"/>
                 <a:cs typeface="Helvetica Neue"/>
               </a:rPr>
-              <a:t>text-embedding-3-large and gpt-5.6-sol</a:t>
+              <a:t>OpenAI (LLM)</a:t>
             </a:r>
           </a:p>
         </p:txBody>
@@ -12441,7 +12441,7 @@
                 <a:ea typeface="Helvetica Neue"/>
                 <a:cs typeface="Helvetica Neue"/>
               </a:rPr>
-              <a:t>Finds related evidence and writes the source-supported brief.</a:t>
+              <a:t>Uses text-embedding-3-large to find evidence and gpt-5.6-sol to write the brief.</a:t>
             </a:r>
           </a:p>
         </p:txBody>

</xml_diff>

<commit_message>
Simplify the testing slide
</commit_message>
<xml_diff>
--- a/docs/AVIC-Portfolio-Intelligence-Brief.pptx
+++ b/docs/AVIC-Portfolio-Intelligence-Brief.pptx
@@ -2,23 +2,23 @@
 <file path=ppt/presentation.xml><?xml version="1.0" encoding="utf-8"?>
 <p:presentation xmlns:p="http://schemas.openxmlformats.org/presentationml/2006/main">
   <p:sldMasterIdLst>
-    <p:sldMasterId xmlns:r="http://schemas.openxmlformats.org/officeDocument/2006/relationships" id="2147483648" r:id="R3b7b45de51ce4e48"/>
+    <p:sldMasterId xmlns:r="http://schemas.openxmlformats.org/officeDocument/2006/relationships" id="2147483648" r:id="R69ef06a043574933"/>
   </p:sldMasterIdLst>
   <p:notesMasterIdLst>
-    <p:notesMasterId xmlns:r="http://schemas.openxmlformats.org/officeDocument/2006/relationships" r:id="R40a0c24913a64f67"/>
+    <p:notesMasterId xmlns:r="http://schemas.openxmlformats.org/officeDocument/2006/relationships" r:id="Rdbde6e52a81f4fba"/>
   </p:notesMasterIdLst>
   <p:sldIdLst>
-    <p:sldId xmlns:r="http://schemas.openxmlformats.org/officeDocument/2006/relationships" id="256" r:id="Rfc70a94677694fac"/>
-    <p:sldId xmlns:r="http://schemas.openxmlformats.org/officeDocument/2006/relationships" id="257" r:id="Rea395bdfaf90483a"/>
-    <p:sldId xmlns:r="http://schemas.openxmlformats.org/officeDocument/2006/relationships" id="258" r:id="Rb649c47639d44ae0"/>
-    <p:sldId xmlns:r="http://schemas.openxmlformats.org/officeDocument/2006/relationships" id="259" r:id="Rb5d7813082044946"/>
-    <p:sldId xmlns:r="http://schemas.openxmlformats.org/officeDocument/2006/relationships" id="260" r:id="Raf5c0346304f4848"/>
-    <p:sldId xmlns:r="http://schemas.openxmlformats.org/officeDocument/2006/relationships" id="261" r:id="Rc0d6e800fd6a4c52"/>
-    <p:sldId xmlns:r="http://schemas.openxmlformats.org/officeDocument/2006/relationships" id="262" r:id="Ra1faa956b9604cdd"/>
-    <p:sldId xmlns:r="http://schemas.openxmlformats.org/officeDocument/2006/relationships" id="263" r:id="Rc13cac6a1cf942e8"/>
-    <p:sldId xmlns:r="http://schemas.openxmlformats.org/officeDocument/2006/relationships" id="264" r:id="Rfa0d2ff427504e5d"/>
-    <p:sldId xmlns:r="http://schemas.openxmlformats.org/officeDocument/2006/relationships" id="265" r:id="R45da4b2750df4a6e"/>
-    <p:sldId xmlns:r="http://schemas.openxmlformats.org/officeDocument/2006/relationships" id="266" r:id="Rcddbb35e049543c2"/>
+    <p:sldId xmlns:r="http://schemas.openxmlformats.org/officeDocument/2006/relationships" id="256" r:id="R7ab30b2b36e94312"/>
+    <p:sldId xmlns:r="http://schemas.openxmlformats.org/officeDocument/2006/relationships" id="257" r:id="Reca84c14265f41f8"/>
+    <p:sldId xmlns:r="http://schemas.openxmlformats.org/officeDocument/2006/relationships" id="258" r:id="R651c0fa970e6425c"/>
+    <p:sldId xmlns:r="http://schemas.openxmlformats.org/officeDocument/2006/relationships" id="259" r:id="Rada03124aa6941bc"/>
+    <p:sldId xmlns:r="http://schemas.openxmlformats.org/officeDocument/2006/relationships" id="260" r:id="Rd6fbf69827204b98"/>
+    <p:sldId xmlns:r="http://schemas.openxmlformats.org/officeDocument/2006/relationships" id="261" r:id="R0a201797d96a42db"/>
+    <p:sldId xmlns:r="http://schemas.openxmlformats.org/officeDocument/2006/relationships" id="262" r:id="R866cf765b79c48f6"/>
+    <p:sldId xmlns:r="http://schemas.openxmlformats.org/officeDocument/2006/relationships" id="263" r:id="R3606e7f921694939"/>
+    <p:sldId xmlns:r="http://schemas.openxmlformats.org/officeDocument/2006/relationships" id="264" r:id="R5a7df18d14b1410e"/>
+    <p:sldId xmlns:r="http://schemas.openxmlformats.org/officeDocument/2006/relationships" id="265" r:id="R01032be473d64778"/>
+    <p:sldId xmlns:r="http://schemas.openxmlformats.org/officeDocument/2006/relationships" id="266" r:id="R0cece4793104484d"/>
   </p:sldIdLst>
   <p:sldSz cx="12192000" cy="6858000"/>
   <p:notesSz cx="6858000" cy="9144000"/>
@@ -1715,7 +1715,7 @@
   </p:cSld>
   <p:clrMap bg1="lt1" tx1="dk1" bg2="lt2" tx2="dk2" accent1="accent1" accent2="accent2" accent3="accent3" accent4="accent4" accent5="accent5" accent6="accent6" hlink="hlink" folHlink="folHlink"/>
   <p:sldLayoutIdLst>
-    <p:sldLayoutId xmlns:r="http://schemas.openxmlformats.org/officeDocument/2006/relationships" id="2147483649" r:id="Rc0a580d107784eee"/>
+    <p:sldLayoutId xmlns:r="http://schemas.openxmlformats.org/officeDocument/2006/relationships" id="2147483649" r:id="Raa75f9bec7494a60"/>
   </p:sldLayoutIdLst>
   <p:txStyles>
     <p:titleStyle>
@@ -7760,7 +7760,7 @@
           <p:nvPr/>
         </p:nvPicPr>
         <p:blipFill>
-          <a:blip xmlns:r="http://schemas.openxmlformats.org/officeDocument/2006/relationships" xmlns:a="http://schemas.openxmlformats.org/drawingml/2006/main" r:embed="Rc7f01ea0a4f24da3"/>
+          <a:blip xmlns:r="http://schemas.openxmlformats.org/officeDocument/2006/relationships" xmlns:a="http://schemas.openxmlformats.org/drawingml/2006/main" r:embed="Ra5e83afa0ac64f0c"/>
           <a:stretch xmlns:a="http://schemas.openxmlformats.org/drawingml/2006/main"/>
         </p:blipFill>
         <p:spPr>
@@ -9267,7 +9267,7 @@
       </p:sp>
       <p:cxnSp>
         <p:nvCxnSpPr>
-          <p:cNvPr id="725" name=""/>
+          <p:cNvPr id="799" name=""/>
           <p:cNvCxnSpPr>
             <a:stCxn xmlns:a="http://schemas.openxmlformats.org/drawingml/2006/main" id="5" idx="3"/>
             <a:endCxn xmlns:a="http://schemas.openxmlformats.org/drawingml/2006/main" id="8" idx="1"/>
@@ -9293,7 +9293,7 @@
       </p:cxnSp>
       <p:cxnSp>
         <p:nvCxnSpPr>
-          <p:cNvPr id="726" name=""/>
+          <p:cNvPr id="800" name=""/>
           <p:cNvCxnSpPr>
             <a:stCxn xmlns:a="http://schemas.openxmlformats.org/drawingml/2006/main" id="8" idx="3"/>
             <a:endCxn xmlns:a="http://schemas.openxmlformats.org/drawingml/2006/main" id="11" idx="1"/>
@@ -9319,7 +9319,7 @@
       </p:cxnSp>
       <p:cxnSp>
         <p:nvCxnSpPr>
-          <p:cNvPr id="727" name=""/>
+          <p:cNvPr id="801" name=""/>
           <p:cNvCxnSpPr>
             <a:stCxn xmlns:a="http://schemas.openxmlformats.org/drawingml/2006/main" id="11" idx="3"/>
             <a:endCxn xmlns:a="http://schemas.openxmlformats.org/drawingml/2006/main" id="14" idx="1"/>
@@ -9345,7 +9345,7 @@
       </p:cxnSp>
       <p:cxnSp>
         <p:nvCxnSpPr>
-          <p:cNvPr id="728" name=""/>
+          <p:cNvPr id="802" name=""/>
           <p:cNvCxnSpPr>
             <a:stCxn xmlns:a="http://schemas.openxmlformats.org/drawingml/2006/main" id="14" idx="3"/>
             <a:endCxn xmlns:a="http://schemas.openxmlformats.org/drawingml/2006/main" id="17" idx="1"/>
@@ -9994,7 +9994,7 @@
       </p:sp>
       <p:cxnSp>
         <p:nvCxnSpPr>
-          <p:cNvPr id="740" name=""/>
+          <p:cNvPr id="814" name=""/>
           <p:cNvCxnSpPr>
             <a:stCxn xmlns:a="http://schemas.openxmlformats.org/drawingml/2006/main" id="14" idx="3"/>
             <a:endCxn xmlns:a="http://schemas.openxmlformats.org/drawingml/2006/main" id="78" idx="1"/>
@@ -10020,7 +10020,7 @@
       </p:cxnSp>
       <p:cxnSp>
         <p:nvCxnSpPr>
-          <p:cNvPr id="741" name=""/>
+          <p:cNvPr id="815" name=""/>
           <p:cNvCxnSpPr>
             <a:stCxn xmlns:a="http://schemas.openxmlformats.org/drawingml/2006/main" id="78" idx="3"/>
             <a:endCxn xmlns:a="http://schemas.openxmlformats.org/drawingml/2006/main" id="17" idx="1"/>
@@ -10083,14 +10083,14 @@
       </p:sp>
       <p:pic>
         <p:nvPicPr>
-          <p:cNvPr id="743" name=""/>
+          <p:cNvPr id="817" name=""/>
           <p:cNvPicPr>
             <a:picLocks xmlns:a="http://schemas.openxmlformats.org/drawingml/2006/main" noChangeAspect="1"/>
           </p:cNvPicPr>
           <p:nvPr/>
         </p:nvPicPr>
         <p:blipFill>
-          <a:blip xmlns:r="http://schemas.openxmlformats.org/officeDocument/2006/relationships" xmlns:a="http://schemas.openxmlformats.org/drawingml/2006/main" r:embed="R33d1060601e44edc"/>
+          <a:blip xmlns:r="http://schemas.openxmlformats.org/officeDocument/2006/relationships" xmlns:a="http://schemas.openxmlformats.org/drawingml/2006/main" r:embed="R76329322abf0447d"/>
           <a:stretch xmlns:a="http://schemas.openxmlformats.org/drawingml/2006/main"/>
         </p:blipFill>
         <p:spPr>
@@ -11372,7 +11372,7 @@
       </p:sp>
       <p:cxnSp>
         <p:nvCxnSpPr>
-          <p:cNvPr id="547" name=""/>
+          <p:cNvPr id="599" name=""/>
           <p:cNvCxnSpPr>
             <a:stCxn xmlns:a="http://schemas.openxmlformats.org/drawingml/2006/main" id="16" idx="3"/>
             <a:endCxn xmlns:a="http://schemas.openxmlformats.org/drawingml/2006/main" id="19" idx="1"/>
@@ -11398,7 +11398,7 @@
       </p:cxnSp>
       <p:cxnSp>
         <p:nvCxnSpPr>
-          <p:cNvPr id="548" name=""/>
+          <p:cNvPr id="600" name=""/>
           <p:cNvCxnSpPr>
             <a:stCxn xmlns:a="http://schemas.openxmlformats.org/drawingml/2006/main" id="19" idx="3"/>
             <a:endCxn xmlns:a="http://schemas.openxmlformats.org/drawingml/2006/main" id="22" idx="1"/>
@@ -12529,7 +12529,7 @@
                 <a:ea typeface="Helvetica Neue"/>
                 <a:cs typeface="Helvetica Neue"/>
               </a:rPr>
-              <a:t>How did I test Lens?</a:t>
+              <a:t>How do I know Lens works?</a:t>
             </a:r>
           </a:p>
         </p:txBody>
@@ -12770,7 +12770,7 @@
                 <a:ea typeface="Helvetica Neue"/>
                 <a:cs typeface="Helvetica Neue"/>
               </a:rPr>
-              <a:t>91 checks pass: 69 app tests and 22 live checks. Two live GPT briefs finish in 30 seconds or less.</a:t>
+              <a:t>Lens passed 91 checks. Two AI briefs finished in 30 seconds or less.</a:t>
             </a:r>
           </a:p>
         </p:txBody>
@@ -12864,7 +12864,7 @@
                 <a:ea typeface="Helvetica Neue"/>
                 <a:cs typeface="Helvetica Neue"/>
               </a:rPr>
-              <a:t>RETRIEVAL</a:t>
+              <a:t>FIND THE RIGHT RECORDS</a:t>
             </a:r>
           </a:p>
         </p:txBody>
@@ -12923,7 +12923,7 @@
                 <a:ea typeface="Helvetica Neue"/>
                 <a:cs typeface="Helvetica Neue"/>
               </a:rPr>
-              <a:t>Recall</a:t>
+              <a:t>Find</a:t>
             </a:r>
           </a:p>
         </p:txBody>
@@ -12982,7 +12982,7 @@
                 <a:ea typeface="Helvetica Neue"/>
                 <a:cs typeface="Helvetica Neue"/>
               </a:rPr>
-              <a:t>Must-find source in top 30</a:t>
+              <a:t>Finds the required record</a:t>
             </a:r>
           </a:p>
           <a:p xmlns:a="http://schemas.openxmlformats.org/drawingml/2006/main">
@@ -13006,7 +13006,7 @@
                 <a:ea typeface="Helvetica Neue"/>
                 <a:cs typeface="Helvetica Neue"/>
               </a:rPr>
-              <a:t>No cross-company result</a:t>
+              <a:t>Does not mix companies</a:t>
             </a:r>
           </a:p>
         </p:txBody>
@@ -13100,7 +13100,7 @@
                 <a:ea typeface="Helvetica Neue"/>
                 <a:cs typeface="Helvetica Neue"/>
               </a:rPr>
-              <a:t>GROUNDING</a:t>
+              <a:t>CHECK THE FACTS</a:t>
             </a:r>
           </a:p>
         </p:txBody>
@@ -13159,7 +13159,7 @@
                 <a:ea typeface="Helvetica Neue"/>
                 <a:cs typeface="Helvetica Neue"/>
               </a:rPr>
-              <a:t>Support</a:t>
+              <a:t>Check</a:t>
             </a:r>
           </a:p>
         </p:txBody>
@@ -13194,7 +13194,7 @@
         </p:spPr>
         <p:txBody>
           <a:bodyPr xmlns:a="http://schemas.openxmlformats.org/drawingml/2006/main" anchor="t">
-            <a:normAutofit fontScale="90128"/>
+            <a:normAutofit fontScale="88253"/>
           </a:bodyPr>
           <a:lstStyle xmlns:a="http://schemas.openxmlformats.org/drawingml/2006/main"/>
           <a:p xmlns:a="http://schemas.openxmlformats.org/drawingml/2006/main">
@@ -13218,7 +13218,7 @@
                 <a:ea typeface="Helvetica Neue"/>
                 <a:cs typeface="Helvetica Neue"/>
               </a:rPr>
-              <a:t>Claim cites retrieved evidence</a:t>
+              <a:t>Each statement links to a source</a:t>
             </a:r>
           </a:p>
           <a:p xmlns:a="http://schemas.openxmlformats.org/drawingml/2006/main">
@@ -13242,7 +13242,7 @@
                 <a:ea typeface="Helvetica Neue"/>
                 <a:cs typeface="Helvetica Neue"/>
               </a:rPr>
-              <a:t>Number matches a cited source</a:t>
+              <a:t>Each number matches a source</a:t>
             </a:r>
           </a:p>
         </p:txBody>
@@ -13336,7 +13336,7 @@
                 <a:ea typeface="Helvetica Neue"/>
                 <a:cs typeface="Helvetica Neue"/>
               </a:rPr>
-              <a:t>PRODUCT</a:t>
+              <a:t>HELP THE USER</a:t>
             </a:r>
           </a:p>
         </p:txBody>
@@ -13430,7 +13430,7 @@
         </p:spPr>
         <p:txBody>
           <a:bodyPr xmlns:a="http://schemas.openxmlformats.org/drawingml/2006/main" anchor="t">
-            <a:normAutofit fontScale="90884"/>
+            <a:normAutofit fontScale="100000"/>
           </a:bodyPr>
           <a:lstStyle xmlns:a="http://schemas.openxmlformats.org/drawingml/2006/main"/>
           <a:p xmlns:a="http://schemas.openxmlformats.org/drawingml/2006/main">
@@ -13454,7 +13454,7 @@
                 <a:ea typeface="Helvetica Neue"/>
                 <a:cs typeface="Helvetica Neue"/>
               </a:rPr>
-              <a:t>Brief in 30 seconds or less</a:t>
+              <a:t>Makes a brief in 30 seconds</a:t>
             </a:r>
           </a:p>
           <a:p xmlns:a="http://schemas.openxmlformats.org/drawingml/2006/main">
@@ -13478,7 +13478,7 @@
                 <a:ea typeface="Helvetica Neue"/>
                 <a:cs typeface="Helvetica Neue"/>
               </a:rPr>
-              <a:t>Principal score is 4 of 5 or more</a:t>
+              <a:t>User target is 4 out of 5</a:t>
             </a:r>
           </a:p>
         </p:txBody>
@@ -13572,7 +13572,7 @@
                 <a:ea typeface="Helvetica Neue"/>
                 <a:cs typeface="Helvetica Neue"/>
               </a:rPr>
-              <a:t>OPERATIONS</a:t>
+              <a:t>HANDLE CHANGES</a:t>
             </a:r>
           </a:p>
         </p:txBody>
@@ -13631,7 +13631,7 @@
                 <a:ea typeface="Helvetica Neue"/>
                 <a:cs typeface="Helvetica Neue"/>
               </a:rPr>
-              <a:t>Change</a:t>
+              <a:t>Update</a:t>
             </a:r>
           </a:p>
         </p:txBody>
@@ -13666,7 +13666,7 @@
         </p:spPr>
         <p:txBody>
           <a:bodyPr xmlns:a="http://schemas.openxmlformats.org/drawingml/2006/main" anchor="t">
-            <a:normAutofit fontScale="80597"/>
+            <a:normAutofit fontScale="83466"/>
           </a:bodyPr>
           <a:lstStyle xmlns:a="http://schemas.openxmlformats.org/drawingml/2006/main"/>
           <a:p xmlns:a="http://schemas.openxmlformats.org/drawingml/2006/main">
@@ -13690,7 +13690,7 @@
                 <a:ea typeface="Helvetica Neue"/>
                 <a:cs typeface="Helvetica Neue"/>
               </a:rPr>
-              <a:t>Invalid output uses fallback</a:t>
+              <a:t>Uses a backup if the AI fails</a:t>
             </a:r>
           </a:p>
           <a:p xmlns:a="http://schemas.openxmlformats.org/drawingml/2006/main">
@@ -13714,7 +13714,7 @@
                 <a:ea typeface="Helvetica Neue"/>
                 <a:cs typeface="Helvetica Neue"/>
               </a:rPr>
-              <a:t>Changed source changes next brief</a:t>
+              <a:t>New records change the next brief</a:t>
             </a:r>
           </a:p>
         </p:txBody>
@@ -13773,7 +13773,7 @@
                 <a:ea typeface="Helvetica Neue"/>
                 <a:cs typeface="Helvetica Neue"/>
               </a:rPr>
-              <a:t>Code checks: Retrieval, Grounding, and Operations · Reviewer checks: Product</a:t>
+              <a:t>Checks cover facts, sources, and changes. A user reviews usefulness.</a:t>
             </a:r>
           </a:p>
         </p:txBody>
@@ -13832,7 +13832,7 @@
                 <a:ea typeface="Helvetica Neue"/>
                 <a:cs typeface="Helvetica Neue"/>
               </a:rPr>
-              <a:t>Run the same set after a retrieval, prompt, model, schema, or source-rule change.</a:t>
+              <a:t>Run the checks again after any system or source change.</a:t>
             </a:r>
           </a:p>
         </p:txBody>

</xml_diff>

<commit_message>
Clean the slide 4 architecture flow
</commit_message>
<xml_diff>
--- a/docs/AVIC-Portfolio-Intelligence-Brief.pptx
+++ b/docs/AVIC-Portfolio-Intelligence-Brief.pptx
@@ -2,20 +2,20 @@
 <file path=ppt/presentation.xml><?xml version="1.0" encoding="utf-8"?>
 <p:presentation xmlns:p="http://schemas.openxmlformats.org/presentationml/2006/main">
   <p:sldMasterIdLst>
-    <p:sldMasterId xmlns:r="http://schemas.openxmlformats.org/officeDocument/2006/relationships" id="2147483648" r:id="Rdad4b009dda14fad"/>
+    <p:sldMasterId xmlns:r="http://schemas.openxmlformats.org/officeDocument/2006/relationships" id="2147483648" r:id="R78108e3aed324e86"/>
   </p:sldMasterIdLst>
   <p:notesMasterIdLst>
-    <p:notesMasterId xmlns:r="http://schemas.openxmlformats.org/officeDocument/2006/relationships" r:id="Rdbb064cc86cf4566"/>
+    <p:notesMasterId xmlns:r="http://schemas.openxmlformats.org/officeDocument/2006/relationships" r:id="R11455d7806b14d0e"/>
   </p:notesMasterIdLst>
   <p:sldIdLst>
-    <p:sldId xmlns:r="http://schemas.openxmlformats.org/officeDocument/2006/relationships" id="256" r:id="Ra1238ae6cfc44322"/>
-    <p:sldId xmlns:r="http://schemas.openxmlformats.org/officeDocument/2006/relationships" id="257" r:id="Rf00ad866928c43c7"/>
-    <p:sldId xmlns:r="http://schemas.openxmlformats.org/officeDocument/2006/relationships" id="258" r:id="R458208d3189c4961"/>
-    <p:sldId xmlns:r="http://schemas.openxmlformats.org/officeDocument/2006/relationships" id="259" r:id="R6a2a2db296ce483a"/>
-    <p:sldId xmlns:r="http://schemas.openxmlformats.org/officeDocument/2006/relationships" id="260" r:id="R5bf06958df1943c5"/>
-    <p:sldId xmlns:r="http://schemas.openxmlformats.org/officeDocument/2006/relationships" id="261" r:id="Rb14d3535793f4eea"/>
-    <p:sldId xmlns:r="http://schemas.openxmlformats.org/officeDocument/2006/relationships" id="262" r:id="R0fcfc38a84b24885"/>
-    <p:sldId xmlns:r="http://schemas.openxmlformats.org/officeDocument/2006/relationships" id="263" r:id="Rc671f5d6ef4c48d2"/>
+    <p:sldId xmlns:r="http://schemas.openxmlformats.org/officeDocument/2006/relationships" id="256" r:id="R03ff38c598aa4389"/>
+    <p:sldId xmlns:r="http://schemas.openxmlformats.org/officeDocument/2006/relationships" id="257" r:id="R3754c2deeb9a4581"/>
+    <p:sldId xmlns:r="http://schemas.openxmlformats.org/officeDocument/2006/relationships" id="258" r:id="Rdff195e6cfdc4c9e"/>
+    <p:sldId xmlns:r="http://schemas.openxmlformats.org/officeDocument/2006/relationships" id="259" r:id="R71b76ff4872f40f1"/>
+    <p:sldId xmlns:r="http://schemas.openxmlformats.org/officeDocument/2006/relationships" id="260" r:id="Rb208b6f6c2664220"/>
+    <p:sldId xmlns:r="http://schemas.openxmlformats.org/officeDocument/2006/relationships" id="261" r:id="R703774e67ecf48ba"/>
+    <p:sldId xmlns:r="http://schemas.openxmlformats.org/officeDocument/2006/relationships" id="262" r:id="R1d8e795a26ad4508"/>
+    <p:sldId xmlns:r="http://schemas.openxmlformats.org/officeDocument/2006/relationships" id="263" r:id="Rd341cd892f304b05"/>
   </p:sldIdLst>
   <p:sldSz cx="12192000" cy="6858000"/>
   <p:notesSz cx="6858000" cy="9144000"/>
@@ -744,7 +744,7 @@
           <a:lstStyle xmlns:a="http://schemas.openxmlformats.org/drawingml/2006/main"/>
           <a:p xmlns:a="http://schemas.openxmlformats.org/drawingml/2006/main">
             <a:r>
-              <a:t>The file import validates each company ID, keeps the source record, calculates checksums, creates chunks, and sends fictional normalized chunk text to the OpenAI Embeddings API. PostgreSQL stores the returned embeddings. A brief request creates one query embedding. SQL filters by company and ranks up to 30 source records. The server sends only the selected company metadata and retrieved evidence to gpt-5.6-sol through the Responses API. It requests a strict schema with low reasoning effort, no tools, and no response storage. A 27-second model timeout and a 29-second request budget have no automatic retry. The server checks source IDs, company isolation, exact source quotes, typed values, qualitative support, source status, and investment safety. It saves the brief, generation mode, model data, and source ranks. If generation fails a check or exceeds the budget, local rules create a source-supported fallback. The app does not call a source system during a brief request. V1 does not watch a folder or Slack. To add a demo record, add it in a supported format, run the import route or the data import command, and select Refresh Brief. The importer reuses unchanged embeddings and embeds only new or changed chunks. A Slack thread must be added to the Slack JSON file with a known company ID.</a:t>
+              <a:t>Opening Lens or selecting a company first loads that company's latest saved brief. This normal open path does not run retrieval or call a model. If no saved brief exists, the app prepares and saves the first brief. Selecting Refresh brief starts the new-brief path. The retrieval service creates one query embedding, applies a hard company filter, and ranks up to 30 source records by full-text match, embedding similarity, source quality, and date. The server sends only the selected company metadata and retrieved evidence to gpt-5.6-sol through the Responses API. It requests a strict schema with low reasoning effort, no tools, and no response storage. The server checks source IDs, company isolation, exact quotes, values, qualitative support, source status, and investment safety. It saves the new brief, generation mode, model data, source ranks, and time. If generation fails a check or exceeds the time budget, local rules create a source-supported fallback. Import is separate from brief use. It validates records, maps company IDs, keeps source records, calculates checksums, creates chunks, requests embeddings for new or changed chunks, and writes them to PostgreSQL. The app does not watch a folder or Slack. To add a demo record, add it in a supported format, run import, then select Refresh brief.</a:t>
             </a:r>
           </a:p>
           <a:p xmlns:a="http://schemas.openxmlformats.org/drawingml/2006/main">
@@ -759,6 +759,26 @@
           </a:p>
           <a:p xmlns:a="http://schemas.openxmlformats.org/drawingml/2006/main">
             <a:r>
+              <a:t>- /Users/alexthorpe/Documents/GitHub/AVIC/README.md</a:t>
+            </a:r>
+          </a:p>
+          <a:p xmlns:a="http://schemas.openxmlformats.org/drawingml/2006/main">
+            <a:r>
+              <a:t>- /Users/alexthorpe/Documents/GitHub/AVIC/docs/architecture.md</a:t>
+            </a:r>
+          </a:p>
+          <a:p xmlns:a="http://schemas.openxmlformats.org/drawingml/2006/main">
+            <a:r>
+              <a:t>- /Users/alexthorpe/Documents/GitHub/AVIC/app/page.tsx</a:t>
+            </a:r>
+          </a:p>
+          <a:p xmlns:a="http://schemas.openxmlformats.org/drawingml/2006/main">
+            <a:r>
+              <a:t>- /Users/alexthorpe/Documents/GitHub/AVIC/app/api/briefs/route.ts</a:t>
+            </a:r>
+          </a:p>
+          <a:p xmlns:a="http://schemas.openxmlformats.org/drawingml/2006/main">
+            <a:r>
               <a:t>- /Users/alexthorpe/Documents/GitHub/AVIC/lib/embeddings.ts</a:t>
             </a:r>
           </a:p>
@@ -779,27 +799,7 @@
           </a:p>
           <a:p xmlns:a="http://schemas.openxmlformats.org/drawingml/2006/main">
             <a:r>
-              <a:t>- /Users/alexthorpe/Documents/GitHub/AVIC/lib/brief.ts</a:t>
-            </a:r>
-          </a:p>
-          <a:p xmlns:a="http://schemas.openxmlformats.org/drawingml/2006/main">
-            <a:r>
-              <a:t>- /Users/alexthorpe/Documents/GitHub/AVIC/app/api/briefs/route.ts</a:t>
-            </a:r>
-          </a:p>
-          <a:p xmlns:a="http://schemas.openxmlformats.org/drawingml/2006/main">
-            <a:r>
               <a:t>- /Users/alexthorpe/Documents/GitHub/AVIC/db/schema.sql</a:t>
-            </a:r>
-          </a:p>
-          <a:p xmlns:a="http://schemas.openxmlformats.org/drawingml/2006/main">
-            <a:r>
-              <a:t>- https://developers.openai.com/api/docs/models/gpt-5.6-sol</a:t>
-            </a:r>
-          </a:p>
-          <a:p xmlns:a="http://schemas.openxmlformats.org/drawingml/2006/main">
-            <a:r>
-              <a:t>- https://developers.openai.com/api/reference/cli/resources/responses/methods/create</a:t>
             </a:r>
           </a:p>
           <a:p xmlns:a="http://schemas.openxmlformats.org/drawingml/2006/main">
@@ -1337,7 +1337,7 @@
   </p:cSld>
   <p:clrMap bg1="lt1" tx1="dk1" bg2="lt2" tx2="dk2" accent1="accent1" accent2="accent2" accent3="accent3" accent4="accent4" accent5="accent5" accent6="accent6" hlink="hlink" folHlink="folHlink"/>
   <p:sldLayoutIdLst>
-    <p:sldLayoutId xmlns:r="http://schemas.openxmlformats.org/officeDocument/2006/relationships" id="2147483649" r:id="Rd8e2d851fd774d51"/>
+    <p:sldLayoutId xmlns:r="http://schemas.openxmlformats.org/officeDocument/2006/relationships" id="2147483649" r:id="Rd797764537a848bd"/>
   </p:sldLayoutIdLst>
   <p:txStyles>
     <p:titleStyle>
@@ -4483,7 +4483,7 @@
           <p:nvPr/>
         </p:nvPicPr>
         <p:blipFill>
-          <a:blip xmlns:r="http://schemas.openxmlformats.org/officeDocument/2006/relationships" xmlns:a="http://schemas.openxmlformats.org/drawingml/2006/main" r:embed="R7c50bf0d13ca4700"/>
+          <a:blip xmlns:r="http://schemas.openxmlformats.org/officeDocument/2006/relationships" xmlns:a="http://schemas.openxmlformats.org/drawingml/2006/main" r:embed="R3140ffa6f7284341"/>
           <a:stretch xmlns:a="http://schemas.openxmlformats.org/drawingml/2006/main"/>
         </p:blipFill>
         <p:spPr>
@@ -4728,7 +4728,7 @@
                 <a:ea typeface="Helvetica Neue"/>
                 <a:cs typeface="Helvetica Neue"/>
               </a:rPr>
-              <a:t>Import reads new or changed demo records. Refresh Brief retrieves them and writes a new brief. There is no live source watcher.</a:t>
+              <a:t>Import prepares the evidence. Open loads the saved brief. Refresh builds and saves a new brief.</a:t>
             </a:r>
           </a:p>
         </p:txBody>
@@ -4824,7 +4824,7 @@
                 <a:ea typeface="Helvetica Neue"/>
                 <a:cs typeface="Helvetica Neue"/>
               </a:rPr>
-              <a:t>Sources</a:t>
+              <a:t>Source files</a:t>
             </a:r>
           </a:p>
         </p:txBody>
@@ -4883,7 +4883,7 @@
                 <a:ea typeface="Helvetica Neue"/>
                 <a:cs typeface="Helvetica Neue"/>
               </a:rPr>
-              <a:t>Static CRM</a:t>
+              <a:t>Fictional CRM</a:t>
             </a:r>
           </a:p>
           <a:p xmlns:a="http://schemas.openxmlformats.org/drawingml/2006/main">
@@ -4979,7 +4979,7 @@
                 <a:ea typeface="Helvetica Neue"/>
                 <a:cs typeface="Helvetica Neue"/>
               </a:rPr>
-              <a:t>No filings adapter</a:t>
+              <a:t>Static files only</a:t>
             </a:r>
           </a:p>
         </p:txBody>
@@ -5134,7 +5134,7 @@
                 <a:ea typeface="Helvetica Neue"/>
                 <a:cs typeface="Helvetica Neue"/>
               </a:rPr>
-              <a:t>Read each file</a:t>
+              <a:t>Read file</a:t>
             </a:r>
           </a:p>
           <a:p xmlns:a="http://schemas.openxmlformats.org/drawingml/2006/main">
@@ -5182,7 +5182,7 @@
                 <a:ea typeface="Helvetica Neue"/>
                 <a:cs typeface="Helvetica Neue"/>
               </a:rPr>
-              <a:t>Check company ID</a:t>
+              <a:t>Map company ID</a:t>
             </a:r>
           </a:p>
           <a:p xmlns:a="http://schemas.openxmlformats.org/drawingml/2006/main">
@@ -5206,7 +5206,7 @@
                 <a:ea typeface="Helvetica Neue"/>
                 <a:cs typeface="Helvetica Neue"/>
               </a:rPr>
-              <a:t>Keep source record</a:t>
+              <a:t>Keep source</a:t>
             </a:r>
           </a:p>
           <a:p xmlns:a="http://schemas.openxmlformats.org/drawingml/2006/main">
@@ -5254,7 +5254,7 @@
                 <a:ea typeface="Helvetica Neue"/>
                 <a:cs typeface="Helvetica Neue"/>
               </a:rPr>
-              <a:t>Request embeddings</a:t>
+              <a:t>OpenAI embeddings</a:t>
             </a:r>
           </a:p>
         </p:txBody>
@@ -5385,7 +5385,7 @@
         </p:spPr>
         <p:txBody>
           <a:bodyPr xmlns:a="http://schemas.openxmlformats.org/drawingml/2006/main" anchor="t">
-            <a:normAutofit fontScale="94180"/>
+            <a:normAutofit fontScale="100000"/>
           </a:bodyPr>
           <a:lstStyle xmlns:a="http://schemas.openxmlformats.org/drawingml/2006/main"/>
           <a:p xmlns:a="http://schemas.openxmlformats.org/drawingml/2006/main">
@@ -5433,7 +5433,7 @@
                 <a:ea typeface="Helvetica Neue"/>
                 <a:cs typeface="Helvetica Neue"/>
               </a:rPr>
-              <a:t>Companies and source records</a:t>
+              <a:t>Source records</a:t>
             </a:r>
           </a:p>
           <a:p xmlns:a="http://schemas.openxmlformats.org/drawingml/2006/main">
@@ -5505,7 +5505,7 @@
                 <a:ea typeface="Helvetica Neue"/>
                 <a:cs typeface="Helvetica Neue"/>
               </a:rPr>
-              <a:t>Brief runs and evidence</a:t>
+              <a:t>Saved briefs and audit</a:t>
             </a:r>
           </a:p>
         </p:txBody>
@@ -5636,7 +5636,7 @@
         </p:spPr>
         <p:txBody>
           <a:bodyPr xmlns:a="http://schemas.openxmlformats.org/drawingml/2006/main" anchor="t">
-            <a:normAutofit fontScale="88868"/>
+            <a:normAutofit fontScale="100000"/>
           </a:bodyPr>
           <a:lstStyle xmlns:a="http://schemas.openxmlformats.org/drawingml/2006/main"/>
           <a:p xmlns:a="http://schemas.openxmlformats.org/drawingml/2006/main">
@@ -5660,7 +5660,7 @@
                 <a:ea typeface="Helvetica Neue"/>
                 <a:cs typeface="Helvetica Neue"/>
               </a:rPr>
-              <a:t>Create query embedding</a:t>
+              <a:t>Refresh only</a:t>
             </a:r>
           </a:p>
           <a:p xmlns:a="http://schemas.openxmlformats.org/drawingml/2006/main">
@@ -5684,7 +5684,7 @@
                 <a:ea typeface="Helvetica Neue"/>
                 <a:cs typeface="Helvetica Neue"/>
               </a:rPr>
-              <a:t>Company ID filter in SQL</a:t>
+              <a:t>Embed query</a:t>
             </a:r>
           </a:p>
           <a:p xmlns:a="http://schemas.openxmlformats.org/drawingml/2006/main">
@@ -5708,7 +5708,7 @@
                 <a:ea typeface="Helvetica Neue"/>
                 <a:cs typeface="Helvetica Neue"/>
               </a:rPr>
-              <a:t>Full-text and embedding search</a:t>
+              <a:t>Filter by company ID</a:t>
             </a:r>
           </a:p>
           <a:p xmlns:a="http://schemas.openxmlformats.org/drawingml/2006/main">
@@ -5732,7 +5732,7 @@
                 <a:ea typeface="Helvetica Neue"/>
                 <a:cs typeface="Helvetica Neue"/>
               </a:rPr>
-              <a:t>Rank up to 30 records</a:t>
+              <a:t>Full text and vectors</a:t>
             </a:r>
           </a:p>
           <a:p xmlns:a="http://schemas.openxmlformats.org/drawingml/2006/main">
@@ -5756,7 +5756,7 @@
                 <a:ea typeface="Helvetica Neue"/>
                 <a:cs typeface="Helvetica Neue"/>
               </a:rPr>
-              <a:t>Use quality and recency</a:t>
+              <a:t>Rank up to 30</a:t>
             </a:r>
           </a:p>
         </p:txBody>
@@ -5852,7 +5852,7 @@
                 <a:ea typeface="Helvetica Neue"/>
                 <a:cs typeface="Helvetica Neue"/>
               </a:rPr>
-              <a:t>Investor UI</a:t>
+              <a:t>Brief interface</a:t>
             </a:r>
           </a:p>
         </p:txBody>
@@ -5911,7 +5911,7 @@
                 <a:ea typeface="Helvetica Neue"/>
                 <a:cs typeface="Helvetica Neue"/>
               </a:rPr>
-              <a:t>Portfolio or pipeline</a:t>
+              <a:t>Load saved brief</a:t>
             </a:r>
           </a:p>
           <a:p xmlns:a="http://schemas.openxmlformats.org/drawingml/2006/main">
@@ -5935,7 +5935,7 @@
                 <a:ea typeface="Helvetica Neue"/>
                 <a:cs typeface="Helvetica Neue"/>
               </a:rPr>
-              <a:t>Brief in 30 seconds or less</a:t>
+              <a:t>Facts, risks, questions</a:t>
             </a:r>
           </a:p>
           <a:p xmlns:a="http://schemas.openxmlformats.org/drawingml/2006/main">
@@ -5959,7 +5959,7 @@
                 <a:ea typeface="Helvetica Neue"/>
                 <a:cs typeface="Helvetica Neue"/>
               </a:rPr>
-              <a:t>Open evidence and full source</a:t>
+              <a:t>Open evidence and source</a:t>
             </a:r>
           </a:p>
           <a:p xmlns:a="http://schemas.openxmlformats.org/drawingml/2006/main">
@@ -5990,7 +5990,7 @@
       </p:sp>
       <p:cxnSp>
         <p:nvCxnSpPr>
-          <p:cNvPr id="1095" name=""/>
+          <p:cNvPr id="1168" name=""/>
           <p:cNvCxnSpPr>
             <a:stCxn xmlns:a="http://schemas.openxmlformats.org/drawingml/2006/main" id="5" idx="3"/>
             <a:endCxn xmlns:a="http://schemas.openxmlformats.org/drawingml/2006/main" id="8" idx="1"/>
@@ -6016,7 +6016,7 @@
       </p:cxnSp>
       <p:cxnSp>
         <p:nvCxnSpPr>
-          <p:cNvPr id="1096" name=""/>
+          <p:cNvPr id="1169" name=""/>
           <p:cNvCxnSpPr>
             <a:stCxn xmlns:a="http://schemas.openxmlformats.org/drawingml/2006/main" id="8" idx="3"/>
             <a:endCxn xmlns:a="http://schemas.openxmlformats.org/drawingml/2006/main" id="11" idx="1"/>
@@ -6042,7 +6042,7 @@
       </p:cxnSp>
       <p:cxnSp>
         <p:nvCxnSpPr>
-          <p:cNvPr id="1097" name=""/>
+          <p:cNvPr id="1170" name=""/>
           <p:cNvCxnSpPr>
             <a:stCxn xmlns:a="http://schemas.openxmlformats.org/drawingml/2006/main" id="11" idx="3"/>
             <a:endCxn xmlns:a="http://schemas.openxmlformats.org/drawingml/2006/main" id="14" idx="1"/>
@@ -6053,32 +6053,6 @@
           <a:xfrm xmlns:a="http://schemas.openxmlformats.org/drawingml/2006/main">
             <a:off x="5838825" y="3048000"/>
             <a:ext cx="190500" cy="0"/>
-          </a:xfrm>
-          <a:prstGeom xmlns:a="http://schemas.openxmlformats.org/drawingml/2006/main" prst="straightConnector1">
-            <a:avLst/>
-          </a:prstGeom>
-          <a:ln xmlns:a="http://schemas.openxmlformats.org/drawingml/2006/main" w="19050">
-            <a:solidFill>
-              <a:srgbClr val="5D7FB4"/>
-            </a:solidFill>
-            <a:prstDash val="solid"/>
-            <a:tailEnd type="triangle" w="sm" len="sm"/>
-          </a:ln>
-        </p:spPr>
-      </p:cxnSp>
-      <p:cxnSp>
-        <p:nvCxnSpPr>
-          <p:cNvPr id="1098" name=""/>
-          <p:cNvCxnSpPr>
-            <a:stCxn xmlns:a="http://schemas.openxmlformats.org/drawingml/2006/main" id="14" idx="3"/>
-            <a:endCxn xmlns:a="http://schemas.openxmlformats.org/drawingml/2006/main" id="17" idx="1"/>
-          </p:cNvCxnSpPr>
-          <p:nvPr/>
-        </p:nvCxnSpPr>
-        <p:spPr>
-          <a:xfrm xmlns:a="http://schemas.openxmlformats.org/drawingml/2006/main">
-            <a:off x="7696200" y="3048000"/>
-            <a:ext cx="2047875" cy="0"/>
           </a:xfrm>
           <a:prstGeom xmlns:a="http://schemas.openxmlformats.org/drawingml/2006/main" prst="straightConnector1">
             <a:avLst/>
@@ -6183,7 +6157,7 @@
                 <a:ea typeface="Helvetica Neue"/>
                 <a:cs typeface="Helvetica Neue"/>
               </a:rPr>
-              <a:t>CONTROLS THAT STAY</a:t>
+              <a:t>OPEN PATH</a:t>
             </a:r>
           </a:p>
         </p:txBody>
@@ -6242,7 +6216,7 @@
                 <a:ea typeface="Helvetica Neue"/>
                 <a:cs typeface="Helvetica Neue"/>
               </a:rPr>
-              <a:t>Checksums · company filter · selected source IDs · value support · source-status guard · timeout · fallback · feedback</a:t>
+              <a:t>Select company → load latest saved brief → show it. No retrieval or model call.</a:t>
             </a:r>
           </a:p>
         </p:txBody>
@@ -6301,7 +6275,7 @@
                 <a:ea typeface="Helvetica Neue"/>
                 <a:cs typeface="Helvetica Neue"/>
               </a:rPr>
-              <a:t>PRODUCTION HARDENING    Managed connectors · access rules · reviewed prompts · model policy · monitoring</a:t>
+              <a:t>REFRESH PATH    Retrieve company evidence → OpenAI writes → server checks → save and show the new brief.</a:t>
             </a:r>
           </a:p>
         </p:txBody>
@@ -6355,7 +6329,7 @@
                 <a:ea typeface="Helvetica Neue"/>
                 <a:cs typeface="Helvetica Neue"/>
               </a:rPr>
-              <a:t>1  CURRENT IMPORT · BEFORE REQUEST</a:t>
+              <a:t>1  IMPORT · PREPARE EVIDENCE</a:t>
             </a:r>
           </a:p>
         </p:txBody>
@@ -6409,7 +6383,7 @@
                 <a:ea typeface="Helvetica Neue"/>
                 <a:cs typeface="Helvetica Neue"/>
               </a:rPr>
-              <a:t>2  CURRENT BRIEF · ON REQUEST</a:t>
+              <a:t>2  BRIEF · LOAD SAVED OR BUILD NEW</a:t>
             </a:r>
           </a:p>
         </p:txBody>
@@ -6560,7 +6534,7 @@
                 <a:ea typeface="Helvetica Neue"/>
                 <a:cs typeface="Helvetica Neue"/>
               </a:rPr>
-              <a:t>Build brief</a:t>
+              <a:t>Create brief</a:t>
             </a:r>
           </a:p>
         </p:txBody>
@@ -6638,7 +6612,7 @@
                 <a:ea typeface="Helvetica Neue"/>
                 <a:cs typeface="Helvetica Neue"/>
               </a:rPr>
-              <a:t>Responses API</a:t>
+              <a:t>Strict JSON</a:t>
             </a:r>
           </a:p>
           <a:p xmlns:a="http://schemas.openxmlformats.org/drawingml/2006/main">
@@ -6662,7 +6636,7 @@
                 <a:ea typeface="Helvetica Neue"/>
                 <a:cs typeface="Helvetica Neue"/>
               </a:rPr>
-              <a:t>Selected sources</a:t>
+              <a:t>Check source IDs</a:t>
             </a:r>
           </a:p>
           <a:p xmlns:a="http://schemas.openxmlformats.org/drawingml/2006/main">
@@ -6686,7 +6660,7 @@
                 <a:ea typeface="Helvetica Neue"/>
                 <a:cs typeface="Helvetica Neue"/>
               </a:rPr>
-              <a:t>Strict checks</a:t>
+              <a:t>Check quotes and values</a:t>
             </a:r>
           </a:p>
           <a:p xmlns:a="http://schemas.openxmlformats.org/drawingml/2006/main">
@@ -6710,14 +6684,14 @@
                 <a:ea typeface="Helvetica Neue"/>
                 <a:cs typeface="Helvetica Neue"/>
               </a:rPr>
-              <a:t>Save or fallback</a:t>
+              <a:t>Save or local fallback</a:t>
             </a:r>
           </a:p>
         </p:txBody>
       </p:sp>
       <p:cxnSp>
         <p:nvCxnSpPr>
-          <p:cNvPr id="1110" name=""/>
+          <p:cNvPr id="1182" name=""/>
           <p:cNvCxnSpPr>
             <a:stCxn xmlns:a="http://schemas.openxmlformats.org/drawingml/2006/main" id="14" idx="3"/>
             <a:endCxn xmlns:a="http://schemas.openxmlformats.org/drawingml/2006/main" id="78" idx="1"/>
@@ -6743,7 +6717,7 @@
       </p:cxnSp>
       <p:cxnSp>
         <p:nvCxnSpPr>
-          <p:cNvPr id="1111" name=""/>
+          <p:cNvPr id="1183" name=""/>
           <p:cNvCxnSpPr>
             <a:stCxn xmlns:a="http://schemas.openxmlformats.org/drawingml/2006/main" id="78" idx="3"/>
             <a:endCxn xmlns:a="http://schemas.openxmlformats.org/drawingml/2006/main" id="17" idx="1"/>
@@ -6804,28 +6778,6 @@
           </a:ln>
         </p:spPr>
       </p:sp>
-      <p:pic>
-        <p:nvPicPr>
-          <p:cNvPr id="1113" name=""/>
-          <p:cNvPicPr>
-            <a:picLocks xmlns:a="http://schemas.openxmlformats.org/drawingml/2006/main" noChangeAspect="1"/>
-          </p:cNvPicPr>
-          <p:nvPr/>
-        </p:nvPicPr>
-        <p:blipFill>
-          <a:blip xmlns:r="http://schemas.openxmlformats.org/officeDocument/2006/relationships" xmlns:a="http://schemas.openxmlformats.org/drawingml/2006/main" r:embed="R904c850d77fb4b7e"/>
-          <a:stretch xmlns:a="http://schemas.openxmlformats.org/drawingml/2006/main"/>
-        </p:blipFill>
-        <p:spPr>
-          <a:xfrm xmlns:a="http://schemas.openxmlformats.org/drawingml/2006/main">
-            <a:off x="439341" y="1476375"/>
-            <a:ext cx="11084719" cy="4667250"/>
-          </a:xfrm>
-          <a:prstGeom xmlns:a="http://schemas.openxmlformats.org/drawingml/2006/main" prst="rect">
-            <a:avLst/>
-          </a:prstGeom>
-        </p:spPr>
-      </p:pic>
     </p:spTree>
     <p:extLst>
       <p:ext uri="{BB962C8B-B14F-4D97-AF65-F5344CB8AC3E}">

</xml_diff>

<commit_message>
Restore the slide 4 architecture view
</commit_message>
<xml_diff>
--- a/docs/AVIC-Portfolio-Intelligence-Brief.pptx
+++ b/docs/AVIC-Portfolio-Intelligence-Brief.pptx
@@ -2,20 +2,20 @@
 <file path=ppt/presentation.xml><?xml version="1.0" encoding="utf-8"?>
 <p:presentation xmlns:p="http://schemas.openxmlformats.org/presentationml/2006/main">
   <p:sldMasterIdLst>
-    <p:sldMasterId xmlns:r="http://schemas.openxmlformats.org/officeDocument/2006/relationships" id="2147483648" r:id="R78108e3aed324e86"/>
+    <p:sldMasterId xmlns:r="http://schemas.openxmlformats.org/officeDocument/2006/relationships" id="2147483648" r:id="Raba9e0329dec4f8c"/>
   </p:sldMasterIdLst>
   <p:notesMasterIdLst>
-    <p:notesMasterId xmlns:r="http://schemas.openxmlformats.org/officeDocument/2006/relationships" r:id="R11455d7806b14d0e"/>
+    <p:notesMasterId xmlns:r="http://schemas.openxmlformats.org/officeDocument/2006/relationships" r:id="R48b2a330f3aa4846"/>
   </p:notesMasterIdLst>
   <p:sldIdLst>
-    <p:sldId xmlns:r="http://schemas.openxmlformats.org/officeDocument/2006/relationships" id="256" r:id="R03ff38c598aa4389"/>
-    <p:sldId xmlns:r="http://schemas.openxmlformats.org/officeDocument/2006/relationships" id="257" r:id="R3754c2deeb9a4581"/>
-    <p:sldId xmlns:r="http://schemas.openxmlformats.org/officeDocument/2006/relationships" id="258" r:id="Rdff195e6cfdc4c9e"/>
-    <p:sldId xmlns:r="http://schemas.openxmlformats.org/officeDocument/2006/relationships" id="259" r:id="R71b76ff4872f40f1"/>
-    <p:sldId xmlns:r="http://schemas.openxmlformats.org/officeDocument/2006/relationships" id="260" r:id="Rb208b6f6c2664220"/>
-    <p:sldId xmlns:r="http://schemas.openxmlformats.org/officeDocument/2006/relationships" id="261" r:id="R703774e67ecf48ba"/>
-    <p:sldId xmlns:r="http://schemas.openxmlformats.org/officeDocument/2006/relationships" id="262" r:id="R1d8e795a26ad4508"/>
-    <p:sldId xmlns:r="http://schemas.openxmlformats.org/officeDocument/2006/relationships" id="263" r:id="Rd341cd892f304b05"/>
+    <p:sldId xmlns:r="http://schemas.openxmlformats.org/officeDocument/2006/relationships" id="256" r:id="R03ea8301162640e0"/>
+    <p:sldId xmlns:r="http://schemas.openxmlformats.org/officeDocument/2006/relationships" id="257" r:id="R30a9a50c85724c3a"/>
+    <p:sldId xmlns:r="http://schemas.openxmlformats.org/officeDocument/2006/relationships" id="258" r:id="R5ae73f5b0aa242d7"/>
+    <p:sldId xmlns:r="http://schemas.openxmlformats.org/officeDocument/2006/relationships" id="259" r:id="Rbb6aa721185f4078"/>
+    <p:sldId xmlns:r="http://schemas.openxmlformats.org/officeDocument/2006/relationships" id="260" r:id="Rdeafd595a50848a2"/>
+    <p:sldId xmlns:r="http://schemas.openxmlformats.org/officeDocument/2006/relationships" id="261" r:id="Rb924f051d3f84473"/>
+    <p:sldId xmlns:r="http://schemas.openxmlformats.org/officeDocument/2006/relationships" id="262" r:id="R5de2992333e049db"/>
+    <p:sldId xmlns:r="http://schemas.openxmlformats.org/officeDocument/2006/relationships" id="263" r:id="Rde078f8ad0e4472c"/>
   </p:sldIdLst>
   <p:sldSz cx="12192000" cy="6858000"/>
   <p:notesSz cx="6858000" cy="9144000"/>
@@ -744,7 +744,7 @@
           <a:lstStyle xmlns:a="http://schemas.openxmlformats.org/drawingml/2006/main"/>
           <a:p xmlns:a="http://schemas.openxmlformats.org/drawingml/2006/main">
             <a:r>
-              <a:t>Opening Lens or selecting a company first loads that company's latest saved brief. This normal open path does not run retrieval or call a model. If no saved brief exists, the app prepares and saves the first brief. Selecting Refresh brief starts the new-brief path. The retrieval service creates one query embedding, applies a hard company filter, and ranks up to 30 source records by full-text match, embedding similarity, source quality, and date. The server sends only the selected company metadata and retrieved evidence to gpt-5.6-sol through the Responses API. It requests a strict schema with low reasoning effort, no tools, and no response storage. The server checks source IDs, company isolation, exact quotes, values, qualitative support, source status, and investment safety. It saves the new brief, generation mode, model data, source ranks, and time. If generation fails a check or exceeds the time budget, local rules create a source-supported fallback. Import is separate from brief use. It validates records, maps company IDs, keeps source records, calculates checksums, creates chunks, requests embeddings for new or changed chunks, and writes them to PostgreSQL. The app does not watch a folder or Slack. To add a demo record, add it in a supported format, run import, then select Refresh brief.</a:t>
+              <a:t>Lens has three paths. First, import prepares evidence before use. It reads the fictional CRM, meeting, Slack, and news files. It validates each record, maps the company ID, creates chunks, requests embeddings, and stores the records and vectors in PostgreSQL with pgvector. Second, the open path is fast. When the principal opens Lens or selects a company, the app loads the latest saved brief. This path does not run retrieval or call a model. If the company has no saved brief, the app prepares the first one. Third, Refresh brief builds a new brief. Retrieval applies a hard company filter and ranks up to 30 records by full-text match, vector similarity, source quality, and date. The app sends only the selected evidence to gpt-5.6-sol through the OpenAI Responses API. The server checks source IDs, company isolation, direct quotes, values, source status, and investment safety. It saves the new brief and audit data. If generation fails a check or exceeds the time budget, local rules create a source-supported fallback. Import is separate from brief use. Lens does not watch a folder or Slack. To add a demo record, add it in a supported format, run import, and then select Refresh brief.</a:t>
             </a:r>
           </a:p>
           <a:p xmlns:a="http://schemas.openxmlformats.org/drawingml/2006/main">
@@ -1337,7 +1337,7 @@
   </p:cSld>
   <p:clrMap bg1="lt1" tx1="dk1" bg2="lt2" tx2="dk2" accent1="accent1" accent2="accent2" accent3="accent3" accent4="accent4" accent5="accent5" accent6="accent6" hlink="hlink" folHlink="folHlink"/>
   <p:sldLayoutIdLst>
-    <p:sldLayoutId xmlns:r="http://schemas.openxmlformats.org/officeDocument/2006/relationships" id="2147483649" r:id="Rd797764537a848bd"/>
+    <p:sldLayoutId xmlns:r="http://schemas.openxmlformats.org/officeDocument/2006/relationships" id="2147483649" r:id="R86ec7c7c39394c8b"/>
   </p:sldLayoutIdLst>
   <p:txStyles>
     <p:titleStyle>
@@ -4483,7 +4483,7 @@
           <p:nvPr/>
         </p:nvPicPr>
         <p:blipFill>
-          <a:blip xmlns:r="http://schemas.openxmlformats.org/officeDocument/2006/relationships" xmlns:a="http://schemas.openxmlformats.org/drawingml/2006/main" r:embed="R3140ffa6f7284341"/>
+          <a:blip xmlns:r="http://schemas.openxmlformats.org/officeDocument/2006/relationships" xmlns:a="http://schemas.openxmlformats.org/drawingml/2006/main" r:embed="R604e2ecfe341414c"/>
           <a:stretch xmlns:a="http://schemas.openxmlformats.org/drawingml/2006/main"/>
         </p:blipFill>
         <p:spPr>
@@ -4728,7 +4728,7 @@
                 <a:ea typeface="Helvetica Neue"/>
                 <a:cs typeface="Helvetica Neue"/>
               </a:rPr>
-              <a:t>Import prepares the evidence. Open loads the saved brief. Refresh builds and saves a new brief.</a:t>
+              <a:t>Import prepares evidence. Open loads the saved brief. Refresh retrieves evidence and builds a new brief.</a:t>
             </a:r>
           </a:p>
         </p:txBody>
@@ -4824,7 +4824,7 @@
                 <a:ea typeface="Helvetica Neue"/>
                 <a:cs typeface="Helvetica Neue"/>
               </a:rPr>
-              <a:t>Source files</a:t>
+              <a:t>Sources</a:t>
             </a:r>
           </a:p>
         </p:txBody>
@@ -4883,7 +4883,7 @@
                 <a:ea typeface="Helvetica Neue"/>
                 <a:cs typeface="Helvetica Neue"/>
               </a:rPr>
-              <a:t>Fictional CRM</a:t>
+              <a:t>Static CRM</a:t>
             </a:r>
           </a:p>
           <a:p xmlns:a="http://schemas.openxmlformats.org/drawingml/2006/main">
@@ -4979,7 +4979,7 @@
                 <a:ea typeface="Helvetica Neue"/>
                 <a:cs typeface="Helvetica Neue"/>
               </a:rPr>
-              <a:t>Static files only</a:t>
+              <a:t>No filings adapter</a:t>
             </a:r>
           </a:p>
         </p:txBody>
@@ -5134,7 +5134,7 @@
                 <a:ea typeface="Helvetica Neue"/>
                 <a:cs typeface="Helvetica Neue"/>
               </a:rPr>
-              <a:t>Read file</a:t>
+              <a:t>Read each file</a:t>
             </a:r>
           </a:p>
           <a:p xmlns:a="http://schemas.openxmlformats.org/drawingml/2006/main">
@@ -5182,7 +5182,7 @@
                 <a:ea typeface="Helvetica Neue"/>
                 <a:cs typeface="Helvetica Neue"/>
               </a:rPr>
-              <a:t>Map company ID</a:t>
+              <a:t>Check company ID</a:t>
             </a:r>
           </a:p>
           <a:p xmlns:a="http://schemas.openxmlformats.org/drawingml/2006/main">
@@ -5206,7 +5206,7 @@
                 <a:ea typeface="Helvetica Neue"/>
                 <a:cs typeface="Helvetica Neue"/>
               </a:rPr>
-              <a:t>Keep source</a:t>
+              <a:t>Keep source record</a:t>
             </a:r>
           </a:p>
           <a:p xmlns:a="http://schemas.openxmlformats.org/drawingml/2006/main">
@@ -5254,7 +5254,7 @@
                 <a:ea typeface="Helvetica Neue"/>
                 <a:cs typeface="Helvetica Neue"/>
               </a:rPr>
-              <a:t>OpenAI embeddings</a:t>
+              <a:t>Request embeddings</a:t>
             </a:r>
           </a:p>
         </p:txBody>
@@ -5385,7 +5385,7 @@
         </p:spPr>
         <p:txBody>
           <a:bodyPr xmlns:a="http://schemas.openxmlformats.org/drawingml/2006/main" anchor="t">
-            <a:normAutofit fontScale="100000"/>
+            <a:normAutofit fontScale="94180"/>
           </a:bodyPr>
           <a:lstStyle xmlns:a="http://schemas.openxmlformats.org/drawingml/2006/main"/>
           <a:p xmlns:a="http://schemas.openxmlformats.org/drawingml/2006/main">
@@ -5433,7 +5433,7 @@
                 <a:ea typeface="Helvetica Neue"/>
                 <a:cs typeface="Helvetica Neue"/>
               </a:rPr>
-              <a:t>Source records</a:t>
+              <a:t>Companies and source records</a:t>
             </a:r>
           </a:p>
           <a:p xmlns:a="http://schemas.openxmlformats.org/drawingml/2006/main">
@@ -5505,7 +5505,7 @@
                 <a:ea typeface="Helvetica Neue"/>
                 <a:cs typeface="Helvetica Neue"/>
               </a:rPr>
-              <a:t>Saved briefs and audit</a:t>
+              <a:t>Brief runs and evidence</a:t>
             </a:r>
           </a:p>
         </p:txBody>
@@ -5636,7 +5636,7 @@
         </p:spPr>
         <p:txBody>
           <a:bodyPr xmlns:a="http://schemas.openxmlformats.org/drawingml/2006/main" anchor="t">
-            <a:normAutofit fontScale="100000"/>
+            <a:normAutofit fontScale="88868"/>
           </a:bodyPr>
           <a:lstStyle xmlns:a="http://schemas.openxmlformats.org/drawingml/2006/main"/>
           <a:p xmlns:a="http://schemas.openxmlformats.org/drawingml/2006/main">
@@ -5660,7 +5660,7 @@
                 <a:ea typeface="Helvetica Neue"/>
                 <a:cs typeface="Helvetica Neue"/>
               </a:rPr>
-              <a:t>Refresh only</a:t>
+              <a:t>Create query embedding</a:t>
             </a:r>
           </a:p>
           <a:p xmlns:a="http://schemas.openxmlformats.org/drawingml/2006/main">
@@ -5684,7 +5684,7 @@
                 <a:ea typeface="Helvetica Neue"/>
                 <a:cs typeface="Helvetica Neue"/>
               </a:rPr>
-              <a:t>Embed query</a:t>
+              <a:t>Company ID filter in SQL</a:t>
             </a:r>
           </a:p>
           <a:p xmlns:a="http://schemas.openxmlformats.org/drawingml/2006/main">
@@ -5708,7 +5708,7 @@
                 <a:ea typeface="Helvetica Neue"/>
                 <a:cs typeface="Helvetica Neue"/>
               </a:rPr>
-              <a:t>Filter by company ID</a:t>
+              <a:t>Full-text and embedding search</a:t>
             </a:r>
           </a:p>
           <a:p xmlns:a="http://schemas.openxmlformats.org/drawingml/2006/main">
@@ -5732,7 +5732,7 @@
                 <a:ea typeface="Helvetica Neue"/>
                 <a:cs typeface="Helvetica Neue"/>
               </a:rPr>
-              <a:t>Full text and vectors</a:t>
+              <a:t>Rank up to 30 records</a:t>
             </a:r>
           </a:p>
           <a:p xmlns:a="http://schemas.openxmlformats.org/drawingml/2006/main">
@@ -5756,7 +5756,7 @@
                 <a:ea typeface="Helvetica Neue"/>
                 <a:cs typeface="Helvetica Neue"/>
               </a:rPr>
-              <a:t>Rank up to 30</a:t>
+              <a:t>Use quality and recency</a:t>
             </a:r>
           </a:p>
         </p:txBody>
@@ -5852,7 +5852,7 @@
                 <a:ea typeface="Helvetica Neue"/>
                 <a:cs typeface="Helvetica Neue"/>
               </a:rPr>
-              <a:t>Brief interface</a:t>
+              <a:t>Investor UI</a:t>
             </a:r>
           </a:p>
         </p:txBody>
@@ -5911,7 +5911,7 @@
                 <a:ea typeface="Helvetica Neue"/>
                 <a:cs typeface="Helvetica Neue"/>
               </a:rPr>
-              <a:t>Load saved brief</a:t>
+              <a:t>Portfolio or pipeline</a:t>
             </a:r>
           </a:p>
           <a:p xmlns:a="http://schemas.openxmlformats.org/drawingml/2006/main">
@@ -5935,7 +5935,7 @@
                 <a:ea typeface="Helvetica Neue"/>
                 <a:cs typeface="Helvetica Neue"/>
               </a:rPr>
-              <a:t>Facts, risks, questions</a:t>
+              <a:t>Brief in 30 seconds or less</a:t>
             </a:r>
           </a:p>
           <a:p xmlns:a="http://schemas.openxmlformats.org/drawingml/2006/main">
@@ -5959,7 +5959,7 @@
                 <a:ea typeface="Helvetica Neue"/>
                 <a:cs typeface="Helvetica Neue"/>
               </a:rPr>
-              <a:t>Open evidence and source</a:t>
+              <a:t>Open evidence and full source</a:t>
             </a:r>
           </a:p>
           <a:p xmlns:a="http://schemas.openxmlformats.org/drawingml/2006/main">
@@ -5990,7 +5990,7 @@
       </p:sp>
       <p:cxnSp>
         <p:nvCxnSpPr>
-          <p:cNvPr id="1168" name=""/>
+          <p:cNvPr id="1169" name=""/>
           <p:cNvCxnSpPr>
             <a:stCxn xmlns:a="http://schemas.openxmlformats.org/drawingml/2006/main" id="5" idx="3"/>
             <a:endCxn xmlns:a="http://schemas.openxmlformats.org/drawingml/2006/main" id="8" idx="1"/>
@@ -6000,32 +6000,6 @@
         <p:spPr>
           <a:xfrm xmlns:a="http://schemas.openxmlformats.org/drawingml/2006/main">
             <a:off x="2124075" y="3048000"/>
-            <a:ext cx="190500" cy="0"/>
-          </a:xfrm>
-          <a:prstGeom xmlns:a="http://schemas.openxmlformats.org/drawingml/2006/main" prst="straightConnector1">
-            <a:avLst/>
-          </a:prstGeom>
-          <a:ln xmlns:a="http://schemas.openxmlformats.org/drawingml/2006/main" w="19050">
-            <a:solidFill>
-              <a:srgbClr val="5D7FB4"/>
-            </a:solidFill>
-            <a:prstDash val="solid"/>
-            <a:tailEnd type="triangle" w="sm" len="sm"/>
-          </a:ln>
-        </p:spPr>
-      </p:cxnSp>
-      <p:cxnSp>
-        <p:nvCxnSpPr>
-          <p:cNvPr id="1169" name=""/>
-          <p:cNvCxnSpPr>
-            <a:stCxn xmlns:a="http://schemas.openxmlformats.org/drawingml/2006/main" id="8" idx="3"/>
-            <a:endCxn xmlns:a="http://schemas.openxmlformats.org/drawingml/2006/main" id="11" idx="1"/>
-          </p:cNvCxnSpPr>
-          <p:nvPr/>
-        </p:nvCxnSpPr>
-        <p:spPr>
-          <a:xfrm xmlns:a="http://schemas.openxmlformats.org/drawingml/2006/main">
-            <a:off x="3981450" y="3048000"/>
             <a:ext cx="190500" cy="0"/>
           </a:xfrm>
           <a:prstGeom xmlns:a="http://schemas.openxmlformats.org/drawingml/2006/main" prst="straightConnector1">
@@ -6044,6 +6018,32 @@
         <p:nvCxnSpPr>
           <p:cNvPr id="1170" name=""/>
           <p:cNvCxnSpPr>
+            <a:stCxn xmlns:a="http://schemas.openxmlformats.org/drawingml/2006/main" id="8" idx="3"/>
+            <a:endCxn xmlns:a="http://schemas.openxmlformats.org/drawingml/2006/main" id="11" idx="1"/>
+          </p:cNvCxnSpPr>
+          <p:nvPr/>
+        </p:nvCxnSpPr>
+        <p:spPr>
+          <a:xfrm xmlns:a="http://schemas.openxmlformats.org/drawingml/2006/main">
+            <a:off x="3981450" y="3048000"/>
+            <a:ext cx="190500" cy="0"/>
+          </a:xfrm>
+          <a:prstGeom xmlns:a="http://schemas.openxmlformats.org/drawingml/2006/main" prst="straightConnector1">
+            <a:avLst/>
+          </a:prstGeom>
+          <a:ln xmlns:a="http://schemas.openxmlformats.org/drawingml/2006/main" w="19050">
+            <a:solidFill>
+              <a:srgbClr val="5D7FB4"/>
+            </a:solidFill>
+            <a:prstDash val="solid"/>
+            <a:tailEnd type="triangle" w="sm" len="sm"/>
+          </a:ln>
+        </p:spPr>
+      </p:cxnSp>
+      <p:cxnSp>
+        <p:nvCxnSpPr>
+          <p:cNvPr id="1171" name=""/>
+          <p:cNvCxnSpPr>
             <a:stCxn xmlns:a="http://schemas.openxmlformats.org/drawingml/2006/main" id="11" idx="3"/>
             <a:endCxn xmlns:a="http://schemas.openxmlformats.org/drawingml/2006/main" id="14" idx="1"/>
           </p:cNvCxnSpPr>
@@ -6053,6 +6053,32 @@
           <a:xfrm xmlns:a="http://schemas.openxmlformats.org/drawingml/2006/main">
             <a:off x="5838825" y="3048000"/>
             <a:ext cx="190500" cy="0"/>
+          </a:xfrm>
+          <a:prstGeom xmlns:a="http://schemas.openxmlformats.org/drawingml/2006/main" prst="straightConnector1">
+            <a:avLst/>
+          </a:prstGeom>
+          <a:ln xmlns:a="http://schemas.openxmlformats.org/drawingml/2006/main" w="19050">
+            <a:solidFill>
+              <a:srgbClr val="5D7FB4"/>
+            </a:solidFill>
+            <a:prstDash val="solid"/>
+            <a:tailEnd type="triangle" w="sm" len="sm"/>
+          </a:ln>
+        </p:spPr>
+      </p:cxnSp>
+      <p:cxnSp>
+        <p:nvCxnSpPr>
+          <p:cNvPr id="1172" name=""/>
+          <p:cNvCxnSpPr>
+            <a:stCxn xmlns:a="http://schemas.openxmlformats.org/drawingml/2006/main" id="14" idx="3"/>
+            <a:endCxn xmlns:a="http://schemas.openxmlformats.org/drawingml/2006/main" id="17" idx="1"/>
+          </p:cNvCxnSpPr>
+          <p:nvPr/>
+        </p:nvCxnSpPr>
+        <p:spPr>
+          <a:xfrm xmlns:a="http://schemas.openxmlformats.org/drawingml/2006/main">
+            <a:off x="7696200" y="3048000"/>
+            <a:ext cx="2047875" cy="0"/>
           </a:xfrm>
           <a:prstGeom xmlns:a="http://schemas.openxmlformats.org/drawingml/2006/main" prst="straightConnector1">
             <a:avLst/>
@@ -6157,7 +6183,7 @@
                 <a:ea typeface="Helvetica Neue"/>
                 <a:cs typeface="Helvetica Neue"/>
               </a:rPr>
-              <a:t>OPEN PATH</a:t>
+              <a:t>CONTROLS THAT STAY</a:t>
             </a:r>
           </a:p>
         </p:txBody>
@@ -6216,7 +6242,7 @@
                 <a:ea typeface="Helvetica Neue"/>
                 <a:cs typeface="Helvetica Neue"/>
               </a:rPr>
-              <a:t>Select company → load latest saved brief → show it. No retrieval or model call.</a:t>
+              <a:t>Checksums · company filter · selected source IDs · value support · source-status guard · timeout · fallback · feedback</a:t>
             </a:r>
           </a:p>
         </p:txBody>
@@ -6275,7 +6301,7 @@
                 <a:ea typeface="Helvetica Neue"/>
                 <a:cs typeface="Helvetica Neue"/>
               </a:rPr>
-              <a:t>REFRESH PATH    Retrieve company evidence → OpenAI writes → server checks → save and show the new brief.</a:t>
+              <a:t>PRODUCTION HARDENING    Managed connectors · access rules · reviewed prompts · model policy · monitoring</a:t>
             </a:r>
           </a:p>
         </p:txBody>
@@ -6329,7 +6355,7 @@
                 <a:ea typeface="Helvetica Neue"/>
                 <a:cs typeface="Helvetica Neue"/>
               </a:rPr>
-              <a:t>1  IMPORT · PREPARE EVIDENCE</a:t>
+              <a:t>1  CURRENT IMPORT · BEFORE REQUEST</a:t>
             </a:r>
           </a:p>
         </p:txBody>
@@ -6383,7 +6409,7 @@
                 <a:ea typeface="Helvetica Neue"/>
                 <a:cs typeface="Helvetica Neue"/>
               </a:rPr>
-              <a:t>2  BRIEF · LOAD SAVED OR BUILD NEW</a:t>
+              <a:t>2  CURRENT BRIEF · ON REQUEST</a:t>
             </a:r>
           </a:p>
         </p:txBody>
@@ -6534,7 +6560,7 @@
                 <a:ea typeface="Helvetica Neue"/>
                 <a:cs typeface="Helvetica Neue"/>
               </a:rPr>
-              <a:t>Create brief</a:t>
+              <a:t>Build brief</a:t>
             </a:r>
           </a:p>
         </p:txBody>
@@ -6612,7 +6638,7 @@
                 <a:ea typeface="Helvetica Neue"/>
                 <a:cs typeface="Helvetica Neue"/>
               </a:rPr>
-              <a:t>Strict JSON</a:t>
+              <a:t>Responses API</a:t>
             </a:r>
           </a:p>
           <a:p xmlns:a="http://schemas.openxmlformats.org/drawingml/2006/main">
@@ -6636,7 +6662,7 @@
                 <a:ea typeface="Helvetica Neue"/>
                 <a:cs typeface="Helvetica Neue"/>
               </a:rPr>
-              <a:t>Check source IDs</a:t>
+              <a:t>Selected sources</a:t>
             </a:r>
           </a:p>
           <a:p xmlns:a="http://schemas.openxmlformats.org/drawingml/2006/main">
@@ -6660,7 +6686,7 @@
                 <a:ea typeface="Helvetica Neue"/>
                 <a:cs typeface="Helvetica Neue"/>
               </a:rPr>
-              <a:t>Check quotes and values</a:t>
+              <a:t>Strict checks</a:t>
             </a:r>
           </a:p>
           <a:p xmlns:a="http://schemas.openxmlformats.org/drawingml/2006/main">
@@ -6684,14 +6710,14 @@
                 <a:ea typeface="Helvetica Neue"/>
                 <a:cs typeface="Helvetica Neue"/>
               </a:rPr>
-              <a:t>Save or local fallback</a:t>
+              <a:t>Save or fallback</a:t>
             </a:r>
           </a:p>
         </p:txBody>
       </p:sp>
       <p:cxnSp>
         <p:nvCxnSpPr>
-          <p:cNvPr id="1182" name=""/>
+          <p:cNvPr id="1184" name=""/>
           <p:cNvCxnSpPr>
             <a:stCxn xmlns:a="http://schemas.openxmlformats.org/drawingml/2006/main" id="14" idx="3"/>
             <a:endCxn xmlns:a="http://schemas.openxmlformats.org/drawingml/2006/main" id="78" idx="1"/>
@@ -6717,7 +6743,7 @@
       </p:cxnSp>
       <p:cxnSp>
         <p:nvCxnSpPr>
-          <p:cNvPr id="1183" name=""/>
+          <p:cNvPr id="1185" name=""/>
           <p:cNvCxnSpPr>
             <a:stCxn xmlns:a="http://schemas.openxmlformats.org/drawingml/2006/main" id="78" idx="3"/>
             <a:endCxn xmlns:a="http://schemas.openxmlformats.org/drawingml/2006/main" id="17" idx="1"/>
@@ -6778,6 +6804,28 @@
           </a:ln>
         </p:spPr>
       </p:sp>
+      <p:pic>
+        <p:nvPicPr>
+          <p:cNvPr id="1187" name=""/>
+          <p:cNvPicPr>
+            <a:picLocks xmlns:a="http://schemas.openxmlformats.org/drawingml/2006/main" noChangeAspect="1"/>
+          </p:cNvPicPr>
+          <p:nvPr/>
+        </p:nvPicPr>
+        <p:blipFill>
+          <a:blip xmlns:r="http://schemas.openxmlformats.org/officeDocument/2006/relationships" xmlns:a="http://schemas.openxmlformats.org/drawingml/2006/main" r:embed="R53a9f4e35b704481"/>
+          <a:stretch xmlns:a="http://schemas.openxmlformats.org/drawingml/2006/main"/>
+        </p:blipFill>
+        <p:spPr>
+          <a:xfrm xmlns:a="http://schemas.openxmlformats.org/drawingml/2006/main" flipH="0" flipV="0">
+            <a:off x="439341" y="1476375"/>
+            <a:ext cx="11084719" cy="4667250"/>
+          </a:xfrm>
+          <a:prstGeom xmlns:a="http://schemas.openxmlformats.org/drawingml/2006/main" prst="rect">
+            <a:avLst/>
+          </a:prstGeom>
+        </p:spPr>
+      </p:pic>
     </p:spTree>
     <p:extLst>
       <p:ext uri="{BB962C8B-B14F-4D97-AF65-F5344CB8AC3E}">

</xml_diff>

<commit_message>
Remove slide 6 from the deck
</commit_message>
<xml_diff>
--- a/docs/AVIC-Portfolio-Intelligence-Brief.pptx
+++ b/docs/AVIC-Portfolio-Intelligence-Brief.pptx
@@ -2,20 +2,19 @@
 <file path=ppt/presentation.xml><?xml version="1.0" encoding="utf-8"?>
 <p:presentation xmlns:p="http://schemas.openxmlformats.org/presentationml/2006/main">
   <p:sldMasterIdLst>
-    <p:sldMasterId xmlns:r="http://schemas.openxmlformats.org/officeDocument/2006/relationships" id="2147483648" r:id="Raba9e0329dec4f8c"/>
+    <p:sldMasterId xmlns:r="http://schemas.openxmlformats.org/officeDocument/2006/relationships" id="2147483648" r:id="R2dc6f99b2e2a40dd"/>
   </p:sldMasterIdLst>
   <p:notesMasterIdLst>
-    <p:notesMasterId xmlns:r="http://schemas.openxmlformats.org/officeDocument/2006/relationships" r:id="R48b2a330f3aa4846"/>
+    <p:notesMasterId xmlns:r="http://schemas.openxmlformats.org/officeDocument/2006/relationships" r:id="R52151129f8b6430c"/>
   </p:notesMasterIdLst>
   <p:sldIdLst>
-    <p:sldId xmlns:r="http://schemas.openxmlformats.org/officeDocument/2006/relationships" id="256" r:id="R03ea8301162640e0"/>
-    <p:sldId xmlns:r="http://schemas.openxmlformats.org/officeDocument/2006/relationships" id="257" r:id="R30a9a50c85724c3a"/>
-    <p:sldId xmlns:r="http://schemas.openxmlformats.org/officeDocument/2006/relationships" id="258" r:id="R5ae73f5b0aa242d7"/>
-    <p:sldId xmlns:r="http://schemas.openxmlformats.org/officeDocument/2006/relationships" id="259" r:id="Rbb6aa721185f4078"/>
-    <p:sldId xmlns:r="http://schemas.openxmlformats.org/officeDocument/2006/relationships" id="260" r:id="Rdeafd595a50848a2"/>
-    <p:sldId xmlns:r="http://schemas.openxmlformats.org/officeDocument/2006/relationships" id="261" r:id="Rb924f051d3f84473"/>
-    <p:sldId xmlns:r="http://schemas.openxmlformats.org/officeDocument/2006/relationships" id="262" r:id="R5de2992333e049db"/>
-    <p:sldId xmlns:r="http://schemas.openxmlformats.org/officeDocument/2006/relationships" id="263" r:id="Rde078f8ad0e4472c"/>
+    <p:sldId xmlns:r="http://schemas.openxmlformats.org/officeDocument/2006/relationships" id="256" r:id="R9003943a41ed4348"/>
+    <p:sldId xmlns:r="http://schemas.openxmlformats.org/officeDocument/2006/relationships" id="257" r:id="R52a588e157e0430d"/>
+    <p:sldId xmlns:r="http://schemas.openxmlformats.org/officeDocument/2006/relationships" id="258" r:id="R2438b7664de24802"/>
+    <p:sldId xmlns:r="http://schemas.openxmlformats.org/officeDocument/2006/relationships" id="259" r:id="R7d1cf84c64734b60"/>
+    <p:sldId xmlns:r="http://schemas.openxmlformats.org/officeDocument/2006/relationships" id="260" r:id="Re94225012ab84231"/>
+    <p:sldId xmlns:r="http://schemas.openxmlformats.org/officeDocument/2006/relationships" id="261" r:id="Rdd9ac5107b8b46bb"/>
+    <p:sldId xmlns:r="http://schemas.openxmlformats.org/officeDocument/2006/relationships" id="262" r:id="R8bde937300fc44fd"/>
   </p:sldIdLst>
   <p:sldSz cx="12192000" cy="6858000"/>
   <p:notesSz cx="6858000" cy="9144000"/>
@@ -1009,7 +1008,7 @@
           <a:lstStyle xmlns:a="http://schemas.openxmlformats.org/drawingml/2006/main"/>
           <a:p xmlns:a="http://schemas.openxmlformats.org/drawingml/2006/main">
             <a:r>
-              <a:t>These are V1 acceptance criteria, not current production service levels. The 4 out of 5 usefulness score is a pilot target and has not been measured.</a:t>
+              <a:t>This is a proposed plan for two people. The 250-company test appears in weeks 7 and 8 because it has not been run. Weeks 5 and 6 include retrieval evaluation and generation-and-fallback evaluation. The plan depends on source access, company IDs, access rules, and review time from the AIVC principal.</a:t>
             </a:r>
           </a:p>
           <a:p xmlns:a="http://schemas.openxmlformats.org/drawingml/2006/main">
@@ -1019,6 +1018,11 @@
           </a:p>
           <a:p xmlns:a="http://schemas.openxmlformats.org/drawingml/2006/main">
             <a:r>
+              <a:t/>
+            </a:r>
+          </a:p>
+          <a:p xmlns:a="http://schemas.openxmlformats.org/drawingml/2006/main">
+            <a:r>
               <a:t>[Sources]</a:t>
             </a:r>
           </a:p>
@@ -1034,7 +1038,12 @@
           </a:p>
           <a:p xmlns:a="http://schemas.openxmlformats.org/drawingml/2006/main">
             <a:r>
-              <a:t>- /Users/alexthorpe/Documents/GitHub/AVIC/scripts/verify-v1.ts</a:t>
+              <a:t>- /Users/alexthorpe/Documents/GitHub/AVIC/docs/architecture.md</a:t>
+            </a:r>
+          </a:p>
+          <a:p xmlns:a="http://schemas.openxmlformats.org/drawingml/2006/main">
+            <a:r>
+              <a:t>- /Users/alexthorpe/Documents/GitHub/AVIC/scripts/verify-generation.ts</a:t>
             </a:r>
           </a:p>
           <a:p xmlns:a="http://schemas.openxmlformats.org/drawingml/2006/main">
@@ -1070,116 +1079,6 @@
 </file>
 
 <file path=ppt/notesSlides/notesSlide7.xml><?xml version="1.0" encoding="utf-8"?>
-<p:notes xmlns:p="http://schemas.openxmlformats.org/presentationml/2006/main">
-  <p:cSld>
-    <p:spTree>
-      <p:nvGrpSpPr>
-        <p:cNvPr id="1" name=""/>
-        <p:cNvGrpSpPr/>
-        <p:nvPr/>
-      </p:nvGrpSpPr>
-      <p:grpSpPr>
-        <a:xfrm xmlns:a="http://schemas.openxmlformats.org/drawingml/2006/main"/>
-      </p:grpSpPr>
-      <p:sp>
-        <p:nvSpPr>
-          <p:cNvPr id="2" name="Slide Image Placeholder 1"/>
-          <p:cNvSpPr>
-            <a:spLocks xmlns:a="http://schemas.openxmlformats.org/drawingml/2006/main" noGrp="1"/>
-          </p:cNvSpPr>
-          <p:nvPr>
-            <p:ph type="sldImg" idx="0"/>
-          </p:nvPr>
-        </p:nvSpPr>
-        <p:spPr/>
-      </p:sp>
-      <p:sp>
-        <p:nvSpPr>
-          <p:cNvPr id="3" name="Notes Placeholder 2"/>
-          <p:cNvSpPr>
-            <a:spLocks xmlns:a="http://schemas.openxmlformats.org/drawingml/2006/main" noGrp="1"/>
-          </p:cNvSpPr>
-          <p:nvPr>
-            <p:ph type="body" idx="1"/>
-          </p:nvPr>
-        </p:nvSpPr>
-        <p:spPr/>
-        <p:txBody>
-          <a:bodyPr xmlns:a="http://schemas.openxmlformats.org/drawingml/2006/main"/>
-          <a:lstStyle xmlns:a="http://schemas.openxmlformats.org/drawingml/2006/main"/>
-          <a:p xmlns:a="http://schemas.openxmlformats.org/drawingml/2006/main">
-            <a:r>
-              <a:t>This is a proposed plan for two people. The 250-company test appears in weeks 7 and 8 because it has not been run. Weeks 5 and 6 include retrieval evaluation and generation-and-fallback evaluation. The plan depends on source access, company IDs, access rules, and review time from the AIVC principal.</a:t>
-            </a:r>
-          </a:p>
-          <a:p xmlns:a="http://schemas.openxmlformats.org/drawingml/2006/main">
-            <a:r>
-              <a:t/>
-            </a:r>
-          </a:p>
-          <a:p xmlns:a="http://schemas.openxmlformats.org/drawingml/2006/main">
-            <a:r>
-              <a:t/>
-            </a:r>
-          </a:p>
-          <a:p xmlns:a="http://schemas.openxmlformats.org/drawingml/2006/main">
-            <a:r>
-              <a:t>[Sources]</a:t>
-            </a:r>
-          </a:p>
-          <a:p xmlns:a="http://schemas.openxmlformats.org/drawingml/2006/main">
-            <a:r>
-              <a:t>- /Users/alexthorpe/Documents/GitHub/AVIC/docs/AIVC_Technical_Challenge_Task_4.2.pdf</a:t>
-            </a:r>
-          </a:p>
-          <a:p xmlns:a="http://schemas.openxmlformats.org/drawingml/2006/main">
-            <a:r>
-              <a:t>- /Users/alexthorpe/Documents/GitHub/AVIC/docs/prd-v1.md</a:t>
-            </a:r>
-          </a:p>
-          <a:p xmlns:a="http://schemas.openxmlformats.org/drawingml/2006/main">
-            <a:r>
-              <a:t>- /Users/alexthorpe/Documents/GitHub/AVIC/docs/architecture.md</a:t>
-            </a:r>
-          </a:p>
-          <a:p xmlns:a="http://schemas.openxmlformats.org/drawingml/2006/main">
-            <a:r>
-              <a:t>- /Users/alexthorpe/Documents/GitHub/AVIC/scripts/verify-generation.ts</a:t>
-            </a:r>
-          </a:p>
-          <a:p xmlns:a="http://schemas.openxmlformats.org/drawingml/2006/main">
-            <a:r>
-              <a:t>[/Sources]</a:t>
-            </a:r>
-          </a:p>
-        </p:txBody>
-      </p:sp>
-      <p:sp>
-        <p:nvSpPr>
-          <p:cNvPr id="4" name="Slide Number Placeholder 3"/>
-          <p:cNvSpPr>
-            <a:spLocks xmlns:a="http://schemas.openxmlformats.org/drawingml/2006/main" noGrp="1"/>
-          </p:cNvSpPr>
-          <p:nvPr>
-            <p:ph type="sldNum" idx="5"/>
-          </p:nvPr>
-        </p:nvSpPr>
-        <p:spPr/>
-        <p:txBody>
-          <a:bodyPr xmlns:a="http://schemas.openxmlformats.org/drawingml/2006/main"/>
-          <a:lstStyle xmlns:a="http://schemas.openxmlformats.org/drawingml/2006/main"/>
-          <a:p xmlns:a="http://schemas.openxmlformats.org/drawingml/2006/main"/>
-        </p:txBody>
-      </p:sp>
-    </p:spTree>
-  </p:cSld>
-  <p:clrMapOvr>
-    <a:masterClrMapping xmlns:a="http://schemas.openxmlformats.org/drawingml/2006/main"/>
-  </p:clrMapOvr>
-</p:notes>
-</file>
-
-<file path=ppt/notesSlides/notesSlide8.xml><?xml version="1.0" encoding="utf-8"?>
 <p:notes xmlns:p="http://schemas.openxmlformats.org/presentationml/2006/main">
   <p:cSld>
     <p:spTree>
@@ -1337,7 +1236,7 @@
   </p:cSld>
   <p:clrMap bg1="lt1" tx1="dk1" bg2="lt2" tx2="dk2" accent1="accent1" accent2="accent2" accent3="accent3" accent4="accent4" accent5="accent5" accent6="accent6" hlink="hlink" folHlink="folHlink"/>
   <p:sldLayoutIdLst>
-    <p:sldLayoutId xmlns:r="http://schemas.openxmlformats.org/officeDocument/2006/relationships" id="2147483649" r:id="R86ec7c7c39394c8b"/>
+    <p:sldLayoutId xmlns:r="http://schemas.openxmlformats.org/officeDocument/2006/relationships" id="2147483649" r:id="Rc19335f50eb947b4"/>
   </p:sldLayoutIdLst>
   <p:txStyles>
     <p:titleStyle>
@@ -4483,7 +4382,7 @@
           <p:nvPr/>
         </p:nvPicPr>
         <p:blipFill>
-          <a:blip xmlns:r="http://schemas.openxmlformats.org/officeDocument/2006/relationships" xmlns:a="http://schemas.openxmlformats.org/drawingml/2006/main" r:embed="R604e2ecfe341414c"/>
+          <a:blip xmlns:r="http://schemas.openxmlformats.org/officeDocument/2006/relationships" xmlns:a="http://schemas.openxmlformats.org/drawingml/2006/main" r:embed="R1164259a882c4baf"/>
           <a:stretch xmlns:a="http://schemas.openxmlformats.org/drawingml/2006/main"/>
         </p:blipFill>
         <p:spPr>
@@ -5990,7 +5889,7 @@
       </p:sp>
       <p:cxnSp>
         <p:nvCxnSpPr>
-          <p:cNvPr id="1169" name=""/>
+          <p:cNvPr id="1243" name=""/>
           <p:cNvCxnSpPr>
             <a:stCxn xmlns:a="http://schemas.openxmlformats.org/drawingml/2006/main" id="5" idx="3"/>
             <a:endCxn xmlns:a="http://schemas.openxmlformats.org/drawingml/2006/main" id="8" idx="1"/>
@@ -6016,7 +5915,7 @@
       </p:cxnSp>
       <p:cxnSp>
         <p:nvCxnSpPr>
-          <p:cNvPr id="1170" name=""/>
+          <p:cNvPr id="1244" name=""/>
           <p:cNvCxnSpPr>
             <a:stCxn xmlns:a="http://schemas.openxmlformats.org/drawingml/2006/main" id="8" idx="3"/>
             <a:endCxn xmlns:a="http://schemas.openxmlformats.org/drawingml/2006/main" id="11" idx="1"/>
@@ -6042,7 +5941,7 @@
       </p:cxnSp>
       <p:cxnSp>
         <p:nvCxnSpPr>
-          <p:cNvPr id="1171" name=""/>
+          <p:cNvPr id="1245" name=""/>
           <p:cNvCxnSpPr>
             <a:stCxn xmlns:a="http://schemas.openxmlformats.org/drawingml/2006/main" id="11" idx="3"/>
             <a:endCxn xmlns:a="http://schemas.openxmlformats.org/drawingml/2006/main" id="14" idx="1"/>
@@ -6068,7 +5967,7 @@
       </p:cxnSp>
       <p:cxnSp>
         <p:nvCxnSpPr>
-          <p:cNvPr id="1172" name=""/>
+          <p:cNvPr id="1246" name=""/>
           <p:cNvCxnSpPr>
             <a:stCxn xmlns:a="http://schemas.openxmlformats.org/drawingml/2006/main" id="14" idx="3"/>
             <a:endCxn xmlns:a="http://schemas.openxmlformats.org/drawingml/2006/main" id="17" idx="1"/>
@@ -6717,7 +6616,7 @@
       </p:sp>
       <p:cxnSp>
         <p:nvCxnSpPr>
-          <p:cNvPr id="1184" name=""/>
+          <p:cNvPr id="1258" name=""/>
           <p:cNvCxnSpPr>
             <a:stCxn xmlns:a="http://schemas.openxmlformats.org/drawingml/2006/main" id="14" idx="3"/>
             <a:endCxn xmlns:a="http://schemas.openxmlformats.org/drawingml/2006/main" id="78" idx="1"/>
@@ -6743,7 +6642,7 @@
       </p:cxnSp>
       <p:cxnSp>
         <p:nvCxnSpPr>
-          <p:cNvPr id="1185" name=""/>
+          <p:cNvPr id="1259" name=""/>
           <p:cNvCxnSpPr>
             <a:stCxn xmlns:a="http://schemas.openxmlformats.org/drawingml/2006/main" id="78" idx="3"/>
             <a:endCxn xmlns:a="http://schemas.openxmlformats.org/drawingml/2006/main" id="17" idx="1"/>
@@ -6806,14 +6705,14 @@
       </p:sp>
       <p:pic>
         <p:nvPicPr>
-          <p:cNvPr id="1187" name=""/>
+          <p:cNvPr id="1261" name=""/>
           <p:cNvPicPr>
             <a:picLocks xmlns:a="http://schemas.openxmlformats.org/drawingml/2006/main" noChangeAspect="1"/>
           </p:cNvPicPr>
           <p:nvPr/>
         </p:nvPicPr>
         <p:blipFill>
-          <a:blip xmlns:r="http://schemas.openxmlformats.org/officeDocument/2006/relationships" xmlns:a="http://schemas.openxmlformats.org/drawingml/2006/main" r:embed="R53a9f4e35b704481"/>
+          <a:blip xmlns:r="http://schemas.openxmlformats.org/officeDocument/2006/relationships" xmlns:a="http://schemas.openxmlformats.org/drawingml/2006/main" r:embed="R1f79be84c1f24591"/>
           <a:stretch xmlns:a="http://schemas.openxmlformats.org/drawingml/2006/main"/>
         </p:blipFill>
         <p:spPr>
@@ -7763,10 +7662,10 @@
       </p:grpSpPr>
       <p:sp>
         <p:nvSpPr>
-          <p:cNvPr id="25" name="">
-            <a:extLst xmlns:a="http://schemas.openxmlformats.org/drawingml/2006/main">
-              <a:ext uri="{FF2B5EF4-FFF2-40B4-BE49-F238E27FC236}">
-                <a16:creationId xmlns:a16="http://schemas.microsoft.com/office/drawing/2014/main" id="{DCB3F631-F107-449F-8532-F0F6CF09ED9C}"/>
+          <p:cNvPr id="29" name="">
+            <a:extLst xmlns:a="http://schemas.openxmlformats.org/drawingml/2006/main">
+              <a:ext uri="{FF2B5EF4-FFF2-40B4-BE49-F238E27FC236}">
+                <a16:creationId xmlns:a16="http://schemas.microsoft.com/office/drawing/2014/main" id="{B48A21C7-CE03-4BC4-898F-2976E47ACF7A}"/>
               </a:ext>
             </a:extLst>
           </p:cNvPr>
@@ -7791,7 +7690,7 @@
         </p:spPr>
         <p:txBody>
           <a:bodyPr xmlns:a="http://schemas.openxmlformats.org/drawingml/2006/main" anchor="t">
-            <a:normAutofit fontScale="100000"/>
+            <a:normAutofit fontScale="97554"/>
           </a:bodyPr>
           <a:lstStyle xmlns:a="http://schemas.openxmlformats.org/drawingml/2006/main"/>
           <a:p xmlns:a="http://schemas.openxmlformats.org/drawingml/2006/main">
@@ -7815,7 +7714,7 @@
                 <a:ea typeface="Helvetica Neue"/>
                 <a:cs typeface="Helvetica Neue"/>
               </a:rPr>
-              <a:t>What is good enough to ship as production V1?</a:t>
+              <a:t>How would two people reach an internal pilot in eight weeks?</a:t>
             </a:r>
           </a:p>
         </p:txBody>
@@ -7825,7 +7724,7 @@
           <p:cNvPr id="2" name="">
             <a:extLst xmlns:a="http://schemas.openxmlformats.org/drawingml/2006/main">
               <a:ext uri="{FF2B5EF4-FFF2-40B4-BE49-F238E27FC236}">
-                <a16:creationId xmlns:a16="http://schemas.microsoft.com/office/drawing/2014/main" id="{FA2C5372-4CF1-4AE4-A3CD-4E138F754CA8}"/>
+                <a16:creationId xmlns:a16="http://schemas.microsoft.com/office/drawing/2014/main" id="{09B70858-4A35-41AC-BA4E-97385B0D613C}"/>
               </a:ext>
             </a:extLst>
           </p:cNvPr>
@@ -7856,7 +7755,7 @@
           <p:cNvPr id="3" name="">
             <a:extLst xmlns:a="http://schemas.openxmlformats.org/drawingml/2006/main">
               <a:ext uri="{FF2B5EF4-FFF2-40B4-BE49-F238E27FC236}">
-                <a16:creationId xmlns:a16="http://schemas.microsoft.com/office/drawing/2014/main" id="{4839D6B0-80AA-4FCC-9C2D-6D215827FBA5}"/>
+                <a16:creationId xmlns:a16="http://schemas.microsoft.com/office/drawing/2014/main" id="{6932D16F-3E93-49C8-A083-E6763E45CD17}"/>
               </a:ext>
             </a:extLst>
           </p:cNvPr>
@@ -7913,23 +7812,384 @@
           <p:cNvPr id="4" name="">
             <a:extLst xmlns:a="http://schemas.openxmlformats.org/drawingml/2006/main">
               <a:ext uri="{FF2B5EF4-FFF2-40B4-BE49-F238E27FC236}">
-                <a16:creationId xmlns:a16="http://schemas.microsoft.com/office/drawing/2014/main" id="{82E64302-6EE1-4371-AB23-0D77F5FE7F75}"/>
-              </a:ext>
-            </a:extLst>
-          </p:cNvPr>
-          <p:cNvSpPr>
-            <a:spLocks xmlns:a="http://schemas.openxmlformats.org/drawingml/2006/main" noGrp="1"/>
-          </p:cNvSpPr>
-          <p:nvPr/>
-        </p:nvSpPr>
-        <p:spPr>
-          <a:xfrm xmlns:a="http://schemas.openxmlformats.org/drawingml/2006/main">
-            <a:off x="457200" y="1466850"/>
-            <a:ext cx="10858500" cy="952500"/>
+                <a16:creationId xmlns:a16="http://schemas.microsoft.com/office/drawing/2014/main" id="{F6AA8900-8D83-489E-AEA5-4DF6BA250739}"/>
+              </a:ext>
+            </a:extLst>
+          </p:cNvPr>
+          <p:cNvSpPr>
+            <a:spLocks xmlns:a="http://schemas.openxmlformats.org/drawingml/2006/main" noGrp="1"/>
+          </p:cNvSpPr>
+          <p:nvPr/>
+        </p:nvSpPr>
+        <p:spPr>
+          <a:xfrm xmlns:a="http://schemas.openxmlformats.org/drawingml/2006/main">
+            <a:off x="1057275" y="2324100"/>
+            <a:ext cx="9001125" cy="0"/>
+          </a:xfrm>
+          <a:prstGeom xmlns:a="http://schemas.openxmlformats.org/drawingml/2006/main" prst="line">
+            <a:avLst/>
+          </a:prstGeom>
+          <a:noFill xmlns:a="http://schemas.openxmlformats.org/drawingml/2006/main"/>
+          <a:ln xmlns:a="http://schemas.openxmlformats.org/drawingml/2006/main" w="28575">
+            <a:solidFill>
+              <a:srgbClr val="9CB5D5"/>
+            </a:solidFill>
+            <a:prstDash val="solid"/>
+          </a:ln>
+        </p:spPr>
+      </p:sp>
+      <p:sp>
+        <p:nvSpPr>
+          <p:cNvPr id="5" name="">
+            <a:extLst xmlns:a="http://schemas.openxmlformats.org/drawingml/2006/main">
+              <a:ext uri="{FF2B5EF4-FFF2-40B4-BE49-F238E27FC236}">
+                <a16:creationId xmlns:a16="http://schemas.microsoft.com/office/drawing/2014/main" id="{20A0FB16-277A-415B-B0A6-8E73C2815796}"/>
+              </a:ext>
+            </a:extLst>
+          </p:cNvPr>
+          <p:cNvSpPr>
+            <a:spLocks xmlns:a="http://schemas.openxmlformats.org/drawingml/2006/main" noGrp="1"/>
+          </p:cNvSpPr>
+          <p:nvPr/>
+        </p:nvSpPr>
+        <p:spPr>
+          <a:xfrm xmlns:a="http://schemas.openxmlformats.org/drawingml/2006/main">
+            <a:off x="1476375" y="2171700"/>
+            <a:ext cx="228600" cy="228600"/>
           </a:xfrm>
           <a:prstGeom xmlns:a="http://schemas.openxmlformats.org/drawingml/2006/main" prst="roundRect">
             <a:avLst>
-              <a:gd name="adj" fmla="val 16000"/>
+              <a:gd name="adj" fmla="val 50000"/>
+            </a:avLst>
+          </a:prstGeom>
+          <a:solidFill xmlns:a="http://schemas.openxmlformats.org/drawingml/2006/main">
+            <a:srgbClr val="315F9F"/>
+          </a:solidFill>
+          <a:ln xmlns:a="http://schemas.openxmlformats.org/drawingml/2006/main" w="9525">
+            <a:solidFill>
+              <a:srgbClr val="315F9F"/>
+            </a:solidFill>
+            <a:prstDash val="solid"/>
+          </a:ln>
+        </p:spPr>
+      </p:sp>
+      <p:sp>
+        <p:nvSpPr>
+          <p:cNvPr id="6" name="">
+            <a:extLst xmlns:a="http://schemas.openxmlformats.org/drawingml/2006/main">
+              <a:ext uri="{FF2B5EF4-FFF2-40B4-BE49-F238E27FC236}">
+                <a16:creationId xmlns:a16="http://schemas.microsoft.com/office/drawing/2014/main" id="{03049BA2-9994-4F21-94A5-B41BE3149E4E}"/>
+              </a:ext>
+            </a:extLst>
+          </p:cNvPr>
+          <p:cNvSpPr>
+            <a:spLocks xmlns:a="http://schemas.openxmlformats.org/drawingml/2006/main" noGrp="1"/>
+          </p:cNvSpPr>
+          <p:nvPr/>
+        </p:nvSpPr>
+        <p:spPr>
+          <a:xfrm xmlns:a="http://schemas.openxmlformats.org/drawingml/2006/main">
+            <a:off x="457200" y="2609850"/>
+            <a:ext cx="2457450" cy="2476500"/>
+          </a:xfrm>
+          <a:prstGeom xmlns:a="http://schemas.openxmlformats.org/drawingml/2006/main" prst="roundRect">
+            <a:avLst>
+              <a:gd name="adj" fmla="val 6202"/>
+            </a:avLst>
+          </a:prstGeom>
+          <a:solidFill xmlns:a="http://schemas.openxmlformats.org/drawingml/2006/main">
+            <a:srgbClr val="FFFFFF"/>
+          </a:solidFill>
+          <a:ln xmlns:a="http://schemas.openxmlformats.org/drawingml/2006/main" w="9525">
+            <a:solidFill>
+              <a:srgbClr val="D0D5DD"/>
+            </a:solidFill>
+            <a:prstDash val="solid"/>
+          </a:ln>
+        </p:spPr>
+      </p:sp>
+      <p:sp>
+        <p:nvSpPr>
+          <p:cNvPr id="7" name="">
+            <a:extLst xmlns:a="http://schemas.openxmlformats.org/drawingml/2006/main">
+              <a:ext uri="{FF2B5EF4-FFF2-40B4-BE49-F238E27FC236}">
+                <a16:creationId xmlns:a16="http://schemas.microsoft.com/office/drawing/2014/main" id="{1F65D154-8701-4349-9AFF-7DA254E7C5CA}"/>
+              </a:ext>
+            </a:extLst>
+          </p:cNvPr>
+          <p:cNvSpPr>
+            <a:spLocks xmlns:a="http://schemas.openxmlformats.org/drawingml/2006/main" noGrp="1"/>
+          </p:cNvSpPr>
+          <p:nvPr/>
+        </p:nvSpPr>
+        <p:spPr>
+          <a:xfrm xmlns:a="http://schemas.openxmlformats.org/drawingml/2006/main">
+            <a:off x="666750" y="2838450"/>
+            <a:ext cx="2000250" cy="209550"/>
+          </a:xfrm>
+          <a:prstGeom xmlns:a="http://schemas.openxmlformats.org/drawingml/2006/main" prst="rect">
+            <a:avLst/>
+          </a:prstGeom>
+          <a:noFill xmlns:a="http://schemas.openxmlformats.org/drawingml/2006/main"/>
+          <a:ln xmlns:a="http://schemas.openxmlformats.org/drawingml/2006/main" w="0">
+            <a:noFill/>
+            <a:prstDash val="solid"/>
+          </a:ln>
+        </p:spPr>
+        <p:txBody>
+          <a:bodyPr xmlns:a="http://schemas.openxmlformats.org/drawingml/2006/main" anchor="t">
+            <a:normAutofit fontScale="86111"/>
+          </a:bodyPr>
+          <a:lstStyle xmlns:a="http://schemas.openxmlformats.org/drawingml/2006/main"/>
+          <a:p xmlns:a="http://schemas.openxmlformats.org/drawingml/2006/main">
+            <a:pPr algn="l">
+              <a:buNone/>
+              <a:defRPr sz="1050" b="1">
+                <a:solidFill>
+                  <a:srgbClr val="315F9F"/>
+                </a:solidFill>
+                <a:latin typeface="Helvetica Neue"/>
+                <a:ea typeface="Helvetica Neue"/>
+                <a:cs typeface="Helvetica Neue"/>
+              </a:defRPr>
+            </a:pPr>
+            <a:r>
+              <a:rPr sz="900" b="1">
+                <a:solidFill>
+                  <a:srgbClr val="315F9F"/>
+                </a:solidFill>
+                <a:latin typeface="Helvetica Neue"/>
+                <a:ea typeface="Helvetica Neue"/>
+                <a:cs typeface="Helvetica Neue"/>
+              </a:rPr>
+              <a:t>PROPOSED · WEEKS 1–2</a:t>
+            </a:r>
+          </a:p>
+        </p:txBody>
+      </p:sp>
+      <p:sp>
+        <p:nvSpPr>
+          <p:cNvPr id="8" name="">
+            <a:extLst xmlns:a="http://schemas.openxmlformats.org/drawingml/2006/main">
+              <a:ext uri="{FF2B5EF4-FFF2-40B4-BE49-F238E27FC236}">
+                <a16:creationId xmlns:a16="http://schemas.microsoft.com/office/drawing/2014/main" id="{C64C3219-E26B-4090-B4AC-9A1D699133EC}"/>
+              </a:ext>
+            </a:extLst>
+          </p:cNvPr>
+          <p:cNvSpPr>
+            <a:spLocks xmlns:a="http://schemas.openxmlformats.org/drawingml/2006/main" noGrp="1"/>
+          </p:cNvSpPr>
+          <p:nvPr/>
+        </p:nvSpPr>
+        <p:spPr>
+          <a:xfrm xmlns:a="http://schemas.openxmlformats.org/drawingml/2006/main">
+            <a:off x="666750" y="3209925"/>
+            <a:ext cx="2038350" cy="438150"/>
+          </a:xfrm>
+          <a:prstGeom xmlns:a="http://schemas.openxmlformats.org/drawingml/2006/main" prst="rect">
+            <a:avLst/>
+          </a:prstGeom>
+          <a:noFill xmlns:a="http://schemas.openxmlformats.org/drawingml/2006/main"/>
+          <a:ln xmlns:a="http://schemas.openxmlformats.org/drawingml/2006/main" w="0">
+            <a:noFill/>
+            <a:prstDash val="solid"/>
+          </a:ln>
+        </p:spPr>
+        <p:txBody>
+          <a:bodyPr xmlns:a="http://schemas.openxmlformats.org/drawingml/2006/main" anchor="t">
+            <a:normAutofit fontScale="68939"/>
+          </a:bodyPr>
+          <a:lstStyle xmlns:a="http://schemas.openxmlformats.org/drawingml/2006/main"/>
+          <a:p xmlns:a="http://schemas.openxmlformats.org/drawingml/2006/main">
+            <a:pPr algn="l">
+              <a:buNone/>
+              <a:defRPr sz="1650" b="1">
+                <a:solidFill>
+                  <a:srgbClr val="101828"/>
+                </a:solidFill>
+                <a:latin typeface="Helvetica Neue"/>
+                <a:ea typeface="Helvetica Neue"/>
+                <a:cs typeface="Helvetica Neue"/>
+              </a:defRPr>
+            </a:pPr>
+            <a:r>
+              <a:rPr sz="1650" b="1">
+                <a:solidFill>
+                  <a:srgbClr val="101828"/>
+                </a:solidFill>
+                <a:latin typeface="Helvetica Neue"/>
+                <a:ea typeface="Helvetica Neue"/>
+                <a:cs typeface="Helvetica Neue"/>
+              </a:rPr>
+              <a:t>Build one source-to-brief path</a:t>
+            </a:r>
+          </a:p>
+        </p:txBody>
+      </p:sp>
+      <p:sp>
+        <p:nvSpPr>
+          <p:cNvPr id="9" name="">
+            <a:extLst xmlns:a="http://schemas.openxmlformats.org/drawingml/2006/main">
+              <a:ext uri="{FF2B5EF4-FFF2-40B4-BE49-F238E27FC236}">
+                <a16:creationId xmlns:a16="http://schemas.microsoft.com/office/drawing/2014/main" id="{EF101CF2-9E15-45BA-BEE2-9A4742BA8580}"/>
+              </a:ext>
+            </a:extLst>
+          </p:cNvPr>
+          <p:cNvSpPr>
+            <a:spLocks xmlns:a="http://schemas.openxmlformats.org/drawingml/2006/main" noGrp="1"/>
+          </p:cNvSpPr>
+          <p:nvPr/>
+        </p:nvSpPr>
+        <p:spPr>
+          <a:xfrm xmlns:a="http://schemas.openxmlformats.org/drawingml/2006/main">
+            <a:off x="666750" y="3876675"/>
+            <a:ext cx="2038350" cy="952500"/>
+          </a:xfrm>
+          <a:prstGeom xmlns:a="http://schemas.openxmlformats.org/drawingml/2006/main" prst="rect">
+            <a:avLst/>
+          </a:prstGeom>
+          <a:noFill xmlns:a="http://schemas.openxmlformats.org/drawingml/2006/main"/>
+          <a:ln xmlns:a="http://schemas.openxmlformats.org/drawingml/2006/main" w="0">
+            <a:noFill/>
+            <a:prstDash val="solid"/>
+          </a:ln>
+        </p:spPr>
+        <p:txBody>
+          <a:bodyPr xmlns:a="http://schemas.openxmlformats.org/drawingml/2006/main" anchor="t">
+            <a:normAutofit fontScale="100000"/>
+          </a:bodyPr>
+          <a:lstStyle xmlns:a="http://schemas.openxmlformats.org/drawingml/2006/main"/>
+          <a:p xmlns:a="http://schemas.openxmlformats.org/drawingml/2006/main">
+            <a:pPr algn="l">
+              <a:buNone/>
+              <a:defRPr sz="1275" b="0">
+                <a:solidFill>
+                  <a:srgbClr val="344054"/>
+                </a:solidFill>
+                <a:latin typeface="Helvetica Neue"/>
+                <a:ea typeface="Helvetica Neue"/>
+                <a:cs typeface="Helvetica Neue"/>
+              </a:defRPr>
+            </a:pPr>
+            <a:r>
+              <a:rPr sz="1275" b="0">
+                <a:solidFill>
+                  <a:srgbClr val="344054"/>
+                </a:solidFill>
+                <a:latin typeface="Helvetica Neue"/>
+                <a:ea typeface="Helvetica Neue"/>
+                <a:cs typeface="Helvetica Neue"/>
+              </a:rPr>
+              <a:t>Reference answers</a:t>
+            </a:r>
+          </a:p>
+          <a:p xmlns:a="http://schemas.openxmlformats.org/drawingml/2006/main">
+            <a:pPr algn="l">
+              <a:buNone/>
+              <a:defRPr sz="1275" b="0">
+                <a:solidFill>
+                  <a:srgbClr val="344054"/>
+                </a:solidFill>
+                <a:latin typeface="Helvetica Neue"/>
+                <a:ea typeface="Helvetica Neue"/>
+                <a:cs typeface="Helvetica Neue"/>
+              </a:defRPr>
+            </a:pPr>
+            <a:r>
+              <a:rPr sz="1275" b="0">
+                <a:solidFill>
+                  <a:srgbClr val="344054"/>
+                </a:solidFill>
+                <a:latin typeface="Helvetica Neue"/>
+                <a:ea typeface="Helvetica Neue"/>
+                <a:cs typeface="Helvetica Neue"/>
+              </a:rPr>
+              <a:t>Source contract</a:t>
+            </a:r>
+          </a:p>
+          <a:p xmlns:a="http://schemas.openxmlformats.org/drawingml/2006/main">
+            <a:pPr algn="l">
+              <a:buNone/>
+              <a:defRPr sz="1275" b="0">
+                <a:solidFill>
+                  <a:srgbClr val="344054"/>
+                </a:solidFill>
+                <a:latin typeface="Helvetica Neue"/>
+                <a:ea typeface="Helvetica Neue"/>
+                <a:cs typeface="Helvetica Neue"/>
+              </a:defRPr>
+            </a:pPr>
+            <a:r>
+              <a:rPr sz="1275" b="0">
+                <a:solidFill>
+                  <a:srgbClr val="344054"/>
+                </a:solidFill>
+                <a:latin typeface="Helvetica Neue"/>
+                <a:ea typeface="Helvetica Neue"/>
+                <a:cs typeface="Helvetica Neue"/>
+              </a:rPr>
+              <a:t>One-company slice</a:t>
+            </a:r>
+          </a:p>
+        </p:txBody>
+      </p:sp>
+      <p:sp>
+        <p:nvSpPr>
+          <p:cNvPr id="10" name="">
+            <a:extLst xmlns:a="http://schemas.openxmlformats.org/drawingml/2006/main">
+              <a:ext uri="{FF2B5EF4-FFF2-40B4-BE49-F238E27FC236}">
+                <a16:creationId xmlns:a16="http://schemas.microsoft.com/office/drawing/2014/main" id="{7AB3725A-8499-4B9F-902D-1547D90E1C54}"/>
+              </a:ext>
+            </a:extLst>
+          </p:cNvPr>
+          <p:cNvSpPr>
+            <a:spLocks xmlns:a="http://schemas.openxmlformats.org/drawingml/2006/main" noGrp="1"/>
+          </p:cNvSpPr>
+          <p:nvPr/>
+        </p:nvSpPr>
+        <p:spPr>
+          <a:xfrm xmlns:a="http://schemas.openxmlformats.org/drawingml/2006/main">
+            <a:off x="4210050" y="2171700"/>
+            <a:ext cx="228600" cy="228600"/>
+          </a:xfrm>
+          <a:prstGeom xmlns:a="http://schemas.openxmlformats.org/drawingml/2006/main" prst="roundRect">
+            <a:avLst>
+              <a:gd name="adj" fmla="val 50000"/>
+            </a:avLst>
+          </a:prstGeom>
+          <a:solidFill xmlns:a="http://schemas.openxmlformats.org/drawingml/2006/main">
+            <a:srgbClr val="315F9F"/>
+          </a:solidFill>
+          <a:ln xmlns:a="http://schemas.openxmlformats.org/drawingml/2006/main" w="9525">
+            <a:solidFill>
+              <a:srgbClr val="315F9F"/>
+            </a:solidFill>
+            <a:prstDash val="solid"/>
+          </a:ln>
+        </p:spPr>
+      </p:sp>
+      <p:sp>
+        <p:nvSpPr>
+          <p:cNvPr id="11" name="">
+            <a:extLst xmlns:a="http://schemas.openxmlformats.org/drawingml/2006/main">
+              <a:ext uri="{FF2B5EF4-FFF2-40B4-BE49-F238E27FC236}">
+                <a16:creationId xmlns:a16="http://schemas.microsoft.com/office/drawing/2014/main" id="{913AFA8F-4649-4DC7-8F2E-34007EF14B85}"/>
+              </a:ext>
+            </a:extLst>
+          </p:cNvPr>
+          <p:cNvSpPr>
+            <a:spLocks xmlns:a="http://schemas.openxmlformats.org/drawingml/2006/main" noGrp="1"/>
+          </p:cNvSpPr>
+          <p:nvPr/>
+        </p:nvSpPr>
+        <p:spPr>
+          <a:xfrm xmlns:a="http://schemas.openxmlformats.org/drawingml/2006/main">
+            <a:off x="3190875" y="2609850"/>
+            <a:ext cx="2457450" cy="2476500"/>
+          </a:xfrm>
+          <a:prstGeom xmlns:a="http://schemas.openxmlformats.org/drawingml/2006/main" prst="roundRect">
+            <a:avLst>
+              <a:gd name="adj" fmla="val 6202"/>
             </a:avLst>
           </a:prstGeom>
           <a:solidFill xmlns:a="http://schemas.openxmlformats.org/drawingml/2006/main">
@@ -7945,22 +8205,22 @@
       </p:sp>
       <p:sp>
         <p:nvSpPr>
-          <p:cNvPr id="5" name="">
-            <a:extLst xmlns:a="http://schemas.openxmlformats.org/drawingml/2006/main">
-              <a:ext uri="{FF2B5EF4-FFF2-40B4-BE49-F238E27FC236}">
-                <a16:creationId xmlns:a16="http://schemas.microsoft.com/office/drawing/2014/main" id="{4A1BEC42-0504-4404-8738-11D6F8F404B8}"/>
-              </a:ext>
-            </a:extLst>
-          </p:cNvPr>
-          <p:cNvSpPr>
-            <a:spLocks xmlns:a="http://schemas.openxmlformats.org/drawingml/2006/main" noGrp="1"/>
-          </p:cNvSpPr>
-          <p:nvPr/>
-        </p:nvSpPr>
-        <p:spPr>
-          <a:xfrm xmlns:a="http://schemas.openxmlformats.org/drawingml/2006/main">
-            <a:off x="685800" y="1657350"/>
-            <a:ext cx="3333750" cy="228600"/>
+          <p:cNvPr id="12" name="">
+            <a:extLst xmlns:a="http://schemas.openxmlformats.org/drawingml/2006/main">
+              <a:ext uri="{FF2B5EF4-FFF2-40B4-BE49-F238E27FC236}">
+                <a16:creationId xmlns:a16="http://schemas.microsoft.com/office/drawing/2014/main" id="{FA8820BD-E9D8-4EE0-91EF-A42C6781D2EC}"/>
+              </a:ext>
+            </a:extLst>
+          </p:cNvPr>
+          <p:cNvSpPr>
+            <a:spLocks xmlns:a="http://schemas.openxmlformats.org/drawingml/2006/main" noGrp="1"/>
+          </p:cNvSpPr>
+          <p:nvPr/>
+        </p:nvSpPr>
+        <p:spPr>
+          <a:xfrm xmlns:a="http://schemas.openxmlformats.org/drawingml/2006/main">
+            <a:off x="3400425" y="2838450"/>
+            <a:ext cx="2000250" cy="209550"/>
           </a:xfrm>
           <a:prstGeom xmlns:a="http://schemas.openxmlformats.org/drawingml/2006/main" prst="rect">
             <a:avLst/>
@@ -7972,14 +8232,12 @@
           </a:ln>
         </p:spPr>
         <p:txBody>
-          <a:bodyPr xmlns:a="http://schemas.openxmlformats.org/drawingml/2006/main" anchor="t">
-            <a:normAutofit fontScale="70588"/>
-          </a:bodyPr>
-          <a:lstStyle xmlns:a="http://schemas.openxmlformats.org/drawingml/2006/main"/>
-          <a:p xmlns:a="http://schemas.openxmlformats.org/drawingml/2006/main">
-            <a:pPr algn="l">
-              <a:buNone/>
-              <a:defRPr sz="1275" b="1">
+          <a:bodyPr xmlns:a="http://schemas.openxmlformats.org/drawingml/2006/main" anchor="t"/>
+          <a:lstStyle xmlns:a="http://schemas.openxmlformats.org/drawingml/2006/main"/>
+          <a:p xmlns:a="http://schemas.openxmlformats.org/drawingml/2006/main">
+            <a:pPr algn="l">
+              <a:buNone/>
+              <a:defRPr sz="1050" b="1">
                 <a:solidFill>
                   <a:srgbClr val="315F9F"/>
                 </a:solidFill>
@@ -7989,7 +8247,7 @@
               </a:defRPr>
             </a:pPr>
             <a:r>
-              <a:rPr sz="1275" b="1">
+              <a:rPr sz="1050" b="1">
                 <a:solidFill>
                   <a:srgbClr val="315F9F"/>
                 </a:solidFill>
@@ -7997,29 +8255,29 @@
                 <a:ea typeface="Helvetica Neue"/>
                 <a:cs typeface="Helvetica Neue"/>
               </a:rPr>
-              <a:t>V1 TARGET · CONTROLLED INTERNAL PILOT</a:t>
-            </a:r>
-          </a:p>
-        </p:txBody>
-      </p:sp>
-      <p:sp>
-        <p:nvSpPr>
-          <p:cNvPr id="6" name="">
-            <a:extLst xmlns:a="http://schemas.openxmlformats.org/drawingml/2006/main">
-              <a:ext uri="{FF2B5EF4-FFF2-40B4-BE49-F238E27FC236}">
-                <a16:creationId xmlns:a16="http://schemas.microsoft.com/office/drawing/2014/main" id="{58AABA6B-7522-4752-984B-13A58F66327C}"/>
-              </a:ext>
-            </a:extLst>
-          </p:cNvPr>
-          <p:cNvSpPr>
-            <a:spLocks xmlns:a="http://schemas.openxmlformats.org/drawingml/2006/main" noGrp="1"/>
-          </p:cNvSpPr>
-          <p:nvPr/>
-        </p:nvSpPr>
-        <p:spPr>
-          <a:xfrm xmlns:a="http://schemas.openxmlformats.org/drawingml/2006/main">
-            <a:off x="685800" y="1952625"/>
-            <a:ext cx="10096500" cy="361950"/>
+              <a:t>WEEKS 3–4</a:t>
+            </a:r>
+          </a:p>
+        </p:txBody>
+      </p:sp>
+      <p:sp>
+        <p:nvSpPr>
+          <p:cNvPr id="13" name="">
+            <a:extLst xmlns:a="http://schemas.openxmlformats.org/drawingml/2006/main">
+              <a:ext uri="{FF2B5EF4-FFF2-40B4-BE49-F238E27FC236}">
+                <a16:creationId xmlns:a16="http://schemas.microsoft.com/office/drawing/2014/main" id="{D25C1FD4-F4A1-44A7-A1AC-BFCA9E9B513A}"/>
+              </a:ext>
+            </a:extLst>
+          </p:cNvPr>
+          <p:cNvSpPr>
+            <a:spLocks xmlns:a="http://schemas.openxmlformats.org/drawingml/2006/main" noGrp="1"/>
+          </p:cNvSpPr>
+          <p:nvPr/>
+        </p:nvSpPr>
+        <p:spPr>
+          <a:xfrm xmlns:a="http://schemas.openxmlformats.org/drawingml/2006/main">
+            <a:off x="3400425" y="3209925"/>
+            <a:ext cx="2038350" cy="438150"/>
           </a:xfrm>
           <a:prstGeom xmlns:a="http://schemas.openxmlformats.org/drawingml/2006/main" prst="rect">
             <a:avLst/>
@@ -8032,57 +8290,199 @@
         </p:spPr>
         <p:txBody>
           <a:bodyPr xmlns:a="http://schemas.openxmlformats.org/drawingml/2006/main" anchor="t">
+            <a:normAutofit fontScale="68939"/>
+          </a:bodyPr>
+          <a:lstStyle xmlns:a="http://schemas.openxmlformats.org/drawingml/2006/main"/>
+          <a:p xmlns:a="http://schemas.openxmlformats.org/drawingml/2006/main">
+            <a:pPr algn="l">
+              <a:buNone/>
+              <a:defRPr sz="1650" b="1">
+                <a:solidFill>
+                  <a:srgbClr val="101828"/>
+                </a:solidFill>
+                <a:latin typeface="Helvetica Neue"/>
+                <a:ea typeface="Helvetica Neue"/>
+                <a:cs typeface="Helvetica Neue"/>
+              </a:defRPr>
+            </a:pPr>
+            <a:r>
+              <a:rPr sz="1650" b="1">
+                <a:solidFill>
+                  <a:srgbClr val="101828"/>
+                </a:solidFill>
+                <a:latin typeface="Helvetica Neue"/>
+                <a:ea typeface="Helvetica Neue"/>
+                <a:cs typeface="Helvetica Neue"/>
+              </a:rPr>
+              <a:t>Connect one approved source</a:t>
+            </a:r>
+          </a:p>
+        </p:txBody>
+      </p:sp>
+      <p:sp>
+        <p:nvSpPr>
+          <p:cNvPr id="14" name="">
+            <a:extLst xmlns:a="http://schemas.openxmlformats.org/drawingml/2006/main">
+              <a:ext uri="{FF2B5EF4-FFF2-40B4-BE49-F238E27FC236}">
+                <a16:creationId xmlns:a16="http://schemas.microsoft.com/office/drawing/2014/main" id="{D6F8C5E2-CF81-455B-A842-DB2C25910D2D}"/>
+              </a:ext>
+            </a:extLst>
+          </p:cNvPr>
+          <p:cNvSpPr>
+            <a:spLocks xmlns:a="http://schemas.openxmlformats.org/drawingml/2006/main" noGrp="1"/>
+          </p:cNvSpPr>
+          <p:nvPr/>
+        </p:nvSpPr>
+        <p:spPr>
+          <a:xfrm xmlns:a="http://schemas.openxmlformats.org/drawingml/2006/main">
+            <a:off x="3400425" y="3876675"/>
+            <a:ext cx="2038350" cy="952500"/>
+          </a:xfrm>
+          <a:prstGeom xmlns:a="http://schemas.openxmlformats.org/drawingml/2006/main" prst="rect">
+            <a:avLst/>
+          </a:prstGeom>
+          <a:noFill xmlns:a="http://schemas.openxmlformats.org/drawingml/2006/main"/>
+          <a:ln xmlns:a="http://schemas.openxmlformats.org/drawingml/2006/main" w="0">
+            <a:noFill/>
+            <a:prstDash val="solid"/>
+          </a:ln>
+        </p:spPr>
+        <p:txBody>
+          <a:bodyPr xmlns:a="http://schemas.openxmlformats.org/drawingml/2006/main" anchor="t">
             <a:normAutofit fontScale="100000"/>
           </a:bodyPr>
           <a:lstStyle xmlns:a="http://schemas.openxmlformats.org/drawingml/2006/main"/>
           <a:p xmlns:a="http://schemas.openxmlformats.org/drawingml/2006/main">
             <a:pPr algn="l">
               <a:buNone/>
-              <a:defRPr sz="1425" b="1">
-                <a:solidFill>
-                  <a:srgbClr val="101828"/>
-                </a:solidFill>
-                <a:latin typeface="Helvetica Neue"/>
-                <a:ea typeface="Helvetica Neue"/>
-                <a:cs typeface="Helvetica Neue"/>
-              </a:defRPr>
-            </a:pPr>
-            <a:r>
-              <a:rPr sz="1425" b="1">
-                <a:solidFill>
-                  <a:srgbClr val="101828"/>
-                </a:solidFill>
-                <a:latin typeface="Helvetica Neue"/>
-                <a:ea typeface="Helvetica Neue"/>
-                <a:cs typeface="Helvetica Neue"/>
-              </a:rPr>
-              <a:t>Move the proof of concept to approved data, access rules, monitored imports, and a named review owner.</a:t>
-            </a:r>
-          </a:p>
-        </p:txBody>
-      </p:sp>
-      <p:sp>
-        <p:nvSpPr>
-          <p:cNvPr id="7" name="">
-            <a:extLst xmlns:a="http://schemas.openxmlformats.org/drawingml/2006/main">
-              <a:ext uri="{FF2B5EF4-FFF2-40B4-BE49-F238E27FC236}">
-                <a16:creationId xmlns:a16="http://schemas.microsoft.com/office/drawing/2014/main" id="{B2253D5B-CB83-4217-B157-E169C1C86900}"/>
-              </a:ext>
-            </a:extLst>
-          </p:cNvPr>
-          <p:cNvSpPr>
-            <a:spLocks xmlns:a="http://schemas.openxmlformats.org/drawingml/2006/main" noGrp="1"/>
-          </p:cNvSpPr>
-          <p:nvPr/>
-        </p:nvSpPr>
-        <p:spPr>
-          <a:xfrm xmlns:a="http://schemas.openxmlformats.org/drawingml/2006/main">
-            <a:off x="457200" y="2781300"/>
-            <a:ext cx="2571750" cy="2038350"/>
+              <a:defRPr sz="1275" b="0">
+                <a:solidFill>
+                  <a:srgbClr val="344054"/>
+                </a:solidFill>
+                <a:latin typeface="Helvetica Neue"/>
+                <a:ea typeface="Helvetica Neue"/>
+                <a:cs typeface="Helvetica Neue"/>
+              </a:defRPr>
+            </a:pPr>
+            <a:r>
+              <a:rPr sz="1275" b="0">
+                <a:solidFill>
+                  <a:srgbClr val="344054"/>
+                </a:solidFill>
+                <a:latin typeface="Helvetica Neue"/>
+                <a:ea typeface="Helvetica Neue"/>
+                <a:cs typeface="Helvetica Neue"/>
+              </a:rPr>
+              <a:t>Read-only connector</a:t>
+            </a:r>
+          </a:p>
+          <a:p xmlns:a="http://schemas.openxmlformats.org/drawingml/2006/main">
+            <a:pPr algn="l">
+              <a:buNone/>
+              <a:defRPr sz="1275" b="0">
+                <a:solidFill>
+                  <a:srgbClr val="344054"/>
+                </a:solidFill>
+                <a:latin typeface="Helvetica Neue"/>
+                <a:ea typeface="Helvetica Neue"/>
+                <a:cs typeface="Helvetica Neue"/>
+              </a:defRPr>
+            </a:pPr>
+            <a:r>
+              <a:rPr sz="1275" b="0">
+                <a:solidFill>
+                  <a:srgbClr val="344054"/>
+                </a:solidFill>
+                <a:latin typeface="Helvetica Neue"/>
+                <a:ea typeface="Helvetica Neue"/>
+                <a:cs typeface="Helvetica Neue"/>
+              </a:rPr>
+              <a:t>Incremental import</a:t>
+            </a:r>
+          </a:p>
+          <a:p xmlns:a="http://schemas.openxmlformats.org/drawingml/2006/main">
+            <a:pPr algn="l">
+              <a:buNone/>
+              <a:defRPr sz="1275" b="0">
+                <a:solidFill>
+                  <a:srgbClr val="344054"/>
+                </a:solidFill>
+                <a:latin typeface="Helvetica Neue"/>
+                <a:ea typeface="Helvetica Neue"/>
+                <a:cs typeface="Helvetica Neue"/>
+              </a:defRPr>
+            </a:pPr>
+            <a:r>
+              <a:rPr sz="1275" b="0">
+                <a:solidFill>
+                  <a:srgbClr val="344054"/>
+                </a:solidFill>
+                <a:latin typeface="Helvetica Neue"/>
+                <a:ea typeface="Helvetica Neue"/>
+                <a:cs typeface="Helvetica Neue"/>
+              </a:rPr>
+              <a:t>Company mapping check</a:t>
+            </a:r>
+          </a:p>
+        </p:txBody>
+      </p:sp>
+      <p:sp>
+        <p:nvSpPr>
+          <p:cNvPr id="15" name="">
+            <a:extLst xmlns:a="http://schemas.openxmlformats.org/drawingml/2006/main">
+              <a:ext uri="{FF2B5EF4-FFF2-40B4-BE49-F238E27FC236}">
+                <a16:creationId xmlns:a16="http://schemas.microsoft.com/office/drawing/2014/main" id="{008777A7-B3A0-4F97-B3F1-99FA5E7A7BC0}"/>
+              </a:ext>
+            </a:extLst>
+          </p:cNvPr>
+          <p:cNvSpPr>
+            <a:spLocks xmlns:a="http://schemas.openxmlformats.org/drawingml/2006/main" noGrp="1"/>
+          </p:cNvSpPr>
+          <p:nvPr/>
+        </p:nvSpPr>
+        <p:spPr>
+          <a:xfrm xmlns:a="http://schemas.openxmlformats.org/drawingml/2006/main">
+            <a:off x="6943725" y="2171700"/>
+            <a:ext cx="228600" cy="228600"/>
           </a:xfrm>
           <a:prstGeom xmlns:a="http://schemas.openxmlformats.org/drawingml/2006/main" prst="roundRect">
             <a:avLst>
-              <a:gd name="adj" fmla="val 7477"/>
+              <a:gd name="adj" fmla="val 50000"/>
+            </a:avLst>
+          </a:prstGeom>
+          <a:solidFill xmlns:a="http://schemas.openxmlformats.org/drawingml/2006/main">
+            <a:srgbClr val="315F9F"/>
+          </a:solidFill>
+          <a:ln xmlns:a="http://schemas.openxmlformats.org/drawingml/2006/main" w="9525">
+            <a:solidFill>
+              <a:srgbClr val="315F9F"/>
+            </a:solidFill>
+            <a:prstDash val="solid"/>
+          </a:ln>
+        </p:spPr>
+      </p:sp>
+      <p:sp>
+        <p:nvSpPr>
+          <p:cNvPr id="16" name="">
+            <a:extLst xmlns:a="http://schemas.openxmlformats.org/drawingml/2006/main">
+              <a:ext uri="{FF2B5EF4-FFF2-40B4-BE49-F238E27FC236}">
+                <a16:creationId xmlns:a16="http://schemas.microsoft.com/office/drawing/2014/main" id="{85A70862-469D-415E-AC13-2BF4C28F4C7B}"/>
+              </a:ext>
+            </a:extLst>
+          </p:cNvPr>
+          <p:cNvSpPr>
+            <a:spLocks xmlns:a="http://schemas.openxmlformats.org/drawingml/2006/main" noGrp="1"/>
+          </p:cNvSpPr>
+          <p:nvPr/>
+        </p:nvSpPr>
+        <p:spPr>
+          <a:xfrm xmlns:a="http://schemas.openxmlformats.org/drawingml/2006/main">
+            <a:off x="5924550" y="2609850"/>
+            <a:ext cx="2457450" cy="2476500"/>
+          </a:xfrm>
+          <a:prstGeom xmlns:a="http://schemas.openxmlformats.org/drawingml/2006/main" prst="roundRect">
+            <a:avLst>
+              <a:gd name="adj" fmla="val 6202"/>
             </a:avLst>
           </a:prstGeom>
           <a:solidFill xmlns:a="http://schemas.openxmlformats.org/drawingml/2006/main">
@@ -8098,22 +8498,22 @@
       </p:sp>
       <p:sp>
         <p:nvSpPr>
-          <p:cNvPr id="8" name="">
-            <a:extLst xmlns:a="http://schemas.openxmlformats.org/drawingml/2006/main">
-              <a:ext uri="{FF2B5EF4-FFF2-40B4-BE49-F238E27FC236}">
-                <a16:creationId xmlns:a16="http://schemas.microsoft.com/office/drawing/2014/main" id="{9B98B8DF-CD87-4BEC-BD37-808E72CD6957}"/>
-              </a:ext>
-            </a:extLst>
-          </p:cNvPr>
-          <p:cNvSpPr>
-            <a:spLocks xmlns:a="http://schemas.openxmlformats.org/drawingml/2006/main" noGrp="1"/>
-          </p:cNvSpPr>
-          <p:nvPr/>
-        </p:nvSpPr>
-        <p:spPr>
-          <a:xfrm xmlns:a="http://schemas.openxmlformats.org/drawingml/2006/main">
-            <a:off x="666750" y="3009900"/>
-            <a:ext cx="2095500" cy="209550"/>
+          <p:cNvPr id="17" name="">
+            <a:extLst xmlns:a="http://schemas.openxmlformats.org/drawingml/2006/main">
+              <a:ext uri="{FF2B5EF4-FFF2-40B4-BE49-F238E27FC236}">
+                <a16:creationId xmlns:a16="http://schemas.microsoft.com/office/drawing/2014/main" id="{2F40EFA4-B3E1-48E9-B048-F8D6BD7FAC88}"/>
+              </a:ext>
+            </a:extLst>
+          </p:cNvPr>
+          <p:cNvSpPr>
+            <a:spLocks xmlns:a="http://schemas.openxmlformats.org/drawingml/2006/main" noGrp="1"/>
+          </p:cNvSpPr>
+          <p:nvPr/>
+        </p:nvSpPr>
+        <p:spPr>
+          <a:xfrm xmlns:a="http://schemas.openxmlformats.org/drawingml/2006/main">
+            <a:off x="6134100" y="2838450"/>
+            <a:ext cx="2000250" cy="209550"/>
           </a:xfrm>
           <a:prstGeom xmlns:a="http://schemas.openxmlformats.org/drawingml/2006/main" prst="rect">
             <a:avLst/>
@@ -8125,9 +8525,7 @@
           </a:ln>
         </p:spPr>
         <p:txBody>
-          <a:bodyPr xmlns:a="http://schemas.openxmlformats.org/drawingml/2006/main" anchor="t">
-            <a:normAutofit fontScale="73809"/>
-          </a:bodyPr>
+          <a:bodyPr xmlns:a="http://schemas.openxmlformats.org/drawingml/2006/main" anchor="t"/>
           <a:lstStyle xmlns:a="http://schemas.openxmlformats.org/drawingml/2006/main"/>
           <a:p xmlns:a="http://schemas.openxmlformats.org/drawingml/2006/main">
             <a:pPr algn="l">
@@ -8150,29 +8548,29 @@
                 <a:ea typeface="Helvetica Neue"/>
                 <a:cs typeface="Helvetica Neue"/>
               </a:rPr>
-              <a:t>CORE USER STORIES</a:t>
-            </a:r>
-          </a:p>
-        </p:txBody>
-      </p:sp>
-      <p:sp>
-        <p:nvSpPr>
-          <p:cNvPr id="9" name="">
-            <a:extLst xmlns:a="http://schemas.openxmlformats.org/drawingml/2006/main">
-              <a:ext uri="{FF2B5EF4-FFF2-40B4-BE49-F238E27FC236}">
-                <a16:creationId xmlns:a16="http://schemas.microsoft.com/office/drawing/2014/main" id="{CCEE06AE-D800-407A-A0B0-2475AB3FC0AF}"/>
-              </a:ext>
-            </a:extLst>
-          </p:cNvPr>
-          <p:cNvSpPr>
-            <a:spLocks xmlns:a="http://schemas.openxmlformats.org/drawingml/2006/main" noGrp="1"/>
-          </p:cNvSpPr>
-          <p:nvPr/>
-        </p:nvSpPr>
-        <p:spPr>
-          <a:xfrm xmlns:a="http://schemas.openxmlformats.org/drawingml/2006/main">
-            <a:off x="666750" y="3371850"/>
-            <a:ext cx="2143125" cy="590550"/>
+              <a:t>WEEKS 5–6</a:t>
+            </a:r>
+          </a:p>
+        </p:txBody>
+      </p:sp>
+      <p:sp>
+        <p:nvSpPr>
+          <p:cNvPr id="18" name="">
+            <a:extLst xmlns:a="http://schemas.openxmlformats.org/drawingml/2006/main">
+              <a:ext uri="{FF2B5EF4-FFF2-40B4-BE49-F238E27FC236}">
+                <a16:creationId xmlns:a16="http://schemas.microsoft.com/office/drawing/2014/main" id="{F0D4F2DF-06EE-4F15-A3C6-C8D3A96833D5}"/>
+              </a:ext>
+            </a:extLst>
+          </p:cNvPr>
+          <p:cNvSpPr>
+            <a:spLocks xmlns:a="http://schemas.openxmlformats.org/drawingml/2006/main" noGrp="1"/>
+          </p:cNvSpPr>
+          <p:nvPr/>
+        </p:nvSpPr>
+        <p:spPr>
+          <a:xfrm xmlns:a="http://schemas.openxmlformats.org/drawingml/2006/main">
+            <a:off x="6134100" y="3209925"/>
+            <a:ext cx="2038350" cy="438150"/>
           </a:xfrm>
           <a:prstGeom xmlns:a="http://schemas.openxmlformats.org/drawingml/2006/main" prst="rect">
             <a:avLst/>
@@ -8185,13 +8583,13 @@
         </p:spPr>
         <p:txBody>
           <a:bodyPr xmlns:a="http://schemas.openxmlformats.org/drawingml/2006/main" anchor="t">
-            <a:normAutofit fontScale="92908"/>
+            <a:normAutofit fontScale="74820"/>
           </a:bodyPr>
           <a:lstStyle xmlns:a="http://schemas.openxmlformats.org/drawingml/2006/main"/>
           <a:p xmlns:a="http://schemas.openxmlformats.org/drawingml/2006/main">
             <a:pPr algn="l">
               <a:buNone/>
-              <a:defRPr sz="3525" b="1">
+              <a:defRPr sz="1650" b="1">
                 <a:solidFill>
                   <a:srgbClr val="101828"/>
                 </a:solidFill>
@@ -8201,7 +8599,7 @@
               </a:defRPr>
             </a:pPr>
             <a:r>
-              <a:rPr sz="3525" b="1">
+              <a:rPr sz="1650" b="1">
                 <a:solidFill>
                   <a:srgbClr val="101828"/>
                 </a:solidFill>
@@ -8209,29 +8607,29 @@
                 <a:ea typeface="Helvetica Neue"/>
                 <a:cs typeface="Helvetica Neue"/>
               </a:rPr>
-              <a:t>4 jobs</a:t>
-            </a:r>
-          </a:p>
-        </p:txBody>
-      </p:sp>
-      <p:sp>
-        <p:nvSpPr>
-          <p:cNvPr id="10" name="">
-            <a:extLst xmlns:a="http://schemas.openxmlformats.org/drawingml/2006/main">
-              <a:ext uri="{FF2B5EF4-FFF2-40B4-BE49-F238E27FC236}">
-                <a16:creationId xmlns:a16="http://schemas.microsoft.com/office/drawing/2014/main" id="{032B57AF-1BAF-46D8-8B4E-B24061CB2A26}"/>
-              </a:ext>
-            </a:extLst>
-          </p:cNvPr>
-          <p:cNvSpPr>
-            <a:spLocks xmlns:a="http://schemas.openxmlformats.org/drawingml/2006/main" noGrp="1"/>
-          </p:cNvSpPr>
-          <p:nvPr/>
-        </p:nvSpPr>
-        <p:spPr>
-          <a:xfrm xmlns:a="http://schemas.openxmlformats.org/drawingml/2006/main">
-            <a:off x="666750" y="4143375"/>
-            <a:ext cx="2143125" cy="457200"/>
+              <a:t>Test retrieval and access</a:t>
+            </a:r>
+          </a:p>
+        </p:txBody>
+      </p:sp>
+      <p:sp>
+        <p:nvSpPr>
+          <p:cNvPr id="19" name="">
+            <a:extLst xmlns:a="http://schemas.openxmlformats.org/drawingml/2006/main">
+              <a:ext uri="{FF2B5EF4-FFF2-40B4-BE49-F238E27FC236}">
+                <a16:creationId xmlns:a16="http://schemas.microsoft.com/office/drawing/2014/main" id="{C5BE0EB4-D171-46D5-AE72-9983A065A3F5}"/>
+              </a:ext>
+            </a:extLst>
+          </p:cNvPr>
+          <p:cNvSpPr>
+            <a:spLocks xmlns:a="http://schemas.openxmlformats.org/drawingml/2006/main" noGrp="1"/>
+          </p:cNvSpPr>
+          <p:nvPr/>
+        </p:nvSpPr>
+        <p:spPr>
+          <a:xfrm xmlns:a="http://schemas.openxmlformats.org/drawingml/2006/main">
+            <a:off x="6134100" y="3876675"/>
+            <a:ext cx="2038350" cy="952500"/>
           </a:xfrm>
           <a:prstGeom xmlns:a="http://schemas.openxmlformats.org/drawingml/2006/main" prst="rect">
             <a:avLst/>
@@ -8250,56 +8648,396 @@
           <a:p xmlns:a="http://schemas.openxmlformats.org/drawingml/2006/main">
             <a:pPr algn="l">
               <a:buNone/>
-              <a:defRPr sz="1200" b="0">
-                <a:solidFill>
-                  <a:srgbClr val="667085"/>
-                </a:solidFill>
-                <a:latin typeface="Helvetica Neue"/>
-                <a:ea typeface="Helvetica Neue"/>
-                <a:cs typeface="Helvetica Neue"/>
-              </a:defRPr>
-            </a:pPr>
-            <a:r>
-              <a:rPr sz="1200" b="0">
-                <a:solidFill>
-                  <a:srgbClr val="667085"/>
-                </a:solidFill>
-                <a:latin typeface="Helvetica Neue"/>
-                <a:ea typeface="Helvetica Neue"/>
-                <a:cs typeface="Helvetica Neue"/>
-              </a:rPr>
-              <a:t>Get brief · check fact
-See gaps · send feedback</a:t>
-            </a:r>
-          </a:p>
-        </p:txBody>
-      </p:sp>
-      <p:sp>
-        <p:nvSpPr>
-          <p:cNvPr id="11" name="">
-            <a:extLst xmlns:a="http://schemas.openxmlformats.org/drawingml/2006/main">
-              <a:ext uri="{FF2B5EF4-FFF2-40B4-BE49-F238E27FC236}">
-                <a16:creationId xmlns:a16="http://schemas.microsoft.com/office/drawing/2014/main" id="{C54EE160-B2FE-4724-B4DB-29B4F6C94ED8}"/>
-              </a:ext>
-            </a:extLst>
-          </p:cNvPr>
-          <p:cNvSpPr>
-            <a:spLocks xmlns:a="http://schemas.openxmlformats.org/drawingml/2006/main" noGrp="1"/>
-          </p:cNvSpPr>
-          <p:nvPr/>
-        </p:nvSpPr>
-        <p:spPr>
-          <a:xfrm xmlns:a="http://schemas.openxmlformats.org/drawingml/2006/main">
-            <a:off x="3219450" y="2781300"/>
-            <a:ext cx="2571750" cy="2038350"/>
+              <a:defRPr sz="1275" b="0">
+                <a:solidFill>
+                  <a:srgbClr val="344054"/>
+                </a:solidFill>
+                <a:latin typeface="Helvetica Neue"/>
+                <a:ea typeface="Helvetica Neue"/>
+                <a:cs typeface="Helvetica Neue"/>
+              </a:defRPr>
+            </a:pPr>
+            <a:r>
+              <a:rPr sz="1275" b="0">
+                <a:solidFill>
+                  <a:srgbClr val="344054"/>
+                </a:solidFill>
+                <a:latin typeface="Helvetica Neue"/>
+                <a:ea typeface="Helvetica Neue"/>
+                <a:cs typeface="Helvetica Neue"/>
+              </a:rPr>
+              <a:t>Access checks</a:t>
+            </a:r>
+          </a:p>
+          <a:p xmlns:a="http://schemas.openxmlformats.org/drawingml/2006/main">
+            <a:pPr algn="l">
+              <a:buNone/>
+              <a:defRPr sz="1275" b="0">
+                <a:solidFill>
+                  <a:srgbClr val="344054"/>
+                </a:solidFill>
+                <a:latin typeface="Helvetica Neue"/>
+                <a:ea typeface="Helvetica Neue"/>
+                <a:cs typeface="Helvetica Neue"/>
+              </a:defRPr>
+            </a:pPr>
+            <a:r>
+              <a:rPr sz="1275" b="0">
+                <a:solidFill>
+                  <a:srgbClr val="344054"/>
+                </a:solidFill>
+                <a:latin typeface="Helvetica Neue"/>
+                <a:ea typeface="Helvetica Neue"/>
+                <a:cs typeface="Helvetica Neue"/>
+              </a:rPr>
+              <a:t>Evaluated retrieval</a:t>
+            </a:r>
+          </a:p>
+          <a:p xmlns:a="http://schemas.openxmlformats.org/drawingml/2006/main">
+            <a:pPr algn="l">
+              <a:buNone/>
+              <a:defRPr sz="1275" b="0">
+                <a:solidFill>
+                  <a:srgbClr val="344054"/>
+                </a:solidFill>
+                <a:latin typeface="Helvetica Neue"/>
+                <a:ea typeface="Helvetica Neue"/>
+                <a:cs typeface="Helvetica Neue"/>
+              </a:defRPr>
+            </a:pPr>
+            <a:r>
+              <a:rPr sz="1275" b="0">
+                <a:solidFill>
+                  <a:srgbClr val="344054"/>
+                </a:solidFill>
+                <a:latin typeface="Helvetica Neue"/>
+                <a:ea typeface="Helvetica Neue"/>
+                <a:cs typeface="Helvetica Neue"/>
+              </a:rPr>
+              <a:t>Generation and fallback evaluation</a:t>
+            </a:r>
+          </a:p>
+        </p:txBody>
+      </p:sp>
+      <p:sp>
+        <p:nvSpPr>
+          <p:cNvPr id="20" name="">
+            <a:extLst xmlns:a="http://schemas.openxmlformats.org/drawingml/2006/main">
+              <a:ext uri="{FF2B5EF4-FFF2-40B4-BE49-F238E27FC236}">
+                <a16:creationId xmlns:a16="http://schemas.microsoft.com/office/drawing/2014/main" id="{1A32A016-7301-49CD-B90A-7D57F4D0D685}"/>
+              </a:ext>
+            </a:extLst>
+          </p:cNvPr>
+          <p:cNvSpPr>
+            <a:spLocks xmlns:a="http://schemas.openxmlformats.org/drawingml/2006/main" noGrp="1"/>
+          </p:cNvSpPr>
+          <p:nvPr/>
+        </p:nvSpPr>
+        <p:spPr>
+          <a:xfrm xmlns:a="http://schemas.openxmlformats.org/drawingml/2006/main">
+            <a:off x="9677400" y="2171700"/>
+            <a:ext cx="228600" cy="228600"/>
           </a:xfrm>
           <a:prstGeom xmlns:a="http://schemas.openxmlformats.org/drawingml/2006/main" prst="roundRect">
             <a:avLst>
-              <a:gd name="adj" fmla="val 7477"/>
+              <a:gd name="adj" fmla="val 50000"/>
             </a:avLst>
           </a:prstGeom>
           <a:solidFill xmlns:a="http://schemas.openxmlformats.org/drawingml/2006/main">
-            <a:srgbClr val="FFFFFF"/>
+            <a:srgbClr val="315F9F"/>
+          </a:solidFill>
+          <a:ln xmlns:a="http://schemas.openxmlformats.org/drawingml/2006/main" w="9525">
+            <a:solidFill>
+              <a:srgbClr val="315F9F"/>
+            </a:solidFill>
+            <a:prstDash val="solid"/>
+          </a:ln>
+        </p:spPr>
+      </p:sp>
+      <p:sp>
+        <p:nvSpPr>
+          <p:cNvPr id="21" name="">
+            <a:extLst xmlns:a="http://schemas.openxmlformats.org/drawingml/2006/main">
+              <a:ext uri="{FF2B5EF4-FFF2-40B4-BE49-F238E27FC236}">
+                <a16:creationId xmlns:a16="http://schemas.microsoft.com/office/drawing/2014/main" id="{99FCB468-F74B-4357-9A52-E37407197048}"/>
+              </a:ext>
+            </a:extLst>
+          </p:cNvPr>
+          <p:cNvSpPr>
+            <a:spLocks xmlns:a="http://schemas.openxmlformats.org/drawingml/2006/main" noGrp="1"/>
+          </p:cNvSpPr>
+          <p:nvPr/>
+        </p:nvSpPr>
+        <p:spPr>
+          <a:xfrm xmlns:a="http://schemas.openxmlformats.org/drawingml/2006/main">
+            <a:off x="8658225" y="2609850"/>
+            <a:ext cx="2457450" cy="2476500"/>
+          </a:xfrm>
+          <a:prstGeom xmlns:a="http://schemas.openxmlformats.org/drawingml/2006/main" prst="roundRect">
+            <a:avLst>
+              <a:gd name="adj" fmla="val 6202"/>
+            </a:avLst>
+          </a:prstGeom>
+          <a:solidFill xmlns:a="http://schemas.openxmlformats.org/drawingml/2006/main">
+            <a:srgbClr val="E8F0FB"/>
+          </a:solidFill>
+          <a:ln xmlns:a="http://schemas.openxmlformats.org/drawingml/2006/main" w="9525">
+            <a:solidFill>
+              <a:srgbClr val="9CB5D5"/>
+            </a:solidFill>
+            <a:prstDash val="solid"/>
+          </a:ln>
+        </p:spPr>
+      </p:sp>
+      <p:sp>
+        <p:nvSpPr>
+          <p:cNvPr id="22" name="">
+            <a:extLst xmlns:a="http://schemas.openxmlformats.org/drawingml/2006/main">
+              <a:ext uri="{FF2B5EF4-FFF2-40B4-BE49-F238E27FC236}">
+                <a16:creationId xmlns:a16="http://schemas.microsoft.com/office/drawing/2014/main" id="{6E06FC1C-4C98-4854-B230-8BE2949563A6}"/>
+              </a:ext>
+            </a:extLst>
+          </p:cNvPr>
+          <p:cNvSpPr>
+            <a:spLocks xmlns:a="http://schemas.openxmlformats.org/drawingml/2006/main" noGrp="1"/>
+          </p:cNvSpPr>
+          <p:nvPr/>
+        </p:nvSpPr>
+        <p:spPr>
+          <a:xfrm xmlns:a="http://schemas.openxmlformats.org/drawingml/2006/main">
+            <a:off x="8867775" y="2838450"/>
+            <a:ext cx="2000250" cy="209550"/>
+          </a:xfrm>
+          <a:prstGeom xmlns:a="http://schemas.openxmlformats.org/drawingml/2006/main" prst="rect">
+            <a:avLst/>
+          </a:prstGeom>
+          <a:noFill xmlns:a="http://schemas.openxmlformats.org/drawingml/2006/main"/>
+          <a:ln xmlns:a="http://schemas.openxmlformats.org/drawingml/2006/main" w="0">
+            <a:noFill/>
+            <a:prstDash val="solid"/>
+          </a:ln>
+        </p:spPr>
+        <p:txBody>
+          <a:bodyPr xmlns:a="http://schemas.openxmlformats.org/drawingml/2006/main" anchor="t"/>
+          <a:lstStyle xmlns:a="http://schemas.openxmlformats.org/drawingml/2006/main"/>
+          <a:p xmlns:a="http://schemas.openxmlformats.org/drawingml/2006/main">
+            <a:pPr algn="l">
+              <a:buNone/>
+              <a:defRPr sz="1050" b="1">
+                <a:solidFill>
+                  <a:srgbClr val="315F9F"/>
+                </a:solidFill>
+                <a:latin typeface="Helvetica Neue"/>
+                <a:ea typeface="Helvetica Neue"/>
+                <a:cs typeface="Helvetica Neue"/>
+              </a:defRPr>
+            </a:pPr>
+            <a:r>
+              <a:rPr sz="1050" b="1">
+                <a:solidFill>
+                  <a:srgbClr val="315F9F"/>
+                </a:solidFill>
+                <a:latin typeface="Helvetica Neue"/>
+                <a:ea typeface="Helvetica Neue"/>
+                <a:cs typeface="Helvetica Neue"/>
+              </a:rPr>
+              <a:t>WEEKS 7–8</a:t>
+            </a:r>
+          </a:p>
+        </p:txBody>
+      </p:sp>
+      <p:sp>
+        <p:nvSpPr>
+          <p:cNvPr id="23" name="">
+            <a:extLst xmlns:a="http://schemas.openxmlformats.org/drawingml/2006/main">
+              <a:ext uri="{FF2B5EF4-FFF2-40B4-BE49-F238E27FC236}">
+                <a16:creationId xmlns:a16="http://schemas.microsoft.com/office/drawing/2014/main" id="{3F5B3583-FB90-4EDE-95F5-3AE6193A1599}"/>
+              </a:ext>
+            </a:extLst>
+          </p:cNvPr>
+          <p:cNvSpPr>
+            <a:spLocks xmlns:a="http://schemas.openxmlformats.org/drawingml/2006/main" noGrp="1"/>
+          </p:cNvSpPr>
+          <p:nvPr/>
+        </p:nvSpPr>
+        <p:spPr>
+          <a:xfrm xmlns:a="http://schemas.openxmlformats.org/drawingml/2006/main">
+            <a:off x="8867775" y="3209925"/>
+            <a:ext cx="2038350" cy="438150"/>
+          </a:xfrm>
+          <a:prstGeom xmlns:a="http://schemas.openxmlformats.org/drawingml/2006/main" prst="rect">
+            <a:avLst/>
+          </a:prstGeom>
+          <a:noFill xmlns:a="http://schemas.openxmlformats.org/drawingml/2006/main"/>
+          <a:ln xmlns:a="http://schemas.openxmlformats.org/drawingml/2006/main" w="0">
+            <a:noFill/>
+            <a:prstDash val="solid"/>
+          </a:ln>
+        </p:spPr>
+        <p:txBody>
+          <a:bodyPr xmlns:a="http://schemas.openxmlformats.org/drawingml/2006/main" anchor="t">
+            <a:normAutofit fontScale="68939"/>
+          </a:bodyPr>
+          <a:lstStyle xmlns:a="http://schemas.openxmlformats.org/drawingml/2006/main"/>
+          <a:p xmlns:a="http://schemas.openxmlformats.org/drawingml/2006/main">
+            <a:pPr algn="l">
+              <a:buNone/>
+              <a:defRPr sz="1650" b="1">
+                <a:solidFill>
+                  <a:srgbClr val="101828"/>
+                </a:solidFill>
+                <a:latin typeface="Helvetica Neue"/>
+                <a:ea typeface="Helvetica Neue"/>
+                <a:cs typeface="Helvetica Neue"/>
+              </a:defRPr>
+            </a:pPr>
+            <a:r>
+              <a:rPr sz="1650" b="1">
+                <a:solidFill>
+                  <a:srgbClr val="101828"/>
+                </a:solidFill>
+                <a:latin typeface="Helvetica Neue"/>
+                <a:ea typeface="Helvetica Neue"/>
+                <a:cs typeface="Helvetica Neue"/>
+              </a:rPr>
+              <a:t>Run the pilot and scale test</a:t>
+            </a:r>
+          </a:p>
+        </p:txBody>
+      </p:sp>
+      <p:sp>
+        <p:nvSpPr>
+          <p:cNvPr id="24" name="">
+            <a:extLst xmlns:a="http://schemas.openxmlformats.org/drawingml/2006/main">
+              <a:ext uri="{FF2B5EF4-FFF2-40B4-BE49-F238E27FC236}">
+                <a16:creationId xmlns:a16="http://schemas.microsoft.com/office/drawing/2014/main" id="{2A76C785-0332-4439-89D8-4C92564AB60F}"/>
+              </a:ext>
+            </a:extLst>
+          </p:cNvPr>
+          <p:cNvSpPr>
+            <a:spLocks xmlns:a="http://schemas.openxmlformats.org/drawingml/2006/main" noGrp="1"/>
+          </p:cNvSpPr>
+          <p:nvPr/>
+        </p:nvSpPr>
+        <p:spPr>
+          <a:xfrm xmlns:a="http://schemas.openxmlformats.org/drawingml/2006/main">
+            <a:off x="8867775" y="3876675"/>
+            <a:ext cx="2038350" cy="952500"/>
+          </a:xfrm>
+          <a:prstGeom xmlns:a="http://schemas.openxmlformats.org/drawingml/2006/main" prst="rect">
+            <a:avLst/>
+          </a:prstGeom>
+          <a:noFill xmlns:a="http://schemas.openxmlformats.org/drawingml/2006/main"/>
+          <a:ln xmlns:a="http://schemas.openxmlformats.org/drawingml/2006/main" w="0">
+            <a:noFill/>
+            <a:prstDash val="solid"/>
+          </a:ln>
+        </p:spPr>
+        <p:txBody>
+          <a:bodyPr xmlns:a="http://schemas.openxmlformats.org/drawingml/2006/main" anchor="t">
+            <a:normAutofit fontScale="100000"/>
+          </a:bodyPr>
+          <a:lstStyle xmlns:a="http://schemas.openxmlformats.org/drawingml/2006/main"/>
+          <a:p xmlns:a="http://schemas.openxmlformats.org/drawingml/2006/main">
+            <a:pPr algn="l">
+              <a:buNone/>
+              <a:defRPr sz="1275" b="0">
+                <a:solidFill>
+                  <a:srgbClr val="344054"/>
+                </a:solidFill>
+                <a:latin typeface="Helvetica Neue"/>
+                <a:ea typeface="Helvetica Neue"/>
+                <a:cs typeface="Helvetica Neue"/>
+              </a:defRPr>
+            </a:pPr>
+            <a:r>
+              <a:rPr sz="1275" b="0">
+                <a:solidFill>
+                  <a:srgbClr val="344054"/>
+                </a:solidFill>
+                <a:latin typeface="Helvetica Neue"/>
+                <a:ea typeface="Helvetica Neue"/>
+                <a:cs typeface="Helvetica Neue"/>
+              </a:rPr>
+              <a:t>Reconciliation</a:t>
+            </a:r>
+          </a:p>
+          <a:p xmlns:a="http://schemas.openxmlformats.org/drawingml/2006/main">
+            <a:pPr algn="l">
+              <a:buNone/>
+              <a:defRPr sz="1275" b="0">
+                <a:solidFill>
+                  <a:srgbClr val="344054"/>
+                </a:solidFill>
+                <a:latin typeface="Helvetica Neue"/>
+                <a:ea typeface="Helvetica Neue"/>
+                <a:cs typeface="Helvetica Neue"/>
+              </a:defRPr>
+            </a:pPr>
+            <a:r>
+              <a:rPr sz="1275" b="0">
+                <a:solidFill>
+                  <a:srgbClr val="344054"/>
+                </a:solidFill>
+                <a:latin typeface="Helvetica Neue"/>
+                <a:ea typeface="Helvetica Neue"/>
+                <a:cs typeface="Helvetica Neue"/>
+              </a:rPr>
+              <a:t>Monitoring</a:t>
+            </a:r>
+          </a:p>
+          <a:p xmlns:a="http://schemas.openxmlformats.org/drawingml/2006/main">
+            <a:pPr algn="l">
+              <a:buNone/>
+              <a:defRPr sz="1275" b="0">
+                <a:solidFill>
+                  <a:srgbClr val="344054"/>
+                </a:solidFill>
+                <a:latin typeface="Helvetica Neue"/>
+                <a:ea typeface="Helvetica Neue"/>
+                <a:cs typeface="Helvetica Neue"/>
+              </a:defRPr>
+            </a:pPr>
+            <a:r>
+              <a:rPr sz="1275" b="0">
+                <a:solidFill>
+                  <a:srgbClr val="344054"/>
+                </a:solidFill>
+                <a:latin typeface="Helvetica Neue"/>
+                <a:ea typeface="Helvetica Neue"/>
+                <a:cs typeface="Helvetica Neue"/>
+              </a:rPr>
+              <a:t>250-company test and principal pilot</a:t>
+            </a:r>
+          </a:p>
+        </p:txBody>
+      </p:sp>
+      <p:sp>
+        <p:nvSpPr>
+          <p:cNvPr id="25" name="">
+            <a:extLst xmlns:a="http://schemas.openxmlformats.org/drawingml/2006/main">
+              <a:ext uri="{FF2B5EF4-FFF2-40B4-BE49-F238E27FC236}">
+                <a16:creationId xmlns:a16="http://schemas.microsoft.com/office/drawing/2014/main" id="{8FD243BD-D1D8-4D5E-9080-89BCC3F63E9D}"/>
+              </a:ext>
+            </a:extLst>
+          </p:cNvPr>
+          <p:cNvSpPr>
+            <a:spLocks xmlns:a="http://schemas.openxmlformats.org/drawingml/2006/main" noGrp="1"/>
+          </p:cNvSpPr>
+          <p:nvPr/>
+        </p:nvSpPr>
+        <p:spPr>
+          <a:xfrm xmlns:a="http://schemas.openxmlformats.org/drawingml/2006/main">
+            <a:off x="457200" y="5391150"/>
+            <a:ext cx="10858500" cy="628650"/>
+          </a:xfrm>
+          <a:prstGeom xmlns:a="http://schemas.openxmlformats.org/drawingml/2006/main" prst="roundRect">
+            <a:avLst>
+              <a:gd name="adj" fmla="val 21212"/>
+            </a:avLst>
+          </a:prstGeom>
+          <a:solidFill xmlns:a="http://schemas.openxmlformats.org/drawingml/2006/main">
+            <a:srgbClr val="F2F4F7"/>
           </a:solidFill>
           <a:ln xmlns:a="http://schemas.openxmlformats.org/drawingml/2006/main" w="9525">
             <a:solidFill>
@@ -8311,22 +9049,22 @@
       </p:sp>
       <p:sp>
         <p:nvSpPr>
-          <p:cNvPr id="12" name="">
-            <a:extLst xmlns:a="http://schemas.openxmlformats.org/drawingml/2006/main">
-              <a:ext uri="{FF2B5EF4-FFF2-40B4-BE49-F238E27FC236}">
-                <a16:creationId xmlns:a16="http://schemas.microsoft.com/office/drawing/2014/main" id="{E103A2B5-5C9B-4684-88A5-D7E54E104F02}"/>
-              </a:ext>
-            </a:extLst>
-          </p:cNvPr>
-          <p:cNvSpPr>
-            <a:spLocks xmlns:a="http://schemas.openxmlformats.org/drawingml/2006/main" noGrp="1"/>
-          </p:cNvSpPr>
-          <p:nvPr/>
-        </p:nvSpPr>
-        <p:spPr>
-          <a:xfrm xmlns:a="http://schemas.openxmlformats.org/drawingml/2006/main">
-            <a:off x="3429000" y="3009900"/>
-            <a:ext cx="2095500" cy="209550"/>
+          <p:cNvPr id="26" name="">
+            <a:extLst xmlns:a="http://schemas.openxmlformats.org/drawingml/2006/main">
+              <a:ext uri="{FF2B5EF4-FFF2-40B4-BE49-F238E27FC236}">
+                <a16:creationId xmlns:a16="http://schemas.microsoft.com/office/drawing/2014/main" id="{6DBF2437-14B5-4A46-9FC0-D460E78897FD}"/>
+              </a:ext>
+            </a:extLst>
+          </p:cNvPr>
+          <p:cNvSpPr>
+            <a:spLocks xmlns:a="http://schemas.openxmlformats.org/drawingml/2006/main" noGrp="1"/>
+          </p:cNvSpPr>
+          <p:nvPr/>
+        </p:nvSpPr>
+        <p:spPr>
+          <a:xfrm xmlns:a="http://schemas.openxmlformats.org/drawingml/2006/main">
+            <a:off x="666750" y="5581650"/>
+            <a:ext cx="3429000" cy="228600"/>
           </a:xfrm>
           <a:prstGeom xmlns:a="http://schemas.openxmlformats.org/drawingml/2006/main" prst="rect">
             <a:avLst/>
@@ -8339,53 +9077,53 @@
         </p:spPr>
         <p:txBody>
           <a:bodyPr xmlns:a="http://schemas.openxmlformats.org/drawingml/2006/main" anchor="t">
-            <a:normAutofit fontScale="73809"/>
+            <a:normAutofit fontScale="75000"/>
           </a:bodyPr>
           <a:lstStyle xmlns:a="http://schemas.openxmlformats.org/drawingml/2006/main"/>
           <a:p xmlns:a="http://schemas.openxmlformats.org/drawingml/2006/main">
             <a:pPr algn="l">
               <a:buNone/>
-              <a:defRPr sz="1050" b="1">
-                <a:solidFill>
-                  <a:srgbClr val="315F9F"/>
-                </a:solidFill>
-                <a:latin typeface="Helvetica Neue"/>
-                <a:ea typeface="Helvetica Neue"/>
-                <a:cs typeface="Helvetica Neue"/>
-              </a:defRPr>
-            </a:pPr>
-            <a:r>
-              <a:rPr sz="1050" b="1">
-                <a:solidFill>
-                  <a:srgbClr val="315F9F"/>
-                </a:solidFill>
-                <a:latin typeface="Helvetica Neue"/>
-                <a:ea typeface="Helvetica Neue"/>
-                <a:cs typeface="Helvetica Neue"/>
-              </a:rPr>
-              <a:t>ACCEPTANCE</a:t>
-            </a:r>
-          </a:p>
-        </p:txBody>
-      </p:sp>
-      <p:sp>
-        <p:nvSpPr>
-          <p:cNvPr id="13" name="">
-            <a:extLst xmlns:a="http://schemas.openxmlformats.org/drawingml/2006/main">
-              <a:ext uri="{FF2B5EF4-FFF2-40B4-BE49-F238E27FC236}">
-                <a16:creationId xmlns:a16="http://schemas.microsoft.com/office/drawing/2014/main" id="{9FCDF1D5-5421-492D-BFC5-2AC7138E96FF}"/>
-              </a:ext>
-            </a:extLst>
-          </p:cNvPr>
-          <p:cNvSpPr>
-            <a:spLocks xmlns:a="http://schemas.openxmlformats.org/drawingml/2006/main" noGrp="1"/>
-          </p:cNvSpPr>
-          <p:nvPr/>
-        </p:nvSpPr>
-        <p:spPr>
-          <a:xfrm xmlns:a="http://schemas.openxmlformats.org/drawingml/2006/main">
-            <a:off x="3429000" y="3371850"/>
-            <a:ext cx="2143125" cy="590550"/>
+              <a:defRPr sz="1200" b="1">
+                <a:solidFill>
+                  <a:srgbClr val="101828"/>
+                </a:solidFill>
+                <a:latin typeface="Helvetica Neue"/>
+                <a:ea typeface="Helvetica Neue"/>
+                <a:cs typeface="Helvetica Neue"/>
+              </a:defRPr>
+            </a:pPr>
+            <a:r>
+              <a:rPr sz="1200" b="1">
+                <a:solidFill>
+                  <a:srgbClr val="101828"/>
+                </a:solidFill>
+                <a:latin typeface="Helvetica Neue"/>
+                <a:ea typeface="Helvetica Neue"/>
+                <a:cs typeface="Helvetica Neue"/>
+              </a:rPr>
+              <a:t>PERSON 1 · Product and application</a:t>
+            </a:r>
+          </a:p>
+        </p:txBody>
+      </p:sp>
+      <p:sp>
+        <p:nvSpPr>
+          <p:cNvPr id="27" name="">
+            <a:extLst xmlns:a="http://schemas.openxmlformats.org/drawingml/2006/main">
+              <a:ext uri="{FF2B5EF4-FFF2-40B4-BE49-F238E27FC236}">
+                <a16:creationId xmlns:a16="http://schemas.microsoft.com/office/drawing/2014/main" id="{918CF25F-52C6-4E33-BCCB-F49769B2D014}"/>
+              </a:ext>
+            </a:extLst>
+          </p:cNvPr>
+          <p:cNvSpPr>
+            <a:spLocks xmlns:a="http://schemas.openxmlformats.org/drawingml/2006/main" noGrp="1"/>
+          </p:cNvSpPr>
+          <p:nvPr/>
+        </p:nvSpPr>
+        <p:spPr>
+          <a:xfrm xmlns:a="http://schemas.openxmlformats.org/drawingml/2006/main">
+            <a:off x="4476750" y="5581650"/>
+            <a:ext cx="3238500" cy="228600"/>
           </a:xfrm>
           <a:prstGeom xmlns:a="http://schemas.openxmlformats.org/drawingml/2006/main" prst="rect">
             <a:avLst/>
@@ -8398,13 +9136,13 @@
         </p:spPr>
         <p:txBody>
           <a:bodyPr xmlns:a="http://schemas.openxmlformats.org/drawingml/2006/main" anchor="t">
-            <a:normAutofit fontScale="100000"/>
+            <a:normAutofit fontScale="75000"/>
           </a:bodyPr>
           <a:lstStyle xmlns:a="http://schemas.openxmlformats.org/drawingml/2006/main"/>
           <a:p xmlns:a="http://schemas.openxmlformats.org/drawingml/2006/main">
             <a:pPr algn="l">
               <a:buNone/>
-              <a:defRPr sz="3525" b="1">
+              <a:defRPr sz="1200" b="1">
                 <a:solidFill>
                   <a:srgbClr val="101828"/>
                 </a:solidFill>
@@ -8414,7 +9152,7 @@
               </a:defRPr>
             </a:pPr>
             <a:r>
-              <a:rPr sz="2850" b="1">
+              <a:rPr sz="1200" b="1">
                 <a:solidFill>
                   <a:srgbClr val="101828"/>
                 </a:solidFill>
@@ -8422,29 +9160,29 @@
                 <a:ea typeface="Helvetica Neue"/>
                 <a:cs typeface="Helvetica Neue"/>
               </a:rPr>
-              <a:t>Pass</a:t>
-            </a:r>
-          </a:p>
-        </p:txBody>
-      </p:sp>
-      <p:sp>
-        <p:nvSpPr>
-          <p:cNvPr id="14" name="">
-            <a:extLst xmlns:a="http://schemas.openxmlformats.org/drawingml/2006/main">
-              <a:ext uri="{FF2B5EF4-FFF2-40B4-BE49-F238E27FC236}">
-                <a16:creationId xmlns:a16="http://schemas.microsoft.com/office/drawing/2014/main" id="{96F3C4E3-ACED-4D21-A3E1-834E7E3DD175}"/>
-              </a:ext>
-            </a:extLst>
-          </p:cNvPr>
-          <p:cNvSpPr>
-            <a:spLocks xmlns:a="http://schemas.openxmlformats.org/drawingml/2006/main" noGrp="1"/>
-          </p:cNvSpPr>
-          <p:nvPr/>
-        </p:nvSpPr>
-        <p:spPr>
-          <a:xfrm xmlns:a="http://schemas.openxmlformats.org/drawingml/2006/main">
-            <a:off x="3429000" y="4143375"/>
-            <a:ext cx="2143125" cy="457200"/>
+              <a:t>PERSON 2 · Data and platform</a:t>
+            </a:r>
+          </a:p>
+        </p:txBody>
+      </p:sp>
+      <p:sp>
+        <p:nvSpPr>
+          <p:cNvPr id="28" name="">
+            <a:extLst xmlns:a="http://schemas.openxmlformats.org/drawingml/2006/main">
+              <a:ext uri="{FF2B5EF4-FFF2-40B4-BE49-F238E27FC236}">
+                <a16:creationId xmlns:a16="http://schemas.microsoft.com/office/drawing/2014/main" id="{DB910F2C-EF3B-4B5A-AC88-78FDB08FE0C6}"/>
+              </a:ext>
+            </a:extLst>
+          </p:cNvPr>
+          <p:cNvSpPr>
+            <a:spLocks xmlns:a="http://schemas.openxmlformats.org/drawingml/2006/main" noGrp="1"/>
+          </p:cNvSpPr>
+          <p:nvPr/>
+        </p:nvSpPr>
+        <p:spPr>
+          <a:xfrm xmlns:a="http://schemas.openxmlformats.org/drawingml/2006/main">
+            <a:off x="7953375" y="5581650"/>
+            <a:ext cx="3048000" cy="228600"/>
           </a:xfrm>
           <a:prstGeom xmlns:a="http://schemas.openxmlformats.org/drawingml/2006/main" prst="rect">
             <a:avLst/>
@@ -8457,108 +9195,13 @@
         </p:spPr>
         <p:txBody>
           <a:bodyPr xmlns:a="http://schemas.openxmlformats.org/drawingml/2006/main" anchor="t">
-            <a:normAutofit fontScale="90116"/>
+            <a:normAutofit fontScale="75000"/>
           </a:bodyPr>
           <a:lstStyle xmlns:a="http://schemas.openxmlformats.org/drawingml/2006/main"/>
           <a:p xmlns:a="http://schemas.openxmlformats.org/drawingml/2006/main">
             <a:pPr algn="l">
               <a:buNone/>
-              <a:defRPr sz="1200" b="0">
-                <a:solidFill>
-                  <a:srgbClr val="667085"/>
-                </a:solidFill>
-                <a:latin typeface="Helvetica Neue"/>
-                <a:ea typeface="Helvetica Neue"/>
-                <a:cs typeface="Helvetica Neue"/>
-              </a:defRPr>
-            </a:pPr>
-            <a:r>
-              <a:rPr sz="1200" b="0">
-                <a:solidFill>
-                  <a:srgbClr val="667085"/>
-                </a:solidFill>
-                <a:latin typeface="Helvetica Neue"/>
-                <a:ea typeface="Helvetica Neue"/>
-                <a:cs typeface="Helvetica Neue"/>
-              </a:rPr>
-              <a:t>Source and date · one company
-New data changes brief</a:t>
-            </a:r>
-          </a:p>
-        </p:txBody>
-      </p:sp>
-      <p:sp>
-        <p:nvSpPr>
-          <p:cNvPr id="15" name="">
-            <a:extLst xmlns:a="http://schemas.openxmlformats.org/drawingml/2006/main">
-              <a:ext uri="{FF2B5EF4-FFF2-40B4-BE49-F238E27FC236}">
-                <a16:creationId xmlns:a16="http://schemas.microsoft.com/office/drawing/2014/main" id="{A7E65777-4F36-4020-AF7C-22F413271467}"/>
-              </a:ext>
-            </a:extLst>
-          </p:cNvPr>
-          <p:cNvSpPr>
-            <a:spLocks xmlns:a="http://schemas.openxmlformats.org/drawingml/2006/main" noGrp="1"/>
-          </p:cNvSpPr>
-          <p:nvPr/>
-        </p:nvSpPr>
-        <p:spPr>
-          <a:xfrm xmlns:a="http://schemas.openxmlformats.org/drawingml/2006/main">
-            <a:off x="5981700" y="2781300"/>
-            <a:ext cx="2571750" cy="2038350"/>
-          </a:xfrm>
-          <a:prstGeom xmlns:a="http://schemas.openxmlformats.org/drawingml/2006/main" prst="roundRect">
-            <a:avLst>
-              <a:gd name="adj" fmla="val 7477"/>
-            </a:avLst>
-          </a:prstGeom>
-          <a:solidFill xmlns:a="http://schemas.openxmlformats.org/drawingml/2006/main">
-            <a:srgbClr val="FFFFFF"/>
-          </a:solidFill>
-          <a:ln xmlns:a="http://schemas.openxmlformats.org/drawingml/2006/main" w="9525">
-            <a:solidFill>
-              <a:srgbClr val="D0D5DD"/>
-            </a:solidFill>
-            <a:prstDash val="solid"/>
-          </a:ln>
-        </p:spPr>
-      </p:sp>
-      <p:sp>
-        <p:nvSpPr>
-          <p:cNvPr id="16" name="">
-            <a:extLst xmlns:a="http://schemas.openxmlformats.org/drawingml/2006/main">
-              <a:ext uri="{FF2B5EF4-FFF2-40B4-BE49-F238E27FC236}">
-                <a16:creationId xmlns:a16="http://schemas.microsoft.com/office/drawing/2014/main" id="{468EA405-4A26-4F28-9A03-279E84257E69}"/>
-              </a:ext>
-            </a:extLst>
-          </p:cNvPr>
-          <p:cNvSpPr>
-            <a:spLocks xmlns:a="http://schemas.openxmlformats.org/drawingml/2006/main" noGrp="1"/>
-          </p:cNvSpPr>
-          <p:nvPr/>
-        </p:nvSpPr>
-        <p:spPr>
-          <a:xfrm xmlns:a="http://schemas.openxmlformats.org/drawingml/2006/main">
-            <a:off x="6191250" y="3009900"/>
-            <a:ext cx="2095500" cy="209550"/>
-          </a:xfrm>
-          <a:prstGeom xmlns:a="http://schemas.openxmlformats.org/drawingml/2006/main" prst="rect">
-            <a:avLst/>
-          </a:prstGeom>
-          <a:noFill xmlns:a="http://schemas.openxmlformats.org/drawingml/2006/main"/>
-          <a:ln xmlns:a="http://schemas.openxmlformats.org/drawingml/2006/main" w="0">
-            <a:noFill/>
-            <a:prstDash val="solid"/>
-          </a:ln>
-        </p:spPr>
-        <p:txBody>
-          <a:bodyPr xmlns:a="http://schemas.openxmlformats.org/drawingml/2006/main" anchor="t">
-            <a:normAutofit fontScale="73809"/>
-          </a:bodyPr>
-          <a:lstStyle xmlns:a="http://schemas.openxmlformats.org/drawingml/2006/main"/>
-          <a:p xmlns:a="http://schemas.openxmlformats.org/drawingml/2006/main">
-            <a:pPr algn="l">
-              <a:buNone/>
-              <a:defRPr sz="1050" b="1">
+              <a:defRPr sz="1200" b="1">
                 <a:solidFill>
                   <a:srgbClr val="315F9F"/>
                 </a:solidFill>
@@ -8568,7 +9211,7 @@
               </a:defRPr>
             </a:pPr>
             <a:r>
-              <a:rPr sz="1050" b="1">
+              <a:rPr sz="1200" b="1">
                 <a:solidFill>
                   <a:srgbClr val="315F9F"/>
                 </a:solidFill>
@@ -8576,457 +9219,7 @@
                 <a:ea typeface="Helvetica Neue"/>
                 <a:cs typeface="Helvetica Neue"/>
               </a:rPr>
-              <a:t>KEY PERFORMANCE INDICATORS</a:t>
-            </a:r>
-          </a:p>
-        </p:txBody>
-      </p:sp>
-      <p:sp>
-        <p:nvSpPr>
-          <p:cNvPr id="17" name="">
-            <a:extLst xmlns:a="http://schemas.openxmlformats.org/drawingml/2006/main">
-              <a:ext uri="{FF2B5EF4-FFF2-40B4-BE49-F238E27FC236}">
-                <a16:creationId xmlns:a16="http://schemas.microsoft.com/office/drawing/2014/main" id="{D8BE85FE-503D-42CD-9E11-C9853F789DE1}"/>
-              </a:ext>
-            </a:extLst>
-          </p:cNvPr>
-          <p:cNvSpPr>
-            <a:spLocks xmlns:a="http://schemas.openxmlformats.org/drawingml/2006/main" noGrp="1"/>
-          </p:cNvSpPr>
-          <p:nvPr/>
-        </p:nvSpPr>
-        <p:spPr>
-          <a:xfrm xmlns:a="http://schemas.openxmlformats.org/drawingml/2006/main">
-            <a:off x="6191250" y="3371850"/>
-            <a:ext cx="2143125" cy="590550"/>
-          </a:xfrm>
-          <a:prstGeom xmlns:a="http://schemas.openxmlformats.org/drawingml/2006/main" prst="rect">
-            <a:avLst/>
-          </a:prstGeom>
-          <a:noFill xmlns:a="http://schemas.openxmlformats.org/drawingml/2006/main"/>
-          <a:ln xmlns:a="http://schemas.openxmlformats.org/drawingml/2006/main" w="0">
-            <a:noFill/>
-            <a:prstDash val="solid"/>
-          </a:ln>
-        </p:spPr>
-        <p:txBody>
-          <a:bodyPr xmlns:a="http://schemas.openxmlformats.org/drawingml/2006/main" anchor="t">
-            <a:normAutofit fontScale="92908"/>
-          </a:bodyPr>
-          <a:lstStyle xmlns:a="http://schemas.openxmlformats.org/drawingml/2006/main"/>
-          <a:p xmlns:a="http://schemas.openxmlformats.org/drawingml/2006/main">
-            <a:pPr algn="l">
-              <a:buNone/>
-              <a:defRPr sz="3525" b="1">
-                <a:solidFill>
-                  <a:srgbClr val="101828"/>
-                </a:solidFill>
-                <a:latin typeface="Helvetica Neue"/>
-                <a:ea typeface="Helvetica Neue"/>
-                <a:cs typeface="Helvetica Neue"/>
-              </a:defRPr>
-            </a:pPr>
-            <a:r>
-              <a:rPr sz="3525" b="1">
-                <a:solidFill>
-                  <a:srgbClr val="101828"/>
-                </a:solidFill>
-                <a:latin typeface="Helvetica Neue"/>
-                <a:ea typeface="Helvetica Neue"/>
-                <a:cs typeface="Helvetica Neue"/>
-              </a:rPr>
-              <a:t>4 gates</a:t>
-            </a:r>
-          </a:p>
-        </p:txBody>
-      </p:sp>
-      <p:sp>
-        <p:nvSpPr>
-          <p:cNvPr id="18" name="">
-            <a:extLst xmlns:a="http://schemas.openxmlformats.org/drawingml/2006/main">
-              <a:ext uri="{FF2B5EF4-FFF2-40B4-BE49-F238E27FC236}">
-                <a16:creationId xmlns:a16="http://schemas.microsoft.com/office/drawing/2014/main" id="{8B3D565A-3552-4FDC-9339-4D2454B4C0FA}"/>
-              </a:ext>
-            </a:extLst>
-          </p:cNvPr>
-          <p:cNvSpPr>
-            <a:spLocks xmlns:a="http://schemas.openxmlformats.org/drawingml/2006/main" noGrp="1"/>
-          </p:cNvSpPr>
-          <p:nvPr/>
-        </p:nvSpPr>
-        <p:spPr>
-          <a:xfrm xmlns:a="http://schemas.openxmlformats.org/drawingml/2006/main">
-            <a:off x="6191250" y="4143375"/>
-            <a:ext cx="2143125" cy="457200"/>
-          </a:xfrm>
-          <a:prstGeom xmlns:a="http://schemas.openxmlformats.org/drawingml/2006/main" prst="rect">
-            <a:avLst/>
-          </a:prstGeom>
-          <a:noFill xmlns:a="http://schemas.openxmlformats.org/drawingml/2006/main"/>
-          <a:ln xmlns:a="http://schemas.openxmlformats.org/drawingml/2006/main" w="0">
-            <a:noFill/>
-            <a:prstDash val="solid"/>
-          </a:ln>
-        </p:spPr>
-        <p:txBody>
-          <a:bodyPr xmlns:a="http://schemas.openxmlformats.org/drawingml/2006/main" anchor="t">
-            <a:normAutofit fontScale="94809"/>
-          </a:bodyPr>
-          <a:lstStyle xmlns:a="http://schemas.openxmlformats.org/drawingml/2006/main"/>
-          <a:p xmlns:a="http://schemas.openxmlformats.org/drawingml/2006/main">
-            <a:pPr algn="l">
-              <a:buNone/>
-              <a:defRPr sz="1200" b="0">
-                <a:solidFill>
-                  <a:srgbClr val="667085"/>
-                </a:solidFill>
-                <a:latin typeface="Helvetica Neue"/>
-                <a:ea typeface="Helvetica Neue"/>
-                <a:cs typeface="Helvetica Neue"/>
-              </a:defRPr>
-            </a:pPr>
-            <a:r>
-              <a:rPr sz="1200" b="0">
-                <a:solidFill>
-                  <a:srgbClr val="667085"/>
-                </a:solidFill>
-                <a:latin typeface="Helvetica Neue"/>
-                <a:ea typeface="Helvetica Neue"/>
-                <a:cs typeface="Helvetica Neue"/>
-              </a:rPr>
-              <a:t>≤30 sec · all key facts sourced
-0 wrong-company facts · ≥4/5</a:t>
-            </a:r>
-          </a:p>
-        </p:txBody>
-      </p:sp>
-      <p:sp>
-        <p:nvSpPr>
-          <p:cNvPr id="19" name="">
-            <a:extLst xmlns:a="http://schemas.openxmlformats.org/drawingml/2006/main">
-              <a:ext uri="{FF2B5EF4-FFF2-40B4-BE49-F238E27FC236}">
-                <a16:creationId xmlns:a16="http://schemas.microsoft.com/office/drawing/2014/main" id="{21909835-C000-476D-BE4E-86B6A009FC7F}"/>
-              </a:ext>
-            </a:extLst>
-          </p:cNvPr>
-          <p:cNvSpPr>
-            <a:spLocks xmlns:a="http://schemas.openxmlformats.org/drawingml/2006/main" noGrp="1"/>
-          </p:cNvSpPr>
-          <p:nvPr/>
-        </p:nvSpPr>
-        <p:spPr>
-          <a:xfrm xmlns:a="http://schemas.openxmlformats.org/drawingml/2006/main">
-            <a:off x="8743950" y="2781300"/>
-            <a:ext cx="2571750" cy="2038350"/>
-          </a:xfrm>
-          <a:prstGeom xmlns:a="http://schemas.openxmlformats.org/drawingml/2006/main" prst="roundRect">
-            <a:avLst>
-              <a:gd name="adj" fmla="val 7477"/>
-            </a:avLst>
-          </a:prstGeom>
-          <a:solidFill xmlns:a="http://schemas.openxmlformats.org/drawingml/2006/main">
-            <a:srgbClr val="FFFFFF"/>
-          </a:solidFill>
-          <a:ln xmlns:a="http://schemas.openxmlformats.org/drawingml/2006/main" w="9525">
-            <a:solidFill>
-              <a:srgbClr val="D0D5DD"/>
-            </a:solidFill>
-            <a:prstDash val="solid"/>
-          </a:ln>
-        </p:spPr>
-      </p:sp>
-      <p:sp>
-        <p:nvSpPr>
-          <p:cNvPr id="20" name="">
-            <a:extLst xmlns:a="http://schemas.openxmlformats.org/drawingml/2006/main">
-              <a:ext uri="{FF2B5EF4-FFF2-40B4-BE49-F238E27FC236}">
-                <a16:creationId xmlns:a16="http://schemas.microsoft.com/office/drawing/2014/main" id="{14D12D1C-71C7-4D5E-841E-35CE6D175B78}"/>
-              </a:ext>
-            </a:extLst>
-          </p:cNvPr>
-          <p:cNvSpPr>
-            <a:spLocks xmlns:a="http://schemas.openxmlformats.org/drawingml/2006/main" noGrp="1"/>
-          </p:cNvSpPr>
-          <p:nvPr/>
-        </p:nvSpPr>
-        <p:spPr>
-          <a:xfrm xmlns:a="http://schemas.openxmlformats.org/drawingml/2006/main">
-            <a:off x="8953500" y="3009900"/>
-            <a:ext cx="2095500" cy="209550"/>
-          </a:xfrm>
-          <a:prstGeom xmlns:a="http://schemas.openxmlformats.org/drawingml/2006/main" prst="rect">
-            <a:avLst/>
-          </a:prstGeom>
-          <a:noFill xmlns:a="http://schemas.openxmlformats.org/drawingml/2006/main"/>
-          <a:ln xmlns:a="http://schemas.openxmlformats.org/drawingml/2006/main" w="0">
-            <a:noFill/>
-            <a:prstDash val="solid"/>
-          </a:ln>
-        </p:spPr>
-        <p:txBody>
-          <a:bodyPr xmlns:a="http://schemas.openxmlformats.org/drawingml/2006/main" anchor="t">
-            <a:normAutofit fontScale="73809"/>
-          </a:bodyPr>
-          <a:lstStyle xmlns:a="http://schemas.openxmlformats.org/drawingml/2006/main"/>
-          <a:p xmlns:a="http://schemas.openxmlformats.org/drawingml/2006/main">
-            <a:pPr algn="l">
-              <a:buNone/>
-              <a:defRPr sz="1050" b="1">
-                <a:solidFill>
-                  <a:srgbClr val="315F9F"/>
-                </a:solidFill>
-                <a:latin typeface="Helvetica Neue"/>
-                <a:ea typeface="Helvetica Neue"/>
-                <a:cs typeface="Helvetica Neue"/>
-              </a:defRPr>
-            </a:pPr>
-            <a:r>
-              <a:rPr sz="1050" b="1">
-                <a:solidFill>
-                  <a:srgbClr val="315F9F"/>
-                </a:solidFill>
-                <a:latin typeface="Helvetica Neue"/>
-                <a:ea typeface="Helvetica Neue"/>
-                <a:cs typeface="Helvetica Neue"/>
-              </a:rPr>
-              <a:t>PROOF OF CONCEPT TO V1</a:t>
-            </a:r>
-          </a:p>
-        </p:txBody>
-      </p:sp>
-      <p:sp>
-        <p:nvSpPr>
-          <p:cNvPr id="21" name="">
-            <a:extLst xmlns:a="http://schemas.openxmlformats.org/drawingml/2006/main">
-              <a:ext uri="{FF2B5EF4-FFF2-40B4-BE49-F238E27FC236}">
-                <a16:creationId xmlns:a16="http://schemas.microsoft.com/office/drawing/2014/main" id="{F686A3A3-BAF9-4CEC-BA6B-8E7459E7CB1A}"/>
-              </a:ext>
-            </a:extLst>
-          </p:cNvPr>
-          <p:cNvSpPr>
-            <a:spLocks xmlns:a="http://schemas.openxmlformats.org/drawingml/2006/main" noGrp="1"/>
-          </p:cNvSpPr>
-          <p:nvPr/>
-        </p:nvSpPr>
-        <p:spPr>
-          <a:xfrm xmlns:a="http://schemas.openxmlformats.org/drawingml/2006/main">
-            <a:off x="8953500" y="3371850"/>
-            <a:ext cx="2143125" cy="590550"/>
-          </a:xfrm>
-          <a:prstGeom xmlns:a="http://schemas.openxmlformats.org/drawingml/2006/main" prst="rect">
-            <a:avLst/>
-          </a:prstGeom>
-          <a:noFill xmlns:a="http://schemas.openxmlformats.org/drawingml/2006/main"/>
-          <a:ln xmlns:a="http://schemas.openxmlformats.org/drawingml/2006/main" w="0">
-            <a:noFill/>
-            <a:prstDash val="solid"/>
-          </a:ln>
-        </p:spPr>
-        <p:txBody>
-          <a:bodyPr xmlns:a="http://schemas.openxmlformats.org/drawingml/2006/main" anchor="t">
-            <a:normAutofit fontScale="92908"/>
-          </a:bodyPr>
-          <a:lstStyle xmlns:a="http://schemas.openxmlformats.org/drawingml/2006/main"/>
-          <a:p xmlns:a="http://schemas.openxmlformats.org/drawingml/2006/main">
-            <a:pPr algn="l">
-              <a:buNone/>
-              <a:defRPr sz="3525" b="1">
-                <a:solidFill>
-                  <a:srgbClr val="101828"/>
-                </a:solidFill>
-                <a:latin typeface="Helvetica Neue"/>
-                <a:ea typeface="Helvetica Neue"/>
-                <a:cs typeface="Helvetica Neue"/>
-              </a:defRPr>
-            </a:pPr>
-            <a:r>
-              <a:rPr sz="3525" b="1">
-                <a:solidFill>
-                  <a:srgbClr val="101828"/>
-                </a:solidFill>
-                <a:latin typeface="Helvetica Neue"/>
-                <a:ea typeface="Helvetica Neue"/>
-                <a:cs typeface="Helvetica Neue"/>
-              </a:rPr>
-              <a:t>Pilot</a:t>
-            </a:r>
-          </a:p>
-        </p:txBody>
-      </p:sp>
-      <p:sp>
-        <p:nvSpPr>
-          <p:cNvPr id="22" name="">
-            <a:extLst xmlns:a="http://schemas.openxmlformats.org/drawingml/2006/main">
-              <a:ext uri="{FF2B5EF4-FFF2-40B4-BE49-F238E27FC236}">
-                <a16:creationId xmlns:a16="http://schemas.microsoft.com/office/drawing/2014/main" id="{98A790D2-D307-426F-AFF6-4F296FCAF988}"/>
-              </a:ext>
-            </a:extLst>
-          </p:cNvPr>
-          <p:cNvSpPr>
-            <a:spLocks xmlns:a="http://schemas.openxmlformats.org/drawingml/2006/main" noGrp="1"/>
-          </p:cNvSpPr>
-          <p:nvPr/>
-        </p:nvSpPr>
-        <p:spPr>
-          <a:xfrm xmlns:a="http://schemas.openxmlformats.org/drawingml/2006/main">
-            <a:off x="8953500" y="4143375"/>
-            <a:ext cx="2143125" cy="457200"/>
-          </a:xfrm>
-          <a:prstGeom xmlns:a="http://schemas.openxmlformats.org/drawingml/2006/main" prst="rect">
-            <a:avLst/>
-          </a:prstGeom>
-          <a:noFill xmlns:a="http://schemas.openxmlformats.org/drawingml/2006/main"/>
-          <a:ln xmlns:a="http://schemas.openxmlformats.org/drawingml/2006/main" w="0">
-            <a:noFill/>
-            <a:prstDash val="solid"/>
-          </a:ln>
-        </p:spPr>
-        <p:txBody>
-          <a:bodyPr xmlns:a="http://schemas.openxmlformats.org/drawingml/2006/main" anchor="t">
-            <a:normAutofit fontScale="82497"/>
-          </a:bodyPr>
-          <a:lstStyle xmlns:a="http://schemas.openxmlformats.org/drawingml/2006/main"/>
-          <a:p xmlns:a="http://schemas.openxmlformats.org/drawingml/2006/main">
-            <a:pPr algn="l">
-              <a:buNone/>
-              <a:defRPr sz="1200" b="0">
-                <a:solidFill>
-                  <a:srgbClr val="667085"/>
-                </a:solidFill>
-                <a:latin typeface="Helvetica Neue"/>
-                <a:ea typeface="Helvetica Neue"/>
-                <a:cs typeface="Helvetica Neue"/>
-              </a:defRPr>
-            </a:pPr>
-            <a:r>
-              <a:rPr sz="1200" b="0">
-                <a:solidFill>
-                  <a:srgbClr val="667085"/>
-                </a:solidFill>
-                <a:latin typeface="Helvetica Neue"/>
-                <a:ea typeface="Helvetica Neue"/>
-                <a:cs typeface="Helvetica Neue"/>
-              </a:rPr>
-              <a:t>Approved connector · access rules
-Import log · review owner</a:t>
-            </a:r>
-          </a:p>
-        </p:txBody>
-      </p:sp>
-      <p:sp>
-        <p:nvSpPr>
-          <p:cNvPr id="23" name="">
-            <a:extLst xmlns:a="http://schemas.openxmlformats.org/drawingml/2006/main">
-              <a:ext uri="{FF2B5EF4-FFF2-40B4-BE49-F238E27FC236}">
-                <a16:creationId xmlns:a16="http://schemas.microsoft.com/office/drawing/2014/main" id="{25EC7D7C-6E01-4D17-AA83-D2DB3D6F5810}"/>
-              </a:ext>
-            </a:extLst>
-          </p:cNvPr>
-          <p:cNvSpPr>
-            <a:spLocks xmlns:a="http://schemas.openxmlformats.org/drawingml/2006/main" noGrp="1"/>
-          </p:cNvSpPr>
-          <p:nvPr/>
-        </p:nvSpPr>
-        <p:spPr>
-          <a:xfrm xmlns:a="http://schemas.openxmlformats.org/drawingml/2006/main">
-            <a:off x="457200" y="5219700"/>
-            <a:ext cx="10858500" cy="285750"/>
-          </a:xfrm>
-          <a:prstGeom xmlns:a="http://schemas.openxmlformats.org/drawingml/2006/main" prst="rect">
-            <a:avLst/>
-          </a:prstGeom>
-          <a:noFill xmlns:a="http://schemas.openxmlformats.org/drawingml/2006/main"/>
-          <a:ln xmlns:a="http://schemas.openxmlformats.org/drawingml/2006/main" w="0">
-            <a:noFill/>
-            <a:prstDash val="solid"/>
-          </a:ln>
-        </p:spPr>
-        <p:txBody>
-          <a:bodyPr xmlns:a="http://schemas.openxmlformats.org/drawingml/2006/main" anchor="t">
-            <a:normAutofit fontScale="94444"/>
-          </a:bodyPr>
-          <a:lstStyle xmlns:a="http://schemas.openxmlformats.org/drawingml/2006/main"/>
-          <a:p xmlns:a="http://schemas.openxmlformats.org/drawingml/2006/main">
-            <a:pPr algn="l">
-              <a:buNone/>
-              <a:defRPr sz="1350" b="1">
-                <a:solidFill>
-                  <a:srgbClr val="344054"/>
-                </a:solidFill>
-                <a:latin typeface="Helvetica Neue"/>
-                <a:ea typeface="Helvetica Neue"/>
-                <a:cs typeface="Helvetica Neue"/>
-              </a:defRPr>
-            </a:pPr>
-            <a:r>
-              <a:rPr sz="1350" b="1">
-                <a:solidFill>
-                  <a:srgbClr val="344054"/>
-                </a:solidFill>
-                <a:latin typeface="Helvetica Neue"/>
-                <a:ea typeface="Helvetica Neue"/>
-                <a:cs typeface="Helvetica Neue"/>
-              </a:rPr>
-              <a:t>Core journey: get a brief · check a fact · see uncertainty · send feedback</a:t>
-            </a:r>
-          </a:p>
-        </p:txBody>
-      </p:sp>
-      <p:sp>
-        <p:nvSpPr>
-          <p:cNvPr id="24" name="">
-            <a:extLst xmlns:a="http://schemas.openxmlformats.org/drawingml/2006/main">
-              <a:ext uri="{FF2B5EF4-FFF2-40B4-BE49-F238E27FC236}">
-                <a16:creationId xmlns:a16="http://schemas.microsoft.com/office/drawing/2014/main" id="{4C39101A-94C4-48DC-82B6-88D1BEEA99D4}"/>
-              </a:ext>
-            </a:extLst>
-          </p:cNvPr>
-          <p:cNvSpPr>
-            <a:spLocks xmlns:a="http://schemas.openxmlformats.org/drawingml/2006/main" noGrp="1"/>
-          </p:cNvSpPr>
-          <p:nvPr/>
-        </p:nvSpPr>
-        <p:spPr>
-          <a:xfrm xmlns:a="http://schemas.openxmlformats.org/drawingml/2006/main">
-            <a:off x="457200" y="5638800"/>
-            <a:ext cx="10858500" cy="285750"/>
-          </a:xfrm>
-          <a:prstGeom xmlns:a="http://schemas.openxmlformats.org/drawingml/2006/main" prst="rect">
-            <a:avLst/>
-          </a:prstGeom>
-          <a:noFill xmlns:a="http://schemas.openxmlformats.org/drawingml/2006/main"/>
-          <a:ln xmlns:a="http://schemas.openxmlformats.org/drawingml/2006/main" w="0">
-            <a:noFill/>
-            <a:prstDash val="solid"/>
-          </a:ln>
-        </p:spPr>
-        <p:txBody>
-          <a:bodyPr xmlns:a="http://schemas.openxmlformats.org/drawingml/2006/main" anchor="t">
-            <a:normAutofit fontScale="100000"/>
-          </a:bodyPr>
-          <a:lstStyle xmlns:a="http://schemas.openxmlformats.org/drawingml/2006/main"/>
-          <a:p xmlns:a="http://schemas.openxmlformats.org/drawingml/2006/main">
-            <a:pPr algn="l">
-              <a:buNone/>
-              <a:defRPr sz="1275" b="1">
-                <a:solidFill>
-                  <a:srgbClr val="315F9F"/>
-                </a:solidFill>
-                <a:latin typeface="Helvetica Neue"/>
-                <a:ea typeface="Helvetica Neue"/>
-                <a:cs typeface="Helvetica Neue"/>
-              </a:defRPr>
-            </a:pPr>
-            <a:r>
-              <a:rPr sz="1275" b="1">
-                <a:solidFill>
-                  <a:srgbClr val="315F9F"/>
-                </a:solidFill>
-                <a:latin typeface="Helvetica Neue"/>
-                <a:ea typeface="Helvetica Neue"/>
-                <a:cs typeface="Helvetica Neue"/>
-              </a:rPr>
-              <a:t>Good enough: all checks pass, the 250-company test meets 30 seconds, and the AIVC principal rates usefulness at least 4 out of 5.</a:t>
+              <a:t>SHARED · Source contract and evaluation set</a:t>
             </a:r>
           </a:p>
         </p:txBody>
@@ -9034,7 +9227,7 @@
     </p:spTree>
     <p:extLst>
       <p:ext uri="{BB962C8B-B14F-4D97-AF65-F5344CB8AC3E}">
-        <p14:creationId xmlns:p14="http://schemas.microsoft.com/office/powerpoint/2010/main" val="1483308295"/>
+        <p14:creationId xmlns:p14="http://schemas.microsoft.com/office/powerpoint/2010/main" val="1276192043"/>
       </p:ext>
     </p:extLst>
   </p:cSld>
@@ -9062,10 +9255,10 @@
       </p:grpSpPr>
       <p:sp>
         <p:nvSpPr>
-          <p:cNvPr id="29" name="">
-            <a:extLst xmlns:a="http://schemas.openxmlformats.org/drawingml/2006/main">
-              <a:ext uri="{FF2B5EF4-FFF2-40B4-BE49-F238E27FC236}">
-                <a16:creationId xmlns:a16="http://schemas.microsoft.com/office/drawing/2014/main" id="{B48A21C7-CE03-4BC4-898F-2976E47ACF7A}"/>
+          <p:cNvPr id="20" name="">
+            <a:extLst xmlns:a="http://schemas.openxmlformats.org/drawingml/2006/main">
+              <a:ext uri="{FF2B5EF4-FFF2-40B4-BE49-F238E27FC236}">
+                <a16:creationId xmlns:a16="http://schemas.microsoft.com/office/drawing/2014/main" id="{47D7DB73-AD97-4C88-8C7A-A4A75DE3DDCC}"/>
               </a:ext>
             </a:extLst>
           </p:cNvPr>
@@ -9090,7 +9283,7 @@
         </p:spPr>
         <p:txBody>
           <a:bodyPr xmlns:a="http://schemas.openxmlformats.org/drawingml/2006/main" anchor="t">
-            <a:normAutofit fontScale="97554"/>
+            <a:normAutofit fontScale="100000"/>
           </a:bodyPr>
           <a:lstStyle xmlns:a="http://schemas.openxmlformats.org/drawingml/2006/main"/>
           <a:p xmlns:a="http://schemas.openxmlformats.org/drawingml/2006/main">
@@ -9114,7 +9307,7 @@
                 <a:ea typeface="Helvetica Neue"/>
                 <a:cs typeface="Helvetica Neue"/>
               </a:rPr>
-              <a:t>How would two people reach an internal pilot in eight weeks?</a:t>
+              <a:t>What do I de-risk first, and what changes with more time?</a:t>
             </a:r>
           </a:p>
         </p:txBody>
@@ -9124,7 +9317,7 @@
           <p:cNvPr id="2" name="">
             <a:extLst xmlns:a="http://schemas.openxmlformats.org/drawingml/2006/main">
               <a:ext uri="{FF2B5EF4-FFF2-40B4-BE49-F238E27FC236}">
-                <a16:creationId xmlns:a16="http://schemas.microsoft.com/office/drawing/2014/main" id="{09B70858-4A35-41AC-BA4E-97385B0D613C}"/>
+                <a16:creationId xmlns:a16="http://schemas.microsoft.com/office/drawing/2014/main" id="{1148B56E-B5D3-40D5-84C7-3298B3E762FB}"/>
               </a:ext>
             </a:extLst>
           </p:cNvPr>
@@ -9155,7 +9348,7 @@
           <p:cNvPr id="3" name="">
             <a:extLst xmlns:a="http://schemas.openxmlformats.org/drawingml/2006/main">
               <a:ext uri="{FF2B5EF4-FFF2-40B4-BE49-F238E27FC236}">
-                <a16:creationId xmlns:a16="http://schemas.microsoft.com/office/drawing/2014/main" id="{6932D16F-3E93-49C8-A083-E6763E45CD17}"/>
+                <a16:creationId xmlns:a16="http://schemas.microsoft.com/office/drawing/2014/main" id="{AB2D00DE-0653-4BEF-8506-56714A0FA028}"/>
               </a:ext>
             </a:extLst>
           </p:cNvPr>
@@ -9203,1599 +9396,6 @@
                 <a:cs typeface="Helvetica Neue"/>
               </a:rPr>
               <a:t>07</a:t>
-            </a:r>
-          </a:p>
-        </p:txBody>
-      </p:sp>
-      <p:sp>
-        <p:nvSpPr>
-          <p:cNvPr id="4" name="">
-            <a:extLst xmlns:a="http://schemas.openxmlformats.org/drawingml/2006/main">
-              <a:ext uri="{FF2B5EF4-FFF2-40B4-BE49-F238E27FC236}">
-                <a16:creationId xmlns:a16="http://schemas.microsoft.com/office/drawing/2014/main" id="{F6AA8900-8D83-489E-AEA5-4DF6BA250739}"/>
-              </a:ext>
-            </a:extLst>
-          </p:cNvPr>
-          <p:cNvSpPr>
-            <a:spLocks xmlns:a="http://schemas.openxmlformats.org/drawingml/2006/main" noGrp="1"/>
-          </p:cNvSpPr>
-          <p:nvPr/>
-        </p:nvSpPr>
-        <p:spPr>
-          <a:xfrm xmlns:a="http://schemas.openxmlformats.org/drawingml/2006/main">
-            <a:off x="1057275" y="2324100"/>
-            <a:ext cx="9001125" cy="0"/>
-          </a:xfrm>
-          <a:prstGeom xmlns:a="http://schemas.openxmlformats.org/drawingml/2006/main" prst="line">
-            <a:avLst/>
-          </a:prstGeom>
-          <a:noFill xmlns:a="http://schemas.openxmlformats.org/drawingml/2006/main"/>
-          <a:ln xmlns:a="http://schemas.openxmlformats.org/drawingml/2006/main" w="28575">
-            <a:solidFill>
-              <a:srgbClr val="9CB5D5"/>
-            </a:solidFill>
-            <a:prstDash val="solid"/>
-          </a:ln>
-        </p:spPr>
-      </p:sp>
-      <p:sp>
-        <p:nvSpPr>
-          <p:cNvPr id="5" name="">
-            <a:extLst xmlns:a="http://schemas.openxmlformats.org/drawingml/2006/main">
-              <a:ext uri="{FF2B5EF4-FFF2-40B4-BE49-F238E27FC236}">
-                <a16:creationId xmlns:a16="http://schemas.microsoft.com/office/drawing/2014/main" id="{20A0FB16-277A-415B-B0A6-8E73C2815796}"/>
-              </a:ext>
-            </a:extLst>
-          </p:cNvPr>
-          <p:cNvSpPr>
-            <a:spLocks xmlns:a="http://schemas.openxmlformats.org/drawingml/2006/main" noGrp="1"/>
-          </p:cNvSpPr>
-          <p:nvPr/>
-        </p:nvSpPr>
-        <p:spPr>
-          <a:xfrm xmlns:a="http://schemas.openxmlformats.org/drawingml/2006/main">
-            <a:off x="1476375" y="2171700"/>
-            <a:ext cx="228600" cy="228600"/>
-          </a:xfrm>
-          <a:prstGeom xmlns:a="http://schemas.openxmlformats.org/drawingml/2006/main" prst="roundRect">
-            <a:avLst>
-              <a:gd name="adj" fmla="val 50000"/>
-            </a:avLst>
-          </a:prstGeom>
-          <a:solidFill xmlns:a="http://schemas.openxmlformats.org/drawingml/2006/main">
-            <a:srgbClr val="315F9F"/>
-          </a:solidFill>
-          <a:ln xmlns:a="http://schemas.openxmlformats.org/drawingml/2006/main" w="9525">
-            <a:solidFill>
-              <a:srgbClr val="315F9F"/>
-            </a:solidFill>
-            <a:prstDash val="solid"/>
-          </a:ln>
-        </p:spPr>
-      </p:sp>
-      <p:sp>
-        <p:nvSpPr>
-          <p:cNvPr id="6" name="">
-            <a:extLst xmlns:a="http://schemas.openxmlformats.org/drawingml/2006/main">
-              <a:ext uri="{FF2B5EF4-FFF2-40B4-BE49-F238E27FC236}">
-                <a16:creationId xmlns:a16="http://schemas.microsoft.com/office/drawing/2014/main" id="{03049BA2-9994-4F21-94A5-B41BE3149E4E}"/>
-              </a:ext>
-            </a:extLst>
-          </p:cNvPr>
-          <p:cNvSpPr>
-            <a:spLocks xmlns:a="http://schemas.openxmlformats.org/drawingml/2006/main" noGrp="1"/>
-          </p:cNvSpPr>
-          <p:nvPr/>
-        </p:nvSpPr>
-        <p:spPr>
-          <a:xfrm xmlns:a="http://schemas.openxmlformats.org/drawingml/2006/main">
-            <a:off x="457200" y="2609850"/>
-            <a:ext cx="2457450" cy="2476500"/>
-          </a:xfrm>
-          <a:prstGeom xmlns:a="http://schemas.openxmlformats.org/drawingml/2006/main" prst="roundRect">
-            <a:avLst>
-              <a:gd name="adj" fmla="val 6202"/>
-            </a:avLst>
-          </a:prstGeom>
-          <a:solidFill xmlns:a="http://schemas.openxmlformats.org/drawingml/2006/main">
-            <a:srgbClr val="FFFFFF"/>
-          </a:solidFill>
-          <a:ln xmlns:a="http://schemas.openxmlformats.org/drawingml/2006/main" w="9525">
-            <a:solidFill>
-              <a:srgbClr val="D0D5DD"/>
-            </a:solidFill>
-            <a:prstDash val="solid"/>
-          </a:ln>
-        </p:spPr>
-      </p:sp>
-      <p:sp>
-        <p:nvSpPr>
-          <p:cNvPr id="7" name="">
-            <a:extLst xmlns:a="http://schemas.openxmlformats.org/drawingml/2006/main">
-              <a:ext uri="{FF2B5EF4-FFF2-40B4-BE49-F238E27FC236}">
-                <a16:creationId xmlns:a16="http://schemas.microsoft.com/office/drawing/2014/main" id="{1F65D154-8701-4349-9AFF-7DA254E7C5CA}"/>
-              </a:ext>
-            </a:extLst>
-          </p:cNvPr>
-          <p:cNvSpPr>
-            <a:spLocks xmlns:a="http://schemas.openxmlformats.org/drawingml/2006/main" noGrp="1"/>
-          </p:cNvSpPr>
-          <p:nvPr/>
-        </p:nvSpPr>
-        <p:spPr>
-          <a:xfrm xmlns:a="http://schemas.openxmlformats.org/drawingml/2006/main">
-            <a:off x="666750" y="2838450"/>
-            <a:ext cx="2000250" cy="209550"/>
-          </a:xfrm>
-          <a:prstGeom xmlns:a="http://schemas.openxmlformats.org/drawingml/2006/main" prst="rect">
-            <a:avLst/>
-          </a:prstGeom>
-          <a:noFill xmlns:a="http://schemas.openxmlformats.org/drawingml/2006/main"/>
-          <a:ln xmlns:a="http://schemas.openxmlformats.org/drawingml/2006/main" w="0">
-            <a:noFill/>
-            <a:prstDash val="solid"/>
-          </a:ln>
-        </p:spPr>
-        <p:txBody>
-          <a:bodyPr xmlns:a="http://schemas.openxmlformats.org/drawingml/2006/main" anchor="t">
-            <a:normAutofit fontScale="86111"/>
-          </a:bodyPr>
-          <a:lstStyle xmlns:a="http://schemas.openxmlformats.org/drawingml/2006/main"/>
-          <a:p xmlns:a="http://schemas.openxmlformats.org/drawingml/2006/main">
-            <a:pPr algn="l">
-              <a:buNone/>
-              <a:defRPr sz="1050" b="1">
-                <a:solidFill>
-                  <a:srgbClr val="315F9F"/>
-                </a:solidFill>
-                <a:latin typeface="Helvetica Neue"/>
-                <a:ea typeface="Helvetica Neue"/>
-                <a:cs typeface="Helvetica Neue"/>
-              </a:defRPr>
-            </a:pPr>
-            <a:r>
-              <a:rPr sz="900" b="1">
-                <a:solidFill>
-                  <a:srgbClr val="315F9F"/>
-                </a:solidFill>
-                <a:latin typeface="Helvetica Neue"/>
-                <a:ea typeface="Helvetica Neue"/>
-                <a:cs typeface="Helvetica Neue"/>
-              </a:rPr>
-              <a:t>PROPOSED · WEEKS 1–2</a:t>
-            </a:r>
-          </a:p>
-        </p:txBody>
-      </p:sp>
-      <p:sp>
-        <p:nvSpPr>
-          <p:cNvPr id="8" name="">
-            <a:extLst xmlns:a="http://schemas.openxmlformats.org/drawingml/2006/main">
-              <a:ext uri="{FF2B5EF4-FFF2-40B4-BE49-F238E27FC236}">
-                <a16:creationId xmlns:a16="http://schemas.microsoft.com/office/drawing/2014/main" id="{C64C3219-E26B-4090-B4AC-9A1D699133EC}"/>
-              </a:ext>
-            </a:extLst>
-          </p:cNvPr>
-          <p:cNvSpPr>
-            <a:spLocks xmlns:a="http://schemas.openxmlformats.org/drawingml/2006/main" noGrp="1"/>
-          </p:cNvSpPr>
-          <p:nvPr/>
-        </p:nvSpPr>
-        <p:spPr>
-          <a:xfrm xmlns:a="http://schemas.openxmlformats.org/drawingml/2006/main">
-            <a:off x="666750" y="3209925"/>
-            <a:ext cx="2038350" cy="438150"/>
-          </a:xfrm>
-          <a:prstGeom xmlns:a="http://schemas.openxmlformats.org/drawingml/2006/main" prst="rect">
-            <a:avLst/>
-          </a:prstGeom>
-          <a:noFill xmlns:a="http://schemas.openxmlformats.org/drawingml/2006/main"/>
-          <a:ln xmlns:a="http://schemas.openxmlformats.org/drawingml/2006/main" w="0">
-            <a:noFill/>
-            <a:prstDash val="solid"/>
-          </a:ln>
-        </p:spPr>
-        <p:txBody>
-          <a:bodyPr xmlns:a="http://schemas.openxmlformats.org/drawingml/2006/main" anchor="t">
-            <a:normAutofit fontScale="68939"/>
-          </a:bodyPr>
-          <a:lstStyle xmlns:a="http://schemas.openxmlformats.org/drawingml/2006/main"/>
-          <a:p xmlns:a="http://schemas.openxmlformats.org/drawingml/2006/main">
-            <a:pPr algn="l">
-              <a:buNone/>
-              <a:defRPr sz="1650" b="1">
-                <a:solidFill>
-                  <a:srgbClr val="101828"/>
-                </a:solidFill>
-                <a:latin typeface="Helvetica Neue"/>
-                <a:ea typeface="Helvetica Neue"/>
-                <a:cs typeface="Helvetica Neue"/>
-              </a:defRPr>
-            </a:pPr>
-            <a:r>
-              <a:rPr sz="1650" b="1">
-                <a:solidFill>
-                  <a:srgbClr val="101828"/>
-                </a:solidFill>
-                <a:latin typeface="Helvetica Neue"/>
-                <a:ea typeface="Helvetica Neue"/>
-                <a:cs typeface="Helvetica Neue"/>
-              </a:rPr>
-              <a:t>Build one source-to-brief path</a:t>
-            </a:r>
-          </a:p>
-        </p:txBody>
-      </p:sp>
-      <p:sp>
-        <p:nvSpPr>
-          <p:cNvPr id="9" name="">
-            <a:extLst xmlns:a="http://schemas.openxmlformats.org/drawingml/2006/main">
-              <a:ext uri="{FF2B5EF4-FFF2-40B4-BE49-F238E27FC236}">
-                <a16:creationId xmlns:a16="http://schemas.microsoft.com/office/drawing/2014/main" id="{EF101CF2-9E15-45BA-BEE2-9A4742BA8580}"/>
-              </a:ext>
-            </a:extLst>
-          </p:cNvPr>
-          <p:cNvSpPr>
-            <a:spLocks xmlns:a="http://schemas.openxmlformats.org/drawingml/2006/main" noGrp="1"/>
-          </p:cNvSpPr>
-          <p:nvPr/>
-        </p:nvSpPr>
-        <p:spPr>
-          <a:xfrm xmlns:a="http://schemas.openxmlformats.org/drawingml/2006/main">
-            <a:off x="666750" y="3876675"/>
-            <a:ext cx="2038350" cy="952500"/>
-          </a:xfrm>
-          <a:prstGeom xmlns:a="http://schemas.openxmlformats.org/drawingml/2006/main" prst="rect">
-            <a:avLst/>
-          </a:prstGeom>
-          <a:noFill xmlns:a="http://schemas.openxmlformats.org/drawingml/2006/main"/>
-          <a:ln xmlns:a="http://schemas.openxmlformats.org/drawingml/2006/main" w="0">
-            <a:noFill/>
-            <a:prstDash val="solid"/>
-          </a:ln>
-        </p:spPr>
-        <p:txBody>
-          <a:bodyPr xmlns:a="http://schemas.openxmlformats.org/drawingml/2006/main" anchor="t">
-            <a:normAutofit fontScale="100000"/>
-          </a:bodyPr>
-          <a:lstStyle xmlns:a="http://schemas.openxmlformats.org/drawingml/2006/main"/>
-          <a:p xmlns:a="http://schemas.openxmlformats.org/drawingml/2006/main">
-            <a:pPr algn="l">
-              <a:buNone/>
-              <a:defRPr sz="1275" b="0">
-                <a:solidFill>
-                  <a:srgbClr val="344054"/>
-                </a:solidFill>
-                <a:latin typeface="Helvetica Neue"/>
-                <a:ea typeface="Helvetica Neue"/>
-                <a:cs typeface="Helvetica Neue"/>
-              </a:defRPr>
-            </a:pPr>
-            <a:r>
-              <a:rPr sz="1275" b="0">
-                <a:solidFill>
-                  <a:srgbClr val="344054"/>
-                </a:solidFill>
-                <a:latin typeface="Helvetica Neue"/>
-                <a:ea typeface="Helvetica Neue"/>
-                <a:cs typeface="Helvetica Neue"/>
-              </a:rPr>
-              <a:t>Reference answers</a:t>
-            </a:r>
-          </a:p>
-          <a:p xmlns:a="http://schemas.openxmlformats.org/drawingml/2006/main">
-            <a:pPr algn="l">
-              <a:buNone/>
-              <a:defRPr sz="1275" b="0">
-                <a:solidFill>
-                  <a:srgbClr val="344054"/>
-                </a:solidFill>
-                <a:latin typeface="Helvetica Neue"/>
-                <a:ea typeface="Helvetica Neue"/>
-                <a:cs typeface="Helvetica Neue"/>
-              </a:defRPr>
-            </a:pPr>
-            <a:r>
-              <a:rPr sz="1275" b="0">
-                <a:solidFill>
-                  <a:srgbClr val="344054"/>
-                </a:solidFill>
-                <a:latin typeface="Helvetica Neue"/>
-                <a:ea typeface="Helvetica Neue"/>
-                <a:cs typeface="Helvetica Neue"/>
-              </a:rPr>
-              <a:t>Source contract</a:t>
-            </a:r>
-          </a:p>
-          <a:p xmlns:a="http://schemas.openxmlformats.org/drawingml/2006/main">
-            <a:pPr algn="l">
-              <a:buNone/>
-              <a:defRPr sz="1275" b="0">
-                <a:solidFill>
-                  <a:srgbClr val="344054"/>
-                </a:solidFill>
-                <a:latin typeface="Helvetica Neue"/>
-                <a:ea typeface="Helvetica Neue"/>
-                <a:cs typeface="Helvetica Neue"/>
-              </a:defRPr>
-            </a:pPr>
-            <a:r>
-              <a:rPr sz="1275" b="0">
-                <a:solidFill>
-                  <a:srgbClr val="344054"/>
-                </a:solidFill>
-                <a:latin typeface="Helvetica Neue"/>
-                <a:ea typeface="Helvetica Neue"/>
-                <a:cs typeface="Helvetica Neue"/>
-              </a:rPr>
-              <a:t>One-company slice</a:t>
-            </a:r>
-          </a:p>
-        </p:txBody>
-      </p:sp>
-      <p:sp>
-        <p:nvSpPr>
-          <p:cNvPr id="10" name="">
-            <a:extLst xmlns:a="http://schemas.openxmlformats.org/drawingml/2006/main">
-              <a:ext uri="{FF2B5EF4-FFF2-40B4-BE49-F238E27FC236}">
-                <a16:creationId xmlns:a16="http://schemas.microsoft.com/office/drawing/2014/main" id="{7AB3725A-8499-4B9F-902D-1547D90E1C54}"/>
-              </a:ext>
-            </a:extLst>
-          </p:cNvPr>
-          <p:cNvSpPr>
-            <a:spLocks xmlns:a="http://schemas.openxmlformats.org/drawingml/2006/main" noGrp="1"/>
-          </p:cNvSpPr>
-          <p:nvPr/>
-        </p:nvSpPr>
-        <p:spPr>
-          <a:xfrm xmlns:a="http://schemas.openxmlformats.org/drawingml/2006/main">
-            <a:off x="4210050" y="2171700"/>
-            <a:ext cx="228600" cy="228600"/>
-          </a:xfrm>
-          <a:prstGeom xmlns:a="http://schemas.openxmlformats.org/drawingml/2006/main" prst="roundRect">
-            <a:avLst>
-              <a:gd name="adj" fmla="val 50000"/>
-            </a:avLst>
-          </a:prstGeom>
-          <a:solidFill xmlns:a="http://schemas.openxmlformats.org/drawingml/2006/main">
-            <a:srgbClr val="315F9F"/>
-          </a:solidFill>
-          <a:ln xmlns:a="http://schemas.openxmlformats.org/drawingml/2006/main" w="9525">
-            <a:solidFill>
-              <a:srgbClr val="315F9F"/>
-            </a:solidFill>
-            <a:prstDash val="solid"/>
-          </a:ln>
-        </p:spPr>
-      </p:sp>
-      <p:sp>
-        <p:nvSpPr>
-          <p:cNvPr id="11" name="">
-            <a:extLst xmlns:a="http://schemas.openxmlformats.org/drawingml/2006/main">
-              <a:ext uri="{FF2B5EF4-FFF2-40B4-BE49-F238E27FC236}">
-                <a16:creationId xmlns:a16="http://schemas.microsoft.com/office/drawing/2014/main" id="{913AFA8F-4649-4DC7-8F2E-34007EF14B85}"/>
-              </a:ext>
-            </a:extLst>
-          </p:cNvPr>
-          <p:cNvSpPr>
-            <a:spLocks xmlns:a="http://schemas.openxmlformats.org/drawingml/2006/main" noGrp="1"/>
-          </p:cNvSpPr>
-          <p:nvPr/>
-        </p:nvSpPr>
-        <p:spPr>
-          <a:xfrm xmlns:a="http://schemas.openxmlformats.org/drawingml/2006/main">
-            <a:off x="3190875" y="2609850"/>
-            <a:ext cx="2457450" cy="2476500"/>
-          </a:xfrm>
-          <a:prstGeom xmlns:a="http://schemas.openxmlformats.org/drawingml/2006/main" prst="roundRect">
-            <a:avLst>
-              <a:gd name="adj" fmla="val 6202"/>
-            </a:avLst>
-          </a:prstGeom>
-          <a:solidFill xmlns:a="http://schemas.openxmlformats.org/drawingml/2006/main">
-            <a:srgbClr val="E8F0FB"/>
-          </a:solidFill>
-          <a:ln xmlns:a="http://schemas.openxmlformats.org/drawingml/2006/main" w="9525">
-            <a:solidFill>
-              <a:srgbClr val="9CB5D5"/>
-            </a:solidFill>
-            <a:prstDash val="solid"/>
-          </a:ln>
-        </p:spPr>
-      </p:sp>
-      <p:sp>
-        <p:nvSpPr>
-          <p:cNvPr id="12" name="">
-            <a:extLst xmlns:a="http://schemas.openxmlformats.org/drawingml/2006/main">
-              <a:ext uri="{FF2B5EF4-FFF2-40B4-BE49-F238E27FC236}">
-                <a16:creationId xmlns:a16="http://schemas.microsoft.com/office/drawing/2014/main" id="{FA8820BD-E9D8-4EE0-91EF-A42C6781D2EC}"/>
-              </a:ext>
-            </a:extLst>
-          </p:cNvPr>
-          <p:cNvSpPr>
-            <a:spLocks xmlns:a="http://schemas.openxmlformats.org/drawingml/2006/main" noGrp="1"/>
-          </p:cNvSpPr>
-          <p:nvPr/>
-        </p:nvSpPr>
-        <p:spPr>
-          <a:xfrm xmlns:a="http://schemas.openxmlformats.org/drawingml/2006/main">
-            <a:off x="3400425" y="2838450"/>
-            <a:ext cx="2000250" cy="209550"/>
-          </a:xfrm>
-          <a:prstGeom xmlns:a="http://schemas.openxmlformats.org/drawingml/2006/main" prst="rect">
-            <a:avLst/>
-          </a:prstGeom>
-          <a:noFill xmlns:a="http://schemas.openxmlformats.org/drawingml/2006/main"/>
-          <a:ln xmlns:a="http://schemas.openxmlformats.org/drawingml/2006/main" w="0">
-            <a:noFill/>
-            <a:prstDash val="solid"/>
-          </a:ln>
-        </p:spPr>
-        <p:txBody>
-          <a:bodyPr xmlns:a="http://schemas.openxmlformats.org/drawingml/2006/main" anchor="t"/>
-          <a:lstStyle xmlns:a="http://schemas.openxmlformats.org/drawingml/2006/main"/>
-          <a:p xmlns:a="http://schemas.openxmlformats.org/drawingml/2006/main">
-            <a:pPr algn="l">
-              <a:buNone/>
-              <a:defRPr sz="1050" b="1">
-                <a:solidFill>
-                  <a:srgbClr val="315F9F"/>
-                </a:solidFill>
-                <a:latin typeface="Helvetica Neue"/>
-                <a:ea typeface="Helvetica Neue"/>
-                <a:cs typeface="Helvetica Neue"/>
-              </a:defRPr>
-            </a:pPr>
-            <a:r>
-              <a:rPr sz="1050" b="1">
-                <a:solidFill>
-                  <a:srgbClr val="315F9F"/>
-                </a:solidFill>
-                <a:latin typeface="Helvetica Neue"/>
-                <a:ea typeface="Helvetica Neue"/>
-                <a:cs typeface="Helvetica Neue"/>
-              </a:rPr>
-              <a:t>WEEKS 3–4</a:t>
-            </a:r>
-          </a:p>
-        </p:txBody>
-      </p:sp>
-      <p:sp>
-        <p:nvSpPr>
-          <p:cNvPr id="13" name="">
-            <a:extLst xmlns:a="http://schemas.openxmlformats.org/drawingml/2006/main">
-              <a:ext uri="{FF2B5EF4-FFF2-40B4-BE49-F238E27FC236}">
-                <a16:creationId xmlns:a16="http://schemas.microsoft.com/office/drawing/2014/main" id="{D25C1FD4-F4A1-44A7-A1AC-BFCA9E9B513A}"/>
-              </a:ext>
-            </a:extLst>
-          </p:cNvPr>
-          <p:cNvSpPr>
-            <a:spLocks xmlns:a="http://schemas.openxmlformats.org/drawingml/2006/main" noGrp="1"/>
-          </p:cNvSpPr>
-          <p:nvPr/>
-        </p:nvSpPr>
-        <p:spPr>
-          <a:xfrm xmlns:a="http://schemas.openxmlformats.org/drawingml/2006/main">
-            <a:off x="3400425" y="3209925"/>
-            <a:ext cx="2038350" cy="438150"/>
-          </a:xfrm>
-          <a:prstGeom xmlns:a="http://schemas.openxmlformats.org/drawingml/2006/main" prst="rect">
-            <a:avLst/>
-          </a:prstGeom>
-          <a:noFill xmlns:a="http://schemas.openxmlformats.org/drawingml/2006/main"/>
-          <a:ln xmlns:a="http://schemas.openxmlformats.org/drawingml/2006/main" w="0">
-            <a:noFill/>
-            <a:prstDash val="solid"/>
-          </a:ln>
-        </p:spPr>
-        <p:txBody>
-          <a:bodyPr xmlns:a="http://schemas.openxmlformats.org/drawingml/2006/main" anchor="t">
-            <a:normAutofit fontScale="68939"/>
-          </a:bodyPr>
-          <a:lstStyle xmlns:a="http://schemas.openxmlformats.org/drawingml/2006/main"/>
-          <a:p xmlns:a="http://schemas.openxmlformats.org/drawingml/2006/main">
-            <a:pPr algn="l">
-              <a:buNone/>
-              <a:defRPr sz="1650" b="1">
-                <a:solidFill>
-                  <a:srgbClr val="101828"/>
-                </a:solidFill>
-                <a:latin typeface="Helvetica Neue"/>
-                <a:ea typeface="Helvetica Neue"/>
-                <a:cs typeface="Helvetica Neue"/>
-              </a:defRPr>
-            </a:pPr>
-            <a:r>
-              <a:rPr sz="1650" b="1">
-                <a:solidFill>
-                  <a:srgbClr val="101828"/>
-                </a:solidFill>
-                <a:latin typeface="Helvetica Neue"/>
-                <a:ea typeface="Helvetica Neue"/>
-                <a:cs typeface="Helvetica Neue"/>
-              </a:rPr>
-              <a:t>Connect one approved source</a:t>
-            </a:r>
-          </a:p>
-        </p:txBody>
-      </p:sp>
-      <p:sp>
-        <p:nvSpPr>
-          <p:cNvPr id="14" name="">
-            <a:extLst xmlns:a="http://schemas.openxmlformats.org/drawingml/2006/main">
-              <a:ext uri="{FF2B5EF4-FFF2-40B4-BE49-F238E27FC236}">
-                <a16:creationId xmlns:a16="http://schemas.microsoft.com/office/drawing/2014/main" id="{D6F8C5E2-CF81-455B-A842-DB2C25910D2D}"/>
-              </a:ext>
-            </a:extLst>
-          </p:cNvPr>
-          <p:cNvSpPr>
-            <a:spLocks xmlns:a="http://schemas.openxmlformats.org/drawingml/2006/main" noGrp="1"/>
-          </p:cNvSpPr>
-          <p:nvPr/>
-        </p:nvSpPr>
-        <p:spPr>
-          <a:xfrm xmlns:a="http://schemas.openxmlformats.org/drawingml/2006/main">
-            <a:off x="3400425" y="3876675"/>
-            <a:ext cx="2038350" cy="952500"/>
-          </a:xfrm>
-          <a:prstGeom xmlns:a="http://schemas.openxmlformats.org/drawingml/2006/main" prst="rect">
-            <a:avLst/>
-          </a:prstGeom>
-          <a:noFill xmlns:a="http://schemas.openxmlformats.org/drawingml/2006/main"/>
-          <a:ln xmlns:a="http://schemas.openxmlformats.org/drawingml/2006/main" w="0">
-            <a:noFill/>
-            <a:prstDash val="solid"/>
-          </a:ln>
-        </p:spPr>
-        <p:txBody>
-          <a:bodyPr xmlns:a="http://schemas.openxmlformats.org/drawingml/2006/main" anchor="t">
-            <a:normAutofit fontScale="100000"/>
-          </a:bodyPr>
-          <a:lstStyle xmlns:a="http://schemas.openxmlformats.org/drawingml/2006/main"/>
-          <a:p xmlns:a="http://schemas.openxmlformats.org/drawingml/2006/main">
-            <a:pPr algn="l">
-              <a:buNone/>
-              <a:defRPr sz="1275" b="0">
-                <a:solidFill>
-                  <a:srgbClr val="344054"/>
-                </a:solidFill>
-                <a:latin typeface="Helvetica Neue"/>
-                <a:ea typeface="Helvetica Neue"/>
-                <a:cs typeface="Helvetica Neue"/>
-              </a:defRPr>
-            </a:pPr>
-            <a:r>
-              <a:rPr sz="1275" b="0">
-                <a:solidFill>
-                  <a:srgbClr val="344054"/>
-                </a:solidFill>
-                <a:latin typeface="Helvetica Neue"/>
-                <a:ea typeface="Helvetica Neue"/>
-                <a:cs typeface="Helvetica Neue"/>
-              </a:rPr>
-              <a:t>Read-only connector</a:t>
-            </a:r>
-          </a:p>
-          <a:p xmlns:a="http://schemas.openxmlformats.org/drawingml/2006/main">
-            <a:pPr algn="l">
-              <a:buNone/>
-              <a:defRPr sz="1275" b="0">
-                <a:solidFill>
-                  <a:srgbClr val="344054"/>
-                </a:solidFill>
-                <a:latin typeface="Helvetica Neue"/>
-                <a:ea typeface="Helvetica Neue"/>
-                <a:cs typeface="Helvetica Neue"/>
-              </a:defRPr>
-            </a:pPr>
-            <a:r>
-              <a:rPr sz="1275" b="0">
-                <a:solidFill>
-                  <a:srgbClr val="344054"/>
-                </a:solidFill>
-                <a:latin typeface="Helvetica Neue"/>
-                <a:ea typeface="Helvetica Neue"/>
-                <a:cs typeface="Helvetica Neue"/>
-              </a:rPr>
-              <a:t>Incremental import</a:t>
-            </a:r>
-          </a:p>
-          <a:p xmlns:a="http://schemas.openxmlformats.org/drawingml/2006/main">
-            <a:pPr algn="l">
-              <a:buNone/>
-              <a:defRPr sz="1275" b="0">
-                <a:solidFill>
-                  <a:srgbClr val="344054"/>
-                </a:solidFill>
-                <a:latin typeface="Helvetica Neue"/>
-                <a:ea typeface="Helvetica Neue"/>
-                <a:cs typeface="Helvetica Neue"/>
-              </a:defRPr>
-            </a:pPr>
-            <a:r>
-              <a:rPr sz="1275" b="0">
-                <a:solidFill>
-                  <a:srgbClr val="344054"/>
-                </a:solidFill>
-                <a:latin typeface="Helvetica Neue"/>
-                <a:ea typeface="Helvetica Neue"/>
-                <a:cs typeface="Helvetica Neue"/>
-              </a:rPr>
-              <a:t>Company mapping check</a:t>
-            </a:r>
-          </a:p>
-        </p:txBody>
-      </p:sp>
-      <p:sp>
-        <p:nvSpPr>
-          <p:cNvPr id="15" name="">
-            <a:extLst xmlns:a="http://schemas.openxmlformats.org/drawingml/2006/main">
-              <a:ext uri="{FF2B5EF4-FFF2-40B4-BE49-F238E27FC236}">
-                <a16:creationId xmlns:a16="http://schemas.microsoft.com/office/drawing/2014/main" id="{008777A7-B3A0-4F97-B3F1-99FA5E7A7BC0}"/>
-              </a:ext>
-            </a:extLst>
-          </p:cNvPr>
-          <p:cNvSpPr>
-            <a:spLocks xmlns:a="http://schemas.openxmlformats.org/drawingml/2006/main" noGrp="1"/>
-          </p:cNvSpPr>
-          <p:nvPr/>
-        </p:nvSpPr>
-        <p:spPr>
-          <a:xfrm xmlns:a="http://schemas.openxmlformats.org/drawingml/2006/main">
-            <a:off x="6943725" y="2171700"/>
-            <a:ext cx="228600" cy="228600"/>
-          </a:xfrm>
-          <a:prstGeom xmlns:a="http://schemas.openxmlformats.org/drawingml/2006/main" prst="roundRect">
-            <a:avLst>
-              <a:gd name="adj" fmla="val 50000"/>
-            </a:avLst>
-          </a:prstGeom>
-          <a:solidFill xmlns:a="http://schemas.openxmlformats.org/drawingml/2006/main">
-            <a:srgbClr val="315F9F"/>
-          </a:solidFill>
-          <a:ln xmlns:a="http://schemas.openxmlformats.org/drawingml/2006/main" w="9525">
-            <a:solidFill>
-              <a:srgbClr val="315F9F"/>
-            </a:solidFill>
-            <a:prstDash val="solid"/>
-          </a:ln>
-        </p:spPr>
-      </p:sp>
-      <p:sp>
-        <p:nvSpPr>
-          <p:cNvPr id="16" name="">
-            <a:extLst xmlns:a="http://schemas.openxmlformats.org/drawingml/2006/main">
-              <a:ext uri="{FF2B5EF4-FFF2-40B4-BE49-F238E27FC236}">
-                <a16:creationId xmlns:a16="http://schemas.microsoft.com/office/drawing/2014/main" id="{85A70862-469D-415E-AC13-2BF4C28F4C7B}"/>
-              </a:ext>
-            </a:extLst>
-          </p:cNvPr>
-          <p:cNvSpPr>
-            <a:spLocks xmlns:a="http://schemas.openxmlformats.org/drawingml/2006/main" noGrp="1"/>
-          </p:cNvSpPr>
-          <p:nvPr/>
-        </p:nvSpPr>
-        <p:spPr>
-          <a:xfrm xmlns:a="http://schemas.openxmlformats.org/drawingml/2006/main">
-            <a:off x="5924550" y="2609850"/>
-            <a:ext cx="2457450" cy="2476500"/>
-          </a:xfrm>
-          <a:prstGeom xmlns:a="http://schemas.openxmlformats.org/drawingml/2006/main" prst="roundRect">
-            <a:avLst>
-              <a:gd name="adj" fmla="val 6202"/>
-            </a:avLst>
-          </a:prstGeom>
-          <a:solidFill xmlns:a="http://schemas.openxmlformats.org/drawingml/2006/main">
-            <a:srgbClr val="FFFFFF"/>
-          </a:solidFill>
-          <a:ln xmlns:a="http://schemas.openxmlformats.org/drawingml/2006/main" w="9525">
-            <a:solidFill>
-              <a:srgbClr val="D0D5DD"/>
-            </a:solidFill>
-            <a:prstDash val="solid"/>
-          </a:ln>
-        </p:spPr>
-      </p:sp>
-      <p:sp>
-        <p:nvSpPr>
-          <p:cNvPr id="17" name="">
-            <a:extLst xmlns:a="http://schemas.openxmlformats.org/drawingml/2006/main">
-              <a:ext uri="{FF2B5EF4-FFF2-40B4-BE49-F238E27FC236}">
-                <a16:creationId xmlns:a16="http://schemas.microsoft.com/office/drawing/2014/main" id="{2F40EFA4-B3E1-48E9-B048-F8D6BD7FAC88}"/>
-              </a:ext>
-            </a:extLst>
-          </p:cNvPr>
-          <p:cNvSpPr>
-            <a:spLocks xmlns:a="http://schemas.openxmlformats.org/drawingml/2006/main" noGrp="1"/>
-          </p:cNvSpPr>
-          <p:nvPr/>
-        </p:nvSpPr>
-        <p:spPr>
-          <a:xfrm xmlns:a="http://schemas.openxmlformats.org/drawingml/2006/main">
-            <a:off x="6134100" y="2838450"/>
-            <a:ext cx="2000250" cy="209550"/>
-          </a:xfrm>
-          <a:prstGeom xmlns:a="http://schemas.openxmlformats.org/drawingml/2006/main" prst="rect">
-            <a:avLst/>
-          </a:prstGeom>
-          <a:noFill xmlns:a="http://schemas.openxmlformats.org/drawingml/2006/main"/>
-          <a:ln xmlns:a="http://schemas.openxmlformats.org/drawingml/2006/main" w="0">
-            <a:noFill/>
-            <a:prstDash val="solid"/>
-          </a:ln>
-        </p:spPr>
-        <p:txBody>
-          <a:bodyPr xmlns:a="http://schemas.openxmlformats.org/drawingml/2006/main" anchor="t"/>
-          <a:lstStyle xmlns:a="http://schemas.openxmlformats.org/drawingml/2006/main"/>
-          <a:p xmlns:a="http://schemas.openxmlformats.org/drawingml/2006/main">
-            <a:pPr algn="l">
-              <a:buNone/>
-              <a:defRPr sz="1050" b="1">
-                <a:solidFill>
-                  <a:srgbClr val="315F9F"/>
-                </a:solidFill>
-                <a:latin typeface="Helvetica Neue"/>
-                <a:ea typeface="Helvetica Neue"/>
-                <a:cs typeface="Helvetica Neue"/>
-              </a:defRPr>
-            </a:pPr>
-            <a:r>
-              <a:rPr sz="1050" b="1">
-                <a:solidFill>
-                  <a:srgbClr val="315F9F"/>
-                </a:solidFill>
-                <a:latin typeface="Helvetica Neue"/>
-                <a:ea typeface="Helvetica Neue"/>
-                <a:cs typeface="Helvetica Neue"/>
-              </a:rPr>
-              <a:t>WEEKS 5–6</a:t>
-            </a:r>
-          </a:p>
-        </p:txBody>
-      </p:sp>
-      <p:sp>
-        <p:nvSpPr>
-          <p:cNvPr id="18" name="">
-            <a:extLst xmlns:a="http://schemas.openxmlformats.org/drawingml/2006/main">
-              <a:ext uri="{FF2B5EF4-FFF2-40B4-BE49-F238E27FC236}">
-                <a16:creationId xmlns:a16="http://schemas.microsoft.com/office/drawing/2014/main" id="{F0D4F2DF-06EE-4F15-A3C6-C8D3A96833D5}"/>
-              </a:ext>
-            </a:extLst>
-          </p:cNvPr>
-          <p:cNvSpPr>
-            <a:spLocks xmlns:a="http://schemas.openxmlformats.org/drawingml/2006/main" noGrp="1"/>
-          </p:cNvSpPr>
-          <p:nvPr/>
-        </p:nvSpPr>
-        <p:spPr>
-          <a:xfrm xmlns:a="http://schemas.openxmlformats.org/drawingml/2006/main">
-            <a:off x="6134100" y="3209925"/>
-            <a:ext cx="2038350" cy="438150"/>
-          </a:xfrm>
-          <a:prstGeom xmlns:a="http://schemas.openxmlformats.org/drawingml/2006/main" prst="rect">
-            <a:avLst/>
-          </a:prstGeom>
-          <a:noFill xmlns:a="http://schemas.openxmlformats.org/drawingml/2006/main"/>
-          <a:ln xmlns:a="http://schemas.openxmlformats.org/drawingml/2006/main" w="0">
-            <a:noFill/>
-            <a:prstDash val="solid"/>
-          </a:ln>
-        </p:spPr>
-        <p:txBody>
-          <a:bodyPr xmlns:a="http://schemas.openxmlformats.org/drawingml/2006/main" anchor="t">
-            <a:normAutofit fontScale="74820"/>
-          </a:bodyPr>
-          <a:lstStyle xmlns:a="http://schemas.openxmlformats.org/drawingml/2006/main"/>
-          <a:p xmlns:a="http://schemas.openxmlformats.org/drawingml/2006/main">
-            <a:pPr algn="l">
-              <a:buNone/>
-              <a:defRPr sz="1650" b="1">
-                <a:solidFill>
-                  <a:srgbClr val="101828"/>
-                </a:solidFill>
-                <a:latin typeface="Helvetica Neue"/>
-                <a:ea typeface="Helvetica Neue"/>
-                <a:cs typeface="Helvetica Neue"/>
-              </a:defRPr>
-            </a:pPr>
-            <a:r>
-              <a:rPr sz="1650" b="1">
-                <a:solidFill>
-                  <a:srgbClr val="101828"/>
-                </a:solidFill>
-                <a:latin typeface="Helvetica Neue"/>
-                <a:ea typeface="Helvetica Neue"/>
-                <a:cs typeface="Helvetica Neue"/>
-              </a:rPr>
-              <a:t>Test retrieval and access</a:t>
-            </a:r>
-          </a:p>
-        </p:txBody>
-      </p:sp>
-      <p:sp>
-        <p:nvSpPr>
-          <p:cNvPr id="19" name="">
-            <a:extLst xmlns:a="http://schemas.openxmlformats.org/drawingml/2006/main">
-              <a:ext uri="{FF2B5EF4-FFF2-40B4-BE49-F238E27FC236}">
-                <a16:creationId xmlns:a16="http://schemas.microsoft.com/office/drawing/2014/main" id="{C5BE0EB4-D171-46D5-AE72-9983A065A3F5}"/>
-              </a:ext>
-            </a:extLst>
-          </p:cNvPr>
-          <p:cNvSpPr>
-            <a:spLocks xmlns:a="http://schemas.openxmlformats.org/drawingml/2006/main" noGrp="1"/>
-          </p:cNvSpPr>
-          <p:nvPr/>
-        </p:nvSpPr>
-        <p:spPr>
-          <a:xfrm xmlns:a="http://schemas.openxmlformats.org/drawingml/2006/main">
-            <a:off x="6134100" y="3876675"/>
-            <a:ext cx="2038350" cy="952500"/>
-          </a:xfrm>
-          <a:prstGeom xmlns:a="http://schemas.openxmlformats.org/drawingml/2006/main" prst="rect">
-            <a:avLst/>
-          </a:prstGeom>
-          <a:noFill xmlns:a="http://schemas.openxmlformats.org/drawingml/2006/main"/>
-          <a:ln xmlns:a="http://schemas.openxmlformats.org/drawingml/2006/main" w="0">
-            <a:noFill/>
-            <a:prstDash val="solid"/>
-          </a:ln>
-        </p:spPr>
-        <p:txBody>
-          <a:bodyPr xmlns:a="http://schemas.openxmlformats.org/drawingml/2006/main" anchor="t">
-            <a:normAutofit fontScale="100000"/>
-          </a:bodyPr>
-          <a:lstStyle xmlns:a="http://schemas.openxmlformats.org/drawingml/2006/main"/>
-          <a:p xmlns:a="http://schemas.openxmlformats.org/drawingml/2006/main">
-            <a:pPr algn="l">
-              <a:buNone/>
-              <a:defRPr sz="1275" b="0">
-                <a:solidFill>
-                  <a:srgbClr val="344054"/>
-                </a:solidFill>
-                <a:latin typeface="Helvetica Neue"/>
-                <a:ea typeface="Helvetica Neue"/>
-                <a:cs typeface="Helvetica Neue"/>
-              </a:defRPr>
-            </a:pPr>
-            <a:r>
-              <a:rPr sz="1275" b="0">
-                <a:solidFill>
-                  <a:srgbClr val="344054"/>
-                </a:solidFill>
-                <a:latin typeface="Helvetica Neue"/>
-                <a:ea typeface="Helvetica Neue"/>
-                <a:cs typeface="Helvetica Neue"/>
-              </a:rPr>
-              <a:t>Access checks</a:t>
-            </a:r>
-          </a:p>
-          <a:p xmlns:a="http://schemas.openxmlformats.org/drawingml/2006/main">
-            <a:pPr algn="l">
-              <a:buNone/>
-              <a:defRPr sz="1275" b="0">
-                <a:solidFill>
-                  <a:srgbClr val="344054"/>
-                </a:solidFill>
-                <a:latin typeface="Helvetica Neue"/>
-                <a:ea typeface="Helvetica Neue"/>
-                <a:cs typeface="Helvetica Neue"/>
-              </a:defRPr>
-            </a:pPr>
-            <a:r>
-              <a:rPr sz="1275" b="0">
-                <a:solidFill>
-                  <a:srgbClr val="344054"/>
-                </a:solidFill>
-                <a:latin typeface="Helvetica Neue"/>
-                <a:ea typeface="Helvetica Neue"/>
-                <a:cs typeface="Helvetica Neue"/>
-              </a:rPr>
-              <a:t>Evaluated retrieval</a:t>
-            </a:r>
-          </a:p>
-          <a:p xmlns:a="http://schemas.openxmlformats.org/drawingml/2006/main">
-            <a:pPr algn="l">
-              <a:buNone/>
-              <a:defRPr sz="1275" b="0">
-                <a:solidFill>
-                  <a:srgbClr val="344054"/>
-                </a:solidFill>
-                <a:latin typeface="Helvetica Neue"/>
-                <a:ea typeface="Helvetica Neue"/>
-                <a:cs typeface="Helvetica Neue"/>
-              </a:defRPr>
-            </a:pPr>
-            <a:r>
-              <a:rPr sz="1275" b="0">
-                <a:solidFill>
-                  <a:srgbClr val="344054"/>
-                </a:solidFill>
-                <a:latin typeface="Helvetica Neue"/>
-                <a:ea typeface="Helvetica Neue"/>
-                <a:cs typeface="Helvetica Neue"/>
-              </a:rPr>
-              <a:t>Generation and fallback evaluation</a:t>
-            </a:r>
-          </a:p>
-        </p:txBody>
-      </p:sp>
-      <p:sp>
-        <p:nvSpPr>
-          <p:cNvPr id="20" name="">
-            <a:extLst xmlns:a="http://schemas.openxmlformats.org/drawingml/2006/main">
-              <a:ext uri="{FF2B5EF4-FFF2-40B4-BE49-F238E27FC236}">
-                <a16:creationId xmlns:a16="http://schemas.microsoft.com/office/drawing/2014/main" id="{1A32A016-7301-49CD-B90A-7D57F4D0D685}"/>
-              </a:ext>
-            </a:extLst>
-          </p:cNvPr>
-          <p:cNvSpPr>
-            <a:spLocks xmlns:a="http://schemas.openxmlformats.org/drawingml/2006/main" noGrp="1"/>
-          </p:cNvSpPr>
-          <p:nvPr/>
-        </p:nvSpPr>
-        <p:spPr>
-          <a:xfrm xmlns:a="http://schemas.openxmlformats.org/drawingml/2006/main">
-            <a:off x="9677400" y="2171700"/>
-            <a:ext cx="228600" cy="228600"/>
-          </a:xfrm>
-          <a:prstGeom xmlns:a="http://schemas.openxmlformats.org/drawingml/2006/main" prst="roundRect">
-            <a:avLst>
-              <a:gd name="adj" fmla="val 50000"/>
-            </a:avLst>
-          </a:prstGeom>
-          <a:solidFill xmlns:a="http://schemas.openxmlformats.org/drawingml/2006/main">
-            <a:srgbClr val="315F9F"/>
-          </a:solidFill>
-          <a:ln xmlns:a="http://schemas.openxmlformats.org/drawingml/2006/main" w="9525">
-            <a:solidFill>
-              <a:srgbClr val="315F9F"/>
-            </a:solidFill>
-            <a:prstDash val="solid"/>
-          </a:ln>
-        </p:spPr>
-      </p:sp>
-      <p:sp>
-        <p:nvSpPr>
-          <p:cNvPr id="21" name="">
-            <a:extLst xmlns:a="http://schemas.openxmlformats.org/drawingml/2006/main">
-              <a:ext uri="{FF2B5EF4-FFF2-40B4-BE49-F238E27FC236}">
-                <a16:creationId xmlns:a16="http://schemas.microsoft.com/office/drawing/2014/main" id="{99FCB468-F74B-4357-9A52-E37407197048}"/>
-              </a:ext>
-            </a:extLst>
-          </p:cNvPr>
-          <p:cNvSpPr>
-            <a:spLocks xmlns:a="http://schemas.openxmlformats.org/drawingml/2006/main" noGrp="1"/>
-          </p:cNvSpPr>
-          <p:nvPr/>
-        </p:nvSpPr>
-        <p:spPr>
-          <a:xfrm xmlns:a="http://schemas.openxmlformats.org/drawingml/2006/main">
-            <a:off x="8658225" y="2609850"/>
-            <a:ext cx="2457450" cy="2476500"/>
-          </a:xfrm>
-          <a:prstGeom xmlns:a="http://schemas.openxmlformats.org/drawingml/2006/main" prst="roundRect">
-            <a:avLst>
-              <a:gd name="adj" fmla="val 6202"/>
-            </a:avLst>
-          </a:prstGeom>
-          <a:solidFill xmlns:a="http://schemas.openxmlformats.org/drawingml/2006/main">
-            <a:srgbClr val="E8F0FB"/>
-          </a:solidFill>
-          <a:ln xmlns:a="http://schemas.openxmlformats.org/drawingml/2006/main" w="9525">
-            <a:solidFill>
-              <a:srgbClr val="9CB5D5"/>
-            </a:solidFill>
-            <a:prstDash val="solid"/>
-          </a:ln>
-        </p:spPr>
-      </p:sp>
-      <p:sp>
-        <p:nvSpPr>
-          <p:cNvPr id="22" name="">
-            <a:extLst xmlns:a="http://schemas.openxmlformats.org/drawingml/2006/main">
-              <a:ext uri="{FF2B5EF4-FFF2-40B4-BE49-F238E27FC236}">
-                <a16:creationId xmlns:a16="http://schemas.microsoft.com/office/drawing/2014/main" id="{6E06FC1C-4C98-4854-B230-8BE2949563A6}"/>
-              </a:ext>
-            </a:extLst>
-          </p:cNvPr>
-          <p:cNvSpPr>
-            <a:spLocks xmlns:a="http://schemas.openxmlformats.org/drawingml/2006/main" noGrp="1"/>
-          </p:cNvSpPr>
-          <p:nvPr/>
-        </p:nvSpPr>
-        <p:spPr>
-          <a:xfrm xmlns:a="http://schemas.openxmlformats.org/drawingml/2006/main">
-            <a:off x="8867775" y="2838450"/>
-            <a:ext cx="2000250" cy="209550"/>
-          </a:xfrm>
-          <a:prstGeom xmlns:a="http://schemas.openxmlformats.org/drawingml/2006/main" prst="rect">
-            <a:avLst/>
-          </a:prstGeom>
-          <a:noFill xmlns:a="http://schemas.openxmlformats.org/drawingml/2006/main"/>
-          <a:ln xmlns:a="http://schemas.openxmlformats.org/drawingml/2006/main" w="0">
-            <a:noFill/>
-            <a:prstDash val="solid"/>
-          </a:ln>
-        </p:spPr>
-        <p:txBody>
-          <a:bodyPr xmlns:a="http://schemas.openxmlformats.org/drawingml/2006/main" anchor="t"/>
-          <a:lstStyle xmlns:a="http://schemas.openxmlformats.org/drawingml/2006/main"/>
-          <a:p xmlns:a="http://schemas.openxmlformats.org/drawingml/2006/main">
-            <a:pPr algn="l">
-              <a:buNone/>
-              <a:defRPr sz="1050" b="1">
-                <a:solidFill>
-                  <a:srgbClr val="315F9F"/>
-                </a:solidFill>
-                <a:latin typeface="Helvetica Neue"/>
-                <a:ea typeface="Helvetica Neue"/>
-                <a:cs typeface="Helvetica Neue"/>
-              </a:defRPr>
-            </a:pPr>
-            <a:r>
-              <a:rPr sz="1050" b="1">
-                <a:solidFill>
-                  <a:srgbClr val="315F9F"/>
-                </a:solidFill>
-                <a:latin typeface="Helvetica Neue"/>
-                <a:ea typeface="Helvetica Neue"/>
-                <a:cs typeface="Helvetica Neue"/>
-              </a:rPr>
-              <a:t>WEEKS 7–8</a:t>
-            </a:r>
-          </a:p>
-        </p:txBody>
-      </p:sp>
-      <p:sp>
-        <p:nvSpPr>
-          <p:cNvPr id="23" name="">
-            <a:extLst xmlns:a="http://schemas.openxmlformats.org/drawingml/2006/main">
-              <a:ext uri="{FF2B5EF4-FFF2-40B4-BE49-F238E27FC236}">
-                <a16:creationId xmlns:a16="http://schemas.microsoft.com/office/drawing/2014/main" id="{3F5B3583-FB90-4EDE-95F5-3AE6193A1599}"/>
-              </a:ext>
-            </a:extLst>
-          </p:cNvPr>
-          <p:cNvSpPr>
-            <a:spLocks xmlns:a="http://schemas.openxmlformats.org/drawingml/2006/main" noGrp="1"/>
-          </p:cNvSpPr>
-          <p:nvPr/>
-        </p:nvSpPr>
-        <p:spPr>
-          <a:xfrm xmlns:a="http://schemas.openxmlformats.org/drawingml/2006/main">
-            <a:off x="8867775" y="3209925"/>
-            <a:ext cx="2038350" cy="438150"/>
-          </a:xfrm>
-          <a:prstGeom xmlns:a="http://schemas.openxmlformats.org/drawingml/2006/main" prst="rect">
-            <a:avLst/>
-          </a:prstGeom>
-          <a:noFill xmlns:a="http://schemas.openxmlformats.org/drawingml/2006/main"/>
-          <a:ln xmlns:a="http://schemas.openxmlformats.org/drawingml/2006/main" w="0">
-            <a:noFill/>
-            <a:prstDash val="solid"/>
-          </a:ln>
-        </p:spPr>
-        <p:txBody>
-          <a:bodyPr xmlns:a="http://schemas.openxmlformats.org/drawingml/2006/main" anchor="t">
-            <a:normAutofit fontScale="68939"/>
-          </a:bodyPr>
-          <a:lstStyle xmlns:a="http://schemas.openxmlformats.org/drawingml/2006/main"/>
-          <a:p xmlns:a="http://schemas.openxmlformats.org/drawingml/2006/main">
-            <a:pPr algn="l">
-              <a:buNone/>
-              <a:defRPr sz="1650" b="1">
-                <a:solidFill>
-                  <a:srgbClr val="101828"/>
-                </a:solidFill>
-                <a:latin typeface="Helvetica Neue"/>
-                <a:ea typeface="Helvetica Neue"/>
-                <a:cs typeface="Helvetica Neue"/>
-              </a:defRPr>
-            </a:pPr>
-            <a:r>
-              <a:rPr sz="1650" b="1">
-                <a:solidFill>
-                  <a:srgbClr val="101828"/>
-                </a:solidFill>
-                <a:latin typeface="Helvetica Neue"/>
-                <a:ea typeface="Helvetica Neue"/>
-                <a:cs typeface="Helvetica Neue"/>
-              </a:rPr>
-              <a:t>Run the pilot and scale test</a:t>
-            </a:r>
-          </a:p>
-        </p:txBody>
-      </p:sp>
-      <p:sp>
-        <p:nvSpPr>
-          <p:cNvPr id="24" name="">
-            <a:extLst xmlns:a="http://schemas.openxmlformats.org/drawingml/2006/main">
-              <a:ext uri="{FF2B5EF4-FFF2-40B4-BE49-F238E27FC236}">
-                <a16:creationId xmlns:a16="http://schemas.microsoft.com/office/drawing/2014/main" id="{2A76C785-0332-4439-89D8-4C92564AB60F}"/>
-              </a:ext>
-            </a:extLst>
-          </p:cNvPr>
-          <p:cNvSpPr>
-            <a:spLocks xmlns:a="http://schemas.openxmlformats.org/drawingml/2006/main" noGrp="1"/>
-          </p:cNvSpPr>
-          <p:nvPr/>
-        </p:nvSpPr>
-        <p:spPr>
-          <a:xfrm xmlns:a="http://schemas.openxmlformats.org/drawingml/2006/main">
-            <a:off x="8867775" y="3876675"/>
-            <a:ext cx="2038350" cy="952500"/>
-          </a:xfrm>
-          <a:prstGeom xmlns:a="http://schemas.openxmlformats.org/drawingml/2006/main" prst="rect">
-            <a:avLst/>
-          </a:prstGeom>
-          <a:noFill xmlns:a="http://schemas.openxmlformats.org/drawingml/2006/main"/>
-          <a:ln xmlns:a="http://schemas.openxmlformats.org/drawingml/2006/main" w="0">
-            <a:noFill/>
-            <a:prstDash val="solid"/>
-          </a:ln>
-        </p:spPr>
-        <p:txBody>
-          <a:bodyPr xmlns:a="http://schemas.openxmlformats.org/drawingml/2006/main" anchor="t">
-            <a:normAutofit fontScale="100000"/>
-          </a:bodyPr>
-          <a:lstStyle xmlns:a="http://schemas.openxmlformats.org/drawingml/2006/main"/>
-          <a:p xmlns:a="http://schemas.openxmlformats.org/drawingml/2006/main">
-            <a:pPr algn="l">
-              <a:buNone/>
-              <a:defRPr sz="1275" b="0">
-                <a:solidFill>
-                  <a:srgbClr val="344054"/>
-                </a:solidFill>
-                <a:latin typeface="Helvetica Neue"/>
-                <a:ea typeface="Helvetica Neue"/>
-                <a:cs typeface="Helvetica Neue"/>
-              </a:defRPr>
-            </a:pPr>
-            <a:r>
-              <a:rPr sz="1275" b="0">
-                <a:solidFill>
-                  <a:srgbClr val="344054"/>
-                </a:solidFill>
-                <a:latin typeface="Helvetica Neue"/>
-                <a:ea typeface="Helvetica Neue"/>
-                <a:cs typeface="Helvetica Neue"/>
-              </a:rPr>
-              <a:t>Reconciliation</a:t>
-            </a:r>
-          </a:p>
-          <a:p xmlns:a="http://schemas.openxmlformats.org/drawingml/2006/main">
-            <a:pPr algn="l">
-              <a:buNone/>
-              <a:defRPr sz="1275" b="0">
-                <a:solidFill>
-                  <a:srgbClr val="344054"/>
-                </a:solidFill>
-                <a:latin typeface="Helvetica Neue"/>
-                <a:ea typeface="Helvetica Neue"/>
-                <a:cs typeface="Helvetica Neue"/>
-              </a:defRPr>
-            </a:pPr>
-            <a:r>
-              <a:rPr sz="1275" b="0">
-                <a:solidFill>
-                  <a:srgbClr val="344054"/>
-                </a:solidFill>
-                <a:latin typeface="Helvetica Neue"/>
-                <a:ea typeface="Helvetica Neue"/>
-                <a:cs typeface="Helvetica Neue"/>
-              </a:rPr>
-              <a:t>Monitoring</a:t>
-            </a:r>
-          </a:p>
-          <a:p xmlns:a="http://schemas.openxmlformats.org/drawingml/2006/main">
-            <a:pPr algn="l">
-              <a:buNone/>
-              <a:defRPr sz="1275" b="0">
-                <a:solidFill>
-                  <a:srgbClr val="344054"/>
-                </a:solidFill>
-                <a:latin typeface="Helvetica Neue"/>
-                <a:ea typeface="Helvetica Neue"/>
-                <a:cs typeface="Helvetica Neue"/>
-              </a:defRPr>
-            </a:pPr>
-            <a:r>
-              <a:rPr sz="1275" b="0">
-                <a:solidFill>
-                  <a:srgbClr val="344054"/>
-                </a:solidFill>
-                <a:latin typeface="Helvetica Neue"/>
-                <a:ea typeface="Helvetica Neue"/>
-                <a:cs typeface="Helvetica Neue"/>
-              </a:rPr>
-              <a:t>250-company test and principal pilot</a:t>
-            </a:r>
-          </a:p>
-        </p:txBody>
-      </p:sp>
-      <p:sp>
-        <p:nvSpPr>
-          <p:cNvPr id="25" name="">
-            <a:extLst xmlns:a="http://schemas.openxmlformats.org/drawingml/2006/main">
-              <a:ext uri="{FF2B5EF4-FFF2-40B4-BE49-F238E27FC236}">
-                <a16:creationId xmlns:a16="http://schemas.microsoft.com/office/drawing/2014/main" id="{8FD243BD-D1D8-4D5E-9080-89BCC3F63E9D}"/>
-              </a:ext>
-            </a:extLst>
-          </p:cNvPr>
-          <p:cNvSpPr>
-            <a:spLocks xmlns:a="http://schemas.openxmlformats.org/drawingml/2006/main" noGrp="1"/>
-          </p:cNvSpPr>
-          <p:nvPr/>
-        </p:nvSpPr>
-        <p:spPr>
-          <a:xfrm xmlns:a="http://schemas.openxmlformats.org/drawingml/2006/main">
-            <a:off x="457200" y="5391150"/>
-            <a:ext cx="10858500" cy="628650"/>
-          </a:xfrm>
-          <a:prstGeom xmlns:a="http://schemas.openxmlformats.org/drawingml/2006/main" prst="roundRect">
-            <a:avLst>
-              <a:gd name="adj" fmla="val 21212"/>
-            </a:avLst>
-          </a:prstGeom>
-          <a:solidFill xmlns:a="http://schemas.openxmlformats.org/drawingml/2006/main">
-            <a:srgbClr val="F2F4F7"/>
-          </a:solidFill>
-          <a:ln xmlns:a="http://schemas.openxmlformats.org/drawingml/2006/main" w="9525">
-            <a:solidFill>
-              <a:srgbClr val="D0D5DD"/>
-            </a:solidFill>
-            <a:prstDash val="solid"/>
-          </a:ln>
-        </p:spPr>
-      </p:sp>
-      <p:sp>
-        <p:nvSpPr>
-          <p:cNvPr id="26" name="">
-            <a:extLst xmlns:a="http://schemas.openxmlformats.org/drawingml/2006/main">
-              <a:ext uri="{FF2B5EF4-FFF2-40B4-BE49-F238E27FC236}">
-                <a16:creationId xmlns:a16="http://schemas.microsoft.com/office/drawing/2014/main" id="{6DBF2437-14B5-4A46-9FC0-D460E78897FD}"/>
-              </a:ext>
-            </a:extLst>
-          </p:cNvPr>
-          <p:cNvSpPr>
-            <a:spLocks xmlns:a="http://schemas.openxmlformats.org/drawingml/2006/main" noGrp="1"/>
-          </p:cNvSpPr>
-          <p:nvPr/>
-        </p:nvSpPr>
-        <p:spPr>
-          <a:xfrm xmlns:a="http://schemas.openxmlformats.org/drawingml/2006/main">
-            <a:off x="666750" y="5581650"/>
-            <a:ext cx="3429000" cy="228600"/>
-          </a:xfrm>
-          <a:prstGeom xmlns:a="http://schemas.openxmlformats.org/drawingml/2006/main" prst="rect">
-            <a:avLst/>
-          </a:prstGeom>
-          <a:noFill xmlns:a="http://schemas.openxmlformats.org/drawingml/2006/main"/>
-          <a:ln xmlns:a="http://schemas.openxmlformats.org/drawingml/2006/main" w="0">
-            <a:noFill/>
-            <a:prstDash val="solid"/>
-          </a:ln>
-        </p:spPr>
-        <p:txBody>
-          <a:bodyPr xmlns:a="http://schemas.openxmlformats.org/drawingml/2006/main" anchor="t">
-            <a:normAutofit fontScale="75000"/>
-          </a:bodyPr>
-          <a:lstStyle xmlns:a="http://schemas.openxmlformats.org/drawingml/2006/main"/>
-          <a:p xmlns:a="http://schemas.openxmlformats.org/drawingml/2006/main">
-            <a:pPr algn="l">
-              <a:buNone/>
-              <a:defRPr sz="1200" b="1">
-                <a:solidFill>
-                  <a:srgbClr val="101828"/>
-                </a:solidFill>
-                <a:latin typeface="Helvetica Neue"/>
-                <a:ea typeface="Helvetica Neue"/>
-                <a:cs typeface="Helvetica Neue"/>
-              </a:defRPr>
-            </a:pPr>
-            <a:r>
-              <a:rPr sz="1200" b="1">
-                <a:solidFill>
-                  <a:srgbClr val="101828"/>
-                </a:solidFill>
-                <a:latin typeface="Helvetica Neue"/>
-                <a:ea typeface="Helvetica Neue"/>
-                <a:cs typeface="Helvetica Neue"/>
-              </a:rPr>
-              <a:t>PERSON 1 · Product and application</a:t>
-            </a:r>
-          </a:p>
-        </p:txBody>
-      </p:sp>
-      <p:sp>
-        <p:nvSpPr>
-          <p:cNvPr id="27" name="">
-            <a:extLst xmlns:a="http://schemas.openxmlformats.org/drawingml/2006/main">
-              <a:ext uri="{FF2B5EF4-FFF2-40B4-BE49-F238E27FC236}">
-                <a16:creationId xmlns:a16="http://schemas.microsoft.com/office/drawing/2014/main" id="{918CF25F-52C6-4E33-BCCB-F49769B2D014}"/>
-              </a:ext>
-            </a:extLst>
-          </p:cNvPr>
-          <p:cNvSpPr>
-            <a:spLocks xmlns:a="http://schemas.openxmlformats.org/drawingml/2006/main" noGrp="1"/>
-          </p:cNvSpPr>
-          <p:nvPr/>
-        </p:nvSpPr>
-        <p:spPr>
-          <a:xfrm xmlns:a="http://schemas.openxmlformats.org/drawingml/2006/main">
-            <a:off x="4476750" y="5581650"/>
-            <a:ext cx="3238500" cy="228600"/>
-          </a:xfrm>
-          <a:prstGeom xmlns:a="http://schemas.openxmlformats.org/drawingml/2006/main" prst="rect">
-            <a:avLst/>
-          </a:prstGeom>
-          <a:noFill xmlns:a="http://schemas.openxmlformats.org/drawingml/2006/main"/>
-          <a:ln xmlns:a="http://schemas.openxmlformats.org/drawingml/2006/main" w="0">
-            <a:noFill/>
-            <a:prstDash val="solid"/>
-          </a:ln>
-        </p:spPr>
-        <p:txBody>
-          <a:bodyPr xmlns:a="http://schemas.openxmlformats.org/drawingml/2006/main" anchor="t">
-            <a:normAutofit fontScale="75000"/>
-          </a:bodyPr>
-          <a:lstStyle xmlns:a="http://schemas.openxmlformats.org/drawingml/2006/main"/>
-          <a:p xmlns:a="http://schemas.openxmlformats.org/drawingml/2006/main">
-            <a:pPr algn="l">
-              <a:buNone/>
-              <a:defRPr sz="1200" b="1">
-                <a:solidFill>
-                  <a:srgbClr val="101828"/>
-                </a:solidFill>
-                <a:latin typeface="Helvetica Neue"/>
-                <a:ea typeface="Helvetica Neue"/>
-                <a:cs typeface="Helvetica Neue"/>
-              </a:defRPr>
-            </a:pPr>
-            <a:r>
-              <a:rPr sz="1200" b="1">
-                <a:solidFill>
-                  <a:srgbClr val="101828"/>
-                </a:solidFill>
-                <a:latin typeface="Helvetica Neue"/>
-                <a:ea typeface="Helvetica Neue"/>
-                <a:cs typeface="Helvetica Neue"/>
-              </a:rPr>
-              <a:t>PERSON 2 · Data and platform</a:t>
-            </a:r>
-          </a:p>
-        </p:txBody>
-      </p:sp>
-      <p:sp>
-        <p:nvSpPr>
-          <p:cNvPr id="28" name="">
-            <a:extLst xmlns:a="http://schemas.openxmlformats.org/drawingml/2006/main">
-              <a:ext uri="{FF2B5EF4-FFF2-40B4-BE49-F238E27FC236}">
-                <a16:creationId xmlns:a16="http://schemas.microsoft.com/office/drawing/2014/main" id="{DB910F2C-EF3B-4B5A-AC88-78FDB08FE0C6}"/>
-              </a:ext>
-            </a:extLst>
-          </p:cNvPr>
-          <p:cNvSpPr>
-            <a:spLocks xmlns:a="http://schemas.openxmlformats.org/drawingml/2006/main" noGrp="1"/>
-          </p:cNvSpPr>
-          <p:nvPr/>
-        </p:nvSpPr>
-        <p:spPr>
-          <a:xfrm xmlns:a="http://schemas.openxmlformats.org/drawingml/2006/main">
-            <a:off x="7953375" y="5581650"/>
-            <a:ext cx="3048000" cy="228600"/>
-          </a:xfrm>
-          <a:prstGeom xmlns:a="http://schemas.openxmlformats.org/drawingml/2006/main" prst="rect">
-            <a:avLst/>
-          </a:prstGeom>
-          <a:noFill xmlns:a="http://schemas.openxmlformats.org/drawingml/2006/main"/>
-          <a:ln xmlns:a="http://schemas.openxmlformats.org/drawingml/2006/main" w="0">
-            <a:noFill/>
-            <a:prstDash val="solid"/>
-          </a:ln>
-        </p:spPr>
-        <p:txBody>
-          <a:bodyPr xmlns:a="http://schemas.openxmlformats.org/drawingml/2006/main" anchor="t">
-            <a:normAutofit fontScale="75000"/>
-          </a:bodyPr>
-          <a:lstStyle xmlns:a="http://schemas.openxmlformats.org/drawingml/2006/main"/>
-          <a:p xmlns:a="http://schemas.openxmlformats.org/drawingml/2006/main">
-            <a:pPr algn="l">
-              <a:buNone/>
-              <a:defRPr sz="1200" b="1">
-                <a:solidFill>
-                  <a:srgbClr val="315F9F"/>
-                </a:solidFill>
-                <a:latin typeface="Helvetica Neue"/>
-                <a:ea typeface="Helvetica Neue"/>
-                <a:cs typeface="Helvetica Neue"/>
-              </a:defRPr>
-            </a:pPr>
-            <a:r>
-              <a:rPr sz="1200" b="1">
-                <a:solidFill>
-                  <a:srgbClr val="315F9F"/>
-                </a:solidFill>
-                <a:latin typeface="Helvetica Neue"/>
-                <a:ea typeface="Helvetica Neue"/>
-                <a:cs typeface="Helvetica Neue"/>
-              </a:rPr>
-              <a:t>SHARED · Source contract and evaluation set</a:t>
-            </a:r>
-          </a:p>
-        </p:txBody>
-      </p:sp>
-    </p:spTree>
-    <p:extLst>
-      <p:ext uri="{BB962C8B-B14F-4D97-AF65-F5344CB8AC3E}">
-        <p14:creationId xmlns:p14="http://schemas.microsoft.com/office/powerpoint/2010/main" val="1276192043"/>
-      </p:ext>
-    </p:extLst>
-  </p:cSld>
-</p:sld>
-</file>
-
-<file path=ppt/slides/slide8.xml><?xml version="1.0" encoding="utf-8"?>
-<p:sld xmlns:p="http://schemas.openxmlformats.org/presentationml/2006/main">
-  <p:cSld>
-    <p:bg>
-      <p:bgPr>
-        <a:solidFill xmlns:a="http://schemas.openxmlformats.org/drawingml/2006/main">
-          <a:srgbClr val="FBFAF7"/>
-        </a:solidFill>
-      </p:bgPr>
-    </p:bg>
-    <p:spTree>
-      <p:nvGrpSpPr>
-        <p:cNvPr id="1" name=""/>
-        <p:cNvGrpSpPr/>
-        <p:nvPr/>
-      </p:nvGrpSpPr>
-      <p:grpSpPr>
-        <a:xfrm xmlns:a="http://schemas.openxmlformats.org/drawingml/2006/main"/>
-      </p:grpSpPr>
-      <p:sp>
-        <p:nvSpPr>
-          <p:cNvPr id="20" name="">
-            <a:extLst xmlns:a="http://schemas.openxmlformats.org/drawingml/2006/main">
-              <a:ext uri="{FF2B5EF4-FFF2-40B4-BE49-F238E27FC236}">
-                <a16:creationId xmlns:a16="http://schemas.microsoft.com/office/drawing/2014/main" id="{47D7DB73-AD97-4C88-8C7A-A4A75DE3DDCC}"/>
-              </a:ext>
-            </a:extLst>
-          </p:cNvPr>
-          <p:cNvSpPr>
-            <a:spLocks xmlns:a="http://schemas.openxmlformats.org/drawingml/2006/main" noGrp="1"/>
-          </p:cNvSpPr>
-          <p:nvPr/>
-        </p:nvSpPr>
-        <p:spPr>
-          <a:xfrm xmlns:a="http://schemas.openxmlformats.org/drawingml/2006/main">
-            <a:off x="457200" y="361950"/>
-            <a:ext cx="11049000" cy="857250"/>
-          </a:xfrm>
-          <a:prstGeom xmlns:a="http://schemas.openxmlformats.org/drawingml/2006/main" prst="rect">
-            <a:avLst/>
-          </a:prstGeom>
-          <a:noFill xmlns:a="http://schemas.openxmlformats.org/drawingml/2006/main"/>
-          <a:ln xmlns:a="http://schemas.openxmlformats.org/drawingml/2006/main" w="0">
-            <a:noFill/>
-            <a:prstDash val="solid"/>
-          </a:ln>
-        </p:spPr>
-        <p:txBody>
-          <a:bodyPr xmlns:a="http://schemas.openxmlformats.org/drawingml/2006/main" anchor="t">
-            <a:normAutofit fontScale="100000"/>
-          </a:bodyPr>
-          <a:lstStyle xmlns:a="http://schemas.openxmlformats.org/drawingml/2006/main"/>
-          <a:p xmlns:a="http://schemas.openxmlformats.org/drawingml/2006/main">
-            <a:pPr algn="l">
-              <a:buNone/>
-              <a:defRPr sz="3000" b="1">
-                <a:solidFill>
-                  <a:srgbClr val="101828"/>
-                </a:solidFill>
-                <a:latin typeface="Helvetica Neue"/>
-                <a:ea typeface="Helvetica Neue"/>
-                <a:cs typeface="Helvetica Neue"/>
-              </a:defRPr>
-            </a:pPr>
-            <a:r>
-              <a:rPr sz="3000" b="1">
-                <a:solidFill>
-                  <a:srgbClr val="101828"/>
-                </a:solidFill>
-                <a:latin typeface="Helvetica Neue"/>
-                <a:ea typeface="Helvetica Neue"/>
-                <a:cs typeface="Helvetica Neue"/>
-              </a:rPr>
-              <a:t>What do I de-risk first, and what changes with more time?</a:t>
-            </a:r>
-          </a:p>
-        </p:txBody>
-      </p:sp>
-      <p:sp>
-        <p:nvSpPr>
-          <p:cNvPr id="2" name="">
-            <a:extLst xmlns:a="http://schemas.openxmlformats.org/drawingml/2006/main">
-              <a:ext uri="{FF2B5EF4-FFF2-40B4-BE49-F238E27FC236}">
-                <a16:creationId xmlns:a16="http://schemas.microsoft.com/office/drawing/2014/main" id="{1148B56E-B5D3-40D5-84C7-3298B3E762FB}"/>
-              </a:ext>
-            </a:extLst>
-          </p:cNvPr>
-          <p:cNvSpPr>
-            <a:spLocks xmlns:a="http://schemas.openxmlformats.org/drawingml/2006/main" noGrp="1"/>
-          </p:cNvSpPr>
-          <p:nvPr/>
-        </p:nvSpPr>
-        <p:spPr>
-          <a:xfrm xmlns:a="http://schemas.openxmlformats.org/drawingml/2006/main">
-            <a:off x="457200" y="6324600"/>
-            <a:ext cx="10858500" cy="0"/>
-          </a:xfrm>
-          <a:prstGeom xmlns:a="http://schemas.openxmlformats.org/drawingml/2006/main" prst="line">
-            <a:avLst/>
-          </a:prstGeom>
-          <a:noFill xmlns:a="http://schemas.openxmlformats.org/drawingml/2006/main"/>
-          <a:ln xmlns:a="http://schemas.openxmlformats.org/drawingml/2006/main" w="9525">
-            <a:solidFill>
-              <a:srgbClr val="D0D5DD"/>
-            </a:solidFill>
-            <a:prstDash val="solid"/>
-          </a:ln>
-        </p:spPr>
-      </p:sp>
-      <p:sp>
-        <p:nvSpPr>
-          <p:cNvPr id="3" name="">
-            <a:extLst xmlns:a="http://schemas.openxmlformats.org/drawingml/2006/main">
-              <a:ext uri="{FF2B5EF4-FFF2-40B4-BE49-F238E27FC236}">
-                <a16:creationId xmlns:a16="http://schemas.microsoft.com/office/drawing/2014/main" id="{AB2D00DE-0653-4BEF-8506-56714A0FA028}"/>
-              </a:ext>
-            </a:extLst>
-          </p:cNvPr>
-          <p:cNvSpPr>
-            <a:spLocks xmlns:a="http://schemas.openxmlformats.org/drawingml/2006/main" noGrp="1"/>
-          </p:cNvSpPr>
-          <p:nvPr/>
-        </p:nvSpPr>
-        <p:spPr>
-          <a:xfrm xmlns:a="http://schemas.openxmlformats.org/drawingml/2006/main">
-            <a:off x="10744200" y="6457950"/>
-            <a:ext cx="571500" cy="171450"/>
-          </a:xfrm>
-          <a:prstGeom xmlns:a="http://schemas.openxmlformats.org/drawingml/2006/main" prst="rect">
-            <a:avLst/>
-          </a:prstGeom>
-          <a:noFill xmlns:a="http://schemas.openxmlformats.org/drawingml/2006/main"/>
-          <a:ln xmlns:a="http://schemas.openxmlformats.org/drawingml/2006/main" w="0">
-            <a:noFill/>
-            <a:prstDash val="solid"/>
-          </a:ln>
-        </p:spPr>
-        <p:txBody>
-          <a:bodyPr xmlns:a="http://schemas.openxmlformats.org/drawingml/2006/main" anchor="t"/>
-          <a:lstStyle xmlns:a="http://schemas.openxmlformats.org/drawingml/2006/main"/>
-          <a:p xmlns:a="http://schemas.openxmlformats.org/drawingml/2006/main">
-            <a:pPr algn="r">
-              <a:buNone/>
-              <a:defRPr sz="975" b="1">
-                <a:solidFill>
-                  <a:srgbClr val="667085"/>
-                </a:solidFill>
-                <a:latin typeface="Helvetica Neue"/>
-                <a:ea typeface="Helvetica Neue"/>
-                <a:cs typeface="Helvetica Neue"/>
-              </a:defRPr>
-            </a:pPr>
-            <a:r>
-              <a:rPr sz="975" b="1">
-                <a:solidFill>
-                  <a:srgbClr val="667085"/>
-                </a:solidFill>
-                <a:latin typeface="Helvetica Neue"/>
-                <a:ea typeface="Helvetica Neue"/>
-                <a:cs typeface="Helvetica Neue"/>
-              </a:rPr>
-              <a:t>08</a:t>
             </a:r>
           </a:p>
         </p:txBody>

</xml_diff>

<commit_message>
Update the product screenshot for desktop and mobile
</commit_message>
<xml_diff>
--- a/docs/AVIC-Portfolio-Intelligence-Brief.pptx
+++ b/docs/AVIC-Portfolio-Intelligence-Brief.pptx
@@ -2,19 +2,19 @@
 <file path=ppt/presentation.xml><?xml version="1.0" encoding="utf-8"?>
 <p:presentation xmlns:p="http://schemas.openxmlformats.org/presentationml/2006/main">
   <p:sldMasterIdLst>
-    <p:sldMasterId xmlns:r="http://schemas.openxmlformats.org/officeDocument/2006/relationships" id="2147483648" r:id="R2dc6f99b2e2a40dd"/>
+    <p:sldMasterId xmlns:r="http://schemas.openxmlformats.org/officeDocument/2006/relationships" id="2147483648" r:id="Ra4b68706b25d430c"/>
   </p:sldMasterIdLst>
   <p:notesMasterIdLst>
-    <p:notesMasterId xmlns:r="http://schemas.openxmlformats.org/officeDocument/2006/relationships" r:id="R52151129f8b6430c"/>
+    <p:notesMasterId xmlns:r="http://schemas.openxmlformats.org/officeDocument/2006/relationships" r:id="R849142d5623147aa"/>
   </p:notesMasterIdLst>
   <p:sldIdLst>
-    <p:sldId xmlns:r="http://schemas.openxmlformats.org/officeDocument/2006/relationships" id="256" r:id="R9003943a41ed4348"/>
-    <p:sldId xmlns:r="http://schemas.openxmlformats.org/officeDocument/2006/relationships" id="257" r:id="R52a588e157e0430d"/>
-    <p:sldId xmlns:r="http://schemas.openxmlformats.org/officeDocument/2006/relationships" id="258" r:id="R2438b7664de24802"/>
-    <p:sldId xmlns:r="http://schemas.openxmlformats.org/officeDocument/2006/relationships" id="259" r:id="R7d1cf84c64734b60"/>
-    <p:sldId xmlns:r="http://schemas.openxmlformats.org/officeDocument/2006/relationships" id="260" r:id="Re94225012ab84231"/>
-    <p:sldId xmlns:r="http://schemas.openxmlformats.org/officeDocument/2006/relationships" id="261" r:id="Rdd9ac5107b8b46bb"/>
-    <p:sldId xmlns:r="http://schemas.openxmlformats.org/officeDocument/2006/relationships" id="262" r:id="R8bde937300fc44fd"/>
+    <p:sldId xmlns:r="http://schemas.openxmlformats.org/officeDocument/2006/relationships" id="256" r:id="Red968a23d1b24551"/>
+    <p:sldId xmlns:r="http://schemas.openxmlformats.org/officeDocument/2006/relationships" id="257" r:id="R28fa0716d57d44e5"/>
+    <p:sldId xmlns:r="http://schemas.openxmlformats.org/officeDocument/2006/relationships" id="258" r:id="Rb3f1969c618c4a46"/>
+    <p:sldId xmlns:r="http://schemas.openxmlformats.org/officeDocument/2006/relationships" id="259" r:id="R279c5c04734f49c5"/>
+    <p:sldId xmlns:r="http://schemas.openxmlformats.org/officeDocument/2006/relationships" id="260" r:id="Ra185b53320af49da"/>
+    <p:sldId xmlns:r="http://schemas.openxmlformats.org/officeDocument/2006/relationships" id="261" r:id="Rd6521e4cd0f144d1"/>
+    <p:sldId xmlns:r="http://schemas.openxmlformats.org/officeDocument/2006/relationships" id="262" r:id="Rff746d26334c4c7c"/>
   </p:sldIdLst>
   <p:sldSz cx="12192000" cy="6858000"/>
   <p:notesSz cx="6858000" cy="9144000"/>
@@ -643,7 +643,7 @@
           <a:lstStyle xmlns:a="http://schemas.openxmlformats.org/drawingml/2006/main"/>
           <a:p xmlns:a="http://schemas.openxmlformats.org/drawingml/2006/main">
             <a:r>
-              <a:t>Show the desktop flow. The AIVC principal selects a company, scans the brief, opens the evidence and original source, and sends feedback without changing context.</a:t>
+              <a:t>Show the current desktop and mobile interface. The AIVC principal can select a company, scan the brief, open evidence, inspect the original source, refresh the brief, and send feedback on either screen size. The screenshots are current captures from the running Lens application.</a:t>
             </a:r>
           </a:p>
           <a:p xmlns:a="http://schemas.openxmlformats.org/drawingml/2006/main">
@@ -668,7 +668,12 @@
           </a:p>
           <a:p xmlns:a="http://schemas.openxmlformats.org/drawingml/2006/main">
             <a:r>
-              <a:t>- /private/tmp/avic-deck-wide-main.png</a:t>
+              <a:t>- /Users/alexthorpe/Documents/ChatGPT/AIVC/_deck_responsive_screenshot.GnRh2f/lens-desktop.png</a:t>
+            </a:r>
+          </a:p>
+          <a:p xmlns:a="http://schemas.openxmlformats.org/drawingml/2006/main">
+            <a:r>
+              <a:t>- /Users/alexthorpe/Documents/ChatGPT/AIVC/_deck_responsive_screenshot.GnRh2f/lens-mobile.png</a:t>
             </a:r>
           </a:p>
           <a:p xmlns:a="http://schemas.openxmlformats.org/drawingml/2006/main">
@@ -1236,7 +1241,7 @@
   </p:cSld>
   <p:clrMap bg1="lt1" tx1="dk1" bg2="lt2" tx2="dk2" accent1="accent1" accent2="accent2" accent3="accent3" accent4="accent4" accent5="accent5" accent6="accent6" hlink="hlink" folHlink="folHlink"/>
   <p:sldLayoutIdLst>
-    <p:sldLayoutId xmlns:r="http://schemas.openxmlformats.org/officeDocument/2006/relationships" id="2147483649" r:id="Rc19335f50eb947b4"/>
+    <p:sldLayoutId xmlns:r="http://schemas.openxmlformats.org/officeDocument/2006/relationships" id="2147483649" r:id="Rdc9bdcfa90d442c1"/>
   </p:sldLayoutIdLst>
   <p:txStyles>
     <p:titleStyle>
@@ -3483,7 +3488,7 @@
                 <a:ea typeface="Helvetica Neue"/>
                 <a:cs typeface="Helvetica Neue"/>
               </a:rPr>
-              <a:t>The brief, evidence, original source, and feedback stay in one flow.</a:t>
+              <a:t>The same brief and evidence flow works on desktop and mobile.</a:t>
             </a:r>
           </a:p>
         </p:txBody>
@@ -4382,18 +4387,16 @@
           <p:nvPr/>
         </p:nvPicPr>
         <p:blipFill>
-          <a:blip xmlns:r="http://schemas.openxmlformats.org/officeDocument/2006/relationships" xmlns:a="http://schemas.openxmlformats.org/drawingml/2006/main" r:embed="R1164259a882c4baf"/>
+          <a:blip xmlns:r="http://schemas.openxmlformats.org/officeDocument/2006/relationships" xmlns:a="http://schemas.openxmlformats.org/drawingml/2006/main" r:embed="R5431079252754729"/>
           <a:stretch xmlns:a="http://schemas.openxmlformats.org/drawingml/2006/main"/>
         </p:blipFill>
         <p:spPr>
-          <a:xfrm xmlns:a="http://schemas.openxmlformats.org/drawingml/2006/main">
+          <a:xfrm xmlns:a="http://schemas.openxmlformats.org/drawingml/2006/main" flipH="0" flipV="0">
             <a:off x="595993" y="1924050"/>
             <a:ext cx="7342414" cy="4057650"/>
           </a:xfrm>
           <a:prstGeom xmlns:a="http://schemas.openxmlformats.org/drawingml/2006/main" prst="roundRect">
-            <a:avLst>
-              <a:gd name="adj" fmla="val 2817"/>
-            </a:avLst>
+            <a:avLst/>
           </a:prstGeom>
         </p:spPr>
       </p:pic>
@@ -5889,7 +5892,7 @@
       </p:sp>
       <p:cxnSp>
         <p:nvCxnSpPr>
-          <p:cNvPr id="1243" name=""/>
+          <p:cNvPr id="1317" name=""/>
           <p:cNvCxnSpPr>
             <a:stCxn xmlns:a="http://schemas.openxmlformats.org/drawingml/2006/main" id="5" idx="3"/>
             <a:endCxn xmlns:a="http://schemas.openxmlformats.org/drawingml/2006/main" id="8" idx="1"/>
@@ -5915,7 +5918,7 @@
       </p:cxnSp>
       <p:cxnSp>
         <p:nvCxnSpPr>
-          <p:cNvPr id="1244" name=""/>
+          <p:cNvPr id="1318" name=""/>
           <p:cNvCxnSpPr>
             <a:stCxn xmlns:a="http://schemas.openxmlformats.org/drawingml/2006/main" id="8" idx="3"/>
             <a:endCxn xmlns:a="http://schemas.openxmlformats.org/drawingml/2006/main" id="11" idx="1"/>
@@ -5941,7 +5944,7 @@
       </p:cxnSp>
       <p:cxnSp>
         <p:nvCxnSpPr>
-          <p:cNvPr id="1245" name=""/>
+          <p:cNvPr id="1319" name=""/>
           <p:cNvCxnSpPr>
             <a:stCxn xmlns:a="http://schemas.openxmlformats.org/drawingml/2006/main" id="11" idx="3"/>
             <a:endCxn xmlns:a="http://schemas.openxmlformats.org/drawingml/2006/main" id="14" idx="1"/>
@@ -5967,7 +5970,7 @@
       </p:cxnSp>
       <p:cxnSp>
         <p:nvCxnSpPr>
-          <p:cNvPr id="1246" name=""/>
+          <p:cNvPr id="1320" name=""/>
           <p:cNvCxnSpPr>
             <a:stCxn xmlns:a="http://schemas.openxmlformats.org/drawingml/2006/main" id="14" idx="3"/>
             <a:endCxn xmlns:a="http://schemas.openxmlformats.org/drawingml/2006/main" id="17" idx="1"/>
@@ -6616,7 +6619,7 @@
       </p:sp>
       <p:cxnSp>
         <p:nvCxnSpPr>
-          <p:cNvPr id="1258" name=""/>
+          <p:cNvPr id="1332" name=""/>
           <p:cNvCxnSpPr>
             <a:stCxn xmlns:a="http://schemas.openxmlformats.org/drawingml/2006/main" id="14" idx="3"/>
             <a:endCxn xmlns:a="http://schemas.openxmlformats.org/drawingml/2006/main" id="78" idx="1"/>
@@ -6642,7 +6645,7 @@
       </p:cxnSp>
       <p:cxnSp>
         <p:nvCxnSpPr>
-          <p:cNvPr id="1259" name=""/>
+          <p:cNvPr id="1333" name=""/>
           <p:cNvCxnSpPr>
             <a:stCxn xmlns:a="http://schemas.openxmlformats.org/drawingml/2006/main" id="78" idx="3"/>
             <a:endCxn xmlns:a="http://schemas.openxmlformats.org/drawingml/2006/main" id="17" idx="1"/>
@@ -6705,14 +6708,14 @@
       </p:sp>
       <p:pic>
         <p:nvPicPr>
-          <p:cNvPr id="1261" name=""/>
+          <p:cNvPr id="1335" name=""/>
           <p:cNvPicPr>
             <a:picLocks xmlns:a="http://schemas.openxmlformats.org/drawingml/2006/main" noChangeAspect="1"/>
           </p:cNvPicPr>
           <p:nvPr/>
         </p:nvPicPr>
         <p:blipFill>
-          <a:blip xmlns:r="http://schemas.openxmlformats.org/officeDocument/2006/relationships" xmlns:a="http://schemas.openxmlformats.org/drawingml/2006/main" r:embed="R1f79be84c1f24591"/>
+          <a:blip xmlns:r="http://schemas.openxmlformats.org/officeDocument/2006/relationships" xmlns:a="http://schemas.openxmlformats.org/drawingml/2006/main" r:embed="R54b85a7ace574071"/>
           <a:stretch xmlns:a="http://schemas.openxmlformats.org/drawingml/2006/main"/>
         </p:blipFill>
         <p:spPr>

</xml_diff>